<commit_message>
Ship content-preserving revenue command center dashboard
</commit_message>
<xml_diff>
--- a/outputs/presentation/Marketing_Analytics_Executive_Deck.pptx
+++ b/outputs/presentation/Marketing_Analytics_Executive_Deck.pptx
@@ -2,24 +2,24 @@
 <file path=ppt/presentation.xml><?xml version="1.0" encoding="utf-8"?>
 <p:presentation xmlns:p="http://schemas.openxmlformats.org/presentationml/2006/main">
   <p:sldMasterIdLst>
-    <p:sldMasterId xmlns:r="http://schemas.openxmlformats.org/officeDocument/2006/relationships" id="2147483648" r:id="Rfc513c1705fa43a4"/>
+    <p:sldMasterId xmlns:r="http://schemas.openxmlformats.org/officeDocument/2006/relationships" id="2147483648" r:id="R6eb190dfb6a843eb"/>
   </p:sldMasterIdLst>
   <p:notesMasterIdLst>
-    <p:notesMasterId xmlns:r="http://schemas.openxmlformats.org/officeDocument/2006/relationships" r:id="R0a57f65b944e4b81"/>
+    <p:notesMasterId xmlns:r="http://schemas.openxmlformats.org/officeDocument/2006/relationships" r:id="R807d07fd88224596"/>
   </p:notesMasterIdLst>
   <p:sldIdLst>
-    <p:sldId xmlns:r="http://schemas.openxmlformats.org/officeDocument/2006/relationships" id="256" r:id="R3dcb5351786240ce"/>
-    <p:sldId xmlns:r="http://schemas.openxmlformats.org/officeDocument/2006/relationships" id="257" r:id="R26bad879508d4e65"/>
-    <p:sldId xmlns:r="http://schemas.openxmlformats.org/officeDocument/2006/relationships" id="258" r:id="R81caefe2e830450a"/>
-    <p:sldId xmlns:r="http://schemas.openxmlformats.org/officeDocument/2006/relationships" id="259" r:id="R496249e6cc794440"/>
-    <p:sldId xmlns:r="http://schemas.openxmlformats.org/officeDocument/2006/relationships" id="260" r:id="Rf962675290154c82"/>
-    <p:sldId xmlns:r="http://schemas.openxmlformats.org/officeDocument/2006/relationships" id="261" r:id="Rae2857f822224459"/>
-    <p:sldId xmlns:r="http://schemas.openxmlformats.org/officeDocument/2006/relationships" id="262" r:id="R4c9fa963e9704031"/>
-    <p:sldId xmlns:r="http://schemas.openxmlformats.org/officeDocument/2006/relationships" id="263" r:id="R62a7de93837b4e7b"/>
-    <p:sldId xmlns:r="http://schemas.openxmlformats.org/officeDocument/2006/relationships" id="264" r:id="Rcca842244a074508"/>
-    <p:sldId xmlns:r="http://schemas.openxmlformats.org/officeDocument/2006/relationships" id="265" r:id="Rb0bde08ecfaa40dd"/>
-    <p:sldId xmlns:r="http://schemas.openxmlformats.org/officeDocument/2006/relationships" id="266" r:id="R719edd9eecf24411"/>
-    <p:sldId xmlns:r="http://schemas.openxmlformats.org/officeDocument/2006/relationships" id="267" r:id="Ra1db85d58e624f31"/>
+    <p:sldId xmlns:r="http://schemas.openxmlformats.org/officeDocument/2006/relationships" id="256" r:id="R9d69febf263547a3"/>
+    <p:sldId xmlns:r="http://schemas.openxmlformats.org/officeDocument/2006/relationships" id="257" r:id="R648bcb426a8b4d3c"/>
+    <p:sldId xmlns:r="http://schemas.openxmlformats.org/officeDocument/2006/relationships" id="258" r:id="R76614dc18c3e4559"/>
+    <p:sldId xmlns:r="http://schemas.openxmlformats.org/officeDocument/2006/relationships" id="259" r:id="Rb0c2a5df9a3c494d"/>
+    <p:sldId xmlns:r="http://schemas.openxmlformats.org/officeDocument/2006/relationships" id="260" r:id="Rb3762954d2c147b9"/>
+    <p:sldId xmlns:r="http://schemas.openxmlformats.org/officeDocument/2006/relationships" id="261" r:id="R959df16bb9cf487e"/>
+    <p:sldId xmlns:r="http://schemas.openxmlformats.org/officeDocument/2006/relationships" id="262" r:id="R94a0ac4c7b8d4ebe"/>
+    <p:sldId xmlns:r="http://schemas.openxmlformats.org/officeDocument/2006/relationships" id="263" r:id="Ra6d1bd88550b42da"/>
+    <p:sldId xmlns:r="http://schemas.openxmlformats.org/officeDocument/2006/relationships" id="264" r:id="R517be230455b4510"/>
+    <p:sldId xmlns:r="http://schemas.openxmlformats.org/officeDocument/2006/relationships" id="265" r:id="R03ee88061150419f"/>
+    <p:sldId xmlns:r="http://schemas.openxmlformats.org/officeDocument/2006/relationships" id="266" r:id="Rbd5ff84f603044f5"/>
+    <p:sldId xmlns:r="http://schemas.openxmlformats.org/officeDocument/2006/relationships" id="267" r:id="R0306ebe4954a47fe"/>
   </p:sldIdLst>
   <p:sldSz cx="12192000" cy="6858000"/>
   <p:notesSz cx="6858000" cy="9144000"/>
@@ -1611,7 +1611,7 @@
   </p:cSld>
   <p:clrMap bg1="lt1" tx1="dk1" bg2="lt2" tx2="dk2" accent1="accent1" accent2="accent2" accent3="accent3" accent4="accent4" accent5="accent5" accent6="accent6" hlink="hlink" folHlink="folHlink"/>
   <p:sldLayoutIdLst>
-    <p:sldLayoutId xmlns:r="http://schemas.openxmlformats.org/officeDocument/2006/relationships" id="2147483649" r:id="R6cff68ce75ce4aff"/>
+    <p:sldLayoutId xmlns:r="http://schemas.openxmlformats.org/officeDocument/2006/relationships" id="2147483649" r:id="R848157d5f5784fdb"/>
   </p:sldLayoutIdLst>
   <p:txStyles>
     <p:titleStyle>
@@ -3728,7 +3728,7 @@
           <p:cNvPr id="22" name="">
             <a:extLst xmlns:a="http://schemas.openxmlformats.org/drawingml/2006/main">
               <a:ext uri="{FF2B5EF4-FFF2-40B4-BE49-F238E27FC236}">
-                <a16:creationId xmlns:a16="http://schemas.microsoft.com/office/drawing/2014/main" id="{AF182BFE-5AE6-4F73-8D2A-716FAD732748}"/>
+                <a16:creationId xmlns:a16="http://schemas.microsoft.com/office/drawing/2014/main" id="{A409D66B-3C49-4ED1-AE54-55965340BE66}"/>
               </a:ext>
             </a:extLst>
           </p:cNvPr>
@@ -3761,7 +3761,7 @@
           <p:cNvPr id="2" name="">
             <a:extLst xmlns:a="http://schemas.openxmlformats.org/drawingml/2006/main">
               <a:ext uri="{FF2B5EF4-FFF2-40B4-BE49-F238E27FC236}">
-                <a16:creationId xmlns:a16="http://schemas.microsoft.com/office/drawing/2014/main" id="{648AD934-8C4D-498C-984E-64CABAF2FAFD}"/>
+                <a16:creationId xmlns:a16="http://schemas.microsoft.com/office/drawing/2014/main" id="{929FF649-9425-4B62-8356-ABCDC5BE1D23}"/>
               </a:ext>
             </a:extLst>
           </p:cNvPr>
@@ -3811,7 +3811,7 @@
           <p:cNvPr id="3" name="">
             <a:extLst xmlns:a="http://schemas.openxmlformats.org/drawingml/2006/main">
               <a:ext uri="{FF2B5EF4-FFF2-40B4-BE49-F238E27FC236}">
-                <a16:creationId xmlns:a16="http://schemas.microsoft.com/office/drawing/2014/main" id="{B900A18F-2B2F-4289-8418-A70354DD33DB}"/>
+                <a16:creationId xmlns:a16="http://schemas.microsoft.com/office/drawing/2014/main" id="{F6863415-52CE-475E-B6C3-632ACAAB3B57}"/>
               </a:ext>
             </a:extLst>
           </p:cNvPr>
@@ -3878,7 +3878,7 @@
           <p:cNvPr id="4" name="">
             <a:extLst xmlns:a="http://schemas.openxmlformats.org/drawingml/2006/main">
               <a:ext uri="{FF2B5EF4-FFF2-40B4-BE49-F238E27FC236}">
-                <a16:creationId xmlns:a16="http://schemas.microsoft.com/office/drawing/2014/main" id="{E39E3142-373C-4E9B-9B71-376964039ECA}"/>
+                <a16:creationId xmlns:a16="http://schemas.microsoft.com/office/drawing/2014/main" id="{3A6736A5-A590-40B3-9000-931CF0F0360C}"/>
               </a:ext>
             </a:extLst>
           </p:cNvPr>
@@ -3928,7 +3928,7 @@
           <p:cNvPr id="5" name="">
             <a:extLst xmlns:a="http://schemas.openxmlformats.org/drawingml/2006/main">
               <a:ext uri="{FF2B5EF4-FFF2-40B4-BE49-F238E27FC236}">
-                <a16:creationId xmlns:a16="http://schemas.microsoft.com/office/drawing/2014/main" id="{D6705479-9D99-43A9-9DAE-AA4EB2436EA3}"/>
+                <a16:creationId xmlns:a16="http://schemas.microsoft.com/office/drawing/2014/main" id="{491E4575-F118-48AF-9B33-3134165B3241}"/>
               </a:ext>
             </a:extLst>
           </p:cNvPr>
@@ -3961,7 +3961,7 @@
           <p:cNvPr id="6" name="">
             <a:extLst xmlns:a="http://schemas.openxmlformats.org/drawingml/2006/main">
               <a:ext uri="{FF2B5EF4-FFF2-40B4-BE49-F238E27FC236}">
-                <a16:creationId xmlns:a16="http://schemas.microsoft.com/office/drawing/2014/main" id="{5E7B95A1-B87F-45AF-BAF6-DF98DEE6990B}"/>
+                <a16:creationId xmlns:a16="http://schemas.microsoft.com/office/drawing/2014/main" id="{F995DEC6-F07A-4A19-9098-557A3CBD5E60}"/>
               </a:ext>
             </a:extLst>
           </p:cNvPr>
@@ -4011,7 +4011,7 @@
           <p:cNvPr id="7" name="">
             <a:extLst xmlns:a="http://schemas.openxmlformats.org/drawingml/2006/main">
               <a:ext uri="{FF2B5EF4-FFF2-40B4-BE49-F238E27FC236}">
-                <a16:creationId xmlns:a16="http://schemas.microsoft.com/office/drawing/2014/main" id="{1F73C0FF-778E-4950-8AE2-2EB176574DC2}"/>
+                <a16:creationId xmlns:a16="http://schemas.microsoft.com/office/drawing/2014/main" id="{2417CA74-59E2-4E18-A4EC-E50492374531}"/>
               </a:ext>
             </a:extLst>
           </p:cNvPr>
@@ -4061,7 +4061,7 @@
           <p:cNvPr id="8" name="">
             <a:extLst xmlns:a="http://schemas.openxmlformats.org/drawingml/2006/main">
               <a:ext uri="{FF2B5EF4-FFF2-40B4-BE49-F238E27FC236}">
-                <a16:creationId xmlns:a16="http://schemas.microsoft.com/office/drawing/2014/main" id="{13F6ED78-09F2-4E51-8F43-ECAA8A25D8F4}"/>
+                <a16:creationId xmlns:a16="http://schemas.microsoft.com/office/drawing/2014/main" id="{E7455EC6-278A-446E-B53C-0FDBA9761BEF}"/>
               </a:ext>
             </a:extLst>
           </p:cNvPr>
@@ -4111,7 +4111,7 @@
           <p:cNvPr id="9" name="">
             <a:extLst xmlns:a="http://schemas.openxmlformats.org/drawingml/2006/main">
               <a:ext uri="{FF2B5EF4-FFF2-40B4-BE49-F238E27FC236}">
-                <a16:creationId xmlns:a16="http://schemas.microsoft.com/office/drawing/2014/main" id="{867252F1-ADB1-4D3A-8DCA-37181C3B79FB}"/>
+                <a16:creationId xmlns:a16="http://schemas.microsoft.com/office/drawing/2014/main" id="{FE47C17A-EEC0-4498-A3B4-BCA8251CA69B}"/>
               </a:ext>
             </a:extLst>
           </p:cNvPr>
@@ -4144,7 +4144,7 @@
           <p:cNvPr id="10" name="">
             <a:extLst xmlns:a="http://schemas.openxmlformats.org/drawingml/2006/main">
               <a:ext uri="{FF2B5EF4-FFF2-40B4-BE49-F238E27FC236}">
-                <a16:creationId xmlns:a16="http://schemas.microsoft.com/office/drawing/2014/main" id="{471759C9-7385-4ABA-8159-7C5C7AF0E47C}"/>
+                <a16:creationId xmlns:a16="http://schemas.microsoft.com/office/drawing/2014/main" id="{FD7632B3-C0EA-4D08-8A81-DF7E7459BDA6}"/>
               </a:ext>
             </a:extLst>
           </p:cNvPr>
@@ -4194,7 +4194,7 @@
           <p:cNvPr id="11" name="">
             <a:extLst xmlns:a="http://schemas.openxmlformats.org/drawingml/2006/main">
               <a:ext uri="{FF2B5EF4-FFF2-40B4-BE49-F238E27FC236}">
-                <a16:creationId xmlns:a16="http://schemas.microsoft.com/office/drawing/2014/main" id="{AD174D64-887E-400C-A4F6-154E48510E5E}"/>
+                <a16:creationId xmlns:a16="http://schemas.microsoft.com/office/drawing/2014/main" id="{C14C807E-FE8B-4B55-86F5-2F957CB66278}"/>
               </a:ext>
             </a:extLst>
           </p:cNvPr>
@@ -4244,7 +4244,7 @@
           <p:cNvPr id="12" name="">
             <a:extLst xmlns:a="http://schemas.openxmlformats.org/drawingml/2006/main">
               <a:ext uri="{FF2B5EF4-FFF2-40B4-BE49-F238E27FC236}">
-                <a16:creationId xmlns:a16="http://schemas.microsoft.com/office/drawing/2014/main" id="{371031D5-5694-4576-8BE0-9293340C973B}"/>
+                <a16:creationId xmlns:a16="http://schemas.microsoft.com/office/drawing/2014/main" id="{77FFBDF2-8D5D-4C16-83C6-64469ECA7F61}"/>
               </a:ext>
             </a:extLst>
           </p:cNvPr>
@@ -4294,7 +4294,7 @@
           <p:cNvPr id="13" name="">
             <a:extLst xmlns:a="http://schemas.openxmlformats.org/drawingml/2006/main">
               <a:ext uri="{FF2B5EF4-FFF2-40B4-BE49-F238E27FC236}">
-                <a16:creationId xmlns:a16="http://schemas.microsoft.com/office/drawing/2014/main" id="{B5E85679-950D-457C-AFC1-1639CE69319B}"/>
+                <a16:creationId xmlns:a16="http://schemas.microsoft.com/office/drawing/2014/main" id="{A209919A-CAA3-415C-9935-8ED044892613}"/>
               </a:ext>
             </a:extLst>
           </p:cNvPr>
@@ -4327,7 +4327,7 @@
           <p:cNvPr id="14" name="">
             <a:extLst xmlns:a="http://schemas.openxmlformats.org/drawingml/2006/main">
               <a:ext uri="{FF2B5EF4-FFF2-40B4-BE49-F238E27FC236}">
-                <a16:creationId xmlns:a16="http://schemas.microsoft.com/office/drawing/2014/main" id="{F849B39A-DAD0-484B-8268-5EC1D2797E9F}"/>
+                <a16:creationId xmlns:a16="http://schemas.microsoft.com/office/drawing/2014/main" id="{E541DFCB-FDDB-4CA7-A947-52023CA0D803}"/>
               </a:ext>
             </a:extLst>
           </p:cNvPr>
@@ -4377,7 +4377,7 @@
           <p:cNvPr id="15" name="">
             <a:extLst xmlns:a="http://schemas.openxmlformats.org/drawingml/2006/main">
               <a:ext uri="{FF2B5EF4-FFF2-40B4-BE49-F238E27FC236}">
-                <a16:creationId xmlns:a16="http://schemas.microsoft.com/office/drawing/2014/main" id="{07BD41F6-2CA2-4412-8712-93BDED35FA1B}"/>
+                <a16:creationId xmlns:a16="http://schemas.microsoft.com/office/drawing/2014/main" id="{987B3F89-F2CB-4633-98EF-AA549E57F363}"/>
               </a:ext>
             </a:extLst>
           </p:cNvPr>
@@ -4427,7 +4427,7 @@
           <p:cNvPr id="16" name="">
             <a:extLst xmlns:a="http://schemas.openxmlformats.org/drawingml/2006/main">
               <a:ext uri="{FF2B5EF4-FFF2-40B4-BE49-F238E27FC236}">
-                <a16:creationId xmlns:a16="http://schemas.microsoft.com/office/drawing/2014/main" id="{C57DC006-86DF-48CE-9291-671707C9601D}"/>
+                <a16:creationId xmlns:a16="http://schemas.microsoft.com/office/drawing/2014/main" id="{DFEA882B-4EC8-4938-A490-1B47A5189605}"/>
               </a:ext>
             </a:extLst>
           </p:cNvPr>
@@ -4477,7 +4477,7 @@
           <p:cNvPr id="17" name="">
             <a:extLst xmlns:a="http://schemas.openxmlformats.org/drawingml/2006/main">
               <a:ext uri="{FF2B5EF4-FFF2-40B4-BE49-F238E27FC236}">
-                <a16:creationId xmlns:a16="http://schemas.microsoft.com/office/drawing/2014/main" id="{57AA17D0-E277-46E3-B14C-DA75355C21BC}"/>
+                <a16:creationId xmlns:a16="http://schemas.microsoft.com/office/drawing/2014/main" id="{3B70AE38-EC16-4866-888B-86E2B7DC0932}"/>
               </a:ext>
             </a:extLst>
           </p:cNvPr>
@@ -4510,7 +4510,7 @@
           <p:cNvPr id="18" name="">
             <a:extLst xmlns:a="http://schemas.openxmlformats.org/drawingml/2006/main">
               <a:ext uri="{FF2B5EF4-FFF2-40B4-BE49-F238E27FC236}">
-                <a16:creationId xmlns:a16="http://schemas.microsoft.com/office/drawing/2014/main" id="{76EDC51F-1AAD-4EDC-B551-5BB11F981A6D}"/>
+                <a16:creationId xmlns:a16="http://schemas.microsoft.com/office/drawing/2014/main" id="{04B2FE99-C5C3-4354-8ECE-E4877E66E41E}"/>
               </a:ext>
             </a:extLst>
           </p:cNvPr>
@@ -4560,7 +4560,7 @@
           <p:cNvPr id="19" name="">
             <a:extLst xmlns:a="http://schemas.openxmlformats.org/drawingml/2006/main">
               <a:ext uri="{FF2B5EF4-FFF2-40B4-BE49-F238E27FC236}">
-                <a16:creationId xmlns:a16="http://schemas.microsoft.com/office/drawing/2014/main" id="{F0076C60-E685-4CF1-AB51-DA583FFF3DF1}"/>
+                <a16:creationId xmlns:a16="http://schemas.microsoft.com/office/drawing/2014/main" id="{3F925CFB-A034-42BC-9AE8-2EDBECDC8B19}"/>
               </a:ext>
             </a:extLst>
           </p:cNvPr>
@@ -4600,7 +4600,7 @@
                   <a:srgbClr val="172033"/>
                 </a:solidFill>
               </a:rPr>
-              <a:t>Target accounts unreached</a:t>
+              <a:t>CRM domains unreached</a:t>
             </a:r>
           </a:p>
         </p:txBody>
@@ -4610,7 +4610,7 @@
           <p:cNvPr id="20" name="">
             <a:extLst xmlns:a="http://schemas.openxmlformats.org/drawingml/2006/main">
               <a:ext uri="{FF2B5EF4-FFF2-40B4-BE49-F238E27FC236}">
-                <a16:creationId xmlns:a16="http://schemas.microsoft.com/office/drawing/2014/main" id="{0ED94726-4BC7-472C-A56F-E37B3C755014}"/>
+                <a16:creationId xmlns:a16="http://schemas.microsoft.com/office/drawing/2014/main" id="{78EB8C3C-DBB0-4162-9D5C-E210920B0017}"/>
               </a:ext>
             </a:extLst>
           </p:cNvPr>
@@ -4660,7 +4660,7 @@
           <p:cNvPr id="21" name="">
             <a:extLst xmlns:a="http://schemas.openxmlformats.org/drawingml/2006/main">
               <a:ext uri="{FF2B5EF4-FFF2-40B4-BE49-F238E27FC236}">
-                <a16:creationId xmlns:a16="http://schemas.microsoft.com/office/drawing/2014/main" id="{613D4562-AC1F-40F6-98B9-BC9EDC86AE2B}"/>
+                <a16:creationId xmlns:a16="http://schemas.microsoft.com/office/drawing/2014/main" id="{4BC644A2-7137-4934-B8A6-CB1FABA3A011}"/>
               </a:ext>
             </a:extLst>
           </p:cNvPr>
@@ -4708,7 +4708,7 @@
     </p:spTree>
     <p:extLst>
       <p:ext uri="{BB962C8B-B14F-4D97-AF65-F5344CB8AC3E}">
-        <p14:creationId xmlns:p14="http://schemas.microsoft.com/office/powerpoint/2010/main" val="1113265550"/>
+        <p14:creationId xmlns:p14="http://schemas.microsoft.com/office/powerpoint/2010/main" val="872923780"/>
       </p:ext>
     </p:extLst>
   </p:cSld>
@@ -4739,7 +4739,7 @@
           <p:cNvPr id="32" name="">
             <a:extLst xmlns:a="http://schemas.openxmlformats.org/drawingml/2006/main">
               <a:ext uri="{FF2B5EF4-FFF2-40B4-BE49-F238E27FC236}">
-                <a16:creationId xmlns:a16="http://schemas.microsoft.com/office/drawing/2014/main" id="{6A6EFCB7-1BFE-4714-A637-DEA8870960DF}"/>
+                <a16:creationId xmlns:a16="http://schemas.microsoft.com/office/drawing/2014/main" id="{023AE36F-5E00-4391-B70C-CBE3D6E51372}"/>
               </a:ext>
             </a:extLst>
           </p:cNvPr>
@@ -4789,7 +4789,7 @@
           <p:cNvPr id="2" name="">
             <a:extLst xmlns:a="http://schemas.openxmlformats.org/drawingml/2006/main">
               <a:ext uri="{FF2B5EF4-FFF2-40B4-BE49-F238E27FC236}">
-                <a16:creationId xmlns:a16="http://schemas.microsoft.com/office/drawing/2014/main" id="{C6278B43-E92A-419F-8CD3-6AF3B57EA393}"/>
+                <a16:creationId xmlns:a16="http://schemas.microsoft.com/office/drawing/2014/main" id="{3B4724BD-300D-47AF-BEE3-5E73FCC31BBB}"/>
               </a:ext>
             </a:extLst>
           </p:cNvPr>
@@ -4839,7 +4839,7 @@
           <p:cNvPr id="3" name="">
             <a:extLst xmlns:a="http://schemas.openxmlformats.org/drawingml/2006/main">
               <a:ext uri="{FF2B5EF4-FFF2-40B4-BE49-F238E27FC236}">
-                <a16:creationId xmlns:a16="http://schemas.microsoft.com/office/drawing/2014/main" id="{FC6EC4C0-3ED8-4191-A3BF-851D6793F901}"/>
+                <a16:creationId xmlns:a16="http://schemas.microsoft.com/office/drawing/2014/main" id="{672D3756-BB3D-4A5C-8BCB-F1F2BA518E02}"/>
               </a:ext>
             </a:extLst>
           </p:cNvPr>
@@ -4889,7 +4889,7 @@
           <p:cNvPr id="4" name="">
             <a:extLst xmlns:a="http://schemas.openxmlformats.org/drawingml/2006/main">
               <a:ext uri="{FF2B5EF4-FFF2-40B4-BE49-F238E27FC236}">
-                <a16:creationId xmlns:a16="http://schemas.microsoft.com/office/drawing/2014/main" id="{2B6863C9-B03F-4A9F-B06D-C3D6893D60E6}"/>
+                <a16:creationId xmlns:a16="http://schemas.microsoft.com/office/drawing/2014/main" id="{B5B3D058-4816-4B6B-B386-D725296D3CA6}"/>
               </a:ext>
             </a:extLst>
           </p:cNvPr>
@@ -4920,7 +4920,7 @@
           <p:cNvPr id="5" name="">
             <a:extLst xmlns:a="http://schemas.openxmlformats.org/drawingml/2006/main">
               <a:ext uri="{FF2B5EF4-FFF2-40B4-BE49-F238E27FC236}">
-                <a16:creationId xmlns:a16="http://schemas.microsoft.com/office/drawing/2014/main" id="{858C04AA-882A-42A3-A677-7CF5127D0318}"/>
+                <a16:creationId xmlns:a16="http://schemas.microsoft.com/office/drawing/2014/main" id="{A56AFDF1-F145-49F2-ACC2-2C91D87FD898}"/>
               </a:ext>
             </a:extLst>
           </p:cNvPr>
@@ -4953,7 +4953,7 @@
           <p:cNvPr id="6" name="">
             <a:extLst xmlns:a="http://schemas.openxmlformats.org/drawingml/2006/main">
               <a:ext uri="{FF2B5EF4-FFF2-40B4-BE49-F238E27FC236}">
-                <a16:creationId xmlns:a16="http://schemas.microsoft.com/office/drawing/2014/main" id="{96B11115-2DA0-42EF-8CE7-740D613E4703}"/>
+                <a16:creationId xmlns:a16="http://schemas.microsoft.com/office/drawing/2014/main" id="{A8C6FAE6-EF78-4056-BBC0-C8DD35797968}"/>
               </a:ext>
             </a:extLst>
           </p:cNvPr>
@@ -5003,7 +5003,7 @@
           <p:cNvPr id="7" name="">
             <a:extLst xmlns:a="http://schemas.openxmlformats.org/drawingml/2006/main">
               <a:ext uri="{FF2B5EF4-FFF2-40B4-BE49-F238E27FC236}">
-                <a16:creationId xmlns:a16="http://schemas.microsoft.com/office/drawing/2014/main" id="{403FD658-A874-4D93-920A-B3A26A3DFDDE}"/>
+                <a16:creationId xmlns:a16="http://schemas.microsoft.com/office/drawing/2014/main" id="{E0CC4F3C-39B7-4C18-86E3-436134C18061}"/>
               </a:ext>
             </a:extLst>
           </p:cNvPr>
@@ -5053,7 +5053,7 @@
           <p:cNvPr id="8" name="">
             <a:extLst xmlns:a="http://schemas.openxmlformats.org/drawingml/2006/main">
               <a:ext uri="{FF2B5EF4-FFF2-40B4-BE49-F238E27FC236}">
-                <a16:creationId xmlns:a16="http://schemas.microsoft.com/office/drawing/2014/main" id="{E8661C59-E7BB-4637-8F1C-46717FC9E17C}"/>
+                <a16:creationId xmlns:a16="http://schemas.microsoft.com/office/drawing/2014/main" id="{D0A9BAEC-AE2E-40B5-980B-840C983388FF}"/>
               </a:ext>
             </a:extLst>
           </p:cNvPr>
@@ -5103,7 +5103,7 @@
           <p:cNvPr id="9" name="">
             <a:extLst xmlns:a="http://schemas.openxmlformats.org/drawingml/2006/main">
               <a:ext uri="{FF2B5EF4-FFF2-40B4-BE49-F238E27FC236}">
-                <a16:creationId xmlns:a16="http://schemas.microsoft.com/office/drawing/2014/main" id="{C577AE0A-95A8-47FB-95CA-D9AE5135C544}"/>
+                <a16:creationId xmlns:a16="http://schemas.microsoft.com/office/drawing/2014/main" id="{08222560-D56E-405E-8175-FAA5128BBB15}"/>
               </a:ext>
             </a:extLst>
           </p:cNvPr>
@@ -5136,7 +5136,7 @@
           <p:cNvPr id="10" name="">
             <a:extLst xmlns:a="http://schemas.openxmlformats.org/drawingml/2006/main">
               <a:ext uri="{FF2B5EF4-FFF2-40B4-BE49-F238E27FC236}">
-                <a16:creationId xmlns:a16="http://schemas.microsoft.com/office/drawing/2014/main" id="{005DF786-DD5C-4961-B398-CF29307A51A7}"/>
+                <a16:creationId xmlns:a16="http://schemas.microsoft.com/office/drawing/2014/main" id="{710E6720-10A1-4BE0-9CD2-AC979EDAC2A6}"/>
               </a:ext>
             </a:extLst>
           </p:cNvPr>
@@ -5186,7 +5186,7 @@
           <p:cNvPr id="11" name="">
             <a:extLst xmlns:a="http://schemas.openxmlformats.org/drawingml/2006/main">
               <a:ext uri="{FF2B5EF4-FFF2-40B4-BE49-F238E27FC236}">
-                <a16:creationId xmlns:a16="http://schemas.microsoft.com/office/drawing/2014/main" id="{01A9AF5E-02E6-4F7D-A208-F834EEBA83F3}"/>
+                <a16:creationId xmlns:a16="http://schemas.microsoft.com/office/drawing/2014/main" id="{2FC94C0E-4F36-4FE5-8A32-17CC8A5A292D}"/>
               </a:ext>
             </a:extLst>
           </p:cNvPr>
@@ -5236,7 +5236,7 @@
           <p:cNvPr id="12" name="">
             <a:extLst xmlns:a="http://schemas.openxmlformats.org/drawingml/2006/main">
               <a:ext uri="{FF2B5EF4-FFF2-40B4-BE49-F238E27FC236}">
-                <a16:creationId xmlns:a16="http://schemas.microsoft.com/office/drawing/2014/main" id="{4201AF93-B1D6-4A39-A40F-3AC15AF17219}"/>
+                <a16:creationId xmlns:a16="http://schemas.microsoft.com/office/drawing/2014/main" id="{42E3D341-ADC8-4FED-BFD5-E97A32248B5D}"/>
               </a:ext>
             </a:extLst>
           </p:cNvPr>
@@ -5286,7 +5286,7 @@
           <p:cNvPr id="13" name="">
             <a:extLst xmlns:a="http://schemas.openxmlformats.org/drawingml/2006/main">
               <a:ext uri="{FF2B5EF4-FFF2-40B4-BE49-F238E27FC236}">
-                <a16:creationId xmlns:a16="http://schemas.microsoft.com/office/drawing/2014/main" id="{779D5B2B-0A36-416A-BAEF-D462FF5BCC21}"/>
+                <a16:creationId xmlns:a16="http://schemas.microsoft.com/office/drawing/2014/main" id="{647E922C-19C8-42E4-80CE-1B276933E663}"/>
               </a:ext>
             </a:extLst>
           </p:cNvPr>
@@ -5319,7 +5319,7 @@
           <p:cNvPr id="14" name="">
             <a:extLst xmlns:a="http://schemas.openxmlformats.org/drawingml/2006/main">
               <a:ext uri="{FF2B5EF4-FFF2-40B4-BE49-F238E27FC236}">
-                <a16:creationId xmlns:a16="http://schemas.microsoft.com/office/drawing/2014/main" id="{C6DDA7BF-7CFE-42DD-9939-E72540B530EA}"/>
+                <a16:creationId xmlns:a16="http://schemas.microsoft.com/office/drawing/2014/main" id="{264E3DE4-0F0A-4EA3-9975-8AA65C0732CD}"/>
               </a:ext>
             </a:extLst>
           </p:cNvPr>
@@ -5369,7 +5369,7 @@
           <p:cNvPr id="15" name="">
             <a:extLst xmlns:a="http://schemas.openxmlformats.org/drawingml/2006/main">
               <a:ext uri="{FF2B5EF4-FFF2-40B4-BE49-F238E27FC236}">
-                <a16:creationId xmlns:a16="http://schemas.microsoft.com/office/drawing/2014/main" id="{3420343E-A3B1-4E7A-90DD-34150F4B8C95}"/>
+                <a16:creationId xmlns:a16="http://schemas.microsoft.com/office/drawing/2014/main" id="{13DF6C13-8E30-4ACD-A14D-E3A696851E70}"/>
               </a:ext>
             </a:extLst>
           </p:cNvPr>
@@ -5419,7 +5419,7 @@
           <p:cNvPr id="16" name="">
             <a:extLst xmlns:a="http://schemas.openxmlformats.org/drawingml/2006/main">
               <a:ext uri="{FF2B5EF4-FFF2-40B4-BE49-F238E27FC236}">
-                <a16:creationId xmlns:a16="http://schemas.microsoft.com/office/drawing/2014/main" id="{47496AE6-5EE8-4CC3-B0E9-2D64EF10005F}"/>
+                <a16:creationId xmlns:a16="http://schemas.microsoft.com/office/drawing/2014/main" id="{AEA65FC2-B331-4E29-9B5D-956DE4354F19}"/>
               </a:ext>
             </a:extLst>
           </p:cNvPr>
@@ -5469,7 +5469,7 @@
           <p:cNvPr id="17" name="">
             <a:extLst xmlns:a="http://schemas.openxmlformats.org/drawingml/2006/main">
               <a:ext uri="{FF2B5EF4-FFF2-40B4-BE49-F238E27FC236}">
-                <a16:creationId xmlns:a16="http://schemas.microsoft.com/office/drawing/2014/main" id="{67F9D97C-100C-4E4B-880D-19C7BDFE484A}"/>
+                <a16:creationId xmlns:a16="http://schemas.microsoft.com/office/drawing/2014/main" id="{A015103D-0BC1-47CF-98C4-296A929757F9}"/>
               </a:ext>
             </a:extLst>
           </p:cNvPr>
@@ -5502,7 +5502,7 @@
           <p:cNvPr id="18" name="">
             <a:extLst xmlns:a="http://schemas.openxmlformats.org/drawingml/2006/main">
               <a:ext uri="{FF2B5EF4-FFF2-40B4-BE49-F238E27FC236}">
-                <a16:creationId xmlns:a16="http://schemas.microsoft.com/office/drawing/2014/main" id="{ED2112FA-5B0C-47FF-88E5-CA9232AF91B9}"/>
+                <a16:creationId xmlns:a16="http://schemas.microsoft.com/office/drawing/2014/main" id="{137E7216-CC20-4823-B744-8E5629CA62BE}"/>
               </a:ext>
             </a:extLst>
           </p:cNvPr>
@@ -5552,7 +5552,7 @@
           <p:cNvPr id="19" name="">
             <a:extLst xmlns:a="http://schemas.openxmlformats.org/drawingml/2006/main">
               <a:ext uri="{FF2B5EF4-FFF2-40B4-BE49-F238E27FC236}">
-                <a16:creationId xmlns:a16="http://schemas.microsoft.com/office/drawing/2014/main" id="{C9C80767-DF5D-4B3B-B4DD-D590EDEBAE72}"/>
+                <a16:creationId xmlns:a16="http://schemas.microsoft.com/office/drawing/2014/main" id="{73710DB2-9A9F-4F45-82DC-FD3CCC926E4B}"/>
               </a:ext>
             </a:extLst>
           </p:cNvPr>
@@ -5602,7 +5602,7 @@
           <p:cNvPr id="20" name="">
             <a:extLst xmlns:a="http://schemas.openxmlformats.org/drawingml/2006/main">
               <a:ext uri="{FF2B5EF4-FFF2-40B4-BE49-F238E27FC236}">
-                <a16:creationId xmlns:a16="http://schemas.microsoft.com/office/drawing/2014/main" id="{CBCB7215-3C68-46FE-858B-857D773F6DF2}"/>
+                <a16:creationId xmlns:a16="http://schemas.microsoft.com/office/drawing/2014/main" id="{075B4C09-BB38-4C22-90FB-830BDC5FDB3A}"/>
               </a:ext>
             </a:extLst>
           </p:cNvPr>
@@ -5652,7 +5652,7 @@
           <p:cNvPr id="21" name="">
             <a:extLst xmlns:a="http://schemas.openxmlformats.org/drawingml/2006/main">
               <a:ext uri="{FF2B5EF4-FFF2-40B4-BE49-F238E27FC236}">
-                <a16:creationId xmlns:a16="http://schemas.microsoft.com/office/drawing/2014/main" id="{94F617CD-8F7D-4085-A72B-924F9F67BE58}"/>
+                <a16:creationId xmlns:a16="http://schemas.microsoft.com/office/drawing/2014/main" id="{A9E171AF-3F9F-4495-87C3-D7C85103B67F}"/>
               </a:ext>
             </a:extLst>
           </p:cNvPr>
@@ -5687,7 +5687,7 @@
           <p:cNvPr id="22" name="">
             <a:extLst xmlns:a="http://schemas.openxmlformats.org/drawingml/2006/main">
               <a:ext uri="{FF2B5EF4-FFF2-40B4-BE49-F238E27FC236}">
-                <a16:creationId xmlns:a16="http://schemas.microsoft.com/office/drawing/2014/main" id="{BDDB647C-1A4F-41CC-99D6-1405ABF855CE}"/>
+                <a16:creationId xmlns:a16="http://schemas.microsoft.com/office/drawing/2014/main" id="{781B9D1F-B86D-4F2A-AEFB-93CE4533CE36}"/>
               </a:ext>
             </a:extLst>
           </p:cNvPr>
@@ -5737,7 +5737,7 @@
           <p:cNvPr id="23" name="">
             <a:extLst xmlns:a="http://schemas.openxmlformats.org/drawingml/2006/main">
               <a:ext uri="{FF2B5EF4-FFF2-40B4-BE49-F238E27FC236}">
-                <a16:creationId xmlns:a16="http://schemas.microsoft.com/office/drawing/2014/main" id="{89E7163C-15C4-41B5-97D8-E04B83418D0D}"/>
+                <a16:creationId xmlns:a16="http://schemas.microsoft.com/office/drawing/2014/main" id="{BCC31859-44B9-481C-84A5-4D19DCCBA5CE}"/>
               </a:ext>
             </a:extLst>
           </p:cNvPr>
@@ -5794,7 +5794,7 @@
         </p:xfrm>
         <a:graphic xmlns:a="http://schemas.openxmlformats.org/drawingml/2006/main">
           <a:graphicData uri="http://schemas.openxmlformats.org/drawingml/2006/chart">
-            <c:chart xmlns:r="http://schemas.openxmlformats.org/officeDocument/2006/relationships" xmlns:c="http://schemas.openxmlformats.org/drawingml/2006/chart" r:id="Rc3f659c50e7b4ff9"/>
+            <c:chart xmlns:r="http://schemas.openxmlformats.org/officeDocument/2006/relationships" xmlns:c="http://schemas.openxmlformats.org/drawingml/2006/chart" r:id="Re43ae3e1b9034721"/>
           </a:graphicData>
         </a:graphic>
       </p:graphicFrame>
@@ -5803,7 +5803,7 @@
           <p:cNvPr id="25" name="">
             <a:extLst xmlns:a="http://schemas.openxmlformats.org/drawingml/2006/main">
               <a:ext uri="{FF2B5EF4-FFF2-40B4-BE49-F238E27FC236}">
-                <a16:creationId xmlns:a16="http://schemas.microsoft.com/office/drawing/2014/main" id="{923891C4-DF00-40DD-B127-0E007ABADCE3}"/>
+                <a16:creationId xmlns:a16="http://schemas.microsoft.com/office/drawing/2014/main" id="{00982B7C-5210-4764-AC5D-4DD1D44948F9}"/>
               </a:ext>
             </a:extLst>
           </p:cNvPr>
@@ -5838,7 +5838,7 @@
           <p:cNvPr id="26" name="">
             <a:extLst xmlns:a="http://schemas.openxmlformats.org/drawingml/2006/main">
               <a:ext uri="{FF2B5EF4-FFF2-40B4-BE49-F238E27FC236}">
-                <a16:creationId xmlns:a16="http://schemas.microsoft.com/office/drawing/2014/main" id="{D8DB33B4-0E31-4BE9-B8FF-1EABDB2E986E}"/>
+                <a16:creationId xmlns:a16="http://schemas.microsoft.com/office/drawing/2014/main" id="{01241FBC-CE33-4433-8B48-01BE10223CAA}"/>
               </a:ext>
             </a:extLst>
           </p:cNvPr>
@@ -5871,7 +5871,7 @@
           <p:cNvPr id="27" name="">
             <a:extLst xmlns:a="http://schemas.openxmlformats.org/drawingml/2006/main">
               <a:ext uri="{FF2B5EF4-FFF2-40B4-BE49-F238E27FC236}">
-                <a16:creationId xmlns:a16="http://schemas.microsoft.com/office/drawing/2014/main" id="{2CD71A53-B1F2-4D90-80F7-68F33A07354E}"/>
+                <a16:creationId xmlns:a16="http://schemas.microsoft.com/office/drawing/2014/main" id="{1A1447AB-EE56-40FD-856F-304901A5B611}"/>
               </a:ext>
             </a:extLst>
           </p:cNvPr>
@@ -5921,7 +5921,7 @@
           <p:cNvPr id="28" name="">
             <a:extLst xmlns:a="http://schemas.openxmlformats.org/drawingml/2006/main">
               <a:ext uri="{FF2B5EF4-FFF2-40B4-BE49-F238E27FC236}">
-                <a16:creationId xmlns:a16="http://schemas.microsoft.com/office/drawing/2014/main" id="{041AE4BF-0556-4006-B20D-E3E84B99B990}"/>
+                <a16:creationId xmlns:a16="http://schemas.microsoft.com/office/drawing/2014/main" id="{F135B6C3-A26B-46BE-8F99-A331A04B5C03}"/>
               </a:ext>
             </a:extLst>
           </p:cNvPr>
@@ -5971,7 +5971,7 @@
           <p:cNvPr id="29" name="">
             <a:extLst xmlns:a="http://schemas.openxmlformats.org/drawingml/2006/main">
               <a:ext uri="{FF2B5EF4-FFF2-40B4-BE49-F238E27FC236}">
-                <a16:creationId xmlns:a16="http://schemas.microsoft.com/office/drawing/2014/main" id="{8B7C59D1-3378-45B5-B96D-6F7F874B44EA}"/>
+                <a16:creationId xmlns:a16="http://schemas.microsoft.com/office/drawing/2014/main" id="{477C60DD-7036-4FC3-B738-9E623B0425F8}"/>
               </a:ext>
             </a:extLst>
           </p:cNvPr>
@@ -6002,7 +6002,7 @@
           <p:cNvPr id="30" name="">
             <a:extLst xmlns:a="http://schemas.openxmlformats.org/drawingml/2006/main">
               <a:ext uri="{FF2B5EF4-FFF2-40B4-BE49-F238E27FC236}">
-                <a16:creationId xmlns:a16="http://schemas.microsoft.com/office/drawing/2014/main" id="{2EF31638-50AE-4493-8C14-665E97470576}"/>
+                <a16:creationId xmlns:a16="http://schemas.microsoft.com/office/drawing/2014/main" id="{BA93A5A4-83BE-4947-9786-2A741E8A6569}"/>
               </a:ext>
             </a:extLst>
           </p:cNvPr>
@@ -6052,7 +6052,7 @@
           <p:cNvPr id="31" name="">
             <a:extLst xmlns:a="http://schemas.openxmlformats.org/drawingml/2006/main">
               <a:ext uri="{FF2B5EF4-FFF2-40B4-BE49-F238E27FC236}">
-                <a16:creationId xmlns:a16="http://schemas.microsoft.com/office/drawing/2014/main" id="{975FF544-47BE-43DE-A0B5-EB59F6676248}"/>
+                <a16:creationId xmlns:a16="http://schemas.microsoft.com/office/drawing/2014/main" id="{5393EBFB-FDB2-40FD-B09D-A44B8FCF6B32}"/>
               </a:ext>
             </a:extLst>
           </p:cNvPr>
@@ -6100,7 +6100,7 @@
     </p:spTree>
     <p:extLst>
       <p:ext uri="{BB962C8B-B14F-4D97-AF65-F5344CB8AC3E}">
-        <p14:creationId xmlns:p14="http://schemas.microsoft.com/office/powerpoint/2010/main" val="1479082210"/>
+        <p14:creationId xmlns:p14="http://schemas.microsoft.com/office/powerpoint/2010/main" val="596428651"/>
       </p:ext>
     </p:extLst>
   </p:cSld>
@@ -6131,7 +6131,7 @@
           <p:cNvPr id="20" name="">
             <a:extLst xmlns:a="http://schemas.openxmlformats.org/drawingml/2006/main">
               <a:ext uri="{FF2B5EF4-FFF2-40B4-BE49-F238E27FC236}">
-                <a16:creationId xmlns:a16="http://schemas.microsoft.com/office/drawing/2014/main" id="{FA34F510-A0DA-43FA-A57C-F4F012DE50B1}"/>
+                <a16:creationId xmlns:a16="http://schemas.microsoft.com/office/drawing/2014/main" id="{C7855D5C-158F-440D-B24F-B097D1AA3D9D}"/>
               </a:ext>
             </a:extLst>
           </p:cNvPr>
@@ -6181,7 +6181,7 @@
           <p:cNvPr id="2" name="">
             <a:extLst xmlns:a="http://schemas.openxmlformats.org/drawingml/2006/main">
               <a:ext uri="{FF2B5EF4-FFF2-40B4-BE49-F238E27FC236}">
-                <a16:creationId xmlns:a16="http://schemas.microsoft.com/office/drawing/2014/main" id="{D1A71848-63D3-4D88-86AF-E00FFC2EE3D8}"/>
+                <a16:creationId xmlns:a16="http://schemas.microsoft.com/office/drawing/2014/main" id="{E389A1A7-A222-4F02-BF69-7B191FC44CCA}"/>
               </a:ext>
             </a:extLst>
           </p:cNvPr>
@@ -6231,7 +6231,7 @@
           <p:cNvPr id="3" name="">
             <a:extLst xmlns:a="http://schemas.openxmlformats.org/drawingml/2006/main">
               <a:ext uri="{FF2B5EF4-FFF2-40B4-BE49-F238E27FC236}">
-                <a16:creationId xmlns:a16="http://schemas.microsoft.com/office/drawing/2014/main" id="{D6F4FB21-6F0B-4EEC-9F5E-2002CED583E0}"/>
+                <a16:creationId xmlns:a16="http://schemas.microsoft.com/office/drawing/2014/main" id="{1BEA4A98-17F1-40A2-84CA-C7F9B3C276FE}"/>
               </a:ext>
             </a:extLst>
           </p:cNvPr>
@@ -6281,7 +6281,7 @@
           <p:cNvPr id="4" name="">
             <a:extLst xmlns:a="http://schemas.openxmlformats.org/drawingml/2006/main">
               <a:ext uri="{FF2B5EF4-FFF2-40B4-BE49-F238E27FC236}">
-                <a16:creationId xmlns:a16="http://schemas.microsoft.com/office/drawing/2014/main" id="{012B39E0-B45F-405B-AC50-4885E25D5A05}"/>
+                <a16:creationId xmlns:a16="http://schemas.microsoft.com/office/drawing/2014/main" id="{F82D6CB0-5F90-4F5B-978A-09E7D188D585}"/>
               </a:ext>
             </a:extLst>
           </p:cNvPr>
@@ -6312,7 +6312,7 @@
           <p:cNvPr id="5" name="">
             <a:extLst xmlns:a="http://schemas.openxmlformats.org/drawingml/2006/main">
               <a:ext uri="{FF2B5EF4-FFF2-40B4-BE49-F238E27FC236}">
-                <a16:creationId xmlns:a16="http://schemas.microsoft.com/office/drawing/2014/main" id="{F2E46CA4-9DA5-4B16-9D70-0DA66A9E7E7F}"/>
+                <a16:creationId xmlns:a16="http://schemas.microsoft.com/office/drawing/2014/main" id="{4A755377-89CF-427F-9757-50AE1AF640EA}"/>
               </a:ext>
             </a:extLst>
           </p:cNvPr>
@@ -6347,7 +6347,7 @@
           <p:cNvPr id="6" name="">
             <a:extLst xmlns:a="http://schemas.openxmlformats.org/drawingml/2006/main">
               <a:ext uri="{FF2B5EF4-FFF2-40B4-BE49-F238E27FC236}">
-                <a16:creationId xmlns:a16="http://schemas.microsoft.com/office/drawing/2014/main" id="{51F29F26-DB23-4AD9-8F08-D4453474AA01}"/>
+                <a16:creationId xmlns:a16="http://schemas.microsoft.com/office/drawing/2014/main" id="{C3A9E04F-A2DA-4E36-92A6-7CA214CDB251}"/>
               </a:ext>
             </a:extLst>
           </p:cNvPr>
@@ -6397,7 +6397,7 @@
           <p:cNvPr id="7" name="">
             <a:extLst xmlns:a="http://schemas.openxmlformats.org/drawingml/2006/main">
               <a:ext uri="{FF2B5EF4-FFF2-40B4-BE49-F238E27FC236}">
-                <a16:creationId xmlns:a16="http://schemas.microsoft.com/office/drawing/2014/main" id="{DD4DCEAB-AA87-4035-9A63-71BD2FF05511}"/>
+                <a16:creationId xmlns:a16="http://schemas.microsoft.com/office/drawing/2014/main" id="{54D139AE-DFFA-4F1B-9A36-F9DE5FBC3D8D}"/>
               </a:ext>
             </a:extLst>
           </p:cNvPr>
@@ -6454,7 +6454,7 @@
         </p:xfrm>
         <a:graphic xmlns:a="http://schemas.openxmlformats.org/drawingml/2006/main">
           <a:graphicData uri="http://schemas.openxmlformats.org/drawingml/2006/chart">
-            <c:chart xmlns:r="http://schemas.openxmlformats.org/officeDocument/2006/relationships" xmlns:c="http://schemas.openxmlformats.org/drawingml/2006/chart" r:id="R9beaa9301ac249f9"/>
+            <c:chart xmlns:r="http://schemas.openxmlformats.org/officeDocument/2006/relationships" xmlns:c="http://schemas.openxmlformats.org/drawingml/2006/chart" r:id="Rafa031b6c1534044"/>
           </a:graphicData>
         </a:graphic>
       </p:graphicFrame>
@@ -6463,7 +6463,7 @@
           <p:cNvPr id="9" name="">
             <a:extLst xmlns:a="http://schemas.openxmlformats.org/drawingml/2006/main">
               <a:ext uri="{FF2B5EF4-FFF2-40B4-BE49-F238E27FC236}">
-                <a16:creationId xmlns:a16="http://schemas.microsoft.com/office/drawing/2014/main" id="{52968322-62E1-4B8D-930C-1115CCEEB78F}"/>
+                <a16:creationId xmlns:a16="http://schemas.microsoft.com/office/drawing/2014/main" id="{2193F224-68AB-4108-AFC4-3F851357E947}"/>
               </a:ext>
             </a:extLst>
           </p:cNvPr>
@@ -6498,7 +6498,7 @@
           <p:cNvPr id="10" name="">
             <a:extLst xmlns:a="http://schemas.openxmlformats.org/drawingml/2006/main">
               <a:ext uri="{FF2B5EF4-FFF2-40B4-BE49-F238E27FC236}">
-                <a16:creationId xmlns:a16="http://schemas.microsoft.com/office/drawing/2014/main" id="{0F1818FA-D7D1-47D2-AC48-466A93EEBD5A}"/>
+                <a16:creationId xmlns:a16="http://schemas.microsoft.com/office/drawing/2014/main" id="{0CA320BD-1C01-4E57-81DA-C79F11001CF7}"/>
               </a:ext>
             </a:extLst>
           </p:cNvPr>
@@ -6531,7 +6531,7 @@
           <p:cNvPr id="11" name="">
             <a:extLst xmlns:a="http://schemas.openxmlformats.org/drawingml/2006/main">
               <a:ext uri="{FF2B5EF4-FFF2-40B4-BE49-F238E27FC236}">
-                <a16:creationId xmlns:a16="http://schemas.microsoft.com/office/drawing/2014/main" id="{B7BEBFA4-9A2E-4D84-8855-A65D31D37D79}"/>
+                <a16:creationId xmlns:a16="http://schemas.microsoft.com/office/drawing/2014/main" id="{11A1C0AE-5BB3-4C40-BACD-FD983ECF63E0}"/>
               </a:ext>
             </a:extLst>
           </p:cNvPr>
@@ -6581,7 +6581,7 @@
           <p:cNvPr id="12" name="">
             <a:extLst xmlns:a="http://schemas.openxmlformats.org/drawingml/2006/main">
               <a:ext uri="{FF2B5EF4-FFF2-40B4-BE49-F238E27FC236}">
-                <a16:creationId xmlns:a16="http://schemas.microsoft.com/office/drawing/2014/main" id="{AE87028D-9C36-4225-8F30-B63E9E6E1A4E}"/>
+                <a16:creationId xmlns:a16="http://schemas.microsoft.com/office/drawing/2014/main" id="{FF3813CC-C564-41B3-A9ED-D1E68577DF43}"/>
               </a:ext>
             </a:extLst>
           </p:cNvPr>
@@ -6631,7 +6631,7 @@
           <p:cNvPr id="13" name="">
             <a:extLst xmlns:a="http://schemas.openxmlformats.org/drawingml/2006/main">
               <a:ext uri="{FF2B5EF4-FFF2-40B4-BE49-F238E27FC236}">
-                <a16:creationId xmlns:a16="http://schemas.microsoft.com/office/drawing/2014/main" id="{46D66F9F-0BCD-4EA1-B38C-D0ABBDC27130}"/>
+                <a16:creationId xmlns:a16="http://schemas.microsoft.com/office/drawing/2014/main" id="{F63EA7E7-E456-4C39-8148-586C97303B1C}"/>
               </a:ext>
             </a:extLst>
           </p:cNvPr>
@@ -6666,7 +6666,7 @@
           <p:cNvPr id="14" name="">
             <a:extLst xmlns:a="http://schemas.openxmlformats.org/drawingml/2006/main">
               <a:ext uri="{FF2B5EF4-FFF2-40B4-BE49-F238E27FC236}">
-                <a16:creationId xmlns:a16="http://schemas.microsoft.com/office/drawing/2014/main" id="{DBFC72D6-EFA8-4CA3-8AF5-08551F390FE9}"/>
+                <a16:creationId xmlns:a16="http://schemas.microsoft.com/office/drawing/2014/main" id="{C65D3550-80AA-4F78-B0B1-48E7438F47C5}"/>
               </a:ext>
             </a:extLst>
           </p:cNvPr>
@@ -6699,7 +6699,7 @@
           <p:cNvPr id="15" name="">
             <a:extLst xmlns:a="http://schemas.openxmlformats.org/drawingml/2006/main">
               <a:ext uri="{FF2B5EF4-FFF2-40B4-BE49-F238E27FC236}">
-                <a16:creationId xmlns:a16="http://schemas.microsoft.com/office/drawing/2014/main" id="{DFE8499D-4374-4F93-8DEF-C1F6390A005E}"/>
+                <a16:creationId xmlns:a16="http://schemas.microsoft.com/office/drawing/2014/main" id="{D7158E83-2201-4816-9DA3-5E8619D1D580}"/>
               </a:ext>
             </a:extLst>
           </p:cNvPr>
@@ -6749,7 +6749,7 @@
           <p:cNvPr id="16" name="">
             <a:extLst xmlns:a="http://schemas.openxmlformats.org/drawingml/2006/main">
               <a:ext uri="{FF2B5EF4-FFF2-40B4-BE49-F238E27FC236}">
-                <a16:creationId xmlns:a16="http://schemas.microsoft.com/office/drawing/2014/main" id="{EF7E9CBE-7EDC-4A00-80AA-305F4774A17B}"/>
+                <a16:creationId xmlns:a16="http://schemas.microsoft.com/office/drawing/2014/main" id="{EB383009-DADA-4268-86E9-14C1F4154FFA}"/>
               </a:ext>
             </a:extLst>
           </p:cNvPr>
@@ -6799,7 +6799,7 @@
           <p:cNvPr id="17" name="">
             <a:extLst xmlns:a="http://schemas.openxmlformats.org/drawingml/2006/main">
               <a:ext uri="{FF2B5EF4-FFF2-40B4-BE49-F238E27FC236}">
-                <a16:creationId xmlns:a16="http://schemas.microsoft.com/office/drawing/2014/main" id="{045D7E23-78A1-421E-AC92-4B7B788C8DE8}"/>
+                <a16:creationId xmlns:a16="http://schemas.microsoft.com/office/drawing/2014/main" id="{9F5DA49E-174B-423D-B8B3-4616053C5A9A}"/>
               </a:ext>
             </a:extLst>
           </p:cNvPr>
@@ -6830,7 +6830,7 @@
           <p:cNvPr id="18" name="">
             <a:extLst xmlns:a="http://schemas.openxmlformats.org/drawingml/2006/main">
               <a:ext uri="{FF2B5EF4-FFF2-40B4-BE49-F238E27FC236}">
-                <a16:creationId xmlns:a16="http://schemas.microsoft.com/office/drawing/2014/main" id="{22C2EBDE-188D-4189-9320-8222B1C8E423}"/>
+                <a16:creationId xmlns:a16="http://schemas.microsoft.com/office/drawing/2014/main" id="{BAB721F4-A26C-462C-A41B-441F2AD1E836}"/>
               </a:ext>
             </a:extLst>
           </p:cNvPr>
@@ -6880,7 +6880,7 @@
           <p:cNvPr id="19" name="">
             <a:extLst xmlns:a="http://schemas.openxmlformats.org/drawingml/2006/main">
               <a:ext uri="{FF2B5EF4-FFF2-40B4-BE49-F238E27FC236}">
-                <a16:creationId xmlns:a16="http://schemas.microsoft.com/office/drawing/2014/main" id="{02CDA4D5-44A4-4077-AF4F-BA2521A1E057}"/>
+                <a16:creationId xmlns:a16="http://schemas.microsoft.com/office/drawing/2014/main" id="{470A10BD-614B-4945-BAA8-78ECED8C8577}"/>
               </a:ext>
             </a:extLst>
           </p:cNvPr>
@@ -6928,7 +6928,7 @@
     </p:spTree>
     <p:extLst>
       <p:ext uri="{BB962C8B-B14F-4D97-AF65-F5344CB8AC3E}">
-        <p14:creationId xmlns:p14="http://schemas.microsoft.com/office/powerpoint/2010/main" val="1565034705"/>
+        <p14:creationId xmlns:p14="http://schemas.microsoft.com/office/powerpoint/2010/main" val="1873938793"/>
       </p:ext>
     </p:extLst>
   </p:cSld>
@@ -6959,7 +6959,7 @@
           <p:cNvPr id="20" name="">
             <a:extLst xmlns:a="http://schemas.openxmlformats.org/drawingml/2006/main">
               <a:ext uri="{FF2B5EF4-FFF2-40B4-BE49-F238E27FC236}">
-                <a16:creationId xmlns:a16="http://schemas.microsoft.com/office/drawing/2014/main" id="{C9C1033F-8D07-4830-8017-3313334FB816}"/>
+                <a16:creationId xmlns:a16="http://schemas.microsoft.com/office/drawing/2014/main" id="{B7FB9BEB-F5B4-4707-B68F-EB78DD531353}"/>
               </a:ext>
             </a:extLst>
           </p:cNvPr>
@@ -6992,7 +6992,7 @@
           <p:cNvPr id="2" name="">
             <a:extLst xmlns:a="http://schemas.openxmlformats.org/drawingml/2006/main">
               <a:ext uri="{FF2B5EF4-FFF2-40B4-BE49-F238E27FC236}">
-                <a16:creationId xmlns:a16="http://schemas.microsoft.com/office/drawing/2014/main" id="{2DE31FC2-BB8D-4B79-B9AB-DDF2E44FF076}"/>
+                <a16:creationId xmlns:a16="http://schemas.microsoft.com/office/drawing/2014/main" id="{1D2F74DC-2E96-4367-B7C4-22B8BFF8E6B8}"/>
               </a:ext>
             </a:extLst>
           </p:cNvPr>
@@ -7042,7 +7042,7 @@
           <p:cNvPr id="3" name="">
             <a:extLst xmlns:a="http://schemas.openxmlformats.org/drawingml/2006/main">
               <a:ext uri="{FF2B5EF4-FFF2-40B4-BE49-F238E27FC236}">
-                <a16:creationId xmlns:a16="http://schemas.microsoft.com/office/drawing/2014/main" id="{6F5EF63B-A215-4964-85AE-12F41914418C}"/>
+                <a16:creationId xmlns:a16="http://schemas.microsoft.com/office/drawing/2014/main" id="{4491B567-333B-4E33-AE88-103D53884969}"/>
               </a:ext>
             </a:extLst>
           </p:cNvPr>
@@ -7092,7 +7092,7 @@
           <p:cNvPr id="4" name="">
             <a:extLst xmlns:a="http://schemas.openxmlformats.org/drawingml/2006/main">
               <a:ext uri="{FF2B5EF4-FFF2-40B4-BE49-F238E27FC236}">
-                <a16:creationId xmlns:a16="http://schemas.microsoft.com/office/drawing/2014/main" id="{0FBA978F-ED28-485C-A076-7B517604BD14}"/>
+                <a16:creationId xmlns:a16="http://schemas.microsoft.com/office/drawing/2014/main" id="{7D740AFE-4D4B-41CA-AF14-140ED61CC8F5}"/>
               </a:ext>
             </a:extLst>
           </p:cNvPr>
@@ -7142,7 +7142,7 @@
           <p:cNvPr id="5" name="">
             <a:extLst xmlns:a="http://schemas.openxmlformats.org/drawingml/2006/main">
               <a:ext uri="{FF2B5EF4-FFF2-40B4-BE49-F238E27FC236}">
-                <a16:creationId xmlns:a16="http://schemas.microsoft.com/office/drawing/2014/main" id="{727C3E85-FE63-4746-B12E-C4AD07F20C17}"/>
+                <a16:creationId xmlns:a16="http://schemas.microsoft.com/office/drawing/2014/main" id="{4300E135-F15C-4F48-84FF-ADDE0E3EF23A}"/>
               </a:ext>
             </a:extLst>
           </p:cNvPr>
@@ -7177,7 +7177,7 @@
           <p:cNvPr id="6" name="">
             <a:extLst xmlns:a="http://schemas.openxmlformats.org/drawingml/2006/main">
               <a:ext uri="{FF2B5EF4-FFF2-40B4-BE49-F238E27FC236}">
-                <a16:creationId xmlns:a16="http://schemas.microsoft.com/office/drawing/2014/main" id="{9A8575ED-D6F1-4EA9-9BA9-B1EE929E5470}"/>
+                <a16:creationId xmlns:a16="http://schemas.microsoft.com/office/drawing/2014/main" id="{4B6A88E9-F43E-4169-A948-0CA8B2CFFB8F}"/>
               </a:ext>
             </a:extLst>
           </p:cNvPr>
@@ -7210,7 +7210,7 @@
           <p:cNvPr id="7" name="">
             <a:extLst xmlns:a="http://schemas.openxmlformats.org/drawingml/2006/main">
               <a:ext uri="{FF2B5EF4-FFF2-40B4-BE49-F238E27FC236}">
-                <a16:creationId xmlns:a16="http://schemas.microsoft.com/office/drawing/2014/main" id="{7C52F23B-55CE-4B46-8132-9DDED818925A}"/>
+                <a16:creationId xmlns:a16="http://schemas.microsoft.com/office/drawing/2014/main" id="{90B1B96F-3480-4D3F-921D-17DF7365AF23}"/>
               </a:ext>
             </a:extLst>
           </p:cNvPr>
@@ -7260,7 +7260,7 @@
           <p:cNvPr id="8" name="">
             <a:extLst xmlns:a="http://schemas.openxmlformats.org/drawingml/2006/main">
               <a:ext uri="{FF2B5EF4-FFF2-40B4-BE49-F238E27FC236}">
-                <a16:creationId xmlns:a16="http://schemas.microsoft.com/office/drawing/2014/main" id="{820263CC-BE49-4C68-962E-8B494C166CA0}"/>
+                <a16:creationId xmlns:a16="http://schemas.microsoft.com/office/drawing/2014/main" id="{725F64B2-8DD1-41DA-95DF-55AD35F3BE8B}"/>
               </a:ext>
             </a:extLst>
           </p:cNvPr>
@@ -7310,7 +7310,7 @@
           <p:cNvPr id="9" name="">
             <a:extLst xmlns:a="http://schemas.openxmlformats.org/drawingml/2006/main">
               <a:ext uri="{FF2B5EF4-FFF2-40B4-BE49-F238E27FC236}">
-                <a16:creationId xmlns:a16="http://schemas.microsoft.com/office/drawing/2014/main" id="{A9B00468-EE8E-493D-B84E-B8A6083DD92D}"/>
+                <a16:creationId xmlns:a16="http://schemas.microsoft.com/office/drawing/2014/main" id="{E85AA777-55E6-4AFB-A2B5-D50591E8CFC3}"/>
               </a:ext>
             </a:extLst>
           </p:cNvPr>
@@ -7345,7 +7345,7 @@
           <p:cNvPr id="10" name="">
             <a:extLst xmlns:a="http://schemas.openxmlformats.org/drawingml/2006/main">
               <a:ext uri="{FF2B5EF4-FFF2-40B4-BE49-F238E27FC236}">
-                <a16:creationId xmlns:a16="http://schemas.microsoft.com/office/drawing/2014/main" id="{14AB0374-9880-4E10-948D-D90DDB533AB1}"/>
+                <a16:creationId xmlns:a16="http://schemas.microsoft.com/office/drawing/2014/main" id="{7D278A43-821E-40CA-A73A-7D1A9C4B525C}"/>
               </a:ext>
             </a:extLst>
           </p:cNvPr>
@@ -7378,7 +7378,7 @@
           <p:cNvPr id="11" name="">
             <a:extLst xmlns:a="http://schemas.openxmlformats.org/drawingml/2006/main">
               <a:ext uri="{FF2B5EF4-FFF2-40B4-BE49-F238E27FC236}">
-                <a16:creationId xmlns:a16="http://schemas.microsoft.com/office/drawing/2014/main" id="{614F7A07-F10E-4207-9742-AB5ABAEFCCAD}"/>
+                <a16:creationId xmlns:a16="http://schemas.microsoft.com/office/drawing/2014/main" id="{2495F16A-DB83-4DCE-BEB4-11097C48366D}"/>
               </a:ext>
             </a:extLst>
           </p:cNvPr>
@@ -7428,7 +7428,7 @@
           <p:cNvPr id="12" name="">
             <a:extLst xmlns:a="http://schemas.openxmlformats.org/drawingml/2006/main">
               <a:ext uri="{FF2B5EF4-FFF2-40B4-BE49-F238E27FC236}">
-                <a16:creationId xmlns:a16="http://schemas.microsoft.com/office/drawing/2014/main" id="{65D25D64-6C9A-41EB-A926-E5FA716B0F63}"/>
+                <a16:creationId xmlns:a16="http://schemas.microsoft.com/office/drawing/2014/main" id="{72A525D1-D601-4CBE-869A-0D086845C683}"/>
               </a:ext>
             </a:extLst>
           </p:cNvPr>
@@ -7478,7 +7478,7 @@
           <p:cNvPr id="13" name="">
             <a:extLst xmlns:a="http://schemas.openxmlformats.org/drawingml/2006/main">
               <a:ext uri="{FF2B5EF4-FFF2-40B4-BE49-F238E27FC236}">
-                <a16:creationId xmlns:a16="http://schemas.microsoft.com/office/drawing/2014/main" id="{088D1327-6BE1-4017-B7C2-A9350B317708}"/>
+                <a16:creationId xmlns:a16="http://schemas.microsoft.com/office/drawing/2014/main" id="{343BEE5A-5D31-496B-B1BB-37539A3DE4B6}"/>
               </a:ext>
             </a:extLst>
           </p:cNvPr>
@@ -7513,7 +7513,7 @@
           <p:cNvPr id="14" name="">
             <a:extLst xmlns:a="http://schemas.openxmlformats.org/drawingml/2006/main">
               <a:ext uri="{FF2B5EF4-FFF2-40B4-BE49-F238E27FC236}">
-                <a16:creationId xmlns:a16="http://schemas.microsoft.com/office/drawing/2014/main" id="{452F3780-A782-4F0B-B603-9869100C433E}"/>
+                <a16:creationId xmlns:a16="http://schemas.microsoft.com/office/drawing/2014/main" id="{9973D0C6-7650-4428-B55B-DB4404E97E63}"/>
               </a:ext>
             </a:extLst>
           </p:cNvPr>
@@ -7546,7 +7546,7 @@
           <p:cNvPr id="15" name="">
             <a:extLst xmlns:a="http://schemas.openxmlformats.org/drawingml/2006/main">
               <a:ext uri="{FF2B5EF4-FFF2-40B4-BE49-F238E27FC236}">
-                <a16:creationId xmlns:a16="http://schemas.microsoft.com/office/drawing/2014/main" id="{EC4A572D-3C69-4F42-9C77-173149FB633D}"/>
+                <a16:creationId xmlns:a16="http://schemas.microsoft.com/office/drawing/2014/main" id="{FF093E13-179A-4DF1-AEF6-B0C906CC5FE7}"/>
               </a:ext>
             </a:extLst>
           </p:cNvPr>
@@ -7596,7 +7596,7 @@
           <p:cNvPr id="16" name="">
             <a:extLst xmlns:a="http://schemas.openxmlformats.org/drawingml/2006/main">
               <a:ext uri="{FF2B5EF4-FFF2-40B4-BE49-F238E27FC236}">
-                <a16:creationId xmlns:a16="http://schemas.microsoft.com/office/drawing/2014/main" id="{93EE3231-2085-455D-A474-7E6898C4B6A9}"/>
+                <a16:creationId xmlns:a16="http://schemas.microsoft.com/office/drawing/2014/main" id="{E586DBBE-A466-4C15-8842-0D91B401A69A}"/>
               </a:ext>
             </a:extLst>
           </p:cNvPr>
@@ -7646,7 +7646,7 @@
           <p:cNvPr id="17" name="">
             <a:extLst xmlns:a="http://schemas.openxmlformats.org/drawingml/2006/main">
               <a:ext uri="{FF2B5EF4-FFF2-40B4-BE49-F238E27FC236}">
-                <a16:creationId xmlns:a16="http://schemas.microsoft.com/office/drawing/2014/main" id="{716FCF2D-3217-432B-AA4D-B9C3F504E19A}"/>
+                <a16:creationId xmlns:a16="http://schemas.microsoft.com/office/drawing/2014/main" id="{3EFAAB49-C864-45E0-85E4-989D6A90E072}"/>
               </a:ext>
             </a:extLst>
           </p:cNvPr>
@@ -7696,7 +7696,7 @@
           <p:cNvPr id="18" name="">
             <a:extLst xmlns:a="http://schemas.openxmlformats.org/drawingml/2006/main">
               <a:ext uri="{FF2B5EF4-FFF2-40B4-BE49-F238E27FC236}">
-                <a16:creationId xmlns:a16="http://schemas.microsoft.com/office/drawing/2014/main" id="{27255D95-EBCB-4EAF-9484-E0E179A93D31}"/>
+                <a16:creationId xmlns:a16="http://schemas.microsoft.com/office/drawing/2014/main" id="{D2641B57-EF13-417A-922C-ABFA69ABCE09}"/>
               </a:ext>
             </a:extLst>
           </p:cNvPr>
@@ -7746,7 +7746,7 @@
           <p:cNvPr id="19" name="">
             <a:extLst xmlns:a="http://schemas.openxmlformats.org/drawingml/2006/main">
               <a:ext uri="{FF2B5EF4-FFF2-40B4-BE49-F238E27FC236}">
-                <a16:creationId xmlns:a16="http://schemas.microsoft.com/office/drawing/2014/main" id="{848F13A9-877E-4EEA-A5D1-5E059933A30C}"/>
+                <a16:creationId xmlns:a16="http://schemas.microsoft.com/office/drawing/2014/main" id="{73CFDF60-03BC-4539-A8BB-BC893841D9D9}"/>
               </a:ext>
             </a:extLst>
           </p:cNvPr>
@@ -7794,7 +7794,7 @@
     </p:spTree>
     <p:extLst>
       <p:ext uri="{BB962C8B-B14F-4D97-AF65-F5344CB8AC3E}">
-        <p14:creationId xmlns:p14="http://schemas.microsoft.com/office/powerpoint/2010/main" val="235528982"/>
+        <p14:creationId xmlns:p14="http://schemas.microsoft.com/office/powerpoint/2010/main" val="1788876364"/>
       </p:ext>
     </p:extLst>
   </p:cSld>
@@ -7825,7 +7825,7 @@
           <p:cNvPr id="22" name="">
             <a:extLst xmlns:a="http://schemas.openxmlformats.org/drawingml/2006/main">
               <a:ext uri="{FF2B5EF4-FFF2-40B4-BE49-F238E27FC236}">
-                <a16:creationId xmlns:a16="http://schemas.microsoft.com/office/drawing/2014/main" id="{F93ED0E2-6981-4F4C-80E3-CD5D1C2831E0}"/>
+                <a16:creationId xmlns:a16="http://schemas.microsoft.com/office/drawing/2014/main" id="{18D9D5D0-B552-4788-97AC-E5A6E568F76D}"/>
               </a:ext>
             </a:extLst>
           </p:cNvPr>
@@ -7875,7 +7875,7 @@
           <p:cNvPr id="2" name="">
             <a:extLst xmlns:a="http://schemas.openxmlformats.org/drawingml/2006/main">
               <a:ext uri="{FF2B5EF4-FFF2-40B4-BE49-F238E27FC236}">
-                <a16:creationId xmlns:a16="http://schemas.microsoft.com/office/drawing/2014/main" id="{AB8C8076-8CBD-46ED-937F-484B1D684A3D}"/>
+                <a16:creationId xmlns:a16="http://schemas.microsoft.com/office/drawing/2014/main" id="{7C4877A2-73AC-4371-817F-D8349D80D503}"/>
               </a:ext>
             </a:extLst>
           </p:cNvPr>
@@ -7925,7 +7925,7 @@
           <p:cNvPr id="3" name="">
             <a:extLst xmlns:a="http://schemas.openxmlformats.org/drawingml/2006/main">
               <a:ext uri="{FF2B5EF4-FFF2-40B4-BE49-F238E27FC236}">
-                <a16:creationId xmlns:a16="http://schemas.microsoft.com/office/drawing/2014/main" id="{8BC8AF37-BA35-4465-BA9D-CEA99FCA968A}"/>
+                <a16:creationId xmlns:a16="http://schemas.microsoft.com/office/drawing/2014/main" id="{A72E9A74-B5B8-4851-A1F2-12DC0F7AE725}"/>
               </a:ext>
             </a:extLst>
           </p:cNvPr>
@@ -7975,7 +7975,7 @@
           <p:cNvPr id="4" name="">
             <a:extLst xmlns:a="http://schemas.openxmlformats.org/drawingml/2006/main">
               <a:ext uri="{FF2B5EF4-FFF2-40B4-BE49-F238E27FC236}">
-                <a16:creationId xmlns:a16="http://schemas.microsoft.com/office/drawing/2014/main" id="{E3E79D61-9774-4F8D-9CD5-1B2E09A9223C}"/>
+                <a16:creationId xmlns:a16="http://schemas.microsoft.com/office/drawing/2014/main" id="{71D5655C-7AED-4CEA-AC1F-5D1E8DF98399}"/>
               </a:ext>
             </a:extLst>
           </p:cNvPr>
@@ -8006,7 +8006,7 @@
           <p:cNvPr id="5" name="">
             <a:extLst xmlns:a="http://schemas.openxmlformats.org/drawingml/2006/main">
               <a:ext uri="{FF2B5EF4-FFF2-40B4-BE49-F238E27FC236}">
-                <a16:creationId xmlns:a16="http://schemas.microsoft.com/office/drawing/2014/main" id="{431FAB00-A3A5-4A16-A362-689776E102B2}"/>
+                <a16:creationId xmlns:a16="http://schemas.microsoft.com/office/drawing/2014/main" id="{59B2B678-75CC-4FFB-9A05-1B1E74BB3862}"/>
               </a:ext>
             </a:extLst>
           </p:cNvPr>
@@ -8041,7 +8041,7 @@
           <p:cNvPr id="6" name="">
             <a:extLst xmlns:a="http://schemas.openxmlformats.org/drawingml/2006/main">
               <a:ext uri="{FF2B5EF4-FFF2-40B4-BE49-F238E27FC236}">
-                <a16:creationId xmlns:a16="http://schemas.microsoft.com/office/drawing/2014/main" id="{76240598-AD42-46E4-B8A4-974A7C52D099}"/>
+                <a16:creationId xmlns:a16="http://schemas.microsoft.com/office/drawing/2014/main" id="{D7D6CA86-FCA5-4D67-A5FF-D34EC3EB7B3B}"/>
               </a:ext>
             </a:extLst>
           </p:cNvPr>
@@ -8074,7 +8074,7 @@
           <p:cNvPr id="7" name="">
             <a:extLst xmlns:a="http://schemas.openxmlformats.org/drawingml/2006/main">
               <a:ext uri="{FF2B5EF4-FFF2-40B4-BE49-F238E27FC236}">
-                <a16:creationId xmlns:a16="http://schemas.microsoft.com/office/drawing/2014/main" id="{D513D6DE-FEDD-443F-9C8E-689FA027F420}"/>
+                <a16:creationId xmlns:a16="http://schemas.microsoft.com/office/drawing/2014/main" id="{9405D91D-A0BE-47CC-93D0-BE17577B7477}"/>
               </a:ext>
             </a:extLst>
           </p:cNvPr>
@@ -8124,7 +8124,7 @@
           <p:cNvPr id="8" name="">
             <a:extLst xmlns:a="http://schemas.openxmlformats.org/drawingml/2006/main">
               <a:ext uri="{FF2B5EF4-FFF2-40B4-BE49-F238E27FC236}">
-                <a16:creationId xmlns:a16="http://schemas.microsoft.com/office/drawing/2014/main" id="{EFF9A3FD-D363-4034-B773-C3BFE0EA8DE5}"/>
+                <a16:creationId xmlns:a16="http://schemas.microsoft.com/office/drawing/2014/main" id="{7278F871-E61E-4700-87FF-DBE89ADBA4D4}"/>
               </a:ext>
             </a:extLst>
           </p:cNvPr>
@@ -8174,7 +8174,7 @@
           <p:cNvPr id="9" name="">
             <a:extLst xmlns:a="http://schemas.openxmlformats.org/drawingml/2006/main">
               <a:ext uri="{FF2B5EF4-FFF2-40B4-BE49-F238E27FC236}">
-                <a16:creationId xmlns:a16="http://schemas.microsoft.com/office/drawing/2014/main" id="{77ABEBB5-D8D5-4E34-BDF7-62FC5F7E1C57}"/>
+                <a16:creationId xmlns:a16="http://schemas.microsoft.com/office/drawing/2014/main" id="{F1FF13DD-74EC-422C-BB94-D40A0862E626}"/>
               </a:ext>
             </a:extLst>
           </p:cNvPr>
@@ -8209,7 +8209,7 @@
           <p:cNvPr id="10" name="">
             <a:extLst xmlns:a="http://schemas.openxmlformats.org/drawingml/2006/main">
               <a:ext uri="{FF2B5EF4-FFF2-40B4-BE49-F238E27FC236}">
-                <a16:creationId xmlns:a16="http://schemas.microsoft.com/office/drawing/2014/main" id="{D7083702-4C98-44CC-A3CE-E4DF25C8CAA7}"/>
+                <a16:creationId xmlns:a16="http://schemas.microsoft.com/office/drawing/2014/main" id="{C3E7EA50-C3AF-4AFC-8DCC-9040ABD31DAB}"/>
               </a:ext>
             </a:extLst>
           </p:cNvPr>
@@ -8242,7 +8242,7 @@
           <p:cNvPr id="11" name="">
             <a:extLst xmlns:a="http://schemas.openxmlformats.org/drawingml/2006/main">
               <a:ext uri="{FF2B5EF4-FFF2-40B4-BE49-F238E27FC236}">
-                <a16:creationId xmlns:a16="http://schemas.microsoft.com/office/drawing/2014/main" id="{62BC93D7-8C08-42AA-A215-A49444AB5C95}"/>
+                <a16:creationId xmlns:a16="http://schemas.microsoft.com/office/drawing/2014/main" id="{A8E9C8A8-8430-4A7E-86B4-62D5A80EF9C7}"/>
               </a:ext>
             </a:extLst>
           </p:cNvPr>
@@ -8292,7 +8292,7 @@
           <p:cNvPr id="12" name="">
             <a:extLst xmlns:a="http://schemas.openxmlformats.org/drawingml/2006/main">
               <a:ext uri="{FF2B5EF4-FFF2-40B4-BE49-F238E27FC236}">
-                <a16:creationId xmlns:a16="http://schemas.microsoft.com/office/drawing/2014/main" id="{47C5E142-7F2C-42C6-ABAE-6006020783C7}"/>
+                <a16:creationId xmlns:a16="http://schemas.microsoft.com/office/drawing/2014/main" id="{4301A31D-C4C1-4217-A980-C22F1E45916F}"/>
               </a:ext>
             </a:extLst>
           </p:cNvPr>
@@ -8332,7 +8332,7 @@
                   <a:srgbClr val="64748B"/>
                 </a:solidFill>
               </a:rPr>
-              <a:t>67.9% of target account domains have no tracked email or 6sense touch. Use that audience for a randomized or phased coverage test.</a:t>
+              <a:t>67.9% of CRM account domains have no tracked email or 6sense touch. Use that audience for a randomized or phased coverage test.</a:t>
             </a:r>
           </a:p>
         </p:txBody>
@@ -8342,7 +8342,7 @@
           <p:cNvPr id="13" name="">
             <a:extLst xmlns:a="http://schemas.openxmlformats.org/drawingml/2006/main">
               <a:ext uri="{FF2B5EF4-FFF2-40B4-BE49-F238E27FC236}">
-                <a16:creationId xmlns:a16="http://schemas.microsoft.com/office/drawing/2014/main" id="{5FF9A999-4461-448F-A9B8-C51BB33A8427}"/>
+                <a16:creationId xmlns:a16="http://schemas.microsoft.com/office/drawing/2014/main" id="{CA65BFDF-DAB3-4539-A278-5CED7DCD8D1D}"/>
               </a:ext>
             </a:extLst>
           </p:cNvPr>
@@ -8377,7 +8377,7 @@
           <p:cNvPr id="14" name="">
             <a:extLst xmlns:a="http://schemas.openxmlformats.org/drawingml/2006/main">
               <a:ext uri="{FF2B5EF4-FFF2-40B4-BE49-F238E27FC236}">
-                <a16:creationId xmlns:a16="http://schemas.microsoft.com/office/drawing/2014/main" id="{53613658-E2C1-41D9-A47E-DD3747916A4F}"/>
+                <a16:creationId xmlns:a16="http://schemas.microsoft.com/office/drawing/2014/main" id="{7CF5F6E2-134D-4BD2-886F-64E3B542FCB4}"/>
               </a:ext>
             </a:extLst>
           </p:cNvPr>
@@ -8410,7 +8410,7 @@
           <p:cNvPr id="15" name="">
             <a:extLst xmlns:a="http://schemas.openxmlformats.org/drawingml/2006/main">
               <a:ext uri="{FF2B5EF4-FFF2-40B4-BE49-F238E27FC236}">
-                <a16:creationId xmlns:a16="http://schemas.microsoft.com/office/drawing/2014/main" id="{6CE89C56-5459-427B-97A4-4295B4877FBE}"/>
+                <a16:creationId xmlns:a16="http://schemas.microsoft.com/office/drawing/2014/main" id="{401D90A4-DBDC-4CBF-B4CD-08D918A533B7}"/>
               </a:ext>
             </a:extLst>
           </p:cNvPr>
@@ -8460,7 +8460,7 @@
           <p:cNvPr id="16" name="">
             <a:extLst xmlns:a="http://schemas.openxmlformats.org/drawingml/2006/main">
               <a:ext uri="{FF2B5EF4-FFF2-40B4-BE49-F238E27FC236}">
-                <a16:creationId xmlns:a16="http://schemas.microsoft.com/office/drawing/2014/main" id="{9D8DCBB6-8307-4E6A-99A6-3ECFC032A41F}"/>
+                <a16:creationId xmlns:a16="http://schemas.microsoft.com/office/drawing/2014/main" id="{C74526F6-9F6C-4A8D-99BD-1914F9F6DAE5}"/>
               </a:ext>
             </a:extLst>
           </p:cNvPr>
@@ -8510,7 +8510,7 @@
           <p:cNvPr id="17" name="">
             <a:extLst xmlns:a="http://schemas.openxmlformats.org/drawingml/2006/main">
               <a:ext uri="{FF2B5EF4-FFF2-40B4-BE49-F238E27FC236}">
-                <a16:creationId xmlns:a16="http://schemas.microsoft.com/office/drawing/2014/main" id="{642F1E44-AE09-4C9B-85A0-318A9C1C018B}"/>
+                <a16:creationId xmlns:a16="http://schemas.microsoft.com/office/drawing/2014/main" id="{8E2007CD-AF48-4D1F-AB7B-EA78A028CBCB}"/>
               </a:ext>
             </a:extLst>
           </p:cNvPr>
@@ -8560,7 +8560,7 @@
           <p:cNvPr id="18" name="">
             <a:extLst xmlns:a="http://schemas.openxmlformats.org/drawingml/2006/main">
               <a:ext uri="{FF2B5EF4-FFF2-40B4-BE49-F238E27FC236}">
-                <a16:creationId xmlns:a16="http://schemas.microsoft.com/office/drawing/2014/main" id="{6AAD8F6A-058E-459C-ADF7-D9169846E0EB}"/>
+                <a16:creationId xmlns:a16="http://schemas.microsoft.com/office/drawing/2014/main" id="{1367E8D9-8F12-4364-BCDE-5E1982BB9EEE}"/>
               </a:ext>
             </a:extLst>
           </p:cNvPr>
@@ -8610,7 +8610,7 @@
           <p:cNvPr id="19" name="">
             <a:extLst xmlns:a="http://schemas.openxmlformats.org/drawingml/2006/main">
               <a:ext uri="{FF2B5EF4-FFF2-40B4-BE49-F238E27FC236}">
-                <a16:creationId xmlns:a16="http://schemas.microsoft.com/office/drawing/2014/main" id="{E492F7B9-20C6-4C8B-B5BF-91BEE6C29EC3}"/>
+                <a16:creationId xmlns:a16="http://schemas.microsoft.com/office/drawing/2014/main" id="{F17A3FBF-6FC9-4BE7-AA40-F77F371FF945}"/>
               </a:ext>
             </a:extLst>
           </p:cNvPr>
@@ -8641,7 +8641,7 @@
           <p:cNvPr id="20" name="">
             <a:extLst xmlns:a="http://schemas.openxmlformats.org/drawingml/2006/main">
               <a:ext uri="{FF2B5EF4-FFF2-40B4-BE49-F238E27FC236}">
-                <a16:creationId xmlns:a16="http://schemas.microsoft.com/office/drawing/2014/main" id="{602BD321-2419-45D6-83F2-1CC93D099FE6}"/>
+                <a16:creationId xmlns:a16="http://schemas.microsoft.com/office/drawing/2014/main" id="{391A0742-14E0-4FAB-B734-B45A45290549}"/>
               </a:ext>
             </a:extLst>
           </p:cNvPr>
@@ -8691,7 +8691,7 @@
           <p:cNvPr id="21" name="">
             <a:extLst xmlns:a="http://schemas.openxmlformats.org/drawingml/2006/main">
               <a:ext uri="{FF2B5EF4-FFF2-40B4-BE49-F238E27FC236}">
-                <a16:creationId xmlns:a16="http://schemas.microsoft.com/office/drawing/2014/main" id="{357D118D-0DD4-449B-8618-D60071DF7DDE}"/>
+                <a16:creationId xmlns:a16="http://schemas.microsoft.com/office/drawing/2014/main" id="{E04CADDF-8434-407D-932D-F42969E9D67C}"/>
               </a:ext>
             </a:extLst>
           </p:cNvPr>
@@ -8739,7 +8739,7 @@
     </p:spTree>
     <p:extLst>
       <p:ext uri="{BB962C8B-B14F-4D97-AF65-F5344CB8AC3E}">
-        <p14:creationId xmlns:p14="http://schemas.microsoft.com/office/powerpoint/2010/main" val="2068111232"/>
+        <p14:creationId xmlns:p14="http://schemas.microsoft.com/office/powerpoint/2010/main" val="157197228"/>
       </p:ext>
     </p:extLst>
   </p:cSld>
@@ -8770,7 +8770,7 @@
           <p:cNvPr id="32" name="">
             <a:extLst xmlns:a="http://schemas.openxmlformats.org/drawingml/2006/main">
               <a:ext uri="{FF2B5EF4-FFF2-40B4-BE49-F238E27FC236}">
-                <a16:creationId xmlns:a16="http://schemas.microsoft.com/office/drawing/2014/main" id="{BD414039-65D5-451A-B1A5-A37FC919A2AD}"/>
+                <a16:creationId xmlns:a16="http://schemas.microsoft.com/office/drawing/2014/main" id="{0C0BE74E-96F8-42C2-91B1-2D4992A5F789}"/>
               </a:ext>
             </a:extLst>
           </p:cNvPr>
@@ -8820,7 +8820,7 @@
           <p:cNvPr id="2" name="">
             <a:extLst xmlns:a="http://schemas.openxmlformats.org/drawingml/2006/main">
               <a:ext uri="{FF2B5EF4-FFF2-40B4-BE49-F238E27FC236}">
-                <a16:creationId xmlns:a16="http://schemas.microsoft.com/office/drawing/2014/main" id="{21A11B56-21FD-43AF-8550-35D349E0FB0F}"/>
+                <a16:creationId xmlns:a16="http://schemas.microsoft.com/office/drawing/2014/main" id="{6F202D02-9352-47C0-AC83-7D375485A17C}"/>
               </a:ext>
             </a:extLst>
           </p:cNvPr>
@@ -8870,7 +8870,7 @@
           <p:cNvPr id="3" name="">
             <a:extLst xmlns:a="http://schemas.openxmlformats.org/drawingml/2006/main">
               <a:ext uri="{FF2B5EF4-FFF2-40B4-BE49-F238E27FC236}">
-                <a16:creationId xmlns:a16="http://schemas.microsoft.com/office/drawing/2014/main" id="{95BD8FFE-C698-4ABF-8ED4-8FFB4A0C74DD}"/>
+                <a16:creationId xmlns:a16="http://schemas.microsoft.com/office/drawing/2014/main" id="{7DD5FC3F-F09D-453E-BC0E-BE8794AEF29D}"/>
               </a:ext>
             </a:extLst>
           </p:cNvPr>
@@ -8920,7 +8920,7 @@
           <p:cNvPr id="4" name="">
             <a:extLst xmlns:a="http://schemas.openxmlformats.org/drawingml/2006/main">
               <a:ext uri="{FF2B5EF4-FFF2-40B4-BE49-F238E27FC236}">
-                <a16:creationId xmlns:a16="http://schemas.microsoft.com/office/drawing/2014/main" id="{F125D189-B20D-4807-A114-FB2F8831B54D}"/>
+                <a16:creationId xmlns:a16="http://schemas.microsoft.com/office/drawing/2014/main" id="{FF0039C0-2ED8-40C8-9AC0-7043BA41B3DB}"/>
               </a:ext>
             </a:extLst>
           </p:cNvPr>
@@ -8951,7 +8951,7 @@
           <p:cNvPr id="5" name="">
             <a:extLst xmlns:a="http://schemas.openxmlformats.org/drawingml/2006/main">
               <a:ext uri="{FF2B5EF4-FFF2-40B4-BE49-F238E27FC236}">
-                <a16:creationId xmlns:a16="http://schemas.microsoft.com/office/drawing/2014/main" id="{6484B51A-6D68-477D-99D3-BA16C17C0A1C}"/>
+                <a16:creationId xmlns:a16="http://schemas.microsoft.com/office/drawing/2014/main" id="{21724B7F-611A-472E-B106-62A7955BF1A9}"/>
               </a:ext>
             </a:extLst>
           </p:cNvPr>
@@ -8984,7 +8984,7 @@
           <p:cNvPr id="6" name="">
             <a:extLst xmlns:a="http://schemas.openxmlformats.org/drawingml/2006/main">
               <a:ext uri="{FF2B5EF4-FFF2-40B4-BE49-F238E27FC236}">
-                <a16:creationId xmlns:a16="http://schemas.microsoft.com/office/drawing/2014/main" id="{EAF4583E-0E4E-46AA-9807-A8432AA7B2A8}"/>
+                <a16:creationId xmlns:a16="http://schemas.microsoft.com/office/drawing/2014/main" id="{D43365C9-74ED-40B9-ABCA-970AB2BAE938}"/>
               </a:ext>
             </a:extLst>
           </p:cNvPr>
@@ -9034,7 +9034,7 @@
           <p:cNvPr id="7" name="">
             <a:extLst xmlns:a="http://schemas.openxmlformats.org/drawingml/2006/main">
               <a:ext uri="{FF2B5EF4-FFF2-40B4-BE49-F238E27FC236}">
-                <a16:creationId xmlns:a16="http://schemas.microsoft.com/office/drawing/2014/main" id="{17EBE702-0F6D-4E13-BFC7-B8411AA15D75}"/>
+                <a16:creationId xmlns:a16="http://schemas.microsoft.com/office/drawing/2014/main" id="{A4AA25B9-6EA4-41C5-B077-835F94714597}"/>
               </a:ext>
             </a:extLst>
           </p:cNvPr>
@@ -9084,7 +9084,7 @@
           <p:cNvPr id="8" name="">
             <a:extLst xmlns:a="http://schemas.openxmlformats.org/drawingml/2006/main">
               <a:ext uri="{FF2B5EF4-FFF2-40B4-BE49-F238E27FC236}">
-                <a16:creationId xmlns:a16="http://schemas.microsoft.com/office/drawing/2014/main" id="{43F68E70-6906-4ED9-B4FC-15977FB6D55F}"/>
+                <a16:creationId xmlns:a16="http://schemas.microsoft.com/office/drawing/2014/main" id="{39C08745-BF9A-4D87-8D43-7E29EFFB5218}"/>
               </a:ext>
             </a:extLst>
           </p:cNvPr>
@@ -9134,7 +9134,7 @@
           <p:cNvPr id="9" name="">
             <a:extLst xmlns:a="http://schemas.openxmlformats.org/drawingml/2006/main">
               <a:ext uri="{FF2B5EF4-FFF2-40B4-BE49-F238E27FC236}">
-                <a16:creationId xmlns:a16="http://schemas.microsoft.com/office/drawing/2014/main" id="{CF4792F9-019B-44B1-82BA-D6D13F20EE40}"/>
+                <a16:creationId xmlns:a16="http://schemas.microsoft.com/office/drawing/2014/main" id="{A58824BD-3773-4178-AB6A-33AA78452D77}"/>
               </a:ext>
             </a:extLst>
           </p:cNvPr>
@@ -9167,7 +9167,7 @@
           <p:cNvPr id="10" name="">
             <a:extLst xmlns:a="http://schemas.openxmlformats.org/drawingml/2006/main">
               <a:ext uri="{FF2B5EF4-FFF2-40B4-BE49-F238E27FC236}">
-                <a16:creationId xmlns:a16="http://schemas.microsoft.com/office/drawing/2014/main" id="{6F9A4AEF-0761-49AE-8C45-C6F81FFE8EC4}"/>
+                <a16:creationId xmlns:a16="http://schemas.microsoft.com/office/drawing/2014/main" id="{D2BDA343-4A84-46D8-9303-39BAA7A0141D}"/>
               </a:ext>
             </a:extLst>
           </p:cNvPr>
@@ -9217,7 +9217,7 @@
           <p:cNvPr id="11" name="">
             <a:extLst xmlns:a="http://schemas.openxmlformats.org/drawingml/2006/main">
               <a:ext uri="{FF2B5EF4-FFF2-40B4-BE49-F238E27FC236}">
-                <a16:creationId xmlns:a16="http://schemas.microsoft.com/office/drawing/2014/main" id="{3CB1F52D-655D-4C5F-9EA7-1A56BEF9A502}"/>
+                <a16:creationId xmlns:a16="http://schemas.microsoft.com/office/drawing/2014/main" id="{8E4EA665-5651-40CE-8DCC-01EB0E9732AC}"/>
               </a:ext>
             </a:extLst>
           </p:cNvPr>
@@ -9267,7 +9267,7 @@
           <p:cNvPr id="12" name="">
             <a:extLst xmlns:a="http://schemas.openxmlformats.org/drawingml/2006/main">
               <a:ext uri="{FF2B5EF4-FFF2-40B4-BE49-F238E27FC236}">
-                <a16:creationId xmlns:a16="http://schemas.microsoft.com/office/drawing/2014/main" id="{01881993-2967-47E2-97C4-0BD89E384163}"/>
+                <a16:creationId xmlns:a16="http://schemas.microsoft.com/office/drawing/2014/main" id="{373F8BF8-1F1C-45AC-8E85-FE6F49FDDFFC}"/>
               </a:ext>
             </a:extLst>
           </p:cNvPr>
@@ -9317,7 +9317,7 @@
           <p:cNvPr id="13" name="">
             <a:extLst xmlns:a="http://schemas.openxmlformats.org/drawingml/2006/main">
               <a:ext uri="{FF2B5EF4-FFF2-40B4-BE49-F238E27FC236}">
-                <a16:creationId xmlns:a16="http://schemas.microsoft.com/office/drawing/2014/main" id="{A9AB8056-E476-4CA1-952E-8ABCCD137C25}"/>
+                <a16:creationId xmlns:a16="http://schemas.microsoft.com/office/drawing/2014/main" id="{2875ABD5-C639-4505-AAEB-E123A04C6A3D}"/>
               </a:ext>
             </a:extLst>
           </p:cNvPr>
@@ -9350,7 +9350,7 @@
           <p:cNvPr id="14" name="">
             <a:extLst xmlns:a="http://schemas.openxmlformats.org/drawingml/2006/main">
               <a:ext uri="{FF2B5EF4-FFF2-40B4-BE49-F238E27FC236}">
-                <a16:creationId xmlns:a16="http://schemas.microsoft.com/office/drawing/2014/main" id="{66A41074-F6BB-4D41-9B33-CDC8EA1CDB8D}"/>
+                <a16:creationId xmlns:a16="http://schemas.microsoft.com/office/drawing/2014/main" id="{42AFE3C0-697C-4FE4-B192-4EB30599417D}"/>
               </a:ext>
             </a:extLst>
           </p:cNvPr>
@@ -9400,7 +9400,7 @@
           <p:cNvPr id="15" name="">
             <a:extLst xmlns:a="http://schemas.openxmlformats.org/drawingml/2006/main">
               <a:ext uri="{FF2B5EF4-FFF2-40B4-BE49-F238E27FC236}">
-                <a16:creationId xmlns:a16="http://schemas.microsoft.com/office/drawing/2014/main" id="{DC589B1B-3F24-4417-91A6-B8555FA1E5A7}"/>
+                <a16:creationId xmlns:a16="http://schemas.microsoft.com/office/drawing/2014/main" id="{84ADAC95-836C-46DA-82C7-7EB8C4D66A58}"/>
               </a:ext>
             </a:extLst>
           </p:cNvPr>
@@ -9450,7 +9450,7 @@
           <p:cNvPr id="16" name="">
             <a:extLst xmlns:a="http://schemas.openxmlformats.org/drawingml/2006/main">
               <a:ext uri="{FF2B5EF4-FFF2-40B4-BE49-F238E27FC236}">
-                <a16:creationId xmlns:a16="http://schemas.microsoft.com/office/drawing/2014/main" id="{6D86C8CF-BAAE-45CB-AA7A-748774AD441E}"/>
+                <a16:creationId xmlns:a16="http://schemas.microsoft.com/office/drawing/2014/main" id="{B7815D62-5F29-46D4-94AA-D688EE54C981}"/>
               </a:ext>
             </a:extLst>
           </p:cNvPr>
@@ -9500,7 +9500,7 @@
           <p:cNvPr id="17" name="">
             <a:extLst xmlns:a="http://schemas.openxmlformats.org/drawingml/2006/main">
               <a:ext uri="{FF2B5EF4-FFF2-40B4-BE49-F238E27FC236}">
-                <a16:creationId xmlns:a16="http://schemas.microsoft.com/office/drawing/2014/main" id="{95709A27-F502-4737-BCB2-E1D10B57DD40}"/>
+                <a16:creationId xmlns:a16="http://schemas.microsoft.com/office/drawing/2014/main" id="{B03500AF-351C-4806-B62D-C24D632C8E48}"/>
               </a:ext>
             </a:extLst>
           </p:cNvPr>
@@ -9533,7 +9533,7 @@
           <p:cNvPr id="18" name="">
             <a:extLst xmlns:a="http://schemas.openxmlformats.org/drawingml/2006/main">
               <a:ext uri="{FF2B5EF4-FFF2-40B4-BE49-F238E27FC236}">
-                <a16:creationId xmlns:a16="http://schemas.microsoft.com/office/drawing/2014/main" id="{DBD0032F-6526-427B-B77B-D6A799475E53}"/>
+                <a16:creationId xmlns:a16="http://schemas.microsoft.com/office/drawing/2014/main" id="{A3F3C2BB-9D60-43C9-97D4-3FA05E25530E}"/>
               </a:ext>
             </a:extLst>
           </p:cNvPr>
@@ -9583,7 +9583,7 @@
           <p:cNvPr id="19" name="">
             <a:extLst xmlns:a="http://schemas.openxmlformats.org/drawingml/2006/main">
               <a:ext uri="{FF2B5EF4-FFF2-40B4-BE49-F238E27FC236}">
-                <a16:creationId xmlns:a16="http://schemas.microsoft.com/office/drawing/2014/main" id="{8B0AB439-4FDE-4CD0-8B97-9217F45DD4E8}"/>
+                <a16:creationId xmlns:a16="http://schemas.microsoft.com/office/drawing/2014/main" id="{FD0FDF58-98C5-4FF0-9395-BA289B194DEA}"/>
               </a:ext>
             </a:extLst>
           </p:cNvPr>
@@ -9633,7 +9633,7 @@
           <p:cNvPr id="20" name="">
             <a:extLst xmlns:a="http://schemas.openxmlformats.org/drawingml/2006/main">
               <a:ext uri="{FF2B5EF4-FFF2-40B4-BE49-F238E27FC236}">
-                <a16:creationId xmlns:a16="http://schemas.microsoft.com/office/drawing/2014/main" id="{34FD22F3-B166-4B2D-8E30-B884ED47AEA7}"/>
+                <a16:creationId xmlns:a16="http://schemas.microsoft.com/office/drawing/2014/main" id="{4F5E8B4E-95E0-45E2-BAF2-D89447BF0BD9}"/>
               </a:ext>
             </a:extLst>
           </p:cNvPr>
@@ -9683,7 +9683,7 @@
           <p:cNvPr id="21" name="">
             <a:extLst xmlns:a="http://schemas.openxmlformats.org/drawingml/2006/main">
               <a:ext uri="{FF2B5EF4-FFF2-40B4-BE49-F238E27FC236}">
-                <a16:creationId xmlns:a16="http://schemas.microsoft.com/office/drawing/2014/main" id="{E4E50072-A120-40DC-9162-9517159ABC6D}"/>
+                <a16:creationId xmlns:a16="http://schemas.microsoft.com/office/drawing/2014/main" id="{31AC4752-20B2-484A-A93A-386947599BDA}"/>
               </a:ext>
             </a:extLst>
           </p:cNvPr>
@@ -9718,7 +9718,7 @@
           <p:cNvPr id="22" name="">
             <a:extLst xmlns:a="http://schemas.openxmlformats.org/drawingml/2006/main">
               <a:ext uri="{FF2B5EF4-FFF2-40B4-BE49-F238E27FC236}">
-                <a16:creationId xmlns:a16="http://schemas.microsoft.com/office/drawing/2014/main" id="{8832E3DB-7C92-4CBE-9C3E-B8618581B272}"/>
+                <a16:creationId xmlns:a16="http://schemas.microsoft.com/office/drawing/2014/main" id="{D830E4E0-6493-4D28-BC93-A5E425BD8554}"/>
               </a:ext>
             </a:extLst>
           </p:cNvPr>
@@ -9751,7 +9751,7 @@
           <p:cNvPr id="23" name="">
             <a:extLst xmlns:a="http://schemas.openxmlformats.org/drawingml/2006/main">
               <a:ext uri="{FF2B5EF4-FFF2-40B4-BE49-F238E27FC236}">
-                <a16:creationId xmlns:a16="http://schemas.microsoft.com/office/drawing/2014/main" id="{1A684DBC-1C0B-4411-9508-DDC275656FA5}"/>
+                <a16:creationId xmlns:a16="http://schemas.microsoft.com/office/drawing/2014/main" id="{5547BEF0-104C-44C1-A936-5E6C95017EB7}"/>
               </a:ext>
             </a:extLst>
           </p:cNvPr>
@@ -9801,7 +9801,7 @@
           <p:cNvPr id="24" name="">
             <a:extLst xmlns:a="http://schemas.openxmlformats.org/drawingml/2006/main">
               <a:ext uri="{FF2B5EF4-FFF2-40B4-BE49-F238E27FC236}">
-                <a16:creationId xmlns:a16="http://schemas.microsoft.com/office/drawing/2014/main" id="{A101C641-6E9E-4853-8BB1-08529925D9A5}"/>
+                <a16:creationId xmlns:a16="http://schemas.microsoft.com/office/drawing/2014/main" id="{F9BEBF91-5CC1-4B53-9AEC-5728045A8AF6}"/>
               </a:ext>
             </a:extLst>
           </p:cNvPr>
@@ -9851,7 +9851,7 @@
           <p:cNvPr id="25" name="">
             <a:extLst xmlns:a="http://schemas.openxmlformats.org/drawingml/2006/main">
               <a:ext uri="{FF2B5EF4-FFF2-40B4-BE49-F238E27FC236}">
-                <a16:creationId xmlns:a16="http://schemas.microsoft.com/office/drawing/2014/main" id="{796FCFF5-6653-43E7-BCF4-4AD5BC94A844}"/>
+                <a16:creationId xmlns:a16="http://schemas.microsoft.com/office/drawing/2014/main" id="{1AFC5BC7-CD42-446C-81F3-22E20741CA5F}"/>
               </a:ext>
             </a:extLst>
           </p:cNvPr>
@@ -9886,7 +9886,7 @@
           <p:cNvPr id="26" name="">
             <a:extLst xmlns:a="http://schemas.openxmlformats.org/drawingml/2006/main">
               <a:ext uri="{FF2B5EF4-FFF2-40B4-BE49-F238E27FC236}">
-                <a16:creationId xmlns:a16="http://schemas.microsoft.com/office/drawing/2014/main" id="{8F74AD91-C4A4-43FE-8CAD-60C7490791BF}"/>
+                <a16:creationId xmlns:a16="http://schemas.microsoft.com/office/drawing/2014/main" id="{4F0C72A4-EB9D-453A-9498-CB7D37AFEB93}"/>
               </a:ext>
             </a:extLst>
           </p:cNvPr>
@@ -9919,7 +9919,7 @@
           <p:cNvPr id="27" name="">
             <a:extLst xmlns:a="http://schemas.openxmlformats.org/drawingml/2006/main">
               <a:ext uri="{FF2B5EF4-FFF2-40B4-BE49-F238E27FC236}">
-                <a16:creationId xmlns:a16="http://schemas.microsoft.com/office/drawing/2014/main" id="{E66E16AF-AD7A-41A3-AB0E-974D3FE0913E}"/>
+                <a16:creationId xmlns:a16="http://schemas.microsoft.com/office/drawing/2014/main" id="{C68224C4-5EBB-4D97-835A-6F2F1597FD30}"/>
               </a:ext>
             </a:extLst>
           </p:cNvPr>
@@ -9969,7 +9969,7 @@
           <p:cNvPr id="28" name="">
             <a:extLst xmlns:a="http://schemas.openxmlformats.org/drawingml/2006/main">
               <a:ext uri="{FF2B5EF4-FFF2-40B4-BE49-F238E27FC236}">
-                <a16:creationId xmlns:a16="http://schemas.microsoft.com/office/drawing/2014/main" id="{A2D8EDAB-AED1-4708-9B96-DB0556CE2905}"/>
+                <a16:creationId xmlns:a16="http://schemas.microsoft.com/office/drawing/2014/main" id="{B7B4B1F3-7BFB-4191-B173-FC8FE127E8EB}"/>
               </a:ext>
             </a:extLst>
           </p:cNvPr>
@@ -10019,7 +10019,7 @@
           <p:cNvPr id="29" name="">
             <a:extLst xmlns:a="http://schemas.openxmlformats.org/drawingml/2006/main">
               <a:ext uri="{FF2B5EF4-FFF2-40B4-BE49-F238E27FC236}">
-                <a16:creationId xmlns:a16="http://schemas.microsoft.com/office/drawing/2014/main" id="{D48EEC33-08F2-4165-9C24-396B6761D5AB}"/>
+                <a16:creationId xmlns:a16="http://schemas.microsoft.com/office/drawing/2014/main" id="{A7ABD24F-12D7-4951-A02C-D2CEBC12B7C9}"/>
               </a:ext>
             </a:extLst>
           </p:cNvPr>
@@ -10050,7 +10050,7 @@
           <p:cNvPr id="30" name="">
             <a:extLst xmlns:a="http://schemas.openxmlformats.org/drawingml/2006/main">
               <a:ext uri="{FF2B5EF4-FFF2-40B4-BE49-F238E27FC236}">
-                <a16:creationId xmlns:a16="http://schemas.microsoft.com/office/drawing/2014/main" id="{95441A7D-6A45-4A19-9428-32686F0AB0E8}"/>
+                <a16:creationId xmlns:a16="http://schemas.microsoft.com/office/drawing/2014/main" id="{63D80787-EC3C-4D11-A5D5-FAFF947EC8FD}"/>
               </a:ext>
             </a:extLst>
           </p:cNvPr>
@@ -10100,7 +10100,7 @@
           <p:cNvPr id="31" name="">
             <a:extLst xmlns:a="http://schemas.openxmlformats.org/drawingml/2006/main">
               <a:ext uri="{FF2B5EF4-FFF2-40B4-BE49-F238E27FC236}">
-                <a16:creationId xmlns:a16="http://schemas.microsoft.com/office/drawing/2014/main" id="{D0551B71-9825-4C62-BF29-690793FBE563}"/>
+                <a16:creationId xmlns:a16="http://schemas.microsoft.com/office/drawing/2014/main" id="{77B0B2B2-0C1D-4C9D-B4AF-8AC5C2ABFC95}"/>
               </a:ext>
             </a:extLst>
           </p:cNvPr>
@@ -10148,7 +10148,7 @@
     </p:spTree>
     <p:extLst>
       <p:ext uri="{BB962C8B-B14F-4D97-AF65-F5344CB8AC3E}">
-        <p14:creationId xmlns:p14="http://schemas.microsoft.com/office/powerpoint/2010/main" val="941847554"/>
+        <p14:creationId xmlns:p14="http://schemas.microsoft.com/office/powerpoint/2010/main" val="1027765503"/>
       </p:ext>
     </p:extLst>
   </p:cSld>
@@ -10179,7 +10179,7 @@
           <p:cNvPr id="24" name="">
             <a:extLst xmlns:a="http://schemas.openxmlformats.org/drawingml/2006/main">
               <a:ext uri="{FF2B5EF4-FFF2-40B4-BE49-F238E27FC236}">
-                <a16:creationId xmlns:a16="http://schemas.microsoft.com/office/drawing/2014/main" id="{98CA26BF-D0E8-41F0-9CE8-E12DEA72797E}"/>
+                <a16:creationId xmlns:a16="http://schemas.microsoft.com/office/drawing/2014/main" id="{FAAAAB4A-CB33-4D07-80D9-98998B741504}"/>
               </a:ext>
             </a:extLst>
           </p:cNvPr>
@@ -10229,7 +10229,7 @@
           <p:cNvPr id="2" name="">
             <a:extLst xmlns:a="http://schemas.openxmlformats.org/drawingml/2006/main">
               <a:ext uri="{FF2B5EF4-FFF2-40B4-BE49-F238E27FC236}">
-                <a16:creationId xmlns:a16="http://schemas.microsoft.com/office/drawing/2014/main" id="{03421219-C4F2-44D7-A03D-651C398016B9}"/>
+                <a16:creationId xmlns:a16="http://schemas.microsoft.com/office/drawing/2014/main" id="{EE8F30D9-CA62-44AD-BC48-28AF7ED90742}"/>
               </a:ext>
             </a:extLst>
           </p:cNvPr>
@@ -10279,7 +10279,7 @@
           <p:cNvPr id="3" name="">
             <a:extLst xmlns:a="http://schemas.openxmlformats.org/drawingml/2006/main">
               <a:ext uri="{FF2B5EF4-FFF2-40B4-BE49-F238E27FC236}">
-                <a16:creationId xmlns:a16="http://schemas.microsoft.com/office/drawing/2014/main" id="{7B279057-79FA-45B4-BEBD-FEAE67E7C4AE}"/>
+                <a16:creationId xmlns:a16="http://schemas.microsoft.com/office/drawing/2014/main" id="{381BCBE6-FEF0-4241-9168-CE9F45F142CB}"/>
               </a:ext>
             </a:extLst>
           </p:cNvPr>
@@ -10329,7 +10329,7 @@
           <p:cNvPr id="4" name="">
             <a:extLst xmlns:a="http://schemas.openxmlformats.org/drawingml/2006/main">
               <a:ext uri="{FF2B5EF4-FFF2-40B4-BE49-F238E27FC236}">
-                <a16:creationId xmlns:a16="http://schemas.microsoft.com/office/drawing/2014/main" id="{E85D0784-C8BF-459C-8105-2893F6990E02}"/>
+                <a16:creationId xmlns:a16="http://schemas.microsoft.com/office/drawing/2014/main" id="{CC9DC1D8-36B7-41E2-8402-0216352AEAED}"/>
               </a:ext>
             </a:extLst>
           </p:cNvPr>
@@ -10360,7 +10360,7 @@
           <p:cNvPr id="5" name="">
             <a:extLst xmlns:a="http://schemas.openxmlformats.org/drawingml/2006/main">
               <a:ext uri="{FF2B5EF4-FFF2-40B4-BE49-F238E27FC236}">
-                <a16:creationId xmlns:a16="http://schemas.microsoft.com/office/drawing/2014/main" id="{4A05054F-D9F0-4D1B-8992-377220D691AE}"/>
+                <a16:creationId xmlns:a16="http://schemas.microsoft.com/office/drawing/2014/main" id="{B22FDC39-0145-4000-9F88-6D9CA60FAB0E}"/>
               </a:ext>
             </a:extLst>
           </p:cNvPr>
@@ -10395,7 +10395,7 @@
           <p:cNvPr id="6" name="">
             <a:extLst xmlns:a="http://schemas.openxmlformats.org/drawingml/2006/main">
               <a:ext uri="{FF2B5EF4-FFF2-40B4-BE49-F238E27FC236}">
-                <a16:creationId xmlns:a16="http://schemas.microsoft.com/office/drawing/2014/main" id="{346D8573-B026-4C75-9FA2-FCC16F456441}"/>
+                <a16:creationId xmlns:a16="http://schemas.microsoft.com/office/drawing/2014/main" id="{AFB6C932-6BB3-422B-98CC-C8DE4BCBE2BB}"/>
               </a:ext>
             </a:extLst>
           </p:cNvPr>
@@ -10445,7 +10445,7 @@
           <p:cNvPr id="7" name="">
             <a:extLst xmlns:a="http://schemas.openxmlformats.org/drawingml/2006/main">
               <a:ext uri="{FF2B5EF4-FFF2-40B4-BE49-F238E27FC236}">
-                <a16:creationId xmlns:a16="http://schemas.microsoft.com/office/drawing/2014/main" id="{7A9EE9FC-B428-4929-BACB-67A755033DEA}"/>
+                <a16:creationId xmlns:a16="http://schemas.microsoft.com/office/drawing/2014/main" id="{CF5D02E9-1869-4531-9B86-316296BAB292}"/>
               </a:ext>
             </a:extLst>
           </p:cNvPr>
@@ -10502,7 +10502,7 @@
         </p:xfrm>
         <a:graphic xmlns:a="http://schemas.openxmlformats.org/drawingml/2006/main">
           <a:graphicData uri="http://schemas.openxmlformats.org/drawingml/2006/chart">
-            <c:chart xmlns:r="http://schemas.openxmlformats.org/officeDocument/2006/relationships" xmlns:c="http://schemas.openxmlformats.org/drawingml/2006/chart" r:id="R32981635c28a4ecd"/>
+            <c:chart xmlns:r="http://schemas.openxmlformats.org/officeDocument/2006/relationships" xmlns:c="http://schemas.openxmlformats.org/drawingml/2006/chart" r:id="R2b8bdc4413cc4ebf"/>
           </a:graphicData>
         </a:graphic>
       </p:graphicFrame>
@@ -10511,7 +10511,7 @@
           <p:cNvPr id="9" name="">
             <a:extLst xmlns:a="http://schemas.openxmlformats.org/drawingml/2006/main">
               <a:ext uri="{FF2B5EF4-FFF2-40B4-BE49-F238E27FC236}">
-                <a16:creationId xmlns:a16="http://schemas.microsoft.com/office/drawing/2014/main" id="{98CBABD1-B16F-417C-AA22-D455CF755660}"/>
+                <a16:creationId xmlns:a16="http://schemas.microsoft.com/office/drawing/2014/main" id="{6976827B-EB15-4DB2-8027-D268A3970B53}"/>
               </a:ext>
             </a:extLst>
           </p:cNvPr>
@@ -10544,7 +10544,7 @@
           <p:cNvPr id="10" name="">
             <a:extLst xmlns:a="http://schemas.openxmlformats.org/drawingml/2006/main">
               <a:ext uri="{FF2B5EF4-FFF2-40B4-BE49-F238E27FC236}">
-                <a16:creationId xmlns:a16="http://schemas.microsoft.com/office/drawing/2014/main" id="{AB0843DD-4C9B-476A-9717-A1936ACFDD1C}"/>
+                <a16:creationId xmlns:a16="http://schemas.microsoft.com/office/drawing/2014/main" id="{F8A41BD3-E969-4628-AD28-883B9CC2B5F2}"/>
               </a:ext>
             </a:extLst>
           </p:cNvPr>
@@ -10594,7 +10594,7 @@
           <p:cNvPr id="11" name="">
             <a:extLst xmlns:a="http://schemas.openxmlformats.org/drawingml/2006/main">
               <a:ext uri="{FF2B5EF4-FFF2-40B4-BE49-F238E27FC236}">
-                <a16:creationId xmlns:a16="http://schemas.microsoft.com/office/drawing/2014/main" id="{8594E8AD-DCF2-4B91-B997-BC62C240D3AF}"/>
+                <a16:creationId xmlns:a16="http://schemas.microsoft.com/office/drawing/2014/main" id="{1009AB41-0E65-4BB8-A5F6-F45AF6905B40}"/>
               </a:ext>
             </a:extLst>
           </p:cNvPr>
@@ -10644,7 +10644,7 @@
           <p:cNvPr id="12" name="">
             <a:extLst xmlns:a="http://schemas.openxmlformats.org/drawingml/2006/main">
               <a:ext uri="{FF2B5EF4-FFF2-40B4-BE49-F238E27FC236}">
-                <a16:creationId xmlns:a16="http://schemas.microsoft.com/office/drawing/2014/main" id="{60C84BCA-843A-43CF-8062-1D2E42B28F76}"/>
+                <a16:creationId xmlns:a16="http://schemas.microsoft.com/office/drawing/2014/main" id="{46A4657F-0E51-4053-AFE3-25BEE2E86F30}"/>
               </a:ext>
             </a:extLst>
           </p:cNvPr>
@@ -10694,7 +10694,7 @@
           <p:cNvPr id="13" name="">
             <a:extLst xmlns:a="http://schemas.openxmlformats.org/drawingml/2006/main">
               <a:ext uri="{FF2B5EF4-FFF2-40B4-BE49-F238E27FC236}">
-                <a16:creationId xmlns:a16="http://schemas.microsoft.com/office/drawing/2014/main" id="{04250F4E-ABEE-4456-BF3C-0B2F6A22E769}"/>
+                <a16:creationId xmlns:a16="http://schemas.microsoft.com/office/drawing/2014/main" id="{DFEE34E4-6621-4D79-832B-7D293FBFD131}"/>
               </a:ext>
             </a:extLst>
           </p:cNvPr>
@@ -10727,7 +10727,7 @@
           <p:cNvPr id="14" name="">
             <a:extLst xmlns:a="http://schemas.openxmlformats.org/drawingml/2006/main">
               <a:ext uri="{FF2B5EF4-FFF2-40B4-BE49-F238E27FC236}">
-                <a16:creationId xmlns:a16="http://schemas.microsoft.com/office/drawing/2014/main" id="{BC658E7E-4749-4059-B956-A1F97991356F}"/>
+                <a16:creationId xmlns:a16="http://schemas.microsoft.com/office/drawing/2014/main" id="{D0921806-B96D-410F-972D-E41CBFF91A95}"/>
               </a:ext>
             </a:extLst>
           </p:cNvPr>
@@ -10777,7 +10777,7 @@
           <p:cNvPr id="15" name="">
             <a:extLst xmlns:a="http://schemas.openxmlformats.org/drawingml/2006/main">
               <a:ext uri="{FF2B5EF4-FFF2-40B4-BE49-F238E27FC236}">
-                <a16:creationId xmlns:a16="http://schemas.microsoft.com/office/drawing/2014/main" id="{F3655BB5-7237-47EE-9FC0-F7A9FEBFA0B2}"/>
+                <a16:creationId xmlns:a16="http://schemas.microsoft.com/office/drawing/2014/main" id="{54D69E08-3A87-4EE7-9F06-A523E2D1F289}"/>
               </a:ext>
             </a:extLst>
           </p:cNvPr>
@@ -10827,7 +10827,7 @@
           <p:cNvPr id="16" name="">
             <a:extLst xmlns:a="http://schemas.openxmlformats.org/drawingml/2006/main">
               <a:ext uri="{FF2B5EF4-FFF2-40B4-BE49-F238E27FC236}">
-                <a16:creationId xmlns:a16="http://schemas.microsoft.com/office/drawing/2014/main" id="{3B388779-D7FD-45CB-BE0A-B65834AD104B}"/>
+                <a16:creationId xmlns:a16="http://schemas.microsoft.com/office/drawing/2014/main" id="{1CC3E3DF-EBEF-47C5-B92B-067CB56C5556}"/>
               </a:ext>
             </a:extLst>
           </p:cNvPr>
@@ -10877,7 +10877,7 @@
           <p:cNvPr id="17" name="">
             <a:extLst xmlns:a="http://schemas.openxmlformats.org/drawingml/2006/main">
               <a:ext uri="{FF2B5EF4-FFF2-40B4-BE49-F238E27FC236}">
-                <a16:creationId xmlns:a16="http://schemas.microsoft.com/office/drawing/2014/main" id="{912B83D6-C50A-4CEF-A634-EB5F38FF09FA}"/>
+                <a16:creationId xmlns:a16="http://schemas.microsoft.com/office/drawing/2014/main" id="{5FAD57F7-E67D-45F0-882F-77B06D5E0284}"/>
               </a:ext>
             </a:extLst>
           </p:cNvPr>
@@ -10912,7 +10912,7 @@
           <p:cNvPr id="18" name="">
             <a:extLst xmlns:a="http://schemas.openxmlformats.org/drawingml/2006/main">
               <a:ext uri="{FF2B5EF4-FFF2-40B4-BE49-F238E27FC236}">
-                <a16:creationId xmlns:a16="http://schemas.microsoft.com/office/drawing/2014/main" id="{44DD99B6-1197-4F33-AE89-E0D50C9713FA}"/>
+                <a16:creationId xmlns:a16="http://schemas.microsoft.com/office/drawing/2014/main" id="{AE7BDB4E-947B-41BC-95AD-7BC5590ED2BE}"/>
               </a:ext>
             </a:extLst>
           </p:cNvPr>
@@ -10945,7 +10945,7 @@
           <p:cNvPr id="19" name="">
             <a:extLst xmlns:a="http://schemas.openxmlformats.org/drawingml/2006/main">
               <a:ext uri="{FF2B5EF4-FFF2-40B4-BE49-F238E27FC236}">
-                <a16:creationId xmlns:a16="http://schemas.microsoft.com/office/drawing/2014/main" id="{89681D22-213E-4AAC-B7D1-7FA0F4663DD8}"/>
+                <a16:creationId xmlns:a16="http://schemas.microsoft.com/office/drawing/2014/main" id="{4952FD3A-F2CF-48B2-9409-D4434D7DBBC2}"/>
               </a:ext>
             </a:extLst>
           </p:cNvPr>
@@ -10995,7 +10995,7 @@
           <p:cNvPr id="20" name="">
             <a:extLst xmlns:a="http://schemas.openxmlformats.org/drawingml/2006/main">
               <a:ext uri="{FF2B5EF4-FFF2-40B4-BE49-F238E27FC236}">
-                <a16:creationId xmlns:a16="http://schemas.microsoft.com/office/drawing/2014/main" id="{7CBF5906-FF5C-4B30-A3DC-CC36183D710F}"/>
+                <a16:creationId xmlns:a16="http://schemas.microsoft.com/office/drawing/2014/main" id="{24138CF4-996E-4594-85FF-073A199BD553}"/>
               </a:ext>
             </a:extLst>
           </p:cNvPr>
@@ -11045,7 +11045,7 @@
           <p:cNvPr id="21" name="">
             <a:extLst xmlns:a="http://schemas.openxmlformats.org/drawingml/2006/main">
               <a:ext uri="{FF2B5EF4-FFF2-40B4-BE49-F238E27FC236}">
-                <a16:creationId xmlns:a16="http://schemas.microsoft.com/office/drawing/2014/main" id="{362428E3-377B-4953-A659-46AF92E5CE6E}"/>
+                <a16:creationId xmlns:a16="http://schemas.microsoft.com/office/drawing/2014/main" id="{278EACC3-0012-4EFD-A2FC-A448629ECB02}"/>
               </a:ext>
             </a:extLst>
           </p:cNvPr>
@@ -11076,7 +11076,7 @@
           <p:cNvPr id="22" name="">
             <a:extLst xmlns:a="http://schemas.openxmlformats.org/drawingml/2006/main">
               <a:ext uri="{FF2B5EF4-FFF2-40B4-BE49-F238E27FC236}">
-                <a16:creationId xmlns:a16="http://schemas.microsoft.com/office/drawing/2014/main" id="{13CA9660-1071-4F96-BB86-3309B1B4070C}"/>
+                <a16:creationId xmlns:a16="http://schemas.microsoft.com/office/drawing/2014/main" id="{77E36802-AD41-404E-9D45-3477646D36C4}"/>
               </a:ext>
             </a:extLst>
           </p:cNvPr>
@@ -11126,7 +11126,7 @@
           <p:cNvPr id="23" name="">
             <a:extLst xmlns:a="http://schemas.openxmlformats.org/drawingml/2006/main">
               <a:ext uri="{FF2B5EF4-FFF2-40B4-BE49-F238E27FC236}">
-                <a16:creationId xmlns:a16="http://schemas.microsoft.com/office/drawing/2014/main" id="{8CF590CA-472E-4F40-9A73-916A5CF76997}"/>
+                <a16:creationId xmlns:a16="http://schemas.microsoft.com/office/drawing/2014/main" id="{7EB62FE5-2A46-4B9C-B2A2-71EB06E48C5B}"/>
               </a:ext>
             </a:extLst>
           </p:cNvPr>
@@ -11174,7 +11174,7 @@
     </p:spTree>
     <p:extLst>
       <p:ext uri="{BB962C8B-B14F-4D97-AF65-F5344CB8AC3E}">
-        <p14:creationId xmlns:p14="http://schemas.microsoft.com/office/powerpoint/2010/main" val="33826178"/>
+        <p14:creationId xmlns:p14="http://schemas.microsoft.com/office/powerpoint/2010/main" val="1289986801"/>
       </p:ext>
     </p:extLst>
   </p:cSld>
@@ -11205,7 +11205,7 @@
           <p:cNvPr id="24" name="">
             <a:extLst xmlns:a="http://schemas.openxmlformats.org/drawingml/2006/main">
               <a:ext uri="{FF2B5EF4-FFF2-40B4-BE49-F238E27FC236}">
-                <a16:creationId xmlns:a16="http://schemas.microsoft.com/office/drawing/2014/main" id="{80467EFE-CED0-4A32-A8D9-7BD26411390C}"/>
+                <a16:creationId xmlns:a16="http://schemas.microsoft.com/office/drawing/2014/main" id="{F7687F18-0224-44B4-A3B1-0EB4B4E5155D}"/>
               </a:ext>
             </a:extLst>
           </p:cNvPr>
@@ -11255,7 +11255,7 @@
           <p:cNvPr id="2" name="">
             <a:extLst xmlns:a="http://schemas.openxmlformats.org/drawingml/2006/main">
               <a:ext uri="{FF2B5EF4-FFF2-40B4-BE49-F238E27FC236}">
-                <a16:creationId xmlns:a16="http://schemas.microsoft.com/office/drawing/2014/main" id="{BE772748-AF6E-491E-8CF5-8D555C69F693}"/>
+                <a16:creationId xmlns:a16="http://schemas.microsoft.com/office/drawing/2014/main" id="{88D93548-C700-4938-8009-B6DB5C0F129B}"/>
               </a:ext>
             </a:extLst>
           </p:cNvPr>
@@ -11305,7 +11305,7 @@
           <p:cNvPr id="3" name="">
             <a:extLst xmlns:a="http://schemas.openxmlformats.org/drawingml/2006/main">
               <a:ext uri="{FF2B5EF4-FFF2-40B4-BE49-F238E27FC236}">
-                <a16:creationId xmlns:a16="http://schemas.microsoft.com/office/drawing/2014/main" id="{B24D78A4-10A9-4446-AE44-5ED901E29C3A}"/>
+                <a16:creationId xmlns:a16="http://schemas.microsoft.com/office/drawing/2014/main" id="{8E177E8F-D0C0-4E6E-B73F-6CAF8D674F99}"/>
               </a:ext>
             </a:extLst>
           </p:cNvPr>
@@ -11355,7 +11355,7 @@
           <p:cNvPr id="4" name="">
             <a:extLst xmlns:a="http://schemas.openxmlformats.org/drawingml/2006/main">
               <a:ext uri="{FF2B5EF4-FFF2-40B4-BE49-F238E27FC236}">
-                <a16:creationId xmlns:a16="http://schemas.microsoft.com/office/drawing/2014/main" id="{02166FCE-FC90-41AE-A5C4-E68E1A206C10}"/>
+                <a16:creationId xmlns:a16="http://schemas.microsoft.com/office/drawing/2014/main" id="{E86165B3-6512-4643-9E6A-C7D96B232D3D}"/>
               </a:ext>
             </a:extLst>
           </p:cNvPr>
@@ -11386,7 +11386,7 @@
           <p:cNvPr id="5" name="">
             <a:extLst xmlns:a="http://schemas.openxmlformats.org/drawingml/2006/main">
               <a:ext uri="{FF2B5EF4-FFF2-40B4-BE49-F238E27FC236}">
-                <a16:creationId xmlns:a16="http://schemas.microsoft.com/office/drawing/2014/main" id="{68741D75-52D8-4690-8F06-E0C4F594FD9F}"/>
+                <a16:creationId xmlns:a16="http://schemas.microsoft.com/office/drawing/2014/main" id="{92B9CC30-5A2E-4BDC-9EE5-86BE957E3B1B}"/>
               </a:ext>
             </a:extLst>
           </p:cNvPr>
@@ -11421,7 +11421,7 @@
           <p:cNvPr id="6" name="">
             <a:extLst xmlns:a="http://schemas.openxmlformats.org/drawingml/2006/main">
               <a:ext uri="{FF2B5EF4-FFF2-40B4-BE49-F238E27FC236}">
-                <a16:creationId xmlns:a16="http://schemas.microsoft.com/office/drawing/2014/main" id="{25F47E6A-C8C2-45BF-BF00-4D5ADD11209A}"/>
+                <a16:creationId xmlns:a16="http://schemas.microsoft.com/office/drawing/2014/main" id="{97F1D44B-606E-44E1-8560-B10418DF1388}"/>
               </a:ext>
             </a:extLst>
           </p:cNvPr>
@@ -11471,7 +11471,7 @@
           <p:cNvPr id="7" name="">
             <a:extLst xmlns:a="http://schemas.openxmlformats.org/drawingml/2006/main">
               <a:ext uri="{FF2B5EF4-FFF2-40B4-BE49-F238E27FC236}">
-                <a16:creationId xmlns:a16="http://schemas.microsoft.com/office/drawing/2014/main" id="{A82E6F01-62D3-44CA-ADFE-168C08FC289F}"/>
+                <a16:creationId xmlns:a16="http://schemas.microsoft.com/office/drawing/2014/main" id="{B43D39A6-4AEE-4B6D-88F4-89312E892FEB}"/>
               </a:ext>
             </a:extLst>
           </p:cNvPr>
@@ -11528,7 +11528,7 @@
         </p:xfrm>
         <a:graphic xmlns:a="http://schemas.openxmlformats.org/drawingml/2006/main">
           <a:graphicData uri="http://schemas.openxmlformats.org/drawingml/2006/chart">
-            <c:chart xmlns:r="http://schemas.openxmlformats.org/officeDocument/2006/relationships" xmlns:c="http://schemas.openxmlformats.org/drawingml/2006/chart" r:id="R3d28be5067304e55"/>
+            <c:chart xmlns:r="http://schemas.openxmlformats.org/officeDocument/2006/relationships" xmlns:c="http://schemas.openxmlformats.org/drawingml/2006/chart" r:id="R10892901339a41ac"/>
           </a:graphicData>
         </a:graphic>
       </p:graphicFrame>
@@ -11537,7 +11537,7 @@
           <p:cNvPr id="9" name="">
             <a:extLst xmlns:a="http://schemas.openxmlformats.org/drawingml/2006/main">
               <a:ext uri="{FF2B5EF4-FFF2-40B4-BE49-F238E27FC236}">
-                <a16:creationId xmlns:a16="http://schemas.microsoft.com/office/drawing/2014/main" id="{446313B0-8590-4E31-91EF-D4BE2D39C22D}"/>
+                <a16:creationId xmlns:a16="http://schemas.microsoft.com/office/drawing/2014/main" id="{5CE40187-3064-4330-AF7B-3FC0BEDA5E1F}"/>
               </a:ext>
             </a:extLst>
           </p:cNvPr>
@@ -11570,7 +11570,7 @@
           <p:cNvPr id="10" name="">
             <a:extLst xmlns:a="http://schemas.openxmlformats.org/drawingml/2006/main">
               <a:ext uri="{FF2B5EF4-FFF2-40B4-BE49-F238E27FC236}">
-                <a16:creationId xmlns:a16="http://schemas.microsoft.com/office/drawing/2014/main" id="{4731B232-9143-4D9C-AF32-1F4C968F22F6}"/>
+                <a16:creationId xmlns:a16="http://schemas.microsoft.com/office/drawing/2014/main" id="{4C1FFE2E-8221-41E8-98BF-1F38B440C94F}"/>
               </a:ext>
             </a:extLst>
           </p:cNvPr>
@@ -11620,7 +11620,7 @@
           <p:cNvPr id="11" name="">
             <a:extLst xmlns:a="http://schemas.openxmlformats.org/drawingml/2006/main">
               <a:ext uri="{FF2B5EF4-FFF2-40B4-BE49-F238E27FC236}">
-                <a16:creationId xmlns:a16="http://schemas.microsoft.com/office/drawing/2014/main" id="{937370E0-C32C-443A-8B4E-C37C305D30F1}"/>
+                <a16:creationId xmlns:a16="http://schemas.microsoft.com/office/drawing/2014/main" id="{37AB2724-CF2D-4F53-A0C0-1FC2BA7B96D7}"/>
               </a:ext>
             </a:extLst>
           </p:cNvPr>
@@ -11670,7 +11670,7 @@
           <p:cNvPr id="12" name="">
             <a:extLst xmlns:a="http://schemas.openxmlformats.org/drawingml/2006/main">
               <a:ext uri="{FF2B5EF4-FFF2-40B4-BE49-F238E27FC236}">
-                <a16:creationId xmlns:a16="http://schemas.microsoft.com/office/drawing/2014/main" id="{A7CCA297-B5FA-466F-AE07-55009201921E}"/>
+                <a16:creationId xmlns:a16="http://schemas.microsoft.com/office/drawing/2014/main" id="{F8438445-2862-49CB-9F51-AB19F434F69F}"/>
               </a:ext>
             </a:extLst>
           </p:cNvPr>
@@ -11720,7 +11720,7 @@
           <p:cNvPr id="13" name="">
             <a:extLst xmlns:a="http://schemas.openxmlformats.org/drawingml/2006/main">
               <a:ext uri="{FF2B5EF4-FFF2-40B4-BE49-F238E27FC236}">
-                <a16:creationId xmlns:a16="http://schemas.microsoft.com/office/drawing/2014/main" id="{784F27E3-1AAE-4DE0-8AE3-C4C4DA824B51}"/>
+                <a16:creationId xmlns:a16="http://schemas.microsoft.com/office/drawing/2014/main" id="{209C16C8-3392-4CFB-9B4D-21B04E5BFBEF}"/>
               </a:ext>
             </a:extLst>
           </p:cNvPr>
@@ -11753,7 +11753,7 @@
           <p:cNvPr id="14" name="">
             <a:extLst xmlns:a="http://schemas.openxmlformats.org/drawingml/2006/main">
               <a:ext uri="{FF2B5EF4-FFF2-40B4-BE49-F238E27FC236}">
-                <a16:creationId xmlns:a16="http://schemas.microsoft.com/office/drawing/2014/main" id="{6C2AB13F-AE2B-4A87-BFE7-720F60FBB31B}"/>
+                <a16:creationId xmlns:a16="http://schemas.microsoft.com/office/drawing/2014/main" id="{7FD91F98-6525-4EF9-81B8-112E2BB7D744}"/>
               </a:ext>
             </a:extLst>
           </p:cNvPr>
@@ -11803,7 +11803,7 @@
           <p:cNvPr id="15" name="">
             <a:extLst xmlns:a="http://schemas.openxmlformats.org/drawingml/2006/main">
               <a:ext uri="{FF2B5EF4-FFF2-40B4-BE49-F238E27FC236}">
-                <a16:creationId xmlns:a16="http://schemas.microsoft.com/office/drawing/2014/main" id="{B53CF835-862B-4EC6-ABE3-BD0F303B255C}"/>
+                <a16:creationId xmlns:a16="http://schemas.microsoft.com/office/drawing/2014/main" id="{648326BE-47B4-4BF9-89B9-5EF894A930DA}"/>
               </a:ext>
             </a:extLst>
           </p:cNvPr>
@@ -11853,7 +11853,7 @@
           <p:cNvPr id="16" name="">
             <a:extLst xmlns:a="http://schemas.openxmlformats.org/drawingml/2006/main">
               <a:ext uri="{FF2B5EF4-FFF2-40B4-BE49-F238E27FC236}">
-                <a16:creationId xmlns:a16="http://schemas.microsoft.com/office/drawing/2014/main" id="{298D1C83-8448-44F2-8665-15C0C7183AF1}"/>
+                <a16:creationId xmlns:a16="http://schemas.microsoft.com/office/drawing/2014/main" id="{79588B94-130B-4D31-AD7C-479AEA6B91BD}"/>
               </a:ext>
             </a:extLst>
           </p:cNvPr>
@@ -11903,7 +11903,7 @@
           <p:cNvPr id="17" name="">
             <a:extLst xmlns:a="http://schemas.openxmlformats.org/drawingml/2006/main">
               <a:ext uri="{FF2B5EF4-FFF2-40B4-BE49-F238E27FC236}">
-                <a16:creationId xmlns:a16="http://schemas.microsoft.com/office/drawing/2014/main" id="{C30B05F3-2E09-43F2-AF7C-3E692EFBA462}"/>
+                <a16:creationId xmlns:a16="http://schemas.microsoft.com/office/drawing/2014/main" id="{FB8C2C86-74AA-4900-8868-D079EB8B361C}"/>
               </a:ext>
             </a:extLst>
           </p:cNvPr>
@@ -11938,7 +11938,7 @@
           <p:cNvPr id="18" name="">
             <a:extLst xmlns:a="http://schemas.openxmlformats.org/drawingml/2006/main">
               <a:ext uri="{FF2B5EF4-FFF2-40B4-BE49-F238E27FC236}">
-                <a16:creationId xmlns:a16="http://schemas.microsoft.com/office/drawing/2014/main" id="{1A237528-BE81-46FC-902A-C27B8DD4E111}"/>
+                <a16:creationId xmlns:a16="http://schemas.microsoft.com/office/drawing/2014/main" id="{79904D0E-CC57-4158-89B8-5875055755EF}"/>
               </a:ext>
             </a:extLst>
           </p:cNvPr>
@@ -11971,7 +11971,7 @@
           <p:cNvPr id="19" name="">
             <a:extLst xmlns:a="http://schemas.openxmlformats.org/drawingml/2006/main">
               <a:ext uri="{FF2B5EF4-FFF2-40B4-BE49-F238E27FC236}">
-                <a16:creationId xmlns:a16="http://schemas.microsoft.com/office/drawing/2014/main" id="{BB30EE2D-C10C-4803-902F-5E0C2BD56862}"/>
+                <a16:creationId xmlns:a16="http://schemas.microsoft.com/office/drawing/2014/main" id="{F512615A-85E1-4D8B-A5AC-44F2F2F15BF6}"/>
               </a:ext>
             </a:extLst>
           </p:cNvPr>
@@ -12021,7 +12021,7 @@
           <p:cNvPr id="20" name="">
             <a:extLst xmlns:a="http://schemas.openxmlformats.org/drawingml/2006/main">
               <a:ext uri="{FF2B5EF4-FFF2-40B4-BE49-F238E27FC236}">
-                <a16:creationId xmlns:a16="http://schemas.microsoft.com/office/drawing/2014/main" id="{F480F33C-8010-48F4-A0E3-A839C6EFDA49}"/>
+                <a16:creationId xmlns:a16="http://schemas.microsoft.com/office/drawing/2014/main" id="{1C423D98-8B7F-48CA-8A98-BBB3EC5B6721}"/>
               </a:ext>
             </a:extLst>
           </p:cNvPr>
@@ -12071,7 +12071,7 @@
           <p:cNvPr id="21" name="">
             <a:extLst xmlns:a="http://schemas.openxmlformats.org/drawingml/2006/main">
               <a:ext uri="{FF2B5EF4-FFF2-40B4-BE49-F238E27FC236}">
-                <a16:creationId xmlns:a16="http://schemas.microsoft.com/office/drawing/2014/main" id="{290A4C8E-AF93-475B-99ED-14F0CA9A56C6}"/>
+                <a16:creationId xmlns:a16="http://schemas.microsoft.com/office/drawing/2014/main" id="{01AD4F0A-ED8D-4BA2-9AE0-3218B20FBDFD}"/>
               </a:ext>
             </a:extLst>
           </p:cNvPr>
@@ -12102,7 +12102,7 @@
           <p:cNvPr id="22" name="">
             <a:extLst xmlns:a="http://schemas.openxmlformats.org/drawingml/2006/main">
               <a:ext uri="{FF2B5EF4-FFF2-40B4-BE49-F238E27FC236}">
-                <a16:creationId xmlns:a16="http://schemas.microsoft.com/office/drawing/2014/main" id="{1B1DED30-7623-414D-9174-DDD3CB00EDF9}"/>
+                <a16:creationId xmlns:a16="http://schemas.microsoft.com/office/drawing/2014/main" id="{8EC7FB55-927F-4644-9B34-3D90DCE0406D}"/>
               </a:ext>
             </a:extLst>
           </p:cNvPr>
@@ -12152,7 +12152,7 @@
           <p:cNvPr id="23" name="">
             <a:extLst xmlns:a="http://schemas.openxmlformats.org/drawingml/2006/main">
               <a:ext uri="{FF2B5EF4-FFF2-40B4-BE49-F238E27FC236}">
-                <a16:creationId xmlns:a16="http://schemas.microsoft.com/office/drawing/2014/main" id="{FB801AF3-EDD0-48B7-B5C6-314750F6F6D7}"/>
+                <a16:creationId xmlns:a16="http://schemas.microsoft.com/office/drawing/2014/main" id="{8A2EE9CF-28FC-4F93-8989-5995D6A31BC8}"/>
               </a:ext>
             </a:extLst>
           </p:cNvPr>
@@ -12200,7 +12200,7 @@
     </p:spTree>
     <p:extLst>
       <p:ext uri="{BB962C8B-B14F-4D97-AF65-F5344CB8AC3E}">
-        <p14:creationId xmlns:p14="http://schemas.microsoft.com/office/powerpoint/2010/main" val="1213956580"/>
+        <p14:creationId xmlns:p14="http://schemas.microsoft.com/office/powerpoint/2010/main" val="1791906614"/>
       </p:ext>
     </p:extLst>
   </p:cSld>
@@ -12231,7 +12231,7 @@
           <p:cNvPr id="20" name="">
             <a:extLst xmlns:a="http://schemas.openxmlformats.org/drawingml/2006/main">
               <a:ext uri="{FF2B5EF4-FFF2-40B4-BE49-F238E27FC236}">
-                <a16:creationId xmlns:a16="http://schemas.microsoft.com/office/drawing/2014/main" id="{77684974-4689-4CA0-86B2-759C3837FA32}"/>
+                <a16:creationId xmlns:a16="http://schemas.microsoft.com/office/drawing/2014/main" id="{82C8D8B2-669C-436B-81BF-555B09BFC196}"/>
               </a:ext>
             </a:extLst>
           </p:cNvPr>
@@ -12281,7 +12281,7 @@
           <p:cNvPr id="2" name="">
             <a:extLst xmlns:a="http://schemas.openxmlformats.org/drawingml/2006/main">
               <a:ext uri="{FF2B5EF4-FFF2-40B4-BE49-F238E27FC236}">
-                <a16:creationId xmlns:a16="http://schemas.microsoft.com/office/drawing/2014/main" id="{A0D28FF5-18A0-41D4-B629-4300F068F5EB}"/>
+                <a16:creationId xmlns:a16="http://schemas.microsoft.com/office/drawing/2014/main" id="{2B3A1002-BFB7-4B95-AAED-81A6159F19A4}"/>
               </a:ext>
             </a:extLst>
           </p:cNvPr>
@@ -12331,7 +12331,7 @@
           <p:cNvPr id="3" name="">
             <a:extLst xmlns:a="http://schemas.openxmlformats.org/drawingml/2006/main">
               <a:ext uri="{FF2B5EF4-FFF2-40B4-BE49-F238E27FC236}">
-                <a16:creationId xmlns:a16="http://schemas.microsoft.com/office/drawing/2014/main" id="{08C04DAB-AA4E-4F05-86BC-585155B1D6AC}"/>
+                <a16:creationId xmlns:a16="http://schemas.microsoft.com/office/drawing/2014/main" id="{BC3DC52A-29F6-4A27-A6D5-C43CB9876C04}"/>
               </a:ext>
             </a:extLst>
           </p:cNvPr>
@@ -12381,7 +12381,7 @@
           <p:cNvPr id="4" name="">
             <a:extLst xmlns:a="http://schemas.openxmlformats.org/drawingml/2006/main">
               <a:ext uri="{FF2B5EF4-FFF2-40B4-BE49-F238E27FC236}">
-                <a16:creationId xmlns:a16="http://schemas.microsoft.com/office/drawing/2014/main" id="{2B1C5867-652A-482F-8AB7-DF0B45B32420}"/>
+                <a16:creationId xmlns:a16="http://schemas.microsoft.com/office/drawing/2014/main" id="{1D6B7234-7BF2-467C-8329-892332A45887}"/>
               </a:ext>
             </a:extLst>
           </p:cNvPr>
@@ -12412,7 +12412,7 @@
           <p:cNvPr id="5" name="">
             <a:extLst xmlns:a="http://schemas.openxmlformats.org/drawingml/2006/main">
               <a:ext uri="{FF2B5EF4-FFF2-40B4-BE49-F238E27FC236}">
-                <a16:creationId xmlns:a16="http://schemas.microsoft.com/office/drawing/2014/main" id="{5C60C071-65E1-4204-8D8F-3DF2F364BFF9}"/>
+                <a16:creationId xmlns:a16="http://schemas.microsoft.com/office/drawing/2014/main" id="{6E54A8D0-A6CD-4FDE-91BB-5126138C5E0E}"/>
               </a:ext>
             </a:extLst>
           </p:cNvPr>
@@ -12447,7 +12447,7 @@
           <p:cNvPr id="6" name="">
             <a:extLst xmlns:a="http://schemas.openxmlformats.org/drawingml/2006/main">
               <a:ext uri="{FF2B5EF4-FFF2-40B4-BE49-F238E27FC236}">
-                <a16:creationId xmlns:a16="http://schemas.microsoft.com/office/drawing/2014/main" id="{3B8CCC16-97E9-46B1-8C81-460232495D8D}"/>
+                <a16:creationId xmlns:a16="http://schemas.microsoft.com/office/drawing/2014/main" id="{70B6646C-7084-4BB6-8CB3-FC1A1358924E}"/>
               </a:ext>
             </a:extLst>
           </p:cNvPr>
@@ -12497,7 +12497,7 @@
           <p:cNvPr id="7" name="">
             <a:extLst xmlns:a="http://schemas.openxmlformats.org/drawingml/2006/main">
               <a:ext uri="{FF2B5EF4-FFF2-40B4-BE49-F238E27FC236}">
-                <a16:creationId xmlns:a16="http://schemas.microsoft.com/office/drawing/2014/main" id="{DD255E82-294B-41CE-BBA9-783804B23132}"/>
+                <a16:creationId xmlns:a16="http://schemas.microsoft.com/office/drawing/2014/main" id="{55DCF0AA-B878-4855-9F15-81C4C13CE383}"/>
               </a:ext>
             </a:extLst>
           </p:cNvPr>
@@ -12554,7 +12554,7 @@
         </p:xfrm>
         <a:graphic xmlns:a="http://schemas.openxmlformats.org/drawingml/2006/main">
           <a:graphicData uri="http://schemas.openxmlformats.org/drawingml/2006/chart">
-            <c:chart xmlns:r="http://schemas.openxmlformats.org/officeDocument/2006/relationships" xmlns:c="http://schemas.openxmlformats.org/drawingml/2006/chart" r:id="Rd4edc32367ac4ef8"/>
+            <c:chart xmlns:r="http://schemas.openxmlformats.org/officeDocument/2006/relationships" xmlns:c="http://schemas.openxmlformats.org/drawingml/2006/chart" r:id="Rc79f729bcbb54107"/>
           </a:graphicData>
         </a:graphic>
       </p:graphicFrame>
@@ -12563,7 +12563,7 @@
           <p:cNvPr id="9" name="">
             <a:extLst xmlns:a="http://schemas.openxmlformats.org/drawingml/2006/main">
               <a:ext uri="{FF2B5EF4-FFF2-40B4-BE49-F238E27FC236}">
-                <a16:creationId xmlns:a16="http://schemas.microsoft.com/office/drawing/2014/main" id="{C7A73D5A-1E08-4CDE-8163-3F2481302700}"/>
+                <a16:creationId xmlns:a16="http://schemas.microsoft.com/office/drawing/2014/main" id="{90A7D62E-2FBF-40E7-9D3B-E9E235691295}"/>
               </a:ext>
             </a:extLst>
           </p:cNvPr>
@@ -12598,7 +12598,7 @@
           <p:cNvPr id="10" name="">
             <a:extLst xmlns:a="http://schemas.openxmlformats.org/drawingml/2006/main">
               <a:ext uri="{FF2B5EF4-FFF2-40B4-BE49-F238E27FC236}">
-                <a16:creationId xmlns:a16="http://schemas.microsoft.com/office/drawing/2014/main" id="{7C20FB52-2AAB-467A-8CFD-0FBF5DD00103}"/>
+                <a16:creationId xmlns:a16="http://schemas.microsoft.com/office/drawing/2014/main" id="{DB25022D-C0F9-4137-8118-554047B0FEAA}"/>
               </a:ext>
             </a:extLst>
           </p:cNvPr>
@@ -12631,7 +12631,7 @@
           <p:cNvPr id="11" name="">
             <a:extLst xmlns:a="http://schemas.openxmlformats.org/drawingml/2006/main">
               <a:ext uri="{FF2B5EF4-FFF2-40B4-BE49-F238E27FC236}">
-                <a16:creationId xmlns:a16="http://schemas.microsoft.com/office/drawing/2014/main" id="{844D9B97-D52C-441A-B756-D1B3D45D233F}"/>
+                <a16:creationId xmlns:a16="http://schemas.microsoft.com/office/drawing/2014/main" id="{CDE54149-BF92-4AB9-8AAB-E08F5DB58770}"/>
               </a:ext>
             </a:extLst>
           </p:cNvPr>
@@ -12681,7 +12681,7 @@
           <p:cNvPr id="12" name="">
             <a:extLst xmlns:a="http://schemas.openxmlformats.org/drawingml/2006/main">
               <a:ext uri="{FF2B5EF4-FFF2-40B4-BE49-F238E27FC236}">
-                <a16:creationId xmlns:a16="http://schemas.microsoft.com/office/drawing/2014/main" id="{0AA8BA8E-0F73-47C8-A794-EBF2C32BAC3C}"/>
+                <a16:creationId xmlns:a16="http://schemas.microsoft.com/office/drawing/2014/main" id="{D5F88AB9-257B-4C22-AAC9-6E8BFD43ADE6}"/>
               </a:ext>
             </a:extLst>
           </p:cNvPr>
@@ -12731,7 +12731,7 @@
           <p:cNvPr id="13" name="">
             <a:extLst xmlns:a="http://schemas.openxmlformats.org/drawingml/2006/main">
               <a:ext uri="{FF2B5EF4-FFF2-40B4-BE49-F238E27FC236}">
-                <a16:creationId xmlns:a16="http://schemas.microsoft.com/office/drawing/2014/main" id="{08C8EDB3-C827-4ADF-BE9D-C109DE9A661C}"/>
+                <a16:creationId xmlns:a16="http://schemas.microsoft.com/office/drawing/2014/main" id="{AF22335E-718E-4B8F-A497-5997114F9714}"/>
               </a:ext>
             </a:extLst>
           </p:cNvPr>
@@ -12766,7 +12766,7 @@
           <p:cNvPr id="14" name="">
             <a:extLst xmlns:a="http://schemas.openxmlformats.org/drawingml/2006/main">
               <a:ext uri="{FF2B5EF4-FFF2-40B4-BE49-F238E27FC236}">
-                <a16:creationId xmlns:a16="http://schemas.microsoft.com/office/drawing/2014/main" id="{AA97F954-3C45-40F1-9CB8-1F6048C112D0}"/>
+                <a16:creationId xmlns:a16="http://schemas.microsoft.com/office/drawing/2014/main" id="{AC6EE912-1218-4BB2-B1A9-EA7D4673AD8E}"/>
               </a:ext>
             </a:extLst>
           </p:cNvPr>
@@ -12799,7 +12799,7 @@
           <p:cNvPr id="15" name="">
             <a:extLst xmlns:a="http://schemas.openxmlformats.org/drawingml/2006/main">
               <a:ext uri="{FF2B5EF4-FFF2-40B4-BE49-F238E27FC236}">
-                <a16:creationId xmlns:a16="http://schemas.microsoft.com/office/drawing/2014/main" id="{35B2EF73-BF64-4F24-BF8C-32293A3D8924}"/>
+                <a16:creationId xmlns:a16="http://schemas.microsoft.com/office/drawing/2014/main" id="{147B9293-39B5-463E-8FF0-7FF11E3C1740}"/>
               </a:ext>
             </a:extLst>
           </p:cNvPr>
@@ -12849,7 +12849,7 @@
           <p:cNvPr id="16" name="">
             <a:extLst xmlns:a="http://schemas.openxmlformats.org/drawingml/2006/main">
               <a:ext uri="{FF2B5EF4-FFF2-40B4-BE49-F238E27FC236}">
-                <a16:creationId xmlns:a16="http://schemas.microsoft.com/office/drawing/2014/main" id="{8E79E375-63AB-42DF-B37A-96DE4214F7EB}"/>
+                <a16:creationId xmlns:a16="http://schemas.microsoft.com/office/drawing/2014/main" id="{2CC6EC7C-4415-4CB4-AFAE-3DA1BC3E9DD9}"/>
               </a:ext>
             </a:extLst>
           </p:cNvPr>
@@ -12899,7 +12899,7 @@
           <p:cNvPr id="17" name="">
             <a:extLst xmlns:a="http://schemas.openxmlformats.org/drawingml/2006/main">
               <a:ext uri="{FF2B5EF4-FFF2-40B4-BE49-F238E27FC236}">
-                <a16:creationId xmlns:a16="http://schemas.microsoft.com/office/drawing/2014/main" id="{42F68CE9-59A5-491A-8B6C-DCA4673E495F}"/>
+                <a16:creationId xmlns:a16="http://schemas.microsoft.com/office/drawing/2014/main" id="{C20254FB-53E7-4FE4-BF4D-2A39DBD5686D}"/>
               </a:ext>
             </a:extLst>
           </p:cNvPr>
@@ -12930,7 +12930,7 @@
           <p:cNvPr id="18" name="">
             <a:extLst xmlns:a="http://schemas.openxmlformats.org/drawingml/2006/main">
               <a:ext uri="{FF2B5EF4-FFF2-40B4-BE49-F238E27FC236}">
-                <a16:creationId xmlns:a16="http://schemas.microsoft.com/office/drawing/2014/main" id="{8F1CF8CD-31C7-494C-980E-2D8EF3F3F338}"/>
+                <a16:creationId xmlns:a16="http://schemas.microsoft.com/office/drawing/2014/main" id="{055B9573-C5E1-4BC4-AE1F-2045E1D2C6CC}"/>
               </a:ext>
             </a:extLst>
           </p:cNvPr>
@@ -12980,7 +12980,7 @@
           <p:cNvPr id="19" name="">
             <a:extLst xmlns:a="http://schemas.openxmlformats.org/drawingml/2006/main">
               <a:ext uri="{FF2B5EF4-FFF2-40B4-BE49-F238E27FC236}">
-                <a16:creationId xmlns:a16="http://schemas.microsoft.com/office/drawing/2014/main" id="{DC9CF237-22C4-4A47-A679-EE057B971F52}"/>
+                <a16:creationId xmlns:a16="http://schemas.microsoft.com/office/drawing/2014/main" id="{2FAFB9CE-F0B7-4AE1-AB40-37E4AF438CF9}"/>
               </a:ext>
             </a:extLst>
           </p:cNvPr>
@@ -13028,7 +13028,7 @@
     </p:spTree>
     <p:extLst>
       <p:ext uri="{BB962C8B-B14F-4D97-AF65-F5344CB8AC3E}">
-        <p14:creationId xmlns:p14="http://schemas.microsoft.com/office/powerpoint/2010/main" val="1635337557"/>
+        <p14:creationId xmlns:p14="http://schemas.microsoft.com/office/powerpoint/2010/main" val="822011949"/>
       </p:ext>
     </p:extLst>
   </p:cSld>
@@ -13059,7 +13059,7 @@
           <p:cNvPr id="29" name="">
             <a:extLst xmlns:a="http://schemas.openxmlformats.org/drawingml/2006/main">
               <a:ext uri="{FF2B5EF4-FFF2-40B4-BE49-F238E27FC236}">
-                <a16:creationId xmlns:a16="http://schemas.microsoft.com/office/drawing/2014/main" id="{C9167F62-8408-4CBF-8A66-18D3FA941DA4}"/>
+                <a16:creationId xmlns:a16="http://schemas.microsoft.com/office/drawing/2014/main" id="{427EBCC6-BDF4-483F-B888-A9E7E75F83E3}"/>
               </a:ext>
             </a:extLst>
           </p:cNvPr>
@@ -13109,7 +13109,7 @@
           <p:cNvPr id="2" name="">
             <a:extLst xmlns:a="http://schemas.openxmlformats.org/drawingml/2006/main">
               <a:ext uri="{FF2B5EF4-FFF2-40B4-BE49-F238E27FC236}">
-                <a16:creationId xmlns:a16="http://schemas.microsoft.com/office/drawing/2014/main" id="{332B3C0B-CA4A-4622-BC4B-ACBBE5B7E7EB}"/>
+                <a16:creationId xmlns:a16="http://schemas.microsoft.com/office/drawing/2014/main" id="{B0EA93ED-05D5-423F-A793-33831037E2A2}"/>
               </a:ext>
             </a:extLst>
           </p:cNvPr>
@@ -13159,7 +13159,7 @@
           <p:cNvPr id="3" name="">
             <a:extLst xmlns:a="http://schemas.openxmlformats.org/drawingml/2006/main">
               <a:ext uri="{FF2B5EF4-FFF2-40B4-BE49-F238E27FC236}">
-                <a16:creationId xmlns:a16="http://schemas.microsoft.com/office/drawing/2014/main" id="{524F1A8A-7FAA-4904-8A68-E5F71E5476D8}"/>
+                <a16:creationId xmlns:a16="http://schemas.microsoft.com/office/drawing/2014/main" id="{3FA22C11-D22A-4BEB-A126-C758D2757CAD}"/>
               </a:ext>
             </a:extLst>
           </p:cNvPr>
@@ -13209,7 +13209,7 @@
           <p:cNvPr id="4" name="">
             <a:extLst xmlns:a="http://schemas.openxmlformats.org/drawingml/2006/main">
               <a:ext uri="{FF2B5EF4-FFF2-40B4-BE49-F238E27FC236}">
-                <a16:creationId xmlns:a16="http://schemas.microsoft.com/office/drawing/2014/main" id="{DA352C65-6732-485B-8BCC-578F24ADA2FC}"/>
+                <a16:creationId xmlns:a16="http://schemas.microsoft.com/office/drawing/2014/main" id="{B8108BC6-0A9A-407F-AFE2-0AAE5A70EF18}"/>
               </a:ext>
             </a:extLst>
           </p:cNvPr>
@@ -13240,7 +13240,7 @@
           <p:cNvPr id="5" name="">
             <a:extLst xmlns:a="http://schemas.openxmlformats.org/drawingml/2006/main">
               <a:ext uri="{FF2B5EF4-FFF2-40B4-BE49-F238E27FC236}">
-                <a16:creationId xmlns:a16="http://schemas.microsoft.com/office/drawing/2014/main" id="{BBC40B5D-6AC2-4B51-9599-858930D16DE0}"/>
+                <a16:creationId xmlns:a16="http://schemas.microsoft.com/office/drawing/2014/main" id="{B2BC072B-4C03-4107-968E-FB1DE46E4AD4}"/>
               </a:ext>
             </a:extLst>
           </p:cNvPr>
@@ -13275,7 +13275,7 @@
           <p:cNvPr id="6" name="">
             <a:extLst xmlns:a="http://schemas.openxmlformats.org/drawingml/2006/main">
               <a:ext uri="{FF2B5EF4-FFF2-40B4-BE49-F238E27FC236}">
-                <a16:creationId xmlns:a16="http://schemas.microsoft.com/office/drawing/2014/main" id="{F17729C7-A02B-4BE9-AA30-CB33FA585D3F}"/>
+                <a16:creationId xmlns:a16="http://schemas.microsoft.com/office/drawing/2014/main" id="{C4E1A9EC-981F-4E90-ACA9-78A508875ECB}"/>
               </a:ext>
             </a:extLst>
           </p:cNvPr>
@@ -13315,7 +13315,7 @@
                   <a:srgbClr val="12233F"/>
                 </a:solidFill>
               </a:rPr>
-              <a:t>Target accounts by tracked coverage</a:t>
+              <a:t>CRM account domains by tracked coverage</a:t>
             </a:r>
           </a:p>
         </p:txBody>
@@ -13325,7 +13325,7 @@
           <p:cNvPr id="7" name="">
             <a:extLst xmlns:a="http://schemas.openxmlformats.org/drawingml/2006/main">
               <a:ext uri="{FF2B5EF4-FFF2-40B4-BE49-F238E27FC236}">
-                <a16:creationId xmlns:a16="http://schemas.microsoft.com/office/drawing/2014/main" id="{4C7F454C-F662-4F90-8071-8A5BCC2555C3}"/>
+                <a16:creationId xmlns:a16="http://schemas.microsoft.com/office/drawing/2014/main" id="{8F0396CD-929E-441E-B431-0103ACCC339C}"/>
               </a:ext>
             </a:extLst>
           </p:cNvPr>
@@ -13382,7 +13382,7 @@
         </p:xfrm>
         <a:graphic xmlns:a="http://schemas.openxmlformats.org/drawingml/2006/main">
           <a:graphicData uri="http://schemas.openxmlformats.org/drawingml/2006/chart">
-            <c:chart xmlns:r="http://schemas.openxmlformats.org/officeDocument/2006/relationships" xmlns:c="http://schemas.openxmlformats.org/drawingml/2006/chart" r:id="R80cd81c475d24eae"/>
+            <c:chart xmlns:r="http://schemas.openxmlformats.org/officeDocument/2006/relationships" xmlns:c="http://schemas.openxmlformats.org/drawingml/2006/chart" r:id="Rf47205b8966e41eb"/>
           </a:graphicData>
         </a:graphic>
       </p:graphicFrame>
@@ -13391,7 +13391,7 @@
           <p:cNvPr id="9" name="">
             <a:extLst xmlns:a="http://schemas.openxmlformats.org/drawingml/2006/main">
               <a:ext uri="{FF2B5EF4-FFF2-40B4-BE49-F238E27FC236}">
-                <a16:creationId xmlns:a16="http://schemas.microsoft.com/office/drawing/2014/main" id="{C0901596-4008-416D-9D45-58B0F91D9BBF}"/>
+                <a16:creationId xmlns:a16="http://schemas.microsoft.com/office/drawing/2014/main" id="{63CA4A04-CA39-4F73-B11B-00DE79C4CDB5}"/>
               </a:ext>
             </a:extLst>
           </p:cNvPr>
@@ -13441,7 +13441,7 @@
           <p:cNvPr id="10" name="">
             <a:extLst xmlns:a="http://schemas.openxmlformats.org/drawingml/2006/main">
               <a:ext uri="{FF2B5EF4-FFF2-40B4-BE49-F238E27FC236}">
-                <a16:creationId xmlns:a16="http://schemas.microsoft.com/office/drawing/2014/main" id="{06F40E49-840E-4B6F-A27E-6B04F1FF3A5A}"/>
+                <a16:creationId xmlns:a16="http://schemas.microsoft.com/office/drawing/2014/main" id="{FA6EB9D3-D67B-4672-B8C2-F5C5EABADF36}"/>
               </a:ext>
             </a:extLst>
           </p:cNvPr>
@@ -13491,7 +13491,7 @@
           <p:cNvPr id="11" name="">
             <a:extLst xmlns:a="http://schemas.openxmlformats.org/drawingml/2006/main">
               <a:ext uri="{FF2B5EF4-FFF2-40B4-BE49-F238E27FC236}">
-                <a16:creationId xmlns:a16="http://schemas.microsoft.com/office/drawing/2014/main" id="{399EA4C1-E196-4702-B7D4-964E352B69A9}"/>
+                <a16:creationId xmlns:a16="http://schemas.microsoft.com/office/drawing/2014/main" id="{F0568A95-B1ED-46F6-8018-3C9AAC36376A}"/>
               </a:ext>
             </a:extLst>
           </p:cNvPr>
@@ -13541,7 +13541,7 @@
           <p:cNvPr id="12" name="">
             <a:extLst xmlns:a="http://schemas.openxmlformats.org/drawingml/2006/main">
               <a:ext uri="{FF2B5EF4-FFF2-40B4-BE49-F238E27FC236}">
-                <a16:creationId xmlns:a16="http://schemas.microsoft.com/office/drawing/2014/main" id="{F6D0C76D-5A78-4D67-A816-C4FCEFE17C53}"/>
+                <a16:creationId xmlns:a16="http://schemas.microsoft.com/office/drawing/2014/main" id="{76ED9568-5E76-4A05-9BBE-2CAAFCA0733B}"/>
               </a:ext>
             </a:extLst>
           </p:cNvPr>
@@ -13591,7 +13591,7 @@
           <p:cNvPr id="13" name="">
             <a:extLst xmlns:a="http://schemas.openxmlformats.org/drawingml/2006/main">
               <a:ext uri="{FF2B5EF4-FFF2-40B4-BE49-F238E27FC236}">
-                <a16:creationId xmlns:a16="http://schemas.microsoft.com/office/drawing/2014/main" id="{1F153607-9CB3-4615-929D-62DFE845BA50}"/>
+                <a16:creationId xmlns:a16="http://schemas.microsoft.com/office/drawing/2014/main" id="{A14B0D09-5B33-4DE5-A4CB-0497DC8F7511}"/>
               </a:ext>
             </a:extLst>
           </p:cNvPr>
@@ -13641,7 +13641,7 @@
           <p:cNvPr id="14" name="">
             <a:extLst xmlns:a="http://schemas.openxmlformats.org/drawingml/2006/main">
               <a:ext uri="{FF2B5EF4-FFF2-40B4-BE49-F238E27FC236}">
-                <a16:creationId xmlns:a16="http://schemas.microsoft.com/office/drawing/2014/main" id="{6516BE06-530B-4FC1-AD8C-3CA04B81BCB8}"/>
+                <a16:creationId xmlns:a16="http://schemas.microsoft.com/office/drawing/2014/main" id="{EF660941-F4A3-4D82-B617-5B96C0694DF0}"/>
               </a:ext>
             </a:extLst>
           </p:cNvPr>
@@ -13691,7 +13691,7 @@
           <p:cNvPr id="15" name="">
             <a:extLst xmlns:a="http://schemas.openxmlformats.org/drawingml/2006/main">
               <a:ext uri="{FF2B5EF4-FFF2-40B4-BE49-F238E27FC236}">
-                <a16:creationId xmlns:a16="http://schemas.microsoft.com/office/drawing/2014/main" id="{4E79FD1C-1CA4-419D-97B0-AC3070281514}"/>
+                <a16:creationId xmlns:a16="http://schemas.microsoft.com/office/drawing/2014/main" id="{8E85FC37-8904-4DE7-BBD6-76BF95DD793D}"/>
               </a:ext>
             </a:extLst>
           </p:cNvPr>
@@ -13741,7 +13741,7 @@
           <p:cNvPr id="16" name="">
             <a:extLst xmlns:a="http://schemas.openxmlformats.org/drawingml/2006/main">
               <a:ext uri="{FF2B5EF4-FFF2-40B4-BE49-F238E27FC236}">
-                <a16:creationId xmlns:a16="http://schemas.microsoft.com/office/drawing/2014/main" id="{BD399F53-70B0-4E06-8423-0B545C8060D4}"/>
+                <a16:creationId xmlns:a16="http://schemas.microsoft.com/office/drawing/2014/main" id="{6EDBDDBB-0D2E-47A6-AEEC-3072F235C24D}"/>
               </a:ext>
             </a:extLst>
           </p:cNvPr>
@@ -13791,7 +13791,7 @@
           <p:cNvPr id="17" name="">
             <a:extLst xmlns:a="http://schemas.openxmlformats.org/drawingml/2006/main">
               <a:ext uri="{FF2B5EF4-FFF2-40B4-BE49-F238E27FC236}">
-                <a16:creationId xmlns:a16="http://schemas.microsoft.com/office/drawing/2014/main" id="{9D3C1E45-8E92-4F6C-B226-E2EA66507AE0}"/>
+                <a16:creationId xmlns:a16="http://schemas.microsoft.com/office/drawing/2014/main" id="{60866F7F-5114-4C4E-B9F4-1B3AA7855EC4}"/>
               </a:ext>
             </a:extLst>
           </p:cNvPr>
@@ -13841,7 +13841,7 @@
           <p:cNvPr id="18" name="">
             <a:extLst xmlns:a="http://schemas.openxmlformats.org/drawingml/2006/main">
               <a:ext uri="{FF2B5EF4-FFF2-40B4-BE49-F238E27FC236}">
-                <a16:creationId xmlns:a16="http://schemas.microsoft.com/office/drawing/2014/main" id="{105A7864-A52A-4DB9-9669-B998C44E59E8}"/>
+                <a16:creationId xmlns:a16="http://schemas.microsoft.com/office/drawing/2014/main" id="{8E35848B-5FC9-461B-A9C2-A745AA316E16}"/>
               </a:ext>
             </a:extLst>
           </p:cNvPr>
@@ -13891,7 +13891,7 @@
           <p:cNvPr id="19" name="">
             <a:extLst xmlns:a="http://schemas.openxmlformats.org/drawingml/2006/main">
               <a:ext uri="{FF2B5EF4-FFF2-40B4-BE49-F238E27FC236}">
-                <a16:creationId xmlns:a16="http://schemas.microsoft.com/office/drawing/2014/main" id="{F087F484-3790-4D8F-BA61-66033E3E8402}"/>
+                <a16:creationId xmlns:a16="http://schemas.microsoft.com/office/drawing/2014/main" id="{43D083D9-E852-49A8-B9E9-BB842BAF1B21}"/>
               </a:ext>
             </a:extLst>
           </p:cNvPr>
@@ -13941,7 +13941,7 @@
           <p:cNvPr id="20" name="">
             <a:extLst xmlns:a="http://schemas.openxmlformats.org/drawingml/2006/main">
               <a:ext uri="{FF2B5EF4-FFF2-40B4-BE49-F238E27FC236}">
-                <a16:creationId xmlns:a16="http://schemas.microsoft.com/office/drawing/2014/main" id="{E1EF6EFD-C17E-4D31-87F6-A8D522AE6887}"/>
+                <a16:creationId xmlns:a16="http://schemas.microsoft.com/office/drawing/2014/main" id="{955E5E0C-D253-46A1-B609-4DA09E72F18D}"/>
               </a:ext>
             </a:extLst>
           </p:cNvPr>
@@ -13991,7 +13991,7 @@
           <p:cNvPr id="21" name="">
             <a:extLst xmlns:a="http://schemas.openxmlformats.org/drawingml/2006/main">
               <a:ext uri="{FF2B5EF4-FFF2-40B4-BE49-F238E27FC236}">
-                <a16:creationId xmlns:a16="http://schemas.microsoft.com/office/drawing/2014/main" id="{91A9E689-27CD-47B8-98C7-91EAABEAE582}"/>
+                <a16:creationId xmlns:a16="http://schemas.microsoft.com/office/drawing/2014/main" id="{958C0996-D34D-4637-ADDE-BD3B79262F69}"/>
               </a:ext>
             </a:extLst>
           </p:cNvPr>
@@ -14041,7 +14041,7 @@
           <p:cNvPr id="22" name="">
             <a:extLst xmlns:a="http://schemas.openxmlformats.org/drawingml/2006/main">
               <a:ext uri="{FF2B5EF4-FFF2-40B4-BE49-F238E27FC236}">
-                <a16:creationId xmlns:a16="http://schemas.microsoft.com/office/drawing/2014/main" id="{083E9D85-D7FB-4301-882B-2BA2D4212095}"/>
+                <a16:creationId xmlns:a16="http://schemas.microsoft.com/office/drawing/2014/main" id="{D5B345B4-FB1B-4FCA-937B-20EB04C00611}"/>
               </a:ext>
             </a:extLst>
           </p:cNvPr>
@@ -14076,7 +14076,7 @@
           <p:cNvPr id="23" name="">
             <a:extLst xmlns:a="http://schemas.openxmlformats.org/drawingml/2006/main">
               <a:ext uri="{FF2B5EF4-FFF2-40B4-BE49-F238E27FC236}">
-                <a16:creationId xmlns:a16="http://schemas.microsoft.com/office/drawing/2014/main" id="{37817D74-D33B-4FCC-B131-7BA1F44FB069}"/>
+                <a16:creationId xmlns:a16="http://schemas.microsoft.com/office/drawing/2014/main" id="{B04A8523-340F-4558-B3C1-6A3AC3DDC215}"/>
               </a:ext>
             </a:extLst>
           </p:cNvPr>
@@ -14109,7 +14109,7 @@
           <p:cNvPr id="24" name="">
             <a:extLst xmlns:a="http://schemas.openxmlformats.org/drawingml/2006/main">
               <a:ext uri="{FF2B5EF4-FFF2-40B4-BE49-F238E27FC236}">
-                <a16:creationId xmlns:a16="http://schemas.microsoft.com/office/drawing/2014/main" id="{56A3DC11-DECA-4D8B-8B22-9E28F4286D3D}"/>
+                <a16:creationId xmlns:a16="http://schemas.microsoft.com/office/drawing/2014/main" id="{F860EA9F-D044-4B07-BDEB-53074A445CE3}"/>
               </a:ext>
             </a:extLst>
           </p:cNvPr>
@@ -14159,7 +14159,7 @@
           <p:cNvPr id="25" name="">
             <a:extLst xmlns:a="http://schemas.openxmlformats.org/drawingml/2006/main">
               <a:ext uri="{FF2B5EF4-FFF2-40B4-BE49-F238E27FC236}">
-                <a16:creationId xmlns:a16="http://schemas.microsoft.com/office/drawing/2014/main" id="{5A3404F3-43E9-4FF3-81D0-5A17802B0A50}"/>
+                <a16:creationId xmlns:a16="http://schemas.microsoft.com/office/drawing/2014/main" id="{EA982454-2F4A-4F64-9C49-5FC7327F015D}"/>
               </a:ext>
             </a:extLst>
           </p:cNvPr>
@@ -14209,7 +14209,7 @@
           <p:cNvPr id="26" name="">
             <a:extLst xmlns:a="http://schemas.openxmlformats.org/drawingml/2006/main">
               <a:ext uri="{FF2B5EF4-FFF2-40B4-BE49-F238E27FC236}">
-                <a16:creationId xmlns:a16="http://schemas.microsoft.com/office/drawing/2014/main" id="{E1CF38BC-E1E7-411C-835F-8D47AF5FAB5B}"/>
+                <a16:creationId xmlns:a16="http://schemas.microsoft.com/office/drawing/2014/main" id="{D14ECD14-4838-43C1-A506-2BC215C1B121}"/>
               </a:ext>
             </a:extLst>
           </p:cNvPr>
@@ -14240,7 +14240,7 @@
           <p:cNvPr id="27" name="">
             <a:extLst xmlns:a="http://schemas.openxmlformats.org/drawingml/2006/main">
               <a:ext uri="{FF2B5EF4-FFF2-40B4-BE49-F238E27FC236}">
-                <a16:creationId xmlns:a16="http://schemas.microsoft.com/office/drawing/2014/main" id="{15D1D475-EADB-4E44-A7DB-D70D3D4C5988}"/>
+                <a16:creationId xmlns:a16="http://schemas.microsoft.com/office/drawing/2014/main" id="{A9DFD676-DBD4-4ABE-92BE-0397A6451CC2}"/>
               </a:ext>
             </a:extLst>
           </p:cNvPr>
@@ -14290,7 +14290,7 @@
           <p:cNvPr id="28" name="">
             <a:extLst xmlns:a="http://schemas.openxmlformats.org/drawingml/2006/main">
               <a:ext uri="{FF2B5EF4-FFF2-40B4-BE49-F238E27FC236}">
-                <a16:creationId xmlns:a16="http://schemas.microsoft.com/office/drawing/2014/main" id="{C209F36D-C97C-4807-831B-D22843105523}"/>
+                <a16:creationId xmlns:a16="http://schemas.microsoft.com/office/drawing/2014/main" id="{E9D8A7FC-79A8-45C8-9D44-1B50862AF3DF}"/>
               </a:ext>
             </a:extLst>
           </p:cNvPr>
@@ -14338,7 +14338,7 @@
     </p:spTree>
     <p:extLst>
       <p:ext uri="{BB962C8B-B14F-4D97-AF65-F5344CB8AC3E}">
-        <p14:creationId xmlns:p14="http://schemas.microsoft.com/office/powerpoint/2010/main" val="749608714"/>
+        <p14:creationId xmlns:p14="http://schemas.microsoft.com/office/powerpoint/2010/main" val="1339612715"/>
       </p:ext>
     </p:extLst>
   </p:cSld>
@@ -14369,7 +14369,7 @@
           <p:cNvPr id="24" name="">
             <a:extLst xmlns:a="http://schemas.openxmlformats.org/drawingml/2006/main">
               <a:ext uri="{FF2B5EF4-FFF2-40B4-BE49-F238E27FC236}">
-                <a16:creationId xmlns:a16="http://schemas.microsoft.com/office/drawing/2014/main" id="{40866E4D-AE42-4F19-937D-752BDE9439C1}"/>
+                <a16:creationId xmlns:a16="http://schemas.microsoft.com/office/drawing/2014/main" id="{34B37338-3060-4D4F-9324-712E80358696}"/>
               </a:ext>
             </a:extLst>
           </p:cNvPr>
@@ -14419,7 +14419,7 @@
           <p:cNvPr id="2" name="">
             <a:extLst xmlns:a="http://schemas.openxmlformats.org/drawingml/2006/main">
               <a:ext uri="{FF2B5EF4-FFF2-40B4-BE49-F238E27FC236}">
-                <a16:creationId xmlns:a16="http://schemas.microsoft.com/office/drawing/2014/main" id="{BB0923E2-0AE8-49F0-AFE2-AE895C9953A6}"/>
+                <a16:creationId xmlns:a16="http://schemas.microsoft.com/office/drawing/2014/main" id="{D58C4FB7-541C-482C-B459-2F25C533ED98}"/>
               </a:ext>
             </a:extLst>
           </p:cNvPr>
@@ -14469,7 +14469,7 @@
           <p:cNvPr id="3" name="">
             <a:extLst xmlns:a="http://schemas.openxmlformats.org/drawingml/2006/main">
               <a:ext uri="{FF2B5EF4-FFF2-40B4-BE49-F238E27FC236}">
-                <a16:creationId xmlns:a16="http://schemas.microsoft.com/office/drawing/2014/main" id="{DA418DB9-AB19-46DB-B6C8-E32E58FF19E1}"/>
+                <a16:creationId xmlns:a16="http://schemas.microsoft.com/office/drawing/2014/main" id="{8A49566B-B561-4ECD-8DA9-F2DAD375A132}"/>
               </a:ext>
             </a:extLst>
           </p:cNvPr>
@@ -14519,7 +14519,7 @@
           <p:cNvPr id="4" name="">
             <a:extLst xmlns:a="http://schemas.openxmlformats.org/drawingml/2006/main">
               <a:ext uri="{FF2B5EF4-FFF2-40B4-BE49-F238E27FC236}">
-                <a16:creationId xmlns:a16="http://schemas.microsoft.com/office/drawing/2014/main" id="{288EEE4B-1B7A-49E2-AEF8-3C42BF22D1EE}"/>
+                <a16:creationId xmlns:a16="http://schemas.microsoft.com/office/drawing/2014/main" id="{8B649016-C5A8-4354-9613-E721482E41D8}"/>
               </a:ext>
             </a:extLst>
           </p:cNvPr>
@@ -14550,7 +14550,7 @@
           <p:cNvPr id="5" name="">
             <a:extLst xmlns:a="http://schemas.openxmlformats.org/drawingml/2006/main">
               <a:ext uri="{FF2B5EF4-FFF2-40B4-BE49-F238E27FC236}">
-                <a16:creationId xmlns:a16="http://schemas.microsoft.com/office/drawing/2014/main" id="{4B4BB278-84D5-4434-B191-B44FE683125E}"/>
+                <a16:creationId xmlns:a16="http://schemas.microsoft.com/office/drawing/2014/main" id="{DE3404F6-812B-447B-9E8E-7F01F5011121}"/>
               </a:ext>
             </a:extLst>
           </p:cNvPr>
@@ -14585,7 +14585,7 @@
           <p:cNvPr id="6" name="">
             <a:extLst xmlns:a="http://schemas.openxmlformats.org/drawingml/2006/main">
               <a:ext uri="{FF2B5EF4-FFF2-40B4-BE49-F238E27FC236}">
-                <a16:creationId xmlns:a16="http://schemas.microsoft.com/office/drawing/2014/main" id="{622C3C87-25EB-4259-AA69-5F8754359E2B}"/>
+                <a16:creationId xmlns:a16="http://schemas.microsoft.com/office/drawing/2014/main" id="{313C9E52-7EB6-4B6B-97B3-19372ACE133A}"/>
               </a:ext>
             </a:extLst>
           </p:cNvPr>
@@ -14635,7 +14635,7 @@
           <p:cNvPr id="7" name="">
             <a:extLst xmlns:a="http://schemas.openxmlformats.org/drawingml/2006/main">
               <a:ext uri="{FF2B5EF4-FFF2-40B4-BE49-F238E27FC236}">
-                <a16:creationId xmlns:a16="http://schemas.microsoft.com/office/drawing/2014/main" id="{E4ACC821-24AB-491D-9A6E-83B4A0BDF985}"/>
+                <a16:creationId xmlns:a16="http://schemas.microsoft.com/office/drawing/2014/main" id="{FFE59B2E-02F2-40F7-8947-ACE0223E91F4}"/>
               </a:ext>
             </a:extLst>
           </p:cNvPr>
@@ -14692,7 +14692,7 @@
         </p:xfrm>
         <a:graphic xmlns:a="http://schemas.openxmlformats.org/drawingml/2006/main">
           <a:graphicData uri="http://schemas.openxmlformats.org/drawingml/2006/chart">
-            <c:chart xmlns:r="http://schemas.openxmlformats.org/officeDocument/2006/relationships" xmlns:c="http://schemas.openxmlformats.org/drawingml/2006/chart" r:id="R58c5f5533551446b"/>
+            <c:chart xmlns:r="http://schemas.openxmlformats.org/officeDocument/2006/relationships" xmlns:c="http://schemas.openxmlformats.org/drawingml/2006/chart" r:id="R9f94f42c72b94e35"/>
           </a:graphicData>
         </a:graphic>
       </p:graphicFrame>
@@ -14701,7 +14701,7 @@
           <p:cNvPr id="9" name="">
             <a:extLst xmlns:a="http://schemas.openxmlformats.org/drawingml/2006/main">
               <a:ext uri="{FF2B5EF4-FFF2-40B4-BE49-F238E27FC236}">
-                <a16:creationId xmlns:a16="http://schemas.microsoft.com/office/drawing/2014/main" id="{4E7E0481-C373-4F70-9E36-12AD0FECB1CA}"/>
+                <a16:creationId xmlns:a16="http://schemas.microsoft.com/office/drawing/2014/main" id="{0645F845-7876-4DE2-9C46-AE188469390A}"/>
               </a:ext>
             </a:extLst>
           </p:cNvPr>
@@ -14734,7 +14734,7 @@
           <p:cNvPr id="10" name="">
             <a:extLst xmlns:a="http://schemas.openxmlformats.org/drawingml/2006/main">
               <a:ext uri="{FF2B5EF4-FFF2-40B4-BE49-F238E27FC236}">
-                <a16:creationId xmlns:a16="http://schemas.microsoft.com/office/drawing/2014/main" id="{FB7D4291-B72A-4C46-8B4B-E461CF68702C}"/>
+                <a16:creationId xmlns:a16="http://schemas.microsoft.com/office/drawing/2014/main" id="{E032623B-D1A2-4942-9EA0-78379F52EECB}"/>
               </a:ext>
             </a:extLst>
           </p:cNvPr>
@@ -14784,7 +14784,7 @@
           <p:cNvPr id="11" name="">
             <a:extLst xmlns:a="http://schemas.openxmlformats.org/drawingml/2006/main">
               <a:ext uri="{FF2B5EF4-FFF2-40B4-BE49-F238E27FC236}">
-                <a16:creationId xmlns:a16="http://schemas.microsoft.com/office/drawing/2014/main" id="{3D3C8B52-A4DF-4DBF-85EE-A77EE59B344C}"/>
+                <a16:creationId xmlns:a16="http://schemas.microsoft.com/office/drawing/2014/main" id="{12959FD7-963B-4BAD-8632-090CB4622F89}"/>
               </a:ext>
             </a:extLst>
           </p:cNvPr>
@@ -14834,7 +14834,7 @@
           <p:cNvPr id="12" name="">
             <a:extLst xmlns:a="http://schemas.openxmlformats.org/drawingml/2006/main">
               <a:ext uri="{FF2B5EF4-FFF2-40B4-BE49-F238E27FC236}">
-                <a16:creationId xmlns:a16="http://schemas.microsoft.com/office/drawing/2014/main" id="{6E6842F6-994A-4FF7-8753-170D22C2610D}"/>
+                <a16:creationId xmlns:a16="http://schemas.microsoft.com/office/drawing/2014/main" id="{C4E501B9-422B-4720-B3A3-92EF428A3463}"/>
               </a:ext>
             </a:extLst>
           </p:cNvPr>
@@ -14884,7 +14884,7 @@
           <p:cNvPr id="13" name="">
             <a:extLst xmlns:a="http://schemas.openxmlformats.org/drawingml/2006/main">
               <a:ext uri="{FF2B5EF4-FFF2-40B4-BE49-F238E27FC236}">
-                <a16:creationId xmlns:a16="http://schemas.microsoft.com/office/drawing/2014/main" id="{2E9F3E33-B96E-4445-80C2-4092BB8405AA}"/>
+                <a16:creationId xmlns:a16="http://schemas.microsoft.com/office/drawing/2014/main" id="{F57DD259-0566-43C0-9A8E-16C88CF2D43C}"/>
               </a:ext>
             </a:extLst>
           </p:cNvPr>
@@ -14917,7 +14917,7 @@
           <p:cNvPr id="14" name="">
             <a:extLst xmlns:a="http://schemas.openxmlformats.org/drawingml/2006/main">
               <a:ext uri="{FF2B5EF4-FFF2-40B4-BE49-F238E27FC236}">
-                <a16:creationId xmlns:a16="http://schemas.microsoft.com/office/drawing/2014/main" id="{6F465E11-B810-4BDF-9BD7-57CF400C98F3}"/>
+                <a16:creationId xmlns:a16="http://schemas.microsoft.com/office/drawing/2014/main" id="{9D29D127-741D-47D9-967F-D379FDB48E6B}"/>
               </a:ext>
             </a:extLst>
           </p:cNvPr>
@@ -14967,7 +14967,7 @@
           <p:cNvPr id="15" name="">
             <a:extLst xmlns:a="http://schemas.openxmlformats.org/drawingml/2006/main">
               <a:ext uri="{FF2B5EF4-FFF2-40B4-BE49-F238E27FC236}">
-                <a16:creationId xmlns:a16="http://schemas.microsoft.com/office/drawing/2014/main" id="{85BFD8EA-421E-495D-B8E9-9F4786CFAF9F}"/>
+                <a16:creationId xmlns:a16="http://schemas.microsoft.com/office/drawing/2014/main" id="{01FAB27E-86C6-42DF-B4A4-F4F013FE5B76}"/>
               </a:ext>
             </a:extLst>
           </p:cNvPr>
@@ -15017,7 +15017,7 @@
           <p:cNvPr id="16" name="">
             <a:extLst xmlns:a="http://schemas.openxmlformats.org/drawingml/2006/main">
               <a:ext uri="{FF2B5EF4-FFF2-40B4-BE49-F238E27FC236}">
-                <a16:creationId xmlns:a16="http://schemas.microsoft.com/office/drawing/2014/main" id="{E1C5B3E9-DAC2-441B-9299-AA8957F948DD}"/>
+                <a16:creationId xmlns:a16="http://schemas.microsoft.com/office/drawing/2014/main" id="{5A2264CB-9BF0-42C9-AD0D-56D297A6110B}"/>
               </a:ext>
             </a:extLst>
           </p:cNvPr>
@@ -15067,7 +15067,7 @@
           <p:cNvPr id="17" name="">
             <a:extLst xmlns:a="http://schemas.openxmlformats.org/drawingml/2006/main">
               <a:ext uri="{FF2B5EF4-FFF2-40B4-BE49-F238E27FC236}">
-                <a16:creationId xmlns:a16="http://schemas.microsoft.com/office/drawing/2014/main" id="{58A4F745-2944-4811-B438-C99562AC0F41}"/>
+                <a16:creationId xmlns:a16="http://schemas.microsoft.com/office/drawing/2014/main" id="{6B06A3E6-F1D1-4B59-B391-9FC7183C2DAF}"/>
               </a:ext>
             </a:extLst>
           </p:cNvPr>
@@ -15102,7 +15102,7 @@
           <p:cNvPr id="18" name="">
             <a:extLst xmlns:a="http://schemas.openxmlformats.org/drawingml/2006/main">
               <a:ext uri="{FF2B5EF4-FFF2-40B4-BE49-F238E27FC236}">
-                <a16:creationId xmlns:a16="http://schemas.microsoft.com/office/drawing/2014/main" id="{58D4FE18-8103-465E-AFA4-11A6B756F182}"/>
+                <a16:creationId xmlns:a16="http://schemas.microsoft.com/office/drawing/2014/main" id="{B13E4C36-6867-42B3-9BEB-8EDE332F19A7}"/>
               </a:ext>
             </a:extLst>
           </p:cNvPr>
@@ -15135,7 +15135,7 @@
           <p:cNvPr id="19" name="">
             <a:extLst xmlns:a="http://schemas.openxmlformats.org/drawingml/2006/main">
               <a:ext uri="{FF2B5EF4-FFF2-40B4-BE49-F238E27FC236}">
-                <a16:creationId xmlns:a16="http://schemas.microsoft.com/office/drawing/2014/main" id="{7ADD5B8E-F148-4800-91E3-EE87381F3255}"/>
+                <a16:creationId xmlns:a16="http://schemas.microsoft.com/office/drawing/2014/main" id="{3C1ED3CF-61E4-45AA-87E2-873382117A92}"/>
               </a:ext>
             </a:extLst>
           </p:cNvPr>
@@ -15185,7 +15185,7 @@
           <p:cNvPr id="20" name="">
             <a:extLst xmlns:a="http://schemas.openxmlformats.org/drawingml/2006/main">
               <a:ext uri="{FF2B5EF4-FFF2-40B4-BE49-F238E27FC236}">
-                <a16:creationId xmlns:a16="http://schemas.microsoft.com/office/drawing/2014/main" id="{C2909A56-3EAB-4151-95C8-A8B7CB915038}"/>
+                <a16:creationId xmlns:a16="http://schemas.microsoft.com/office/drawing/2014/main" id="{EF2B3094-600F-4A78-A8D4-F62F3452F43C}"/>
               </a:ext>
             </a:extLst>
           </p:cNvPr>
@@ -15235,7 +15235,7 @@
           <p:cNvPr id="21" name="">
             <a:extLst xmlns:a="http://schemas.openxmlformats.org/drawingml/2006/main">
               <a:ext uri="{FF2B5EF4-FFF2-40B4-BE49-F238E27FC236}">
-                <a16:creationId xmlns:a16="http://schemas.microsoft.com/office/drawing/2014/main" id="{A41A0541-DF7F-4312-98C4-D2B7E307B054}"/>
+                <a16:creationId xmlns:a16="http://schemas.microsoft.com/office/drawing/2014/main" id="{A4DE8309-A480-42CB-9423-A80A6E7FCC85}"/>
               </a:ext>
             </a:extLst>
           </p:cNvPr>
@@ -15266,7 +15266,7 @@
           <p:cNvPr id="22" name="">
             <a:extLst xmlns:a="http://schemas.openxmlformats.org/drawingml/2006/main">
               <a:ext uri="{FF2B5EF4-FFF2-40B4-BE49-F238E27FC236}">
-                <a16:creationId xmlns:a16="http://schemas.microsoft.com/office/drawing/2014/main" id="{28BD9823-A4E8-4F4F-AA24-F34F73C32FBC}"/>
+                <a16:creationId xmlns:a16="http://schemas.microsoft.com/office/drawing/2014/main" id="{74AF76A5-5473-475D-88DF-7A71BD4B8ABC}"/>
               </a:ext>
             </a:extLst>
           </p:cNvPr>
@@ -15316,7 +15316,7 @@
           <p:cNvPr id="23" name="">
             <a:extLst xmlns:a="http://schemas.openxmlformats.org/drawingml/2006/main">
               <a:ext uri="{FF2B5EF4-FFF2-40B4-BE49-F238E27FC236}">
-                <a16:creationId xmlns:a16="http://schemas.microsoft.com/office/drawing/2014/main" id="{93E96B98-85CC-4955-9CAF-A9DE05799AA1}"/>
+                <a16:creationId xmlns:a16="http://schemas.microsoft.com/office/drawing/2014/main" id="{6717B90E-38CC-4B9C-9597-A4CBE3294FCE}"/>
               </a:ext>
             </a:extLst>
           </p:cNvPr>
@@ -15364,7 +15364,7 @@
     </p:spTree>
     <p:extLst>
       <p:ext uri="{BB962C8B-B14F-4D97-AF65-F5344CB8AC3E}">
-        <p14:creationId xmlns:p14="http://schemas.microsoft.com/office/powerpoint/2010/main" val="1159764753"/>
+        <p14:creationId xmlns:p14="http://schemas.microsoft.com/office/powerpoint/2010/main" val="1868239136"/>
       </p:ext>
     </p:extLst>
   </p:cSld>
@@ -15395,7 +15395,7 @@
           <p:cNvPr id="20" name="">
             <a:extLst xmlns:a="http://schemas.openxmlformats.org/drawingml/2006/main">
               <a:ext uri="{FF2B5EF4-FFF2-40B4-BE49-F238E27FC236}">
-                <a16:creationId xmlns:a16="http://schemas.microsoft.com/office/drawing/2014/main" id="{5028A246-95D1-45A7-9F6D-4112F09C9E54}"/>
+                <a16:creationId xmlns:a16="http://schemas.microsoft.com/office/drawing/2014/main" id="{3552D5DB-04EE-44EB-9D0B-06F4C2E14CB3}"/>
               </a:ext>
             </a:extLst>
           </p:cNvPr>
@@ -15445,7 +15445,7 @@
           <p:cNvPr id="2" name="">
             <a:extLst xmlns:a="http://schemas.openxmlformats.org/drawingml/2006/main">
               <a:ext uri="{FF2B5EF4-FFF2-40B4-BE49-F238E27FC236}">
-                <a16:creationId xmlns:a16="http://schemas.microsoft.com/office/drawing/2014/main" id="{2D31ACE3-E06D-4B38-B079-9D79F5F43D7D}"/>
+                <a16:creationId xmlns:a16="http://schemas.microsoft.com/office/drawing/2014/main" id="{58BCCB2A-AFDA-4CE3-A5B6-F69D419DFCB1}"/>
               </a:ext>
             </a:extLst>
           </p:cNvPr>
@@ -15495,7 +15495,7 @@
           <p:cNvPr id="3" name="">
             <a:extLst xmlns:a="http://schemas.openxmlformats.org/drawingml/2006/main">
               <a:ext uri="{FF2B5EF4-FFF2-40B4-BE49-F238E27FC236}">
-                <a16:creationId xmlns:a16="http://schemas.microsoft.com/office/drawing/2014/main" id="{E579DD85-89C9-4D57-A77C-16CE6436546C}"/>
+                <a16:creationId xmlns:a16="http://schemas.microsoft.com/office/drawing/2014/main" id="{C3FA45F9-C707-425C-84B3-648FD54A9078}"/>
               </a:ext>
             </a:extLst>
           </p:cNvPr>
@@ -15545,7 +15545,7 @@
           <p:cNvPr id="4" name="">
             <a:extLst xmlns:a="http://schemas.openxmlformats.org/drawingml/2006/main">
               <a:ext uri="{FF2B5EF4-FFF2-40B4-BE49-F238E27FC236}">
-                <a16:creationId xmlns:a16="http://schemas.microsoft.com/office/drawing/2014/main" id="{83DB4D89-AD81-4E8D-8A41-29E6BD42497A}"/>
+                <a16:creationId xmlns:a16="http://schemas.microsoft.com/office/drawing/2014/main" id="{2E2268C8-8499-403C-A586-E2E671D98FFD}"/>
               </a:ext>
             </a:extLst>
           </p:cNvPr>
@@ -15576,7 +15576,7 @@
           <p:cNvPr id="5" name="">
             <a:extLst xmlns:a="http://schemas.openxmlformats.org/drawingml/2006/main">
               <a:ext uri="{FF2B5EF4-FFF2-40B4-BE49-F238E27FC236}">
-                <a16:creationId xmlns:a16="http://schemas.microsoft.com/office/drawing/2014/main" id="{05A0DDC0-5FE5-40F1-A0F8-D536F9E93309}"/>
+                <a16:creationId xmlns:a16="http://schemas.microsoft.com/office/drawing/2014/main" id="{1AB10E14-F897-4720-B83C-082FA389CD43}"/>
               </a:ext>
             </a:extLst>
           </p:cNvPr>
@@ -15611,7 +15611,7 @@
           <p:cNvPr id="6" name="">
             <a:extLst xmlns:a="http://schemas.openxmlformats.org/drawingml/2006/main">
               <a:ext uri="{FF2B5EF4-FFF2-40B4-BE49-F238E27FC236}">
-                <a16:creationId xmlns:a16="http://schemas.microsoft.com/office/drawing/2014/main" id="{E0F0A33C-A59A-444E-8A8D-A1315DF8E421}"/>
+                <a16:creationId xmlns:a16="http://schemas.microsoft.com/office/drawing/2014/main" id="{6DD8BC33-A3F4-4E60-9B0A-1A8134E65176}"/>
               </a:ext>
             </a:extLst>
           </p:cNvPr>
@@ -15661,7 +15661,7 @@
           <p:cNvPr id="7" name="">
             <a:extLst xmlns:a="http://schemas.openxmlformats.org/drawingml/2006/main">
               <a:ext uri="{FF2B5EF4-FFF2-40B4-BE49-F238E27FC236}">
-                <a16:creationId xmlns:a16="http://schemas.microsoft.com/office/drawing/2014/main" id="{1CA58C05-3149-4B6E-8044-5C9D6A390920}"/>
+                <a16:creationId xmlns:a16="http://schemas.microsoft.com/office/drawing/2014/main" id="{F3C65E2B-A6F0-4EFA-A574-5AB3D777CFA7}"/>
               </a:ext>
             </a:extLst>
           </p:cNvPr>
@@ -15718,7 +15718,7 @@
         </p:xfrm>
         <a:graphic xmlns:a="http://schemas.openxmlformats.org/drawingml/2006/main">
           <a:graphicData uri="http://schemas.openxmlformats.org/drawingml/2006/chart">
-            <c:chart xmlns:r="http://schemas.openxmlformats.org/officeDocument/2006/relationships" xmlns:c="http://schemas.openxmlformats.org/drawingml/2006/chart" r:id="R4bf9579fd61f4599"/>
+            <c:chart xmlns:r="http://schemas.openxmlformats.org/officeDocument/2006/relationships" xmlns:c="http://schemas.openxmlformats.org/drawingml/2006/chart" r:id="Rb3e5d4f6d526484c"/>
           </a:graphicData>
         </a:graphic>
       </p:graphicFrame>
@@ -15727,7 +15727,7 @@
           <p:cNvPr id="9" name="">
             <a:extLst xmlns:a="http://schemas.openxmlformats.org/drawingml/2006/main">
               <a:ext uri="{FF2B5EF4-FFF2-40B4-BE49-F238E27FC236}">
-                <a16:creationId xmlns:a16="http://schemas.microsoft.com/office/drawing/2014/main" id="{897BF426-09FB-46AC-9B51-BDBC2C276496}"/>
+                <a16:creationId xmlns:a16="http://schemas.microsoft.com/office/drawing/2014/main" id="{17279D5A-7ED2-4409-BAAF-F9E505F52833}"/>
               </a:ext>
             </a:extLst>
           </p:cNvPr>
@@ -15762,7 +15762,7 @@
           <p:cNvPr id="10" name="">
             <a:extLst xmlns:a="http://schemas.openxmlformats.org/drawingml/2006/main">
               <a:ext uri="{FF2B5EF4-FFF2-40B4-BE49-F238E27FC236}">
-                <a16:creationId xmlns:a16="http://schemas.microsoft.com/office/drawing/2014/main" id="{BA575B57-1F6F-4799-A256-80DE49CCE419}"/>
+                <a16:creationId xmlns:a16="http://schemas.microsoft.com/office/drawing/2014/main" id="{C7531E55-C052-4C8C-9329-B2F02F07A156}"/>
               </a:ext>
             </a:extLst>
           </p:cNvPr>
@@ -15795,7 +15795,7 @@
           <p:cNvPr id="11" name="">
             <a:extLst xmlns:a="http://schemas.openxmlformats.org/drawingml/2006/main">
               <a:ext uri="{FF2B5EF4-FFF2-40B4-BE49-F238E27FC236}">
-                <a16:creationId xmlns:a16="http://schemas.microsoft.com/office/drawing/2014/main" id="{88CADD85-B422-4300-9825-110963E97656}"/>
+                <a16:creationId xmlns:a16="http://schemas.microsoft.com/office/drawing/2014/main" id="{3442B126-8D87-4248-B6E7-1F14DE158346}"/>
               </a:ext>
             </a:extLst>
           </p:cNvPr>
@@ -15845,7 +15845,7 @@
           <p:cNvPr id="12" name="">
             <a:extLst xmlns:a="http://schemas.openxmlformats.org/drawingml/2006/main">
               <a:ext uri="{FF2B5EF4-FFF2-40B4-BE49-F238E27FC236}">
-                <a16:creationId xmlns:a16="http://schemas.microsoft.com/office/drawing/2014/main" id="{8DC25B69-1901-4874-B3CC-EE06381679D4}"/>
+                <a16:creationId xmlns:a16="http://schemas.microsoft.com/office/drawing/2014/main" id="{7C0395CF-8E07-446C-A407-F9E7322DC288}"/>
               </a:ext>
             </a:extLst>
           </p:cNvPr>
@@ -15895,7 +15895,7 @@
           <p:cNvPr id="13" name="">
             <a:extLst xmlns:a="http://schemas.openxmlformats.org/drawingml/2006/main">
               <a:ext uri="{FF2B5EF4-FFF2-40B4-BE49-F238E27FC236}">
-                <a16:creationId xmlns:a16="http://schemas.microsoft.com/office/drawing/2014/main" id="{28510738-BE50-49C2-88F5-E5788DD12B95}"/>
+                <a16:creationId xmlns:a16="http://schemas.microsoft.com/office/drawing/2014/main" id="{7FECC879-9AB6-4365-8788-E4E283DB3923}"/>
               </a:ext>
             </a:extLst>
           </p:cNvPr>
@@ -15930,7 +15930,7 @@
           <p:cNvPr id="14" name="">
             <a:extLst xmlns:a="http://schemas.openxmlformats.org/drawingml/2006/main">
               <a:ext uri="{FF2B5EF4-FFF2-40B4-BE49-F238E27FC236}">
-                <a16:creationId xmlns:a16="http://schemas.microsoft.com/office/drawing/2014/main" id="{041D0470-2389-4E11-BEA6-6A24EFA151CA}"/>
+                <a16:creationId xmlns:a16="http://schemas.microsoft.com/office/drawing/2014/main" id="{114D7C38-2DB3-4CC1-9F5A-0B1D88D35EEB}"/>
               </a:ext>
             </a:extLst>
           </p:cNvPr>
@@ -15963,7 +15963,7 @@
           <p:cNvPr id="15" name="">
             <a:extLst xmlns:a="http://schemas.openxmlformats.org/drawingml/2006/main">
               <a:ext uri="{FF2B5EF4-FFF2-40B4-BE49-F238E27FC236}">
-                <a16:creationId xmlns:a16="http://schemas.microsoft.com/office/drawing/2014/main" id="{5CAA19FE-6EB1-4AF7-B621-9DC46A1518A7}"/>
+                <a16:creationId xmlns:a16="http://schemas.microsoft.com/office/drawing/2014/main" id="{2D5A4AE7-A83E-4A55-8141-1A9F1AC80AB7}"/>
               </a:ext>
             </a:extLst>
           </p:cNvPr>
@@ -16013,7 +16013,7 @@
           <p:cNvPr id="16" name="">
             <a:extLst xmlns:a="http://schemas.openxmlformats.org/drawingml/2006/main">
               <a:ext uri="{FF2B5EF4-FFF2-40B4-BE49-F238E27FC236}">
-                <a16:creationId xmlns:a16="http://schemas.microsoft.com/office/drawing/2014/main" id="{6FCFEE03-5FF1-4CD7-A58D-F74D757AAA0B}"/>
+                <a16:creationId xmlns:a16="http://schemas.microsoft.com/office/drawing/2014/main" id="{589AD504-D9EE-43EE-8B00-92CD54EF713C}"/>
               </a:ext>
             </a:extLst>
           </p:cNvPr>
@@ -16063,7 +16063,7 @@
           <p:cNvPr id="17" name="">
             <a:extLst xmlns:a="http://schemas.openxmlformats.org/drawingml/2006/main">
               <a:ext uri="{FF2B5EF4-FFF2-40B4-BE49-F238E27FC236}">
-                <a16:creationId xmlns:a16="http://schemas.microsoft.com/office/drawing/2014/main" id="{2750354A-8960-4D9C-97F2-8148E0E49321}"/>
+                <a16:creationId xmlns:a16="http://schemas.microsoft.com/office/drawing/2014/main" id="{D4A3D0E0-F77E-4DC0-86A7-A533F0E57CB9}"/>
               </a:ext>
             </a:extLst>
           </p:cNvPr>
@@ -16094,7 +16094,7 @@
           <p:cNvPr id="18" name="">
             <a:extLst xmlns:a="http://schemas.openxmlformats.org/drawingml/2006/main">
               <a:ext uri="{FF2B5EF4-FFF2-40B4-BE49-F238E27FC236}">
-                <a16:creationId xmlns:a16="http://schemas.microsoft.com/office/drawing/2014/main" id="{6B941939-0B06-4A38-AAB9-D7989B49C7E7}"/>
+                <a16:creationId xmlns:a16="http://schemas.microsoft.com/office/drawing/2014/main" id="{BBCD47E0-023D-4489-8D60-65189582B2B3}"/>
               </a:ext>
             </a:extLst>
           </p:cNvPr>
@@ -16144,7 +16144,7 @@
           <p:cNvPr id="19" name="">
             <a:extLst xmlns:a="http://schemas.openxmlformats.org/drawingml/2006/main">
               <a:ext uri="{FF2B5EF4-FFF2-40B4-BE49-F238E27FC236}">
-                <a16:creationId xmlns:a16="http://schemas.microsoft.com/office/drawing/2014/main" id="{9D970C92-B607-4095-A3C2-61B072B9FCAC}"/>
+                <a16:creationId xmlns:a16="http://schemas.microsoft.com/office/drawing/2014/main" id="{03F4E4EF-6733-44DD-906C-3A2154D60DD3}"/>
               </a:ext>
             </a:extLst>
           </p:cNvPr>
@@ -16192,7 +16192,7 @@
     </p:spTree>
     <p:extLst>
       <p:ext uri="{BB962C8B-B14F-4D97-AF65-F5344CB8AC3E}">
-        <p14:creationId xmlns:p14="http://schemas.microsoft.com/office/powerpoint/2010/main" val="1820039179"/>
+        <p14:creationId xmlns:p14="http://schemas.microsoft.com/office/powerpoint/2010/main" val="2033039794"/>
       </p:ext>
     </p:extLst>
   </p:cSld>

</xml_diff>

<commit_message>
Polish dashboard evidence interactions and accessibility
</commit_message>
<xml_diff>
--- a/outputs/presentation/Marketing_Analytics_Executive_Deck.pptx
+++ b/outputs/presentation/Marketing_Analytics_Executive_Deck.pptx
@@ -2,24 +2,24 @@
 <file path=ppt/presentation.xml><?xml version="1.0" encoding="utf-8"?>
 <p:presentation xmlns:p="http://schemas.openxmlformats.org/presentationml/2006/main">
   <p:sldMasterIdLst>
-    <p:sldMasterId xmlns:r="http://schemas.openxmlformats.org/officeDocument/2006/relationships" id="2147483648" r:id="R6eb190dfb6a843eb"/>
+    <p:sldMasterId xmlns:r="http://schemas.openxmlformats.org/officeDocument/2006/relationships" id="2147483648" r:id="R65dd4852345941cf"/>
   </p:sldMasterIdLst>
   <p:notesMasterIdLst>
-    <p:notesMasterId xmlns:r="http://schemas.openxmlformats.org/officeDocument/2006/relationships" r:id="R807d07fd88224596"/>
+    <p:notesMasterId xmlns:r="http://schemas.openxmlformats.org/officeDocument/2006/relationships" r:id="R1938dac0ade64d2c"/>
   </p:notesMasterIdLst>
   <p:sldIdLst>
-    <p:sldId xmlns:r="http://schemas.openxmlformats.org/officeDocument/2006/relationships" id="256" r:id="R9d69febf263547a3"/>
-    <p:sldId xmlns:r="http://schemas.openxmlformats.org/officeDocument/2006/relationships" id="257" r:id="R648bcb426a8b4d3c"/>
-    <p:sldId xmlns:r="http://schemas.openxmlformats.org/officeDocument/2006/relationships" id="258" r:id="R76614dc18c3e4559"/>
-    <p:sldId xmlns:r="http://schemas.openxmlformats.org/officeDocument/2006/relationships" id="259" r:id="Rb0c2a5df9a3c494d"/>
-    <p:sldId xmlns:r="http://schemas.openxmlformats.org/officeDocument/2006/relationships" id="260" r:id="Rb3762954d2c147b9"/>
-    <p:sldId xmlns:r="http://schemas.openxmlformats.org/officeDocument/2006/relationships" id="261" r:id="R959df16bb9cf487e"/>
-    <p:sldId xmlns:r="http://schemas.openxmlformats.org/officeDocument/2006/relationships" id="262" r:id="R94a0ac4c7b8d4ebe"/>
-    <p:sldId xmlns:r="http://schemas.openxmlformats.org/officeDocument/2006/relationships" id="263" r:id="Ra6d1bd88550b42da"/>
-    <p:sldId xmlns:r="http://schemas.openxmlformats.org/officeDocument/2006/relationships" id="264" r:id="R517be230455b4510"/>
-    <p:sldId xmlns:r="http://schemas.openxmlformats.org/officeDocument/2006/relationships" id="265" r:id="R03ee88061150419f"/>
-    <p:sldId xmlns:r="http://schemas.openxmlformats.org/officeDocument/2006/relationships" id="266" r:id="Rbd5ff84f603044f5"/>
-    <p:sldId xmlns:r="http://schemas.openxmlformats.org/officeDocument/2006/relationships" id="267" r:id="R0306ebe4954a47fe"/>
+    <p:sldId xmlns:r="http://schemas.openxmlformats.org/officeDocument/2006/relationships" id="256" r:id="R405c5c32f60a482d"/>
+    <p:sldId xmlns:r="http://schemas.openxmlformats.org/officeDocument/2006/relationships" id="257" r:id="R4c2c3dbd1ef741e0"/>
+    <p:sldId xmlns:r="http://schemas.openxmlformats.org/officeDocument/2006/relationships" id="258" r:id="Rd2e8d9ce94e046d1"/>
+    <p:sldId xmlns:r="http://schemas.openxmlformats.org/officeDocument/2006/relationships" id="259" r:id="R0e586d2171b747ff"/>
+    <p:sldId xmlns:r="http://schemas.openxmlformats.org/officeDocument/2006/relationships" id="260" r:id="Rd5972f9ed4e94050"/>
+    <p:sldId xmlns:r="http://schemas.openxmlformats.org/officeDocument/2006/relationships" id="261" r:id="Rab384426d6b447c8"/>
+    <p:sldId xmlns:r="http://schemas.openxmlformats.org/officeDocument/2006/relationships" id="262" r:id="Rbac4db78d479494d"/>
+    <p:sldId xmlns:r="http://schemas.openxmlformats.org/officeDocument/2006/relationships" id="263" r:id="Rb87edefb930146d9"/>
+    <p:sldId xmlns:r="http://schemas.openxmlformats.org/officeDocument/2006/relationships" id="264" r:id="R3038adc8078c4f36"/>
+    <p:sldId xmlns:r="http://schemas.openxmlformats.org/officeDocument/2006/relationships" id="265" r:id="R074f94efbc554c0b"/>
+    <p:sldId xmlns:r="http://schemas.openxmlformats.org/officeDocument/2006/relationships" id="266" r:id="R4edabfeb85bf4628"/>
+    <p:sldId xmlns:r="http://schemas.openxmlformats.org/officeDocument/2006/relationships" id="267" r:id="R93e1fd8867214576"/>
   </p:sldIdLst>
   <p:sldSz cx="12192000" cy="6858000"/>
   <p:notesSz cx="6858000" cy="9144000"/>
@@ -1611,7 +1611,7 @@
   </p:cSld>
   <p:clrMap bg1="lt1" tx1="dk1" bg2="lt2" tx2="dk2" accent1="accent1" accent2="accent2" accent3="accent3" accent4="accent4" accent5="accent5" accent6="accent6" hlink="hlink" folHlink="folHlink"/>
   <p:sldLayoutIdLst>
-    <p:sldLayoutId xmlns:r="http://schemas.openxmlformats.org/officeDocument/2006/relationships" id="2147483649" r:id="R848157d5f5784fdb"/>
+    <p:sldLayoutId xmlns:r="http://schemas.openxmlformats.org/officeDocument/2006/relationships" id="2147483649" r:id="R4c8d0454ec2044a4"/>
   </p:sldLayoutIdLst>
   <p:txStyles>
     <p:titleStyle>
@@ -3728,7 +3728,7 @@
           <p:cNvPr id="22" name="">
             <a:extLst xmlns:a="http://schemas.openxmlformats.org/drawingml/2006/main">
               <a:ext uri="{FF2B5EF4-FFF2-40B4-BE49-F238E27FC236}">
-                <a16:creationId xmlns:a16="http://schemas.microsoft.com/office/drawing/2014/main" id="{A409D66B-3C49-4ED1-AE54-55965340BE66}"/>
+                <a16:creationId xmlns:a16="http://schemas.microsoft.com/office/drawing/2014/main" id="{C19C4DAB-49A9-4505-B87F-D788AA828582}"/>
               </a:ext>
             </a:extLst>
           </p:cNvPr>
@@ -3761,7 +3761,7 @@
           <p:cNvPr id="2" name="">
             <a:extLst xmlns:a="http://schemas.openxmlformats.org/drawingml/2006/main">
               <a:ext uri="{FF2B5EF4-FFF2-40B4-BE49-F238E27FC236}">
-                <a16:creationId xmlns:a16="http://schemas.microsoft.com/office/drawing/2014/main" id="{929FF649-9425-4B62-8356-ABCDC5BE1D23}"/>
+                <a16:creationId xmlns:a16="http://schemas.microsoft.com/office/drawing/2014/main" id="{CA606748-CBE4-46F3-9E5A-DE4496FF4901}"/>
               </a:ext>
             </a:extLst>
           </p:cNvPr>
@@ -3811,7 +3811,7 @@
           <p:cNvPr id="3" name="">
             <a:extLst xmlns:a="http://schemas.openxmlformats.org/drawingml/2006/main">
               <a:ext uri="{FF2B5EF4-FFF2-40B4-BE49-F238E27FC236}">
-                <a16:creationId xmlns:a16="http://schemas.microsoft.com/office/drawing/2014/main" id="{F6863415-52CE-475E-B6C3-632ACAAB3B57}"/>
+                <a16:creationId xmlns:a16="http://schemas.microsoft.com/office/drawing/2014/main" id="{CBFBA271-AB74-44A5-A685-0B37967E7BDD}"/>
               </a:ext>
             </a:extLst>
           </p:cNvPr>
@@ -3878,7 +3878,7 @@
           <p:cNvPr id="4" name="">
             <a:extLst xmlns:a="http://schemas.openxmlformats.org/drawingml/2006/main">
               <a:ext uri="{FF2B5EF4-FFF2-40B4-BE49-F238E27FC236}">
-                <a16:creationId xmlns:a16="http://schemas.microsoft.com/office/drawing/2014/main" id="{3A6736A5-A590-40B3-9000-931CF0F0360C}"/>
+                <a16:creationId xmlns:a16="http://schemas.microsoft.com/office/drawing/2014/main" id="{D942D5E0-4953-4EE8-A9DF-DB71AC69DFC1}"/>
               </a:ext>
             </a:extLst>
           </p:cNvPr>
@@ -3928,7 +3928,7 @@
           <p:cNvPr id="5" name="">
             <a:extLst xmlns:a="http://schemas.openxmlformats.org/drawingml/2006/main">
               <a:ext uri="{FF2B5EF4-FFF2-40B4-BE49-F238E27FC236}">
-                <a16:creationId xmlns:a16="http://schemas.microsoft.com/office/drawing/2014/main" id="{491E4575-F118-48AF-9B33-3134165B3241}"/>
+                <a16:creationId xmlns:a16="http://schemas.microsoft.com/office/drawing/2014/main" id="{1319F71E-1B9F-456F-A2B2-1E6DFC56E5A3}"/>
               </a:ext>
             </a:extLst>
           </p:cNvPr>
@@ -3961,7 +3961,7 @@
           <p:cNvPr id="6" name="">
             <a:extLst xmlns:a="http://schemas.openxmlformats.org/drawingml/2006/main">
               <a:ext uri="{FF2B5EF4-FFF2-40B4-BE49-F238E27FC236}">
-                <a16:creationId xmlns:a16="http://schemas.microsoft.com/office/drawing/2014/main" id="{F995DEC6-F07A-4A19-9098-557A3CBD5E60}"/>
+                <a16:creationId xmlns:a16="http://schemas.microsoft.com/office/drawing/2014/main" id="{E89B900E-50FD-425E-9DBE-FF253407B7DB}"/>
               </a:ext>
             </a:extLst>
           </p:cNvPr>
@@ -4011,7 +4011,7 @@
           <p:cNvPr id="7" name="">
             <a:extLst xmlns:a="http://schemas.openxmlformats.org/drawingml/2006/main">
               <a:ext uri="{FF2B5EF4-FFF2-40B4-BE49-F238E27FC236}">
-                <a16:creationId xmlns:a16="http://schemas.microsoft.com/office/drawing/2014/main" id="{2417CA74-59E2-4E18-A4EC-E50492374531}"/>
+                <a16:creationId xmlns:a16="http://schemas.microsoft.com/office/drawing/2014/main" id="{20B70647-D791-4545-B97D-7DC3E3BF8BD2}"/>
               </a:ext>
             </a:extLst>
           </p:cNvPr>
@@ -4061,7 +4061,7 @@
           <p:cNvPr id="8" name="">
             <a:extLst xmlns:a="http://schemas.openxmlformats.org/drawingml/2006/main">
               <a:ext uri="{FF2B5EF4-FFF2-40B4-BE49-F238E27FC236}">
-                <a16:creationId xmlns:a16="http://schemas.microsoft.com/office/drawing/2014/main" id="{E7455EC6-278A-446E-B53C-0FDBA9761BEF}"/>
+                <a16:creationId xmlns:a16="http://schemas.microsoft.com/office/drawing/2014/main" id="{80166305-2F7D-4F1C-8A07-92FFF67F44E9}"/>
               </a:ext>
             </a:extLst>
           </p:cNvPr>
@@ -4111,7 +4111,7 @@
           <p:cNvPr id="9" name="">
             <a:extLst xmlns:a="http://schemas.openxmlformats.org/drawingml/2006/main">
               <a:ext uri="{FF2B5EF4-FFF2-40B4-BE49-F238E27FC236}">
-                <a16:creationId xmlns:a16="http://schemas.microsoft.com/office/drawing/2014/main" id="{FE47C17A-EEC0-4498-A3B4-BCA8251CA69B}"/>
+                <a16:creationId xmlns:a16="http://schemas.microsoft.com/office/drawing/2014/main" id="{6C46C028-DCF7-4681-B597-534AE2DEE5B0}"/>
               </a:ext>
             </a:extLst>
           </p:cNvPr>
@@ -4144,7 +4144,7 @@
           <p:cNvPr id="10" name="">
             <a:extLst xmlns:a="http://schemas.openxmlformats.org/drawingml/2006/main">
               <a:ext uri="{FF2B5EF4-FFF2-40B4-BE49-F238E27FC236}">
-                <a16:creationId xmlns:a16="http://schemas.microsoft.com/office/drawing/2014/main" id="{FD7632B3-C0EA-4D08-8A81-DF7E7459BDA6}"/>
+                <a16:creationId xmlns:a16="http://schemas.microsoft.com/office/drawing/2014/main" id="{90D7100D-69ED-404F-8F60-59AED3FFAC1A}"/>
               </a:ext>
             </a:extLst>
           </p:cNvPr>
@@ -4194,7 +4194,7 @@
           <p:cNvPr id="11" name="">
             <a:extLst xmlns:a="http://schemas.openxmlformats.org/drawingml/2006/main">
               <a:ext uri="{FF2B5EF4-FFF2-40B4-BE49-F238E27FC236}">
-                <a16:creationId xmlns:a16="http://schemas.microsoft.com/office/drawing/2014/main" id="{C14C807E-FE8B-4B55-86F5-2F957CB66278}"/>
+                <a16:creationId xmlns:a16="http://schemas.microsoft.com/office/drawing/2014/main" id="{00801A80-4282-433C-A906-4945B5175946}"/>
               </a:ext>
             </a:extLst>
           </p:cNvPr>
@@ -4244,7 +4244,7 @@
           <p:cNvPr id="12" name="">
             <a:extLst xmlns:a="http://schemas.openxmlformats.org/drawingml/2006/main">
               <a:ext uri="{FF2B5EF4-FFF2-40B4-BE49-F238E27FC236}">
-                <a16:creationId xmlns:a16="http://schemas.microsoft.com/office/drawing/2014/main" id="{77FFBDF2-8D5D-4C16-83C6-64469ECA7F61}"/>
+                <a16:creationId xmlns:a16="http://schemas.microsoft.com/office/drawing/2014/main" id="{DA8A93C3-16FF-43A1-88C4-4AEFA98D0C5F}"/>
               </a:ext>
             </a:extLst>
           </p:cNvPr>
@@ -4294,7 +4294,7 @@
           <p:cNvPr id="13" name="">
             <a:extLst xmlns:a="http://schemas.openxmlformats.org/drawingml/2006/main">
               <a:ext uri="{FF2B5EF4-FFF2-40B4-BE49-F238E27FC236}">
-                <a16:creationId xmlns:a16="http://schemas.microsoft.com/office/drawing/2014/main" id="{A209919A-CAA3-415C-9935-8ED044892613}"/>
+                <a16:creationId xmlns:a16="http://schemas.microsoft.com/office/drawing/2014/main" id="{1726AF96-6C2F-4CAC-BA63-015AE4906D4F}"/>
               </a:ext>
             </a:extLst>
           </p:cNvPr>
@@ -4327,7 +4327,7 @@
           <p:cNvPr id="14" name="">
             <a:extLst xmlns:a="http://schemas.openxmlformats.org/drawingml/2006/main">
               <a:ext uri="{FF2B5EF4-FFF2-40B4-BE49-F238E27FC236}">
-                <a16:creationId xmlns:a16="http://schemas.microsoft.com/office/drawing/2014/main" id="{E541DFCB-FDDB-4CA7-A947-52023CA0D803}"/>
+                <a16:creationId xmlns:a16="http://schemas.microsoft.com/office/drawing/2014/main" id="{46D4AC7A-129D-4CE9-B8A8-8D96E646E45D}"/>
               </a:ext>
             </a:extLst>
           </p:cNvPr>
@@ -4377,7 +4377,7 @@
           <p:cNvPr id="15" name="">
             <a:extLst xmlns:a="http://schemas.openxmlformats.org/drawingml/2006/main">
               <a:ext uri="{FF2B5EF4-FFF2-40B4-BE49-F238E27FC236}">
-                <a16:creationId xmlns:a16="http://schemas.microsoft.com/office/drawing/2014/main" id="{987B3F89-F2CB-4633-98EF-AA549E57F363}"/>
+                <a16:creationId xmlns:a16="http://schemas.microsoft.com/office/drawing/2014/main" id="{ACDEF9FB-DE13-46D5-AF36-0088A6CB04E9}"/>
               </a:ext>
             </a:extLst>
           </p:cNvPr>
@@ -4427,7 +4427,7 @@
           <p:cNvPr id="16" name="">
             <a:extLst xmlns:a="http://schemas.openxmlformats.org/drawingml/2006/main">
               <a:ext uri="{FF2B5EF4-FFF2-40B4-BE49-F238E27FC236}">
-                <a16:creationId xmlns:a16="http://schemas.microsoft.com/office/drawing/2014/main" id="{DFEA882B-4EC8-4938-A490-1B47A5189605}"/>
+                <a16:creationId xmlns:a16="http://schemas.microsoft.com/office/drawing/2014/main" id="{4AA1D104-A761-4F00-A9A5-788C14569828}"/>
               </a:ext>
             </a:extLst>
           </p:cNvPr>
@@ -4477,7 +4477,7 @@
           <p:cNvPr id="17" name="">
             <a:extLst xmlns:a="http://schemas.openxmlformats.org/drawingml/2006/main">
               <a:ext uri="{FF2B5EF4-FFF2-40B4-BE49-F238E27FC236}">
-                <a16:creationId xmlns:a16="http://schemas.microsoft.com/office/drawing/2014/main" id="{3B70AE38-EC16-4866-888B-86E2B7DC0932}"/>
+                <a16:creationId xmlns:a16="http://schemas.microsoft.com/office/drawing/2014/main" id="{8572BA3C-C11E-417D-A460-52E66631A255}"/>
               </a:ext>
             </a:extLst>
           </p:cNvPr>
@@ -4510,7 +4510,7 @@
           <p:cNvPr id="18" name="">
             <a:extLst xmlns:a="http://schemas.openxmlformats.org/drawingml/2006/main">
               <a:ext uri="{FF2B5EF4-FFF2-40B4-BE49-F238E27FC236}">
-                <a16:creationId xmlns:a16="http://schemas.microsoft.com/office/drawing/2014/main" id="{04B2FE99-C5C3-4354-8ECE-E4877E66E41E}"/>
+                <a16:creationId xmlns:a16="http://schemas.microsoft.com/office/drawing/2014/main" id="{2C9A4B7B-E32E-4F5F-8384-19851D8A6E3F}"/>
               </a:ext>
             </a:extLst>
           </p:cNvPr>
@@ -4560,7 +4560,7 @@
           <p:cNvPr id="19" name="">
             <a:extLst xmlns:a="http://schemas.openxmlformats.org/drawingml/2006/main">
               <a:ext uri="{FF2B5EF4-FFF2-40B4-BE49-F238E27FC236}">
-                <a16:creationId xmlns:a16="http://schemas.microsoft.com/office/drawing/2014/main" id="{3F925CFB-A034-42BC-9AE8-2EDBECDC8B19}"/>
+                <a16:creationId xmlns:a16="http://schemas.microsoft.com/office/drawing/2014/main" id="{3992212A-9DB7-4F0D-9D55-0152C6FFF383}"/>
               </a:ext>
             </a:extLst>
           </p:cNvPr>
@@ -4610,7 +4610,7 @@
           <p:cNvPr id="20" name="">
             <a:extLst xmlns:a="http://schemas.openxmlformats.org/drawingml/2006/main">
               <a:ext uri="{FF2B5EF4-FFF2-40B4-BE49-F238E27FC236}">
-                <a16:creationId xmlns:a16="http://schemas.microsoft.com/office/drawing/2014/main" id="{78EB8C3C-DBB0-4162-9D5C-E210920B0017}"/>
+                <a16:creationId xmlns:a16="http://schemas.microsoft.com/office/drawing/2014/main" id="{AA4CDC29-20DF-4A7F-874B-516D00AE1C42}"/>
               </a:ext>
             </a:extLst>
           </p:cNvPr>
@@ -4660,7 +4660,7 @@
           <p:cNvPr id="21" name="">
             <a:extLst xmlns:a="http://schemas.openxmlformats.org/drawingml/2006/main">
               <a:ext uri="{FF2B5EF4-FFF2-40B4-BE49-F238E27FC236}">
-                <a16:creationId xmlns:a16="http://schemas.microsoft.com/office/drawing/2014/main" id="{4BC644A2-7137-4934-B8A6-CB1FABA3A011}"/>
+                <a16:creationId xmlns:a16="http://schemas.microsoft.com/office/drawing/2014/main" id="{701BA1CD-2D18-4A88-B102-780BD154E58F}"/>
               </a:ext>
             </a:extLst>
           </p:cNvPr>
@@ -4708,7 +4708,7 @@
     </p:spTree>
     <p:extLst>
       <p:ext uri="{BB962C8B-B14F-4D97-AF65-F5344CB8AC3E}">
-        <p14:creationId xmlns:p14="http://schemas.microsoft.com/office/powerpoint/2010/main" val="872923780"/>
+        <p14:creationId xmlns:p14="http://schemas.microsoft.com/office/powerpoint/2010/main" val="1826635573"/>
       </p:ext>
     </p:extLst>
   </p:cSld>
@@ -4739,7 +4739,7 @@
           <p:cNvPr id="32" name="">
             <a:extLst xmlns:a="http://schemas.openxmlformats.org/drawingml/2006/main">
               <a:ext uri="{FF2B5EF4-FFF2-40B4-BE49-F238E27FC236}">
-                <a16:creationId xmlns:a16="http://schemas.microsoft.com/office/drawing/2014/main" id="{023AE36F-5E00-4391-B70C-CBE3D6E51372}"/>
+                <a16:creationId xmlns:a16="http://schemas.microsoft.com/office/drawing/2014/main" id="{F2384849-C019-417E-B79C-B1B1D36038CD}"/>
               </a:ext>
             </a:extLst>
           </p:cNvPr>
@@ -4789,7 +4789,7 @@
           <p:cNvPr id="2" name="">
             <a:extLst xmlns:a="http://schemas.openxmlformats.org/drawingml/2006/main">
               <a:ext uri="{FF2B5EF4-FFF2-40B4-BE49-F238E27FC236}">
-                <a16:creationId xmlns:a16="http://schemas.microsoft.com/office/drawing/2014/main" id="{3B4724BD-300D-47AF-BEE3-5E73FCC31BBB}"/>
+                <a16:creationId xmlns:a16="http://schemas.microsoft.com/office/drawing/2014/main" id="{F2EE3935-4911-479C-97C1-B37C287D5269}"/>
               </a:ext>
             </a:extLst>
           </p:cNvPr>
@@ -4839,7 +4839,7 @@
           <p:cNvPr id="3" name="">
             <a:extLst xmlns:a="http://schemas.openxmlformats.org/drawingml/2006/main">
               <a:ext uri="{FF2B5EF4-FFF2-40B4-BE49-F238E27FC236}">
-                <a16:creationId xmlns:a16="http://schemas.microsoft.com/office/drawing/2014/main" id="{672D3756-BB3D-4A5C-8BCB-F1F2BA518E02}"/>
+                <a16:creationId xmlns:a16="http://schemas.microsoft.com/office/drawing/2014/main" id="{DCADF16F-43CE-4FD2-8CEB-BE5B9DE39D09}"/>
               </a:ext>
             </a:extLst>
           </p:cNvPr>
@@ -4889,7 +4889,7 @@
           <p:cNvPr id="4" name="">
             <a:extLst xmlns:a="http://schemas.openxmlformats.org/drawingml/2006/main">
               <a:ext uri="{FF2B5EF4-FFF2-40B4-BE49-F238E27FC236}">
-                <a16:creationId xmlns:a16="http://schemas.microsoft.com/office/drawing/2014/main" id="{B5B3D058-4816-4B6B-B386-D725296D3CA6}"/>
+                <a16:creationId xmlns:a16="http://schemas.microsoft.com/office/drawing/2014/main" id="{A25D2028-5873-433E-A78E-59B4235F7966}"/>
               </a:ext>
             </a:extLst>
           </p:cNvPr>
@@ -4920,7 +4920,7 @@
           <p:cNvPr id="5" name="">
             <a:extLst xmlns:a="http://schemas.openxmlformats.org/drawingml/2006/main">
               <a:ext uri="{FF2B5EF4-FFF2-40B4-BE49-F238E27FC236}">
-                <a16:creationId xmlns:a16="http://schemas.microsoft.com/office/drawing/2014/main" id="{A56AFDF1-F145-49F2-ACC2-2C91D87FD898}"/>
+                <a16:creationId xmlns:a16="http://schemas.microsoft.com/office/drawing/2014/main" id="{A99D6551-209B-4085-B455-749AE25A8AC9}"/>
               </a:ext>
             </a:extLst>
           </p:cNvPr>
@@ -4953,7 +4953,7 @@
           <p:cNvPr id="6" name="">
             <a:extLst xmlns:a="http://schemas.openxmlformats.org/drawingml/2006/main">
               <a:ext uri="{FF2B5EF4-FFF2-40B4-BE49-F238E27FC236}">
-                <a16:creationId xmlns:a16="http://schemas.microsoft.com/office/drawing/2014/main" id="{A8C6FAE6-EF78-4056-BBC0-C8DD35797968}"/>
+                <a16:creationId xmlns:a16="http://schemas.microsoft.com/office/drawing/2014/main" id="{7C9BAE9D-C603-40EE-90DC-FA8FC5B2C72B}"/>
               </a:ext>
             </a:extLst>
           </p:cNvPr>
@@ -5003,7 +5003,7 @@
           <p:cNvPr id="7" name="">
             <a:extLst xmlns:a="http://schemas.openxmlformats.org/drawingml/2006/main">
               <a:ext uri="{FF2B5EF4-FFF2-40B4-BE49-F238E27FC236}">
-                <a16:creationId xmlns:a16="http://schemas.microsoft.com/office/drawing/2014/main" id="{E0CC4F3C-39B7-4C18-86E3-436134C18061}"/>
+                <a16:creationId xmlns:a16="http://schemas.microsoft.com/office/drawing/2014/main" id="{E5832532-F2A0-4EB6-A48F-301E84AA7E04}"/>
               </a:ext>
             </a:extLst>
           </p:cNvPr>
@@ -5053,7 +5053,7 @@
           <p:cNvPr id="8" name="">
             <a:extLst xmlns:a="http://schemas.openxmlformats.org/drawingml/2006/main">
               <a:ext uri="{FF2B5EF4-FFF2-40B4-BE49-F238E27FC236}">
-                <a16:creationId xmlns:a16="http://schemas.microsoft.com/office/drawing/2014/main" id="{D0A9BAEC-AE2E-40B5-980B-840C983388FF}"/>
+                <a16:creationId xmlns:a16="http://schemas.microsoft.com/office/drawing/2014/main" id="{78F408A0-D818-4068-9A89-395F3FE38E44}"/>
               </a:ext>
             </a:extLst>
           </p:cNvPr>
@@ -5103,7 +5103,7 @@
           <p:cNvPr id="9" name="">
             <a:extLst xmlns:a="http://schemas.openxmlformats.org/drawingml/2006/main">
               <a:ext uri="{FF2B5EF4-FFF2-40B4-BE49-F238E27FC236}">
-                <a16:creationId xmlns:a16="http://schemas.microsoft.com/office/drawing/2014/main" id="{08222560-D56E-405E-8175-FAA5128BBB15}"/>
+                <a16:creationId xmlns:a16="http://schemas.microsoft.com/office/drawing/2014/main" id="{AE96254C-2FAD-4E22-A0C6-59D074CAC674}"/>
               </a:ext>
             </a:extLst>
           </p:cNvPr>
@@ -5136,7 +5136,7 @@
           <p:cNvPr id="10" name="">
             <a:extLst xmlns:a="http://schemas.openxmlformats.org/drawingml/2006/main">
               <a:ext uri="{FF2B5EF4-FFF2-40B4-BE49-F238E27FC236}">
-                <a16:creationId xmlns:a16="http://schemas.microsoft.com/office/drawing/2014/main" id="{710E6720-10A1-4BE0-9CD2-AC979EDAC2A6}"/>
+                <a16:creationId xmlns:a16="http://schemas.microsoft.com/office/drawing/2014/main" id="{E263EE36-A8E0-4417-AD22-24DFEA64272B}"/>
               </a:ext>
             </a:extLst>
           </p:cNvPr>
@@ -5186,7 +5186,7 @@
           <p:cNvPr id="11" name="">
             <a:extLst xmlns:a="http://schemas.openxmlformats.org/drawingml/2006/main">
               <a:ext uri="{FF2B5EF4-FFF2-40B4-BE49-F238E27FC236}">
-                <a16:creationId xmlns:a16="http://schemas.microsoft.com/office/drawing/2014/main" id="{2FC94C0E-4F36-4FE5-8A32-17CC8A5A292D}"/>
+                <a16:creationId xmlns:a16="http://schemas.microsoft.com/office/drawing/2014/main" id="{FAA2EA5A-CAFC-42F8-9D9A-1FB41FF094EE}"/>
               </a:ext>
             </a:extLst>
           </p:cNvPr>
@@ -5236,7 +5236,7 @@
           <p:cNvPr id="12" name="">
             <a:extLst xmlns:a="http://schemas.openxmlformats.org/drawingml/2006/main">
               <a:ext uri="{FF2B5EF4-FFF2-40B4-BE49-F238E27FC236}">
-                <a16:creationId xmlns:a16="http://schemas.microsoft.com/office/drawing/2014/main" id="{42E3D341-ADC8-4FED-BFD5-E97A32248B5D}"/>
+                <a16:creationId xmlns:a16="http://schemas.microsoft.com/office/drawing/2014/main" id="{7D320DFD-6DB7-4118-A166-D6243A5C7503}"/>
               </a:ext>
             </a:extLst>
           </p:cNvPr>
@@ -5286,7 +5286,7 @@
           <p:cNvPr id="13" name="">
             <a:extLst xmlns:a="http://schemas.openxmlformats.org/drawingml/2006/main">
               <a:ext uri="{FF2B5EF4-FFF2-40B4-BE49-F238E27FC236}">
-                <a16:creationId xmlns:a16="http://schemas.microsoft.com/office/drawing/2014/main" id="{647E922C-19C8-42E4-80CE-1B276933E663}"/>
+                <a16:creationId xmlns:a16="http://schemas.microsoft.com/office/drawing/2014/main" id="{1FB60B29-5F46-45AB-944C-B377D2552078}"/>
               </a:ext>
             </a:extLst>
           </p:cNvPr>
@@ -5319,7 +5319,7 @@
           <p:cNvPr id="14" name="">
             <a:extLst xmlns:a="http://schemas.openxmlformats.org/drawingml/2006/main">
               <a:ext uri="{FF2B5EF4-FFF2-40B4-BE49-F238E27FC236}">
-                <a16:creationId xmlns:a16="http://schemas.microsoft.com/office/drawing/2014/main" id="{264E3DE4-0F0A-4EA3-9975-8AA65C0732CD}"/>
+                <a16:creationId xmlns:a16="http://schemas.microsoft.com/office/drawing/2014/main" id="{AF8503A8-DF31-4C05-B368-5EED919781D0}"/>
               </a:ext>
             </a:extLst>
           </p:cNvPr>
@@ -5369,7 +5369,7 @@
           <p:cNvPr id="15" name="">
             <a:extLst xmlns:a="http://schemas.openxmlformats.org/drawingml/2006/main">
               <a:ext uri="{FF2B5EF4-FFF2-40B4-BE49-F238E27FC236}">
-                <a16:creationId xmlns:a16="http://schemas.microsoft.com/office/drawing/2014/main" id="{13DF6C13-8E30-4ACD-A14D-E3A696851E70}"/>
+                <a16:creationId xmlns:a16="http://schemas.microsoft.com/office/drawing/2014/main" id="{A66FF827-71F6-4B2D-8953-2D4EA82B6225}"/>
               </a:ext>
             </a:extLst>
           </p:cNvPr>
@@ -5419,7 +5419,7 @@
           <p:cNvPr id="16" name="">
             <a:extLst xmlns:a="http://schemas.openxmlformats.org/drawingml/2006/main">
               <a:ext uri="{FF2B5EF4-FFF2-40B4-BE49-F238E27FC236}">
-                <a16:creationId xmlns:a16="http://schemas.microsoft.com/office/drawing/2014/main" id="{AEA65FC2-B331-4E29-9B5D-956DE4354F19}"/>
+                <a16:creationId xmlns:a16="http://schemas.microsoft.com/office/drawing/2014/main" id="{3D309C96-2516-49AF-BF27-6538F6A31503}"/>
               </a:ext>
             </a:extLst>
           </p:cNvPr>
@@ -5469,7 +5469,7 @@
           <p:cNvPr id="17" name="">
             <a:extLst xmlns:a="http://schemas.openxmlformats.org/drawingml/2006/main">
               <a:ext uri="{FF2B5EF4-FFF2-40B4-BE49-F238E27FC236}">
-                <a16:creationId xmlns:a16="http://schemas.microsoft.com/office/drawing/2014/main" id="{A015103D-0BC1-47CF-98C4-296A929757F9}"/>
+                <a16:creationId xmlns:a16="http://schemas.microsoft.com/office/drawing/2014/main" id="{FBAF3D13-90AD-466F-8A96-FF6669179204}"/>
               </a:ext>
             </a:extLst>
           </p:cNvPr>
@@ -5502,7 +5502,7 @@
           <p:cNvPr id="18" name="">
             <a:extLst xmlns:a="http://schemas.openxmlformats.org/drawingml/2006/main">
               <a:ext uri="{FF2B5EF4-FFF2-40B4-BE49-F238E27FC236}">
-                <a16:creationId xmlns:a16="http://schemas.microsoft.com/office/drawing/2014/main" id="{137E7216-CC20-4823-B744-8E5629CA62BE}"/>
+                <a16:creationId xmlns:a16="http://schemas.microsoft.com/office/drawing/2014/main" id="{E3869C21-24A8-4850-BD0A-502BFEBA8D94}"/>
               </a:ext>
             </a:extLst>
           </p:cNvPr>
@@ -5552,7 +5552,7 @@
           <p:cNvPr id="19" name="">
             <a:extLst xmlns:a="http://schemas.openxmlformats.org/drawingml/2006/main">
               <a:ext uri="{FF2B5EF4-FFF2-40B4-BE49-F238E27FC236}">
-                <a16:creationId xmlns:a16="http://schemas.microsoft.com/office/drawing/2014/main" id="{73710DB2-9A9F-4F45-82DC-FD3CCC926E4B}"/>
+                <a16:creationId xmlns:a16="http://schemas.microsoft.com/office/drawing/2014/main" id="{8CE7A126-AE98-4F95-9A5D-4C1EB75BD4A8}"/>
               </a:ext>
             </a:extLst>
           </p:cNvPr>
@@ -5602,7 +5602,7 @@
           <p:cNvPr id="20" name="">
             <a:extLst xmlns:a="http://schemas.openxmlformats.org/drawingml/2006/main">
               <a:ext uri="{FF2B5EF4-FFF2-40B4-BE49-F238E27FC236}">
-                <a16:creationId xmlns:a16="http://schemas.microsoft.com/office/drawing/2014/main" id="{075B4C09-BB38-4C22-90FB-830BDC5FDB3A}"/>
+                <a16:creationId xmlns:a16="http://schemas.microsoft.com/office/drawing/2014/main" id="{8423E82E-657F-4781-B116-505C16F6157E}"/>
               </a:ext>
             </a:extLst>
           </p:cNvPr>
@@ -5652,7 +5652,7 @@
           <p:cNvPr id="21" name="">
             <a:extLst xmlns:a="http://schemas.openxmlformats.org/drawingml/2006/main">
               <a:ext uri="{FF2B5EF4-FFF2-40B4-BE49-F238E27FC236}">
-                <a16:creationId xmlns:a16="http://schemas.microsoft.com/office/drawing/2014/main" id="{A9E171AF-3F9F-4495-87C3-D7C85103B67F}"/>
+                <a16:creationId xmlns:a16="http://schemas.microsoft.com/office/drawing/2014/main" id="{45A4A664-F62C-4B47-AA51-5A7640A87F2F}"/>
               </a:ext>
             </a:extLst>
           </p:cNvPr>
@@ -5687,7 +5687,7 @@
           <p:cNvPr id="22" name="">
             <a:extLst xmlns:a="http://schemas.openxmlformats.org/drawingml/2006/main">
               <a:ext uri="{FF2B5EF4-FFF2-40B4-BE49-F238E27FC236}">
-                <a16:creationId xmlns:a16="http://schemas.microsoft.com/office/drawing/2014/main" id="{781B9D1F-B86D-4F2A-AEFB-93CE4533CE36}"/>
+                <a16:creationId xmlns:a16="http://schemas.microsoft.com/office/drawing/2014/main" id="{09A84567-ECC5-4ED7-B6DA-06672FE764DD}"/>
               </a:ext>
             </a:extLst>
           </p:cNvPr>
@@ -5737,7 +5737,7 @@
           <p:cNvPr id="23" name="">
             <a:extLst xmlns:a="http://schemas.openxmlformats.org/drawingml/2006/main">
               <a:ext uri="{FF2B5EF4-FFF2-40B4-BE49-F238E27FC236}">
-                <a16:creationId xmlns:a16="http://schemas.microsoft.com/office/drawing/2014/main" id="{BCC31859-44B9-481C-84A5-4D19DCCBA5CE}"/>
+                <a16:creationId xmlns:a16="http://schemas.microsoft.com/office/drawing/2014/main" id="{CBAE7F65-6035-403D-8886-D7120FFCCDB4}"/>
               </a:ext>
             </a:extLst>
           </p:cNvPr>
@@ -5794,7 +5794,7 @@
         </p:xfrm>
         <a:graphic xmlns:a="http://schemas.openxmlformats.org/drawingml/2006/main">
           <a:graphicData uri="http://schemas.openxmlformats.org/drawingml/2006/chart">
-            <c:chart xmlns:r="http://schemas.openxmlformats.org/officeDocument/2006/relationships" xmlns:c="http://schemas.openxmlformats.org/drawingml/2006/chart" r:id="Re43ae3e1b9034721"/>
+            <c:chart xmlns:r="http://schemas.openxmlformats.org/officeDocument/2006/relationships" xmlns:c="http://schemas.openxmlformats.org/drawingml/2006/chart" r:id="Rafd8937be75449f5"/>
           </a:graphicData>
         </a:graphic>
       </p:graphicFrame>
@@ -5803,7 +5803,7 @@
           <p:cNvPr id="25" name="">
             <a:extLst xmlns:a="http://schemas.openxmlformats.org/drawingml/2006/main">
               <a:ext uri="{FF2B5EF4-FFF2-40B4-BE49-F238E27FC236}">
-                <a16:creationId xmlns:a16="http://schemas.microsoft.com/office/drawing/2014/main" id="{00982B7C-5210-4764-AC5D-4DD1D44948F9}"/>
+                <a16:creationId xmlns:a16="http://schemas.microsoft.com/office/drawing/2014/main" id="{F98281A3-3B93-4A84-B186-5336468D81F1}"/>
               </a:ext>
             </a:extLst>
           </p:cNvPr>
@@ -5838,7 +5838,7 @@
           <p:cNvPr id="26" name="">
             <a:extLst xmlns:a="http://schemas.openxmlformats.org/drawingml/2006/main">
               <a:ext uri="{FF2B5EF4-FFF2-40B4-BE49-F238E27FC236}">
-                <a16:creationId xmlns:a16="http://schemas.microsoft.com/office/drawing/2014/main" id="{01241FBC-CE33-4433-8B48-01BE10223CAA}"/>
+                <a16:creationId xmlns:a16="http://schemas.microsoft.com/office/drawing/2014/main" id="{7E2AB4E4-E7D3-40E7-931B-22FC808F5E95}"/>
               </a:ext>
             </a:extLst>
           </p:cNvPr>
@@ -5871,7 +5871,7 @@
           <p:cNvPr id="27" name="">
             <a:extLst xmlns:a="http://schemas.openxmlformats.org/drawingml/2006/main">
               <a:ext uri="{FF2B5EF4-FFF2-40B4-BE49-F238E27FC236}">
-                <a16:creationId xmlns:a16="http://schemas.microsoft.com/office/drawing/2014/main" id="{1A1447AB-EE56-40FD-856F-304901A5B611}"/>
+                <a16:creationId xmlns:a16="http://schemas.microsoft.com/office/drawing/2014/main" id="{D7BB5C50-6DF9-47A7-A86C-C2E417C4F486}"/>
               </a:ext>
             </a:extLst>
           </p:cNvPr>
@@ -5921,7 +5921,7 @@
           <p:cNvPr id="28" name="">
             <a:extLst xmlns:a="http://schemas.openxmlformats.org/drawingml/2006/main">
               <a:ext uri="{FF2B5EF4-FFF2-40B4-BE49-F238E27FC236}">
-                <a16:creationId xmlns:a16="http://schemas.microsoft.com/office/drawing/2014/main" id="{F135B6C3-A26B-46BE-8F99-A331A04B5C03}"/>
+                <a16:creationId xmlns:a16="http://schemas.microsoft.com/office/drawing/2014/main" id="{5580FB1E-337B-4948-819B-8BD4DAF73CEC}"/>
               </a:ext>
             </a:extLst>
           </p:cNvPr>
@@ -5971,7 +5971,7 @@
           <p:cNvPr id="29" name="">
             <a:extLst xmlns:a="http://schemas.openxmlformats.org/drawingml/2006/main">
               <a:ext uri="{FF2B5EF4-FFF2-40B4-BE49-F238E27FC236}">
-                <a16:creationId xmlns:a16="http://schemas.microsoft.com/office/drawing/2014/main" id="{477C60DD-7036-4FC3-B738-9E623B0425F8}"/>
+                <a16:creationId xmlns:a16="http://schemas.microsoft.com/office/drawing/2014/main" id="{B6AEE7D6-A423-42D6-BDC1-99BE4D6EFE10}"/>
               </a:ext>
             </a:extLst>
           </p:cNvPr>
@@ -6002,7 +6002,7 @@
           <p:cNvPr id="30" name="">
             <a:extLst xmlns:a="http://schemas.openxmlformats.org/drawingml/2006/main">
               <a:ext uri="{FF2B5EF4-FFF2-40B4-BE49-F238E27FC236}">
-                <a16:creationId xmlns:a16="http://schemas.microsoft.com/office/drawing/2014/main" id="{BA93A5A4-83BE-4947-9786-2A741E8A6569}"/>
+                <a16:creationId xmlns:a16="http://schemas.microsoft.com/office/drawing/2014/main" id="{7A585BBE-FFAD-44C3-9B36-5B5B2BD16BCF}"/>
               </a:ext>
             </a:extLst>
           </p:cNvPr>
@@ -6052,7 +6052,7 @@
           <p:cNvPr id="31" name="">
             <a:extLst xmlns:a="http://schemas.openxmlformats.org/drawingml/2006/main">
               <a:ext uri="{FF2B5EF4-FFF2-40B4-BE49-F238E27FC236}">
-                <a16:creationId xmlns:a16="http://schemas.microsoft.com/office/drawing/2014/main" id="{5393EBFB-FDB2-40FD-B09D-A44B8FCF6B32}"/>
+                <a16:creationId xmlns:a16="http://schemas.microsoft.com/office/drawing/2014/main" id="{B8F505FF-B157-47D2-B16E-0E01A08D720C}"/>
               </a:ext>
             </a:extLst>
           </p:cNvPr>
@@ -6100,7 +6100,7 @@
     </p:spTree>
     <p:extLst>
       <p:ext uri="{BB962C8B-B14F-4D97-AF65-F5344CB8AC3E}">
-        <p14:creationId xmlns:p14="http://schemas.microsoft.com/office/powerpoint/2010/main" val="596428651"/>
+        <p14:creationId xmlns:p14="http://schemas.microsoft.com/office/powerpoint/2010/main" val="1956173917"/>
       </p:ext>
     </p:extLst>
   </p:cSld>
@@ -6131,7 +6131,7 @@
           <p:cNvPr id="20" name="">
             <a:extLst xmlns:a="http://schemas.openxmlformats.org/drawingml/2006/main">
               <a:ext uri="{FF2B5EF4-FFF2-40B4-BE49-F238E27FC236}">
-                <a16:creationId xmlns:a16="http://schemas.microsoft.com/office/drawing/2014/main" id="{C7855D5C-158F-440D-B24F-B097D1AA3D9D}"/>
+                <a16:creationId xmlns:a16="http://schemas.microsoft.com/office/drawing/2014/main" id="{64DC5438-9B10-4109-8A2A-4C6C19A6075C}"/>
               </a:ext>
             </a:extLst>
           </p:cNvPr>
@@ -6181,7 +6181,7 @@
           <p:cNvPr id="2" name="">
             <a:extLst xmlns:a="http://schemas.openxmlformats.org/drawingml/2006/main">
               <a:ext uri="{FF2B5EF4-FFF2-40B4-BE49-F238E27FC236}">
-                <a16:creationId xmlns:a16="http://schemas.microsoft.com/office/drawing/2014/main" id="{E389A1A7-A222-4F02-BF69-7B191FC44CCA}"/>
+                <a16:creationId xmlns:a16="http://schemas.microsoft.com/office/drawing/2014/main" id="{A87A2ABC-A0DF-462E-A434-1EB2677B5895}"/>
               </a:ext>
             </a:extLst>
           </p:cNvPr>
@@ -6231,7 +6231,7 @@
           <p:cNvPr id="3" name="">
             <a:extLst xmlns:a="http://schemas.openxmlformats.org/drawingml/2006/main">
               <a:ext uri="{FF2B5EF4-FFF2-40B4-BE49-F238E27FC236}">
-                <a16:creationId xmlns:a16="http://schemas.microsoft.com/office/drawing/2014/main" id="{1BEA4A98-17F1-40A2-84CA-C7F9B3C276FE}"/>
+                <a16:creationId xmlns:a16="http://schemas.microsoft.com/office/drawing/2014/main" id="{1DE1BD00-BC5E-4B8B-88C4-4E9AE2B1A207}"/>
               </a:ext>
             </a:extLst>
           </p:cNvPr>
@@ -6281,7 +6281,7 @@
           <p:cNvPr id="4" name="">
             <a:extLst xmlns:a="http://schemas.openxmlformats.org/drawingml/2006/main">
               <a:ext uri="{FF2B5EF4-FFF2-40B4-BE49-F238E27FC236}">
-                <a16:creationId xmlns:a16="http://schemas.microsoft.com/office/drawing/2014/main" id="{F82D6CB0-5F90-4F5B-978A-09E7D188D585}"/>
+                <a16:creationId xmlns:a16="http://schemas.microsoft.com/office/drawing/2014/main" id="{CECACB75-3B1B-4BCE-926A-9BD311B5D97A}"/>
               </a:ext>
             </a:extLst>
           </p:cNvPr>
@@ -6312,7 +6312,7 @@
           <p:cNvPr id="5" name="">
             <a:extLst xmlns:a="http://schemas.openxmlformats.org/drawingml/2006/main">
               <a:ext uri="{FF2B5EF4-FFF2-40B4-BE49-F238E27FC236}">
-                <a16:creationId xmlns:a16="http://schemas.microsoft.com/office/drawing/2014/main" id="{4A755377-89CF-427F-9757-50AE1AF640EA}"/>
+                <a16:creationId xmlns:a16="http://schemas.microsoft.com/office/drawing/2014/main" id="{8AA5AED6-539F-4A0F-81B2-39C2E36FB8B3}"/>
               </a:ext>
             </a:extLst>
           </p:cNvPr>
@@ -6347,7 +6347,7 @@
           <p:cNvPr id="6" name="">
             <a:extLst xmlns:a="http://schemas.openxmlformats.org/drawingml/2006/main">
               <a:ext uri="{FF2B5EF4-FFF2-40B4-BE49-F238E27FC236}">
-                <a16:creationId xmlns:a16="http://schemas.microsoft.com/office/drawing/2014/main" id="{C3A9E04F-A2DA-4E36-92A6-7CA214CDB251}"/>
+                <a16:creationId xmlns:a16="http://schemas.microsoft.com/office/drawing/2014/main" id="{D6B5E1FC-5D1A-456D-8C11-0EBDA250F35D}"/>
               </a:ext>
             </a:extLst>
           </p:cNvPr>
@@ -6397,7 +6397,7 @@
           <p:cNvPr id="7" name="">
             <a:extLst xmlns:a="http://schemas.openxmlformats.org/drawingml/2006/main">
               <a:ext uri="{FF2B5EF4-FFF2-40B4-BE49-F238E27FC236}">
-                <a16:creationId xmlns:a16="http://schemas.microsoft.com/office/drawing/2014/main" id="{54D139AE-DFFA-4F1B-9A36-F9DE5FBC3D8D}"/>
+                <a16:creationId xmlns:a16="http://schemas.microsoft.com/office/drawing/2014/main" id="{4BD510E1-4E80-4B89-8654-DCB2746D1739}"/>
               </a:ext>
             </a:extLst>
           </p:cNvPr>
@@ -6454,7 +6454,7 @@
         </p:xfrm>
         <a:graphic xmlns:a="http://schemas.openxmlformats.org/drawingml/2006/main">
           <a:graphicData uri="http://schemas.openxmlformats.org/drawingml/2006/chart">
-            <c:chart xmlns:r="http://schemas.openxmlformats.org/officeDocument/2006/relationships" xmlns:c="http://schemas.openxmlformats.org/drawingml/2006/chart" r:id="Rafa031b6c1534044"/>
+            <c:chart xmlns:r="http://schemas.openxmlformats.org/officeDocument/2006/relationships" xmlns:c="http://schemas.openxmlformats.org/drawingml/2006/chart" r:id="Rc122c7fd73bb4f4c"/>
           </a:graphicData>
         </a:graphic>
       </p:graphicFrame>
@@ -6463,7 +6463,7 @@
           <p:cNvPr id="9" name="">
             <a:extLst xmlns:a="http://schemas.openxmlformats.org/drawingml/2006/main">
               <a:ext uri="{FF2B5EF4-FFF2-40B4-BE49-F238E27FC236}">
-                <a16:creationId xmlns:a16="http://schemas.microsoft.com/office/drawing/2014/main" id="{2193F224-68AB-4108-AFC4-3F851357E947}"/>
+                <a16:creationId xmlns:a16="http://schemas.microsoft.com/office/drawing/2014/main" id="{6B59F544-1256-4CF1-812F-121FCA1F4152}"/>
               </a:ext>
             </a:extLst>
           </p:cNvPr>
@@ -6498,7 +6498,7 @@
           <p:cNvPr id="10" name="">
             <a:extLst xmlns:a="http://schemas.openxmlformats.org/drawingml/2006/main">
               <a:ext uri="{FF2B5EF4-FFF2-40B4-BE49-F238E27FC236}">
-                <a16:creationId xmlns:a16="http://schemas.microsoft.com/office/drawing/2014/main" id="{0CA320BD-1C01-4E57-81DA-C79F11001CF7}"/>
+                <a16:creationId xmlns:a16="http://schemas.microsoft.com/office/drawing/2014/main" id="{3CDDC489-6B69-4E04-936D-4342836776E3}"/>
               </a:ext>
             </a:extLst>
           </p:cNvPr>
@@ -6531,7 +6531,7 @@
           <p:cNvPr id="11" name="">
             <a:extLst xmlns:a="http://schemas.openxmlformats.org/drawingml/2006/main">
               <a:ext uri="{FF2B5EF4-FFF2-40B4-BE49-F238E27FC236}">
-                <a16:creationId xmlns:a16="http://schemas.microsoft.com/office/drawing/2014/main" id="{11A1C0AE-5BB3-4C40-BACD-FD983ECF63E0}"/>
+                <a16:creationId xmlns:a16="http://schemas.microsoft.com/office/drawing/2014/main" id="{7EFC2405-90FA-429A-AD62-FBECBB888972}"/>
               </a:ext>
             </a:extLst>
           </p:cNvPr>
@@ -6581,7 +6581,7 @@
           <p:cNvPr id="12" name="">
             <a:extLst xmlns:a="http://schemas.openxmlformats.org/drawingml/2006/main">
               <a:ext uri="{FF2B5EF4-FFF2-40B4-BE49-F238E27FC236}">
-                <a16:creationId xmlns:a16="http://schemas.microsoft.com/office/drawing/2014/main" id="{FF3813CC-C564-41B3-A9ED-D1E68577DF43}"/>
+                <a16:creationId xmlns:a16="http://schemas.microsoft.com/office/drawing/2014/main" id="{BEB9DD0E-EF6B-499A-8BC3-FDD94C011F4D}"/>
               </a:ext>
             </a:extLst>
           </p:cNvPr>
@@ -6631,7 +6631,7 @@
           <p:cNvPr id="13" name="">
             <a:extLst xmlns:a="http://schemas.openxmlformats.org/drawingml/2006/main">
               <a:ext uri="{FF2B5EF4-FFF2-40B4-BE49-F238E27FC236}">
-                <a16:creationId xmlns:a16="http://schemas.microsoft.com/office/drawing/2014/main" id="{F63EA7E7-E456-4C39-8148-586C97303B1C}"/>
+                <a16:creationId xmlns:a16="http://schemas.microsoft.com/office/drawing/2014/main" id="{0260FC45-82FF-4C99-80DA-9B7A88242314}"/>
               </a:ext>
             </a:extLst>
           </p:cNvPr>
@@ -6666,7 +6666,7 @@
           <p:cNvPr id="14" name="">
             <a:extLst xmlns:a="http://schemas.openxmlformats.org/drawingml/2006/main">
               <a:ext uri="{FF2B5EF4-FFF2-40B4-BE49-F238E27FC236}">
-                <a16:creationId xmlns:a16="http://schemas.microsoft.com/office/drawing/2014/main" id="{C65D3550-80AA-4F78-B0B1-48E7438F47C5}"/>
+                <a16:creationId xmlns:a16="http://schemas.microsoft.com/office/drawing/2014/main" id="{A7D3BE46-C39C-4A96-9D91-7A5AFCE476D9}"/>
               </a:ext>
             </a:extLst>
           </p:cNvPr>
@@ -6699,7 +6699,7 @@
           <p:cNvPr id="15" name="">
             <a:extLst xmlns:a="http://schemas.openxmlformats.org/drawingml/2006/main">
               <a:ext uri="{FF2B5EF4-FFF2-40B4-BE49-F238E27FC236}">
-                <a16:creationId xmlns:a16="http://schemas.microsoft.com/office/drawing/2014/main" id="{D7158E83-2201-4816-9DA3-5E8619D1D580}"/>
+                <a16:creationId xmlns:a16="http://schemas.microsoft.com/office/drawing/2014/main" id="{6C476950-09B1-40AD-B6F2-C69D4DF60066}"/>
               </a:ext>
             </a:extLst>
           </p:cNvPr>
@@ -6749,7 +6749,7 @@
           <p:cNvPr id="16" name="">
             <a:extLst xmlns:a="http://schemas.openxmlformats.org/drawingml/2006/main">
               <a:ext uri="{FF2B5EF4-FFF2-40B4-BE49-F238E27FC236}">
-                <a16:creationId xmlns:a16="http://schemas.microsoft.com/office/drawing/2014/main" id="{EB383009-DADA-4268-86E9-14C1F4154FFA}"/>
+                <a16:creationId xmlns:a16="http://schemas.microsoft.com/office/drawing/2014/main" id="{04A0DA65-903D-4AE3-854F-131C26D0E250}"/>
               </a:ext>
             </a:extLst>
           </p:cNvPr>
@@ -6799,7 +6799,7 @@
           <p:cNvPr id="17" name="">
             <a:extLst xmlns:a="http://schemas.openxmlformats.org/drawingml/2006/main">
               <a:ext uri="{FF2B5EF4-FFF2-40B4-BE49-F238E27FC236}">
-                <a16:creationId xmlns:a16="http://schemas.microsoft.com/office/drawing/2014/main" id="{9F5DA49E-174B-423D-B8B3-4616053C5A9A}"/>
+                <a16:creationId xmlns:a16="http://schemas.microsoft.com/office/drawing/2014/main" id="{AC73923A-9BA9-4703-9760-B6D1E8A4C815}"/>
               </a:ext>
             </a:extLst>
           </p:cNvPr>
@@ -6830,7 +6830,7 @@
           <p:cNvPr id="18" name="">
             <a:extLst xmlns:a="http://schemas.openxmlformats.org/drawingml/2006/main">
               <a:ext uri="{FF2B5EF4-FFF2-40B4-BE49-F238E27FC236}">
-                <a16:creationId xmlns:a16="http://schemas.microsoft.com/office/drawing/2014/main" id="{BAB721F4-A26C-462C-A41B-441F2AD1E836}"/>
+                <a16:creationId xmlns:a16="http://schemas.microsoft.com/office/drawing/2014/main" id="{A0B6AECE-E01E-466E-BC80-0F012FF401EB}"/>
               </a:ext>
             </a:extLst>
           </p:cNvPr>
@@ -6880,7 +6880,7 @@
           <p:cNvPr id="19" name="">
             <a:extLst xmlns:a="http://schemas.openxmlformats.org/drawingml/2006/main">
               <a:ext uri="{FF2B5EF4-FFF2-40B4-BE49-F238E27FC236}">
-                <a16:creationId xmlns:a16="http://schemas.microsoft.com/office/drawing/2014/main" id="{470A10BD-614B-4945-BAA8-78ECED8C8577}"/>
+                <a16:creationId xmlns:a16="http://schemas.microsoft.com/office/drawing/2014/main" id="{7BE974AD-5C0A-4994-8348-62870532CE8D}"/>
               </a:ext>
             </a:extLst>
           </p:cNvPr>
@@ -6928,7 +6928,7 @@
     </p:spTree>
     <p:extLst>
       <p:ext uri="{BB962C8B-B14F-4D97-AF65-F5344CB8AC3E}">
-        <p14:creationId xmlns:p14="http://schemas.microsoft.com/office/powerpoint/2010/main" val="1873938793"/>
+        <p14:creationId xmlns:p14="http://schemas.microsoft.com/office/powerpoint/2010/main" val="1206292574"/>
       </p:ext>
     </p:extLst>
   </p:cSld>
@@ -6959,7 +6959,7 @@
           <p:cNvPr id="20" name="">
             <a:extLst xmlns:a="http://schemas.openxmlformats.org/drawingml/2006/main">
               <a:ext uri="{FF2B5EF4-FFF2-40B4-BE49-F238E27FC236}">
-                <a16:creationId xmlns:a16="http://schemas.microsoft.com/office/drawing/2014/main" id="{B7FB9BEB-F5B4-4707-B68F-EB78DD531353}"/>
+                <a16:creationId xmlns:a16="http://schemas.microsoft.com/office/drawing/2014/main" id="{C4353786-5315-43F2-AD65-935591B6B2C8}"/>
               </a:ext>
             </a:extLst>
           </p:cNvPr>
@@ -6992,7 +6992,7 @@
           <p:cNvPr id="2" name="">
             <a:extLst xmlns:a="http://schemas.openxmlformats.org/drawingml/2006/main">
               <a:ext uri="{FF2B5EF4-FFF2-40B4-BE49-F238E27FC236}">
-                <a16:creationId xmlns:a16="http://schemas.microsoft.com/office/drawing/2014/main" id="{1D2F74DC-2E96-4367-B7C4-22B8BFF8E6B8}"/>
+                <a16:creationId xmlns:a16="http://schemas.microsoft.com/office/drawing/2014/main" id="{9E60F0E5-0A2A-4B4C-8B5B-814BA6230117}"/>
               </a:ext>
             </a:extLst>
           </p:cNvPr>
@@ -7042,7 +7042,7 @@
           <p:cNvPr id="3" name="">
             <a:extLst xmlns:a="http://schemas.openxmlformats.org/drawingml/2006/main">
               <a:ext uri="{FF2B5EF4-FFF2-40B4-BE49-F238E27FC236}">
-                <a16:creationId xmlns:a16="http://schemas.microsoft.com/office/drawing/2014/main" id="{4491B567-333B-4E33-AE88-103D53884969}"/>
+                <a16:creationId xmlns:a16="http://schemas.microsoft.com/office/drawing/2014/main" id="{4C87A444-6146-4E82-93CD-E7DB167201DE}"/>
               </a:ext>
             </a:extLst>
           </p:cNvPr>
@@ -7092,7 +7092,7 @@
           <p:cNvPr id="4" name="">
             <a:extLst xmlns:a="http://schemas.openxmlformats.org/drawingml/2006/main">
               <a:ext uri="{FF2B5EF4-FFF2-40B4-BE49-F238E27FC236}">
-                <a16:creationId xmlns:a16="http://schemas.microsoft.com/office/drawing/2014/main" id="{7D740AFE-4D4B-41CA-AF14-140ED61CC8F5}"/>
+                <a16:creationId xmlns:a16="http://schemas.microsoft.com/office/drawing/2014/main" id="{DE23CEFD-233A-4EAB-A023-DD507CC2357F}"/>
               </a:ext>
             </a:extLst>
           </p:cNvPr>
@@ -7142,7 +7142,7 @@
           <p:cNvPr id="5" name="">
             <a:extLst xmlns:a="http://schemas.openxmlformats.org/drawingml/2006/main">
               <a:ext uri="{FF2B5EF4-FFF2-40B4-BE49-F238E27FC236}">
-                <a16:creationId xmlns:a16="http://schemas.microsoft.com/office/drawing/2014/main" id="{4300E135-F15C-4F48-84FF-ADDE0E3EF23A}"/>
+                <a16:creationId xmlns:a16="http://schemas.microsoft.com/office/drawing/2014/main" id="{4B72892F-20F7-48F9-9520-682316D15E8E}"/>
               </a:ext>
             </a:extLst>
           </p:cNvPr>
@@ -7177,7 +7177,7 @@
           <p:cNvPr id="6" name="">
             <a:extLst xmlns:a="http://schemas.openxmlformats.org/drawingml/2006/main">
               <a:ext uri="{FF2B5EF4-FFF2-40B4-BE49-F238E27FC236}">
-                <a16:creationId xmlns:a16="http://schemas.microsoft.com/office/drawing/2014/main" id="{4B6A88E9-F43E-4169-A948-0CA8B2CFFB8F}"/>
+                <a16:creationId xmlns:a16="http://schemas.microsoft.com/office/drawing/2014/main" id="{FBF63C1F-434C-4BCA-BEAE-24777B192292}"/>
               </a:ext>
             </a:extLst>
           </p:cNvPr>
@@ -7210,7 +7210,7 @@
           <p:cNvPr id="7" name="">
             <a:extLst xmlns:a="http://schemas.openxmlformats.org/drawingml/2006/main">
               <a:ext uri="{FF2B5EF4-FFF2-40B4-BE49-F238E27FC236}">
-                <a16:creationId xmlns:a16="http://schemas.microsoft.com/office/drawing/2014/main" id="{90B1B96F-3480-4D3F-921D-17DF7365AF23}"/>
+                <a16:creationId xmlns:a16="http://schemas.microsoft.com/office/drawing/2014/main" id="{B18F38C9-CE04-4617-B8E2-4D9898C50729}"/>
               </a:ext>
             </a:extLst>
           </p:cNvPr>
@@ -7260,7 +7260,7 @@
           <p:cNvPr id="8" name="">
             <a:extLst xmlns:a="http://schemas.openxmlformats.org/drawingml/2006/main">
               <a:ext uri="{FF2B5EF4-FFF2-40B4-BE49-F238E27FC236}">
-                <a16:creationId xmlns:a16="http://schemas.microsoft.com/office/drawing/2014/main" id="{725F64B2-8DD1-41DA-95DF-55AD35F3BE8B}"/>
+                <a16:creationId xmlns:a16="http://schemas.microsoft.com/office/drawing/2014/main" id="{99DD70B5-F042-4231-878C-A69E7CB1BD46}"/>
               </a:ext>
             </a:extLst>
           </p:cNvPr>
@@ -7310,7 +7310,7 @@
           <p:cNvPr id="9" name="">
             <a:extLst xmlns:a="http://schemas.openxmlformats.org/drawingml/2006/main">
               <a:ext uri="{FF2B5EF4-FFF2-40B4-BE49-F238E27FC236}">
-                <a16:creationId xmlns:a16="http://schemas.microsoft.com/office/drawing/2014/main" id="{E85AA777-55E6-4AFB-A2B5-D50591E8CFC3}"/>
+                <a16:creationId xmlns:a16="http://schemas.microsoft.com/office/drawing/2014/main" id="{DDAAB3A5-A424-4802-AF23-62E5C736FC96}"/>
               </a:ext>
             </a:extLst>
           </p:cNvPr>
@@ -7345,7 +7345,7 @@
           <p:cNvPr id="10" name="">
             <a:extLst xmlns:a="http://schemas.openxmlformats.org/drawingml/2006/main">
               <a:ext uri="{FF2B5EF4-FFF2-40B4-BE49-F238E27FC236}">
-                <a16:creationId xmlns:a16="http://schemas.microsoft.com/office/drawing/2014/main" id="{7D278A43-821E-40CA-A73A-7D1A9C4B525C}"/>
+                <a16:creationId xmlns:a16="http://schemas.microsoft.com/office/drawing/2014/main" id="{17689022-AE1B-4D58-8523-C157B27A3E47}"/>
               </a:ext>
             </a:extLst>
           </p:cNvPr>
@@ -7378,7 +7378,7 @@
           <p:cNvPr id="11" name="">
             <a:extLst xmlns:a="http://schemas.openxmlformats.org/drawingml/2006/main">
               <a:ext uri="{FF2B5EF4-FFF2-40B4-BE49-F238E27FC236}">
-                <a16:creationId xmlns:a16="http://schemas.microsoft.com/office/drawing/2014/main" id="{2495F16A-DB83-4DCE-BEB4-11097C48366D}"/>
+                <a16:creationId xmlns:a16="http://schemas.microsoft.com/office/drawing/2014/main" id="{D02BCEEF-448D-4B9D-8388-069A9CA49AA5}"/>
               </a:ext>
             </a:extLst>
           </p:cNvPr>
@@ -7428,7 +7428,7 @@
           <p:cNvPr id="12" name="">
             <a:extLst xmlns:a="http://schemas.openxmlformats.org/drawingml/2006/main">
               <a:ext uri="{FF2B5EF4-FFF2-40B4-BE49-F238E27FC236}">
-                <a16:creationId xmlns:a16="http://schemas.microsoft.com/office/drawing/2014/main" id="{72A525D1-D601-4CBE-869A-0D086845C683}"/>
+                <a16:creationId xmlns:a16="http://schemas.microsoft.com/office/drawing/2014/main" id="{A0184275-7E9A-44A9-A6DA-AFD3109658F9}"/>
               </a:ext>
             </a:extLst>
           </p:cNvPr>
@@ -7478,7 +7478,7 @@
           <p:cNvPr id="13" name="">
             <a:extLst xmlns:a="http://schemas.openxmlformats.org/drawingml/2006/main">
               <a:ext uri="{FF2B5EF4-FFF2-40B4-BE49-F238E27FC236}">
-                <a16:creationId xmlns:a16="http://schemas.microsoft.com/office/drawing/2014/main" id="{343BEE5A-5D31-496B-B1BB-37539A3DE4B6}"/>
+                <a16:creationId xmlns:a16="http://schemas.microsoft.com/office/drawing/2014/main" id="{BDDFDA4A-8F6F-4810-A83A-EF33646B9871}"/>
               </a:ext>
             </a:extLst>
           </p:cNvPr>
@@ -7513,7 +7513,7 @@
           <p:cNvPr id="14" name="">
             <a:extLst xmlns:a="http://schemas.openxmlformats.org/drawingml/2006/main">
               <a:ext uri="{FF2B5EF4-FFF2-40B4-BE49-F238E27FC236}">
-                <a16:creationId xmlns:a16="http://schemas.microsoft.com/office/drawing/2014/main" id="{9973D0C6-7650-4428-B55B-DB4404E97E63}"/>
+                <a16:creationId xmlns:a16="http://schemas.microsoft.com/office/drawing/2014/main" id="{CCCE9962-DDB8-44AE-8A29-64235B07F837}"/>
               </a:ext>
             </a:extLst>
           </p:cNvPr>
@@ -7546,7 +7546,7 @@
           <p:cNvPr id="15" name="">
             <a:extLst xmlns:a="http://schemas.openxmlformats.org/drawingml/2006/main">
               <a:ext uri="{FF2B5EF4-FFF2-40B4-BE49-F238E27FC236}">
-                <a16:creationId xmlns:a16="http://schemas.microsoft.com/office/drawing/2014/main" id="{FF093E13-179A-4DF1-AEF6-B0C906CC5FE7}"/>
+                <a16:creationId xmlns:a16="http://schemas.microsoft.com/office/drawing/2014/main" id="{8ADB8A2B-98B1-408E-8BB7-40447E8AC1B1}"/>
               </a:ext>
             </a:extLst>
           </p:cNvPr>
@@ -7596,7 +7596,7 @@
           <p:cNvPr id="16" name="">
             <a:extLst xmlns:a="http://schemas.openxmlformats.org/drawingml/2006/main">
               <a:ext uri="{FF2B5EF4-FFF2-40B4-BE49-F238E27FC236}">
-                <a16:creationId xmlns:a16="http://schemas.microsoft.com/office/drawing/2014/main" id="{E586DBBE-A466-4C15-8842-0D91B401A69A}"/>
+                <a16:creationId xmlns:a16="http://schemas.microsoft.com/office/drawing/2014/main" id="{4524CDF3-AA0A-4D85-B6E4-62CE2E121CA4}"/>
               </a:ext>
             </a:extLst>
           </p:cNvPr>
@@ -7646,7 +7646,7 @@
           <p:cNvPr id="17" name="">
             <a:extLst xmlns:a="http://schemas.openxmlformats.org/drawingml/2006/main">
               <a:ext uri="{FF2B5EF4-FFF2-40B4-BE49-F238E27FC236}">
-                <a16:creationId xmlns:a16="http://schemas.microsoft.com/office/drawing/2014/main" id="{3EFAAB49-C864-45E0-85E4-989D6A90E072}"/>
+                <a16:creationId xmlns:a16="http://schemas.microsoft.com/office/drawing/2014/main" id="{44837987-9AEE-444B-82EB-184A548BFF90}"/>
               </a:ext>
             </a:extLst>
           </p:cNvPr>
@@ -7696,7 +7696,7 @@
           <p:cNvPr id="18" name="">
             <a:extLst xmlns:a="http://schemas.openxmlformats.org/drawingml/2006/main">
               <a:ext uri="{FF2B5EF4-FFF2-40B4-BE49-F238E27FC236}">
-                <a16:creationId xmlns:a16="http://schemas.microsoft.com/office/drawing/2014/main" id="{D2641B57-EF13-417A-922C-ABFA69ABCE09}"/>
+                <a16:creationId xmlns:a16="http://schemas.microsoft.com/office/drawing/2014/main" id="{6337C7B0-FAC6-4362-B146-3A31CC464202}"/>
               </a:ext>
             </a:extLst>
           </p:cNvPr>
@@ -7746,7 +7746,7 @@
           <p:cNvPr id="19" name="">
             <a:extLst xmlns:a="http://schemas.openxmlformats.org/drawingml/2006/main">
               <a:ext uri="{FF2B5EF4-FFF2-40B4-BE49-F238E27FC236}">
-                <a16:creationId xmlns:a16="http://schemas.microsoft.com/office/drawing/2014/main" id="{73CFDF60-03BC-4539-A8BB-BC893841D9D9}"/>
+                <a16:creationId xmlns:a16="http://schemas.microsoft.com/office/drawing/2014/main" id="{AE648937-16B7-42DF-A0B5-152B2DA3F284}"/>
               </a:ext>
             </a:extLst>
           </p:cNvPr>
@@ -7794,7 +7794,7 @@
     </p:spTree>
     <p:extLst>
       <p:ext uri="{BB962C8B-B14F-4D97-AF65-F5344CB8AC3E}">
-        <p14:creationId xmlns:p14="http://schemas.microsoft.com/office/powerpoint/2010/main" val="1788876364"/>
+        <p14:creationId xmlns:p14="http://schemas.microsoft.com/office/powerpoint/2010/main" val="1873527480"/>
       </p:ext>
     </p:extLst>
   </p:cSld>
@@ -7825,7 +7825,7 @@
           <p:cNvPr id="22" name="">
             <a:extLst xmlns:a="http://schemas.openxmlformats.org/drawingml/2006/main">
               <a:ext uri="{FF2B5EF4-FFF2-40B4-BE49-F238E27FC236}">
-                <a16:creationId xmlns:a16="http://schemas.microsoft.com/office/drawing/2014/main" id="{18D9D5D0-B552-4788-97AC-E5A6E568F76D}"/>
+                <a16:creationId xmlns:a16="http://schemas.microsoft.com/office/drawing/2014/main" id="{AA61438C-F08E-4D9D-8E6C-3D78CCE3EE7C}"/>
               </a:ext>
             </a:extLst>
           </p:cNvPr>
@@ -7875,7 +7875,7 @@
           <p:cNvPr id="2" name="">
             <a:extLst xmlns:a="http://schemas.openxmlformats.org/drawingml/2006/main">
               <a:ext uri="{FF2B5EF4-FFF2-40B4-BE49-F238E27FC236}">
-                <a16:creationId xmlns:a16="http://schemas.microsoft.com/office/drawing/2014/main" id="{7C4877A2-73AC-4371-817F-D8349D80D503}"/>
+                <a16:creationId xmlns:a16="http://schemas.microsoft.com/office/drawing/2014/main" id="{09C69430-9869-4316-94E7-CA7A9BE8174C}"/>
               </a:ext>
             </a:extLst>
           </p:cNvPr>
@@ -7925,7 +7925,7 @@
           <p:cNvPr id="3" name="">
             <a:extLst xmlns:a="http://schemas.openxmlformats.org/drawingml/2006/main">
               <a:ext uri="{FF2B5EF4-FFF2-40B4-BE49-F238E27FC236}">
-                <a16:creationId xmlns:a16="http://schemas.microsoft.com/office/drawing/2014/main" id="{A72E9A74-B5B8-4851-A1F2-12DC0F7AE725}"/>
+                <a16:creationId xmlns:a16="http://schemas.microsoft.com/office/drawing/2014/main" id="{B4637590-7963-44D2-B942-91D5B57A16D5}"/>
               </a:ext>
             </a:extLst>
           </p:cNvPr>
@@ -7975,7 +7975,7 @@
           <p:cNvPr id="4" name="">
             <a:extLst xmlns:a="http://schemas.openxmlformats.org/drawingml/2006/main">
               <a:ext uri="{FF2B5EF4-FFF2-40B4-BE49-F238E27FC236}">
-                <a16:creationId xmlns:a16="http://schemas.microsoft.com/office/drawing/2014/main" id="{71D5655C-7AED-4CEA-AC1F-5D1E8DF98399}"/>
+                <a16:creationId xmlns:a16="http://schemas.microsoft.com/office/drawing/2014/main" id="{CC70C989-BBF5-491D-B217-71BCF9E9034B}"/>
               </a:ext>
             </a:extLst>
           </p:cNvPr>
@@ -8006,7 +8006,7 @@
           <p:cNvPr id="5" name="">
             <a:extLst xmlns:a="http://schemas.openxmlformats.org/drawingml/2006/main">
               <a:ext uri="{FF2B5EF4-FFF2-40B4-BE49-F238E27FC236}">
-                <a16:creationId xmlns:a16="http://schemas.microsoft.com/office/drawing/2014/main" id="{59B2B678-75CC-4FFB-9A05-1B1E74BB3862}"/>
+                <a16:creationId xmlns:a16="http://schemas.microsoft.com/office/drawing/2014/main" id="{A29C4A41-DFEF-4A21-AB4F-83BEAAF827B1}"/>
               </a:ext>
             </a:extLst>
           </p:cNvPr>
@@ -8041,7 +8041,7 @@
           <p:cNvPr id="6" name="">
             <a:extLst xmlns:a="http://schemas.openxmlformats.org/drawingml/2006/main">
               <a:ext uri="{FF2B5EF4-FFF2-40B4-BE49-F238E27FC236}">
-                <a16:creationId xmlns:a16="http://schemas.microsoft.com/office/drawing/2014/main" id="{D7D6CA86-FCA5-4D67-A5FF-D34EC3EB7B3B}"/>
+                <a16:creationId xmlns:a16="http://schemas.microsoft.com/office/drawing/2014/main" id="{ECD268B2-DC69-41BD-9200-22A9C0E7E78F}"/>
               </a:ext>
             </a:extLst>
           </p:cNvPr>
@@ -8074,7 +8074,7 @@
           <p:cNvPr id="7" name="">
             <a:extLst xmlns:a="http://schemas.openxmlformats.org/drawingml/2006/main">
               <a:ext uri="{FF2B5EF4-FFF2-40B4-BE49-F238E27FC236}">
-                <a16:creationId xmlns:a16="http://schemas.microsoft.com/office/drawing/2014/main" id="{9405D91D-A0BE-47CC-93D0-BE17577B7477}"/>
+                <a16:creationId xmlns:a16="http://schemas.microsoft.com/office/drawing/2014/main" id="{579C35AC-A48A-4022-B68E-3F106369E0DE}"/>
               </a:ext>
             </a:extLst>
           </p:cNvPr>
@@ -8124,7 +8124,7 @@
           <p:cNvPr id="8" name="">
             <a:extLst xmlns:a="http://schemas.openxmlformats.org/drawingml/2006/main">
               <a:ext uri="{FF2B5EF4-FFF2-40B4-BE49-F238E27FC236}">
-                <a16:creationId xmlns:a16="http://schemas.microsoft.com/office/drawing/2014/main" id="{7278F871-E61E-4700-87FF-DBE89ADBA4D4}"/>
+                <a16:creationId xmlns:a16="http://schemas.microsoft.com/office/drawing/2014/main" id="{FAA1667A-1013-4F38-A904-E1BD3A148BD8}"/>
               </a:ext>
             </a:extLst>
           </p:cNvPr>
@@ -8174,7 +8174,7 @@
           <p:cNvPr id="9" name="">
             <a:extLst xmlns:a="http://schemas.openxmlformats.org/drawingml/2006/main">
               <a:ext uri="{FF2B5EF4-FFF2-40B4-BE49-F238E27FC236}">
-                <a16:creationId xmlns:a16="http://schemas.microsoft.com/office/drawing/2014/main" id="{F1FF13DD-74EC-422C-BB94-D40A0862E626}"/>
+                <a16:creationId xmlns:a16="http://schemas.microsoft.com/office/drawing/2014/main" id="{6BB82F10-5B4F-4540-9A24-011F535C8FCC}"/>
               </a:ext>
             </a:extLst>
           </p:cNvPr>
@@ -8209,7 +8209,7 @@
           <p:cNvPr id="10" name="">
             <a:extLst xmlns:a="http://schemas.openxmlformats.org/drawingml/2006/main">
               <a:ext uri="{FF2B5EF4-FFF2-40B4-BE49-F238E27FC236}">
-                <a16:creationId xmlns:a16="http://schemas.microsoft.com/office/drawing/2014/main" id="{C3E7EA50-C3AF-4AFC-8DCC-9040ABD31DAB}"/>
+                <a16:creationId xmlns:a16="http://schemas.microsoft.com/office/drawing/2014/main" id="{C5163ADA-5C21-49DE-AF61-6B8A14E81277}"/>
               </a:ext>
             </a:extLst>
           </p:cNvPr>
@@ -8242,7 +8242,7 @@
           <p:cNvPr id="11" name="">
             <a:extLst xmlns:a="http://schemas.openxmlformats.org/drawingml/2006/main">
               <a:ext uri="{FF2B5EF4-FFF2-40B4-BE49-F238E27FC236}">
-                <a16:creationId xmlns:a16="http://schemas.microsoft.com/office/drawing/2014/main" id="{A8E9C8A8-8430-4A7E-86B4-62D5A80EF9C7}"/>
+                <a16:creationId xmlns:a16="http://schemas.microsoft.com/office/drawing/2014/main" id="{A5835B51-0CDC-4582-BD05-28F9AE20D0A0}"/>
               </a:ext>
             </a:extLst>
           </p:cNvPr>
@@ -8292,7 +8292,7 @@
           <p:cNvPr id="12" name="">
             <a:extLst xmlns:a="http://schemas.openxmlformats.org/drawingml/2006/main">
               <a:ext uri="{FF2B5EF4-FFF2-40B4-BE49-F238E27FC236}">
-                <a16:creationId xmlns:a16="http://schemas.microsoft.com/office/drawing/2014/main" id="{4301A31D-C4C1-4217-A980-C22F1E45916F}"/>
+                <a16:creationId xmlns:a16="http://schemas.microsoft.com/office/drawing/2014/main" id="{5470387B-BB05-4023-8901-4ACD6290EC5E}"/>
               </a:ext>
             </a:extLst>
           </p:cNvPr>
@@ -8342,7 +8342,7 @@
           <p:cNvPr id="13" name="">
             <a:extLst xmlns:a="http://schemas.openxmlformats.org/drawingml/2006/main">
               <a:ext uri="{FF2B5EF4-FFF2-40B4-BE49-F238E27FC236}">
-                <a16:creationId xmlns:a16="http://schemas.microsoft.com/office/drawing/2014/main" id="{CA65BFDF-DAB3-4539-A278-5CED7DCD8D1D}"/>
+                <a16:creationId xmlns:a16="http://schemas.microsoft.com/office/drawing/2014/main" id="{BD30F805-AE29-4DDD-B325-778F66547240}"/>
               </a:ext>
             </a:extLst>
           </p:cNvPr>
@@ -8377,7 +8377,7 @@
           <p:cNvPr id="14" name="">
             <a:extLst xmlns:a="http://schemas.openxmlformats.org/drawingml/2006/main">
               <a:ext uri="{FF2B5EF4-FFF2-40B4-BE49-F238E27FC236}">
-                <a16:creationId xmlns:a16="http://schemas.microsoft.com/office/drawing/2014/main" id="{7CF5F6E2-134D-4BD2-886F-64E3B542FCB4}"/>
+                <a16:creationId xmlns:a16="http://schemas.microsoft.com/office/drawing/2014/main" id="{6B71F129-AA6B-4A59-9F70-B0AF80F67451}"/>
               </a:ext>
             </a:extLst>
           </p:cNvPr>
@@ -8410,7 +8410,7 @@
           <p:cNvPr id="15" name="">
             <a:extLst xmlns:a="http://schemas.openxmlformats.org/drawingml/2006/main">
               <a:ext uri="{FF2B5EF4-FFF2-40B4-BE49-F238E27FC236}">
-                <a16:creationId xmlns:a16="http://schemas.microsoft.com/office/drawing/2014/main" id="{401D90A4-DBDC-4CBF-B4CD-08D918A533B7}"/>
+                <a16:creationId xmlns:a16="http://schemas.microsoft.com/office/drawing/2014/main" id="{DA1FB580-5840-4DFD-B135-F4699AD5809A}"/>
               </a:ext>
             </a:extLst>
           </p:cNvPr>
@@ -8460,7 +8460,7 @@
           <p:cNvPr id="16" name="">
             <a:extLst xmlns:a="http://schemas.openxmlformats.org/drawingml/2006/main">
               <a:ext uri="{FF2B5EF4-FFF2-40B4-BE49-F238E27FC236}">
-                <a16:creationId xmlns:a16="http://schemas.microsoft.com/office/drawing/2014/main" id="{C74526F6-9F6C-4A8D-99BD-1914F9F6DAE5}"/>
+                <a16:creationId xmlns:a16="http://schemas.microsoft.com/office/drawing/2014/main" id="{0B53D0CA-9441-41C6-B432-57F8271BB297}"/>
               </a:ext>
             </a:extLst>
           </p:cNvPr>
@@ -8510,7 +8510,7 @@
           <p:cNvPr id="17" name="">
             <a:extLst xmlns:a="http://schemas.openxmlformats.org/drawingml/2006/main">
               <a:ext uri="{FF2B5EF4-FFF2-40B4-BE49-F238E27FC236}">
-                <a16:creationId xmlns:a16="http://schemas.microsoft.com/office/drawing/2014/main" id="{8E2007CD-AF48-4D1F-AB7B-EA78A028CBCB}"/>
+                <a16:creationId xmlns:a16="http://schemas.microsoft.com/office/drawing/2014/main" id="{58EEF1CE-9541-4326-9271-FD891C71476C}"/>
               </a:ext>
             </a:extLst>
           </p:cNvPr>
@@ -8560,7 +8560,7 @@
           <p:cNvPr id="18" name="">
             <a:extLst xmlns:a="http://schemas.openxmlformats.org/drawingml/2006/main">
               <a:ext uri="{FF2B5EF4-FFF2-40B4-BE49-F238E27FC236}">
-                <a16:creationId xmlns:a16="http://schemas.microsoft.com/office/drawing/2014/main" id="{1367E8D9-8F12-4364-BCDE-5E1982BB9EEE}"/>
+                <a16:creationId xmlns:a16="http://schemas.microsoft.com/office/drawing/2014/main" id="{732B614A-10BC-4FB9-87A4-B311446BD018}"/>
               </a:ext>
             </a:extLst>
           </p:cNvPr>
@@ -8610,7 +8610,7 @@
           <p:cNvPr id="19" name="">
             <a:extLst xmlns:a="http://schemas.openxmlformats.org/drawingml/2006/main">
               <a:ext uri="{FF2B5EF4-FFF2-40B4-BE49-F238E27FC236}">
-                <a16:creationId xmlns:a16="http://schemas.microsoft.com/office/drawing/2014/main" id="{F17A3FBF-6FC9-4BE7-AA40-F77F371FF945}"/>
+                <a16:creationId xmlns:a16="http://schemas.microsoft.com/office/drawing/2014/main" id="{08617CB4-8CEE-4E7C-B65A-359F680D4796}"/>
               </a:ext>
             </a:extLst>
           </p:cNvPr>
@@ -8641,7 +8641,7 @@
           <p:cNvPr id="20" name="">
             <a:extLst xmlns:a="http://schemas.openxmlformats.org/drawingml/2006/main">
               <a:ext uri="{FF2B5EF4-FFF2-40B4-BE49-F238E27FC236}">
-                <a16:creationId xmlns:a16="http://schemas.microsoft.com/office/drawing/2014/main" id="{391A0742-14E0-4FAB-B734-B45A45290549}"/>
+                <a16:creationId xmlns:a16="http://schemas.microsoft.com/office/drawing/2014/main" id="{8C4DFC4B-0E9E-4E67-A5CD-B593BF896D04}"/>
               </a:ext>
             </a:extLst>
           </p:cNvPr>
@@ -8691,7 +8691,7 @@
           <p:cNvPr id="21" name="">
             <a:extLst xmlns:a="http://schemas.openxmlformats.org/drawingml/2006/main">
               <a:ext uri="{FF2B5EF4-FFF2-40B4-BE49-F238E27FC236}">
-                <a16:creationId xmlns:a16="http://schemas.microsoft.com/office/drawing/2014/main" id="{E04CADDF-8434-407D-932D-F42969E9D67C}"/>
+                <a16:creationId xmlns:a16="http://schemas.microsoft.com/office/drawing/2014/main" id="{8AD3E678-AC58-477D-B5C6-A55DFCF395E8}"/>
               </a:ext>
             </a:extLst>
           </p:cNvPr>
@@ -8739,7 +8739,7 @@
     </p:spTree>
     <p:extLst>
       <p:ext uri="{BB962C8B-B14F-4D97-AF65-F5344CB8AC3E}">
-        <p14:creationId xmlns:p14="http://schemas.microsoft.com/office/powerpoint/2010/main" val="157197228"/>
+        <p14:creationId xmlns:p14="http://schemas.microsoft.com/office/powerpoint/2010/main" val="1651675626"/>
       </p:ext>
     </p:extLst>
   </p:cSld>
@@ -8770,7 +8770,7 @@
           <p:cNvPr id="32" name="">
             <a:extLst xmlns:a="http://schemas.openxmlformats.org/drawingml/2006/main">
               <a:ext uri="{FF2B5EF4-FFF2-40B4-BE49-F238E27FC236}">
-                <a16:creationId xmlns:a16="http://schemas.microsoft.com/office/drawing/2014/main" id="{0C0BE74E-96F8-42C2-91B1-2D4992A5F789}"/>
+                <a16:creationId xmlns:a16="http://schemas.microsoft.com/office/drawing/2014/main" id="{A1347B42-F5E0-4E6D-8967-FD9714FA7C13}"/>
               </a:ext>
             </a:extLst>
           </p:cNvPr>
@@ -8820,7 +8820,7 @@
           <p:cNvPr id="2" name="">
             <a:extLst xmlns:a="http://schemas.openxmlformats.org/drawingml/2006/main">
               <a:ext uri="{FF2B5EF4-FFF2-40B4-BE49-F238E27FC236}">
-                <a16:creationId xmlns:a16="http://schemas.microsoft.com/office/drawing/2014/main" id="{6F202D02-9352-47C0-AC83-7D375485A17C}"/>
+                <a16:creationId xmlns:a16="http://schemas.microsoft.com/office/drawing/2014/main" id="{BD652286-4C68-46B2-91E2-465D41D5E154}"/>
               </a:ext>
             </a:extLst>
           </p:cNvPr>
@@ -8870,7 +8870,7 @@
           <p:cNvPr id="3" name="">
             <a:extLst xmlns:a="http://schemas.openxmlformats.org/drawingml/2006/main">
               <a:ext uri="{FF2B5EF4-FFF2-40B4-BE49-F238E27FC236}">
-                <a16:creationId xmlns:a16="http://schemas.microsoft.com/office/drawing/2014/main" id="{7DD5FC3F-F09D-453E-BC0E-BE8794AEF29D}"/>
+                <a16:creationId xmlns:a16="http://schemas.microsoft.com/office/drawing/2014/main" id="{FD545DE9-987A-4847-9C15-7EB3CD3197F4}"/>
               </a:ext>
             </a:extLst>
           </p:cNvPr>
@@ -8920,7 +8920,7 @@
           <p:cNvPr id="4" name="">
             <a:extLst xmlns:a="http://schemas.openxmlformats.org/drawingml/2006/main">
               <a:ext uri="{FF2B5EF4-FFF2-40B4-BE49-F238E27FC236}">
-                <a16:creationId xmlns:a16="http://schemas.microsoft.com/office/drawing/2014/main" id="{FF0039C0-2ED8-40C8-9AC0-7043BA41B3DB}"/>
+                <a16:creationId xmlns:a16="http://schemas.microsoft.com/office/drawing/2014/main" id="{BB13409B-5B0A-49D2-AE20-8EDCAC2039FC}"/>
               </a:ext>
             </a:extLst>
           </p:cNvPr>
@@ -8951,7 +8951,7 @@
           <p:cNvPr id="5" name="">
             <a:extLst xmlns:a="http://schemas.openxmlformats.org/drawingml/2006/main">
               <a:ext uri="{FF2B5EF4-FFF2-40B4-BE49-F238E27FC236}">
-                <a16:creationId xmlns:a16="http://schemas.microsoft.com/office/drawing/2014/main" id="{21724B7F-611A-472E-B106-62A7955BF1A9}"/>
+                <a16:creationId xmlns:a16="http://schemas.microsoft.com/office/drawing/2014/main" id="{65A0F4A6-64D2-4004-8E62-CB39ED6B5F7B}"/>
               </a:ext>
             </a:extLst>
           </p:cNvPr>
@@ -8984,7 +8984,7 @@
           <p:cNvPr id="6" name="">
             <a:extLst xmlns:a="http://schemas.openxmlformats.org/drawingml/2006/main">
               <a:ext uri="{FF2B5EF4-FFF2-40B4-BE49-F238E27FC236}">
-                <a16:creationId xmlns:a16="http://schemas.microsoft.com/office/drawing/2014/main" id="{D43365C9-74ED-40B9-ABCA-970AB2BAE938}"/>
+                <a16:creationId xmlns:a16="http://schemas.microsoft.com/office/drawing/2014/main" id="{F80E699F-2570-4007-BE08-9622C299EDF8}"/>
               </a:ext>
             </a:extLst>
           </p:cNvPr>
@@ -9034,7 +9034,7 @@
           <p:cNvPr id="7" name="">
             <a:extLst xmlns:a="http://schemas.openxmlformats.org/drawingml/2006/main">
               <a:ext uri="{FF2B5EF4-FFF2-40B4-BE49-F238E27FC236}">
-                <a16:creationId xmlns:a16="http://schemas.microsoft.com/office/drawing/2014/main" id="{A4AA25B9-6EA4-41C5-B077-835F94714597}"/>
+                <a16:creationId xmlns:a16="http://schemas.microsoft.com/office/drawing/2014/main" id="{96460024-2DDB-42F2-A928-B4726882A670}"/>
               </a:ext>
             </a:extLst>
           </p:cNvPr>
@@ -9084,7 +9084,7 @@
           <p:cNvPr id="8" name="">
             <a:extLst xmlns:a="http://schemas.openxmlformats.org/drawingml/2006/main">
               <a:ext uri="{FF2B5EF4-FFF2-40B4-BE49-F238E27FC236}">
-                <a16:creationId xmlns:a16="http://schemas.microsoft.com/office/drawing/2014/main" id="{39C08745-BF9A-4D87-8D43-7E29EFFB5218}"/>
+                <a16:creationId xmlns:a16="http://schemas.microsoft.com/office/drawing/2014/main" id="{7B4981D1-BF76-48B2-AC37-2D0FF386DE6E}"/>
               </a:ext>
             </a:extLst>
           </p:cNvPr>
@@ -9134,7 +9134,7 @@
           <p:cNvPr id="9" name="">
             <a:extLst xmlns:a="http://schemas.openxmlformats.org/drawingml/2006/main">
               <a:ext uri="{FF2B5EF4-FFF2-40B4-BE49-F238E27FC236}">
-                <a16:creationId xmlns:a16="http://schemas.microsoft.com/office/drawing/2014/main" id="{A58824BD-3773-4178-AB6A-33AA78452D77}"/>
+                <a16:creationId xmlns:a16="http://schemas.microsoft.com/office/drawing/2014/main" id="{B5EA6201-4F2B-4021-B279-5613DE1C2A9E}"/>
               </a:ext>
             </a:extLst>
           </p:cNvPr>
@@ -9167,7 +9167,7 @@
           <p:cNvPr id="10" name="">
             <a:extLst xmlns:a="http://schemas.openxmlformats.org/drawingml/2006/main">
               <a:ext uri="{FF2B5EF4-FFF2-40B4-BE49-F238E27FC236}">
-                <a16:creationId xmlns:a16="http://schemas.microsoft.com/office/drawing/2014/main" id="{D2BDA343-4A84-46D8-9303-39BAA7A0141D}"/>
+                <a16:creationId xmlns:a16="http://schemas.microsoft.com/office/drawing/2014/main" id="{52A98B50-4C34-4420-BA1C-7725839348F9}"/>
               </a:ext>
             </a:extLst>
           </p:cNvPr>
@@ -9217,7 +9217,7 @@
           <p:cNvPr id="11" name="">
             <a:extLst xmlns:a="http://schemas.openxmlformats.org/drawingml/2006/main">
               <a:ext uri="{FF2B5EF4-FFF2-40B4-BE49-F238E27FC236}">
-                <a16:creationId xmlns:a16="http://schemas.microsoft.com/office/drawing/2014/main" id="{8E4EA665-5651-40CE-8DCC-01EB0E9732AC}"/>
+                <a16:creationId xmlns:a16="http://schemas.microsoft.com/office/drawing/2014/main" id="{2C496576-933E-4107-A595-11709653DFCC}"/>
               </a:ext>
             </a:extLst>
           </p:cNvPr>
@@ -9267,7 +9267,7 @@
           <p:cNvPr id="12" name="">
             <a:extLst xmlns:a="http://schemas.openxmlformats.org/drawingml/2006/main">
               <a:ext uri="{FF2B5EF4-FFF2-40B4-BE49-F238E27FC236}">
-                <a16:creationId xmlns:a16="http://schemas.microsoft.com/office/drawing/2014/main" id="{373F8BF8-1F1C-45AC-8E85-FE6F49FDDFFC}"/>
+                <a16:creationId xmlns:a16="http://schemas.microsoft.com/office/drawing/2014/main" id="{4E0AE380-3CCA-4721-8009-5EDEBAF9CDE2}"/>
               </a:ext>
             </a:extLst>
           </p:cNvPr>
@@ -9317,7 +9317,7 @@
           <p:cNvPr id="13" name="">
             <a:extLst xmlns:a="http://schemas.openxmlformats.org/drawingml/2006/main">
               <a:ext uri="{FF2B5EF4-FFF2-40B4-BE49-F238E27FC236}">
-                <a16:creationId xmlns:a16="http://schemas.microsoft.com/office/drawing/2014/main" id="{2875ABD5-C639-4505-AAEB-E123A04C6A3D}"/>
+                <a16:creationId xmlns:a16="http://schemas.microsoft.com/office/drawing/2014/main" id="{98ABCE4A-469E-495C-9639-EB06B08F498A}"/>
               </a:ext>
             </a:extLst>
           </p:cNvPr>
@@ -9350,7 +9350,7 @@
           <p:cNvPr id="14" name="">
             <a:extLst xmlns:a="http://schemas.openxmlformats.org/drawingml/2006/main">
               <a:ext uri="{FF2B5EF4-FFF2-40B4-BE49-F238E27FC236}">
-                <a16:creationId xmlns:a16="http://schemas.microsoft.com/office/drawing/2014/main" id="{42AFE3C0-697C-4FE4-B192-4EB30599417D}"/>
+                <a16:creationId xmlns:a16="http://schemas.microsoft.com/office/drawing/2014/main" id="{45BAAE87-4046-4FEA-B36D-18B96C88DFCD}"/>
               </a:ext>
             </a:extLst>
           </p:cNvPr>
@@ -9400,7 +9400,7 @@
           <p:cNvPr id="15" name="">
             <a:extLst xmlns:a="http://schemas.openxmlformats.org/drawingml/2006/main">
               <a:ext uri="{FF2B5EF4-FFF2-40B4-BE49-F238E27FC236}">
-                <a16:creationId xmlns:a16="http://schemas.microsoft.com/office/drawing/2014/main" id="{84ADAC95-836C-46DA-82C7-7EB8C4D66A58}"/>
+                <a16:creationId xmlns:a16="http://schemas.microsoft.com/office/drawing/2014/main" id="{CC6D7F6B-E542-409A-BAC7-D1DE9F61B3BC}"/>
               </a:ext>
             </a:extLst>
           </p:cNvPr>
@@ -9450,7 +9450,7 @@
           <p:cNvPr id="16" name="">
             <a:extLst xmlns:a="http://schemas.openxmlformats.org/drawingml/2006/main">
               <a:ext uri="{FF2B5EF4-FFF2-40B4-BE49-F238E27FC236}">
-                <a16:creationId xmlns:a16="http://schemas.microsoft.com/office/drawing/2014/main" id="{B7815D62-5F29-46D4-94AA-D688EE54C981}"/>
+                <a16:creationId xmlns:a16="http://schemas.microsoft.com/office/drawing/2014/main" id="{69B8F4FA-EA94-4886-B2CA-95D1A39E63B1}"/>
               </a:ext>
             </a:extLst>
           </p:cNvPr>
@@ -9500,7 +9500,7 @@
           <p:cNvPr id="17" name="">
             <a:extLst xmlns:a="http://schemas.openxmlformats.org/drawingml/2006/main">
               <a:ext uri="{FF2B5EF4-FFF2-40B4-BE49-F238E27FC236}">
-                <a16:creationId xmlns:a16="http://schemas.microsoft.com/office/drawing/2014/main" id="{B03500AF-351C-4806-B62D-C24D632C8E48}"/>
+                <a16:creationId xmlns:a16="http://schemas.microsoft.com/office/drawing/2014/main" id="{A54E660C-F00B-4316-9A88-5D3CE5CA0C0E}"/>
               </a:ext>
             </a:extLst>
           </p:cNvPr>
@@ -9533,7 +9533,7 @@
           <p:cNvPr id="18" name="">
             <a:extLst xmlns:a="http://schemas.openxmlformats.org/drawingml/2006/main">
               <a:ext uri="{FF2B5EF4-FFF2-40B4-BE49-F238E27FC236}">
-                <a16:creationId xmlns:a16="http://schemas.microsoft.com/office/drawing/2014/main" id="{A3F3C2BB-9D60-43C9-97D4-3FA05E25530E}"/>
+                <a16:creationId xmlns:a16="http://schemas.microsoft.com/office/drawing/2014/main" id="{95D15735-E3E5-4756-BA03-BC9FFBA53FFC}"/>
               </a:ext>
             </a:extLst>
           </p:cNvPr>
@@ -9583,7 +9583,7 @@
           <p:cNvPr id="19" name="">
             <a:extLst xmlns:a="http://schemas.openxmlformats.org/drawingml/2006/main">
               <a:ext uri="{FF2B5EF4-FFF2-40B4-BE49-F238E27FC236}">
-                <a16:creationId xmlns:a16="http://schemas.microsoft.com/office/drawing/2014/main" id="{FD0FDF58-98C5-4FF0-9395-BA289B194DEA}"/>
+                <a16:creationId xmlns:a16="http://schemas.microsoft.com/office/drawing/2014/main" id="{F49F26E0-7F57-4CD6-B190-A3DDF36DFBBC}"/>
               </a:ext>
             </a:extLst>
           </p:cNvPr>
@@ -9633,7 +9633,7 @@
           <p:cNvPr id="20" name="">
             <a:extLst xmlns:a="http://schemas.openxmlformats.org/drawingml/2006/main">
               <a:ext uri="{FF2B5EF4-FFF2-40B4-BE49-F238E27FC236}">
-                <a16:creationId xmlns:a16="http://schemas.microsoft.com/office/drawing/2014/main" id="{4F5E8B4E-95E0-45E2-BAF2-D89447BF0BD9}"/>
+                <a16:creationId xmlns:a16="http://schemas.microsoft.com/office/drawing/2014/main" id="{12FAC1BC-DF8D-4CE2-BCC7-9413C1C18CA1}"/>
               </a:ext>
             </a:extLst>
           </p:cNvPr>
@@ -9683,7 +9683,7 @@
           <p:cNvPr id="21" name="">
             <a:extLst xmlns:a="http://schemas.openxmlformats.org/drawingml/2006/main">
               <a:ext uri="{FF2B5EF4-FFF2-40B4-BE49-F238E27FC236}">
-                <a16:creationId xmlns:a16="http://schemas.microsoft.com/office/drawing/2014/main" id="{31AC4752-20B2-484A-A93A-386947599BDA}"/>
+                <a16:creationId xmlns:a16="http://schemas.microsoft.com/office/drawing/2014/main" id="{00EBBA9A-94AF-4C22-9246-5CF703D900DA}"/>
               </a:ext>
             </a:extLst>
           </p:cNvPr>
@@ -9718,7 +9718,7 @@
           <p:cNvPr id="22" name="">
             <a:extLst xmlns:a="http://schemas.openxmlformats.org/drawingml/2006/main">
               <a:ext uri="{FF2B5EF4-FFF2-40B4-BE49-F238E27FC236}">
-                <a16:creationId xmlns:a16="http://schemas.microsoft.com/office/drawing/2014/main" id="{D830E4E0-6493-4D28-BC93-A5E425BD8554}"/>
+                <a16:creationId xmlns:a16="http://schemas.microsoft.com/office/drawing/2014/main" id="{A704279A-44D4-4ABC-ABD4-58627180CA0A}"/>
               </a:ext>
             </a:extLst>
           </p:cNvPr>
@@ -9751,7 +9751,7 @@
           <p:cNvPr id="23" name="">
             <a:extLst xmlns:a="http://schemas.openxmlformats.org/drawingml/2006/main">
               <a:ext uri="{FF2B5EF4-FFF2-40B4-BE49-F238E27FC236}">
-                <a16:creationId xmlns:a16="http://schemas.microsoft.com/office/drawing/2014/main" id="{5547BEF0-104C-44C1-A936-5E6C95017EB7}"/>
+                <a16:creationId xmlns:a16="http://schemas.microsoft.com/office/drawing/2014/main" id="{F6108740-FB5A-4963-B50A-FDC6AC3BD2C3}"/>
               </a:ext>
             </a:extLst>
           </p:cNvPr>
@@ -9801,7 +9801,7 @@
           <p:cNvPr id="24" name="">
             <a:extLst xmlns:a="http://schemas.openxmlformats.org/drawingml/2006/main">
               <a:ext uri="{FF2B5EF4-FFF2-40B4-BE49-F238E27FC236}">
-                <a16:creationId xmlns:a16="http://schemas.microsoft.com/office/drawing/2014/main" id="{F9BEBF91-5CC1-4B53-9AEC-5728045A8AF6}"/>
+                <a16:creationId xmlns:a16="http://schemas.microsoft.com/office/drawing/2014/main" id="{5B7D6236-D186-477C-8D4B-AE7CC19C12C5}"/>
               </a:ext>
             </a:extLst>
           </p:cNvPr>
@@ -9851,7 +9851,7 @@
           <p:cNvPr id="25" name="">
             <a:extLst xmlns:a="http://schemas.openxmlformats.org/drawingml/2006/main">
               <a:ext uri="{FF2B5EF4-FFF2-40B4-BE49-F238E27FC236}">
-                <a16:creationId xmlns:a16="http://schemas.microsoft.com/office/drawing/2014/main" id="{1AFC5BC7-CD42-446C-81F3-22E20741CA5F}"/>
+                <a16:creationId xmlns:a16="http://schemas.microsoft.com/office/drawing/2014/main" id="{FED8513D-39EA-481D-B5DC-9C5FD0BECB2B}"/>
               </a:ext>
             </a:extLst>
           </p:cNvPr>
@@ -9886,7 +9886,7 @@
           <p:cNvPr id="26" name="">
             <a:extLst xmlns:a="http://schemas.openxmlformats.org/drawingml/2006/main">
               <a:ext uri="{FF2B5EF4-FFF2-40B4-BE49-F238E27FC236}">
-                <a16:creationId xmlns:a16="http://schemas.microsoft.com/office/drawing/2014/main" id="{4F0C72A4-EB9D-453A-9498-CB7D37AFEB93}"/>
+                <a16:creationId xmlns:a16="http://schemas.microsoft.com/office/drawing/2014/main" id="{FDCBB596-E87A-49B9-A10B-1B228BD6F1FA}"/>
               </a:ext>
             </a:extLst>
           </p:cNvPr>
@@ -9919,7 +9919,7 @@
           <p:cNvPr id="27" name="">
             <a:extLst xmlns:a="http://schemas.openxmlformats.org/drawingml/2006/main">
               <a:ext uri="{FF2B5EF4-FFF2-40B4-BE49-F238E27FC236}">
-                <a16:creationId xmlns:a16="http://schemas.microsoft.com/office/drawing/2014/main" id="{C68224C4-5EBB-4D97-835A-6F2F1597FD30}"/>
+                <a16:creationId xmlns:a16="http://schemas.microsoft.com/office/drawing/2014/main" id="{8337D035-8FFB-4DF6-A957-4D00DADDBDE6}"/>
               </a:ext>
             </a:extLst>
           </p:cNvPr>
@@ -9969,7 +9969,7 @@
           <p:cNvPr id="28" name="">
             <a:extLst xmlns:a="http://schemas.openxmlformats.org/drawingml/2006/main">
               <a:ext uri="{FF2B5EF4-FFF2-40B4-BE49-F238E27FC236}">
-                <a16:creationId xmlns:a16="http://schemas.microsoft.com/office/drawing/2014/main" id="{B7B4B1F3-7BFB-4191-B173-FC8FE127E8EB}"/>
+                <a16:creationId xmlns:a16="http://schemas.microsoft.com/office/drawing/2014/main" id="{3C3574B8-EB2E-4B74-9A1C-2DF0420B0861}"/>
               </a:ext>
             </a:extLst>
           </p:cNvPr>
@@ -10019,7 +10019,7 @@
           <p:cNvPr id="29" name="">
             <a:extLst xmlns:a="http://schemas.openxmlformats.org/drawingml/2006/main">
               <a:ext uri="{FF2B5EF4-FFF2-40B4-BE49-F238E27FC236}">
-                <a16:creationId xmlns:a16="http://schemas.microsoft.com/office/drawing/2014/main" id="{A7ABD24F-12D7-4951-A02C-D2CEBC12B7C9}"/>
+                <a16:creationId xmlns:a16="http://schemas.microsoft.com/office/drawing/2014/main" id="{E9099BEE-69F7-4A8D-8830-D8640B6373C4}"/>
               </a:ext>
             </a:extLst>
           </p:cNvPr>
@@ -10050,7 +10050,7 @@
           <p:cNvPr id="30" name="">
             <a:extLst xmlns:a="http://schemas.openxmlformats.org/drawingml/2006/main">
               <a:ext uri="{FF2B5EF4-FFF2-40B4-BE49-F238E27FC236}">
-                <a16:creationId xmlns:a16="http://schemas.microsoft.com/office/drawing/2014/main" id="{63D80787-EC3C-4D11-A5D5-FAFF947EC8FD}"/>
+                <a16:creationId xmlns:a16="http://schemas.microsoft.com/office/drawing/2014/main" id="{1C227533-46FC-4D53-8639-743679EB3129}"/>
               </a:ext>
             </a:extLst>
           </p:cNvPr>
@@ -10100,7 +10100,7 @@
           <p:cNvPr id="31" name="">
             <a:extLst xmlns:a="http://schemas.openxmlformats.org/drawingml/2006/main">
               <a:ext uri="{FF2B5EF4-FFF2-40B4-BE49-F238E27FC236}">
-                <a16:creationId xmlns:a16="http://schemas.microsoft.com/office/drawing/2014/main" id="{77B0B2B2-0C1D-4C9D-B4AF-8AC5C2ABFC95}"/>
+                <a16:creationId xmlns:a16="http://schemas.microsoft.com/office/drawing/2014/main" id="{350F4B69-C733-4662-B8BF-DB5DDA5BC612}"/>
               </a:ext>
             </a:extLst>
           </p:cNvPr>
@@ -10148,7 +10148,7 @@
     </p:spTree>
     <p:extLst>
       <p:ext uri="{BB962C8B-B14F-4D97-AF65-F5344CB8AC3E}">
-        <p14:creationId xmlns:p14="http://schemas.microsoft.com/office/powerpoint/2010/main" val="1027765503"/>
+        <p14:creationId xmlns:p14="http://schemas.microsoft.com/office/powerpoint/2010/main" val="1165726871"/>
       </p:ext>
     </p:extLst>
   </p:cSld>
@@ -10179,7 +10179,7 @@
           <p:cNvPr id="24" name="">
             <a:extLst xmlns:a="http://schemas.openxmlformats.org/drawingml/2006/main">
               <a:ext uri="{FF2B5EF4-FFF2-40B4-BE49-F238E27FC236}">
-                <a16:creationId xmlns:a16="http://schemas.microsoft.com/office/drawing/2014/main" id="{FAAAAB4A-CB33-4D07-80D9-98998B741504}"/>
+                <a16:creationId xmlns:a16="http://schemas.microsoft.com/office/drawing/2014/main" id="{00BE0D6D-6079-416B-9910-40A6EB433EDB}"/>
               </a:ext>
             </a:extLst>
           </p:cNvPr>
@@ -10229,7 +10229,7 @@
           <p:cNvPr id="2" name="">
             <a:extLst xmlns:a="http://schemas.openxmlformats.org/drawingml/2006/main">
               <a:ext uri="{FF2B5EF4-FFF2-40B4-BE49-F238E27FC236}">
-                <a16:creationId xmlns:a16="http://schemas.microsoft.com/office/drawing/2014/main" id="{EE8F30D9-CA62-44AD-BC48-28AF7ED90742}"/>
+                <a16:creationId xmlns:a16="http://schemas.microsoft.com/office/drawing/2014/main" id="{EC1338DB-A79D-4429-9C6B-39CADA4C0B2F}"/>
               </a:ext>
             </a:extLst>
           </p:cNvPr>
@@ -10279,7 +10279,7 @@
           <p:cNvPr id="3" name="">
             <a:extLst xmlns:a="http://schemas.openxmlformats.org/drawingml/2006/main">
               <a:ext uri="{FF2B5EF4-FFF2-40B4-BE49-F238E27FC236}">
-                <a16:creationId xmlns:a16="http://schemas.microsoft.com/office/drawing/2014/main" id="{381BCBE6-FEF0-4241-9168-CE9F45F142CB}"/>
+                <a16:creationId xmlns:a16="http://schemas.microsoft.com/office/drawing/2014/main" id="{5C3DEC06-495C-4735-B5E0-E13C34CBD86B}"/>
               </a:ext>
             </a:extLst>
           </p:cNvPr>
@@ -10329,7 +10329,7 @@
           <p:cNvPr id="4" name="">
             <a:extLst xmlns:a="http://schemas.openxmlformats.org/drawingml/2006/main">
               <a:ext uri="{FF2B5EF4-FFF2-40B4-BE49-F238E27FC236}">
-                <a16:creationId xmlns:a16="http://schemas.microsoft.com/office/drawing/2014/main" id="{CC9DC1D8-36B7-41E2-8402-0216352AEAED}"/>
+                <a16:creationId xmlns:a16="http://schemas.microsoft.com/office/drawing/2014/main" id="{D9497151-C378-4E46-AAA0-97016A8EEC51}"/>
               </a:ext>
             </a:extLst>
           </p:cNvPr>
@@ -10360,7 +10360,7 @@
           <p:cNvPr id="5" name="">
             <a:extLst xmlns:a="http://schemas.openxmlformats.org/drawingml/2006/main">
               <a:ext uri="{FF2B5EF4-FFF2-40B4-BE49-F238E27FC236}">
-                <a16:creationId xmlns:a16="http://schemas.microsoft.com/office/drawing/2014/main" id="{B22FDC39-0145-4000-9F88-6D9CA60FAB0E}"/>
+                <a16:creationId xmlns:a16="http://schemas.microsoft.com/office/drawing/2014/main" id="{769C97D7-FB4D-4428-ACF2-D73CD49ED8E3}"/>
               </a:ext>
             </a:extLst>
           </p:cNvPr>
@@ -10395,7 +10395,7 @@
           <p:cNvPr id="6" name="">
             <a:extLst xmlns:a="http://schemas.openxmlformats.org/drawingml/2006/main">
               <a:ext uri="{FF2B5EF4-FFF2-40B4-BE49-F238E27FC236}">
-                <a16:creationId xmlns:a16="http://schemas.microsoft.com/office/drawing/2014/main" id="{AFB6C932-6BB3-422B-98CC-C8DE4BCBE2BB}"/>
+                <a16:creationId xmlns:a16="http://schemas.microsoft.com/office/drawing/2014/main" id="{A3DDE434-070E-4F18-A875-64B8B65E9AE3}"/>
               </a:ext>
             </a:extLst>
           </p:cNvPr>
@@ -10445,7 +10445,7 @@
           <p:cNvPr id="7" name="">
             <a:extLst xmlns:a="http://schemas.openxmlformats.org/drawingml/2006/main">
               <a:ext uri="{FF2B5EF4-FFF2-40B4-BE49-F238E27FC236}">
-                <a16:creationId xmlns:a16="http://schemas.microsoft.com/office/drawing/2014/main" id="{CF5D02E9-1869-4531-9B86-316296BAB292}"/>
+                <a16:creationId xmlns:a16="http://schemas.microsoft.com/office/drawing/2014/main" id="{36D4E002-5E57-4E34-8C85-E4D541C12CA5}"/>
               </a:ext>
             </a:extLst>
           </p:cNvPr>
@@ -10502,7 +10502,7 @@
         </p:xfrm>
         <a:graphic xmlns:a="http://schemas.openxmlformats.org/drawingml/2006/main">
           <a:graphicData uri="http://schemas.openxmlformats.org/drawingml/2006/chart">
-            <c:chart xmlns:r="http://schemas.openxmlformats.org/officeDocument/2006/relationships" xmlns:c="http://schemas.openxmlformats.org/drawingml/2006/chart" r:id="R2b8bdc4413cc4ebf"/>
+            <c:chart xmlns:r="http://schemas.openxmlformats.org/officeDocument/2006/relationships" xmlns:c="http://schemas.openxmlformats.org/drawingml/2006/chart" r:id="R11480aec1d2343f2"/>
           </a:graphicData>
         </a:graphic>
       </p:graphicFrame>
@@ -10511,7 +10511,7 @@
           <p:cNvPr id="9" name="">
             <a:extLst xmlns:a="http://schemas.openxmlformats.org/drawingml/2006/main">
               <a:ext uri="{FF2B5EF4-FFF2-40B4-BE49-F238E27FC236}">
-                <a16:creationId xmlns:a16="http://schemas.microsoft.com/office/drawing/2014/main" id="{6976827B-EB15-4DB2-8027-D268A3970B53}"/>
+                <a16:creationId xmlns:a16="http://schemas.microsoft.com/office/drawing/2014/main" id="{6D647C2C-43A1-4D90-8429-8B67838C5EB7}"/>
               </a:ext>
             </a:extLst>
           </p:cNvPr>
@@ -10544,7 +10544,7 @@
           <p:cNvPr id="10" name="">
             <a:extLst xmlns:a="http://schemas.openxmlformats.org/drawingml/2006/main">
               <a:ext uri="{FF2B5EF4-FFF2-40B4-BE49-F238E27FC236}">
-                <a16:creationId xmlns:a16="http://schemas.microsoft.com/office/drawing/2014/main" id="{F8A41BD3-E969-4628-AD28-883B9CC2B5F2}"/>
+                <a16:creationId xmlns:a16="http://schemas.microsoft.com/office/drawing/2014/main" id="{D90131D0-D9BF-4838-8C61-017D53BFB19C}"/>
               </a:ext>
             </a:extLst>
           </p:cNvPr>
@@ -10594,7 +10594,7 @@
           <p:cNvPr id="11" name="">
             <a:extLst xmlns:a="http://schemas.openxmlformats.org/drawingml/2006/main">
               <a:ext uri="{FF2B5EF4-FFF2-40B4-BE49-F238E27FC236}">
-                <a16:creationId xmlns:a16="http://schemas.microsoft.com/office/drawing/2014/main" id="{1009AB41-0E65-4BB8-A5F6-F45AF6905B40}"/>
+                <a16:creationId xmlns:a16="http://schemas.microsoft.com/office/drawing/2014/main" id="{D9740EAF-3F5B-4BB9-8C24-480F5BB692C7}"/>
               </a:ext>
             </a:extLst>
           </p:cNvPr>
@@ -10644,7 +10644,7 @@
           <p:cNvPr id="12" name="">
             <a:extLst xmlns:a="http://schemas.openxmlformats.org/drawingml/2006/main">
               <a:ext uri="{FF2B5EF4-FFF2-40B4-BE49-F238E27FC236}">
-                <a16:creationId xmlns:a16="http://schemas.microsoft.com/office/drawing/2014/main" id="{46A4657F-0E51-4053-AFE3-25BEE2E86F30}"/>
+                <a16:creationId xmlns:a16="http://schemas.microsoft.com/office/drawing/2014/main" id="{9A272160-241F-4C1C-9A80-829AC20097A0}"/>
               </a:ext>
             </a:extLst>
           </p:cNvPr>
@@ -10694,7 +10694,7 @@
           <p:cNvPr id="13" name="">
             <a:extLst xmlns:a="http://schemas.openxmlformats.org/drawingml/2006/main">
               <a:ext uri="{FF2B5EF4-FFF2-40B4-BE49-F238E27FC236}">
-                <a16:creationId xmlns:a16="http://schemas.microsoft.com/office/drawing/2014/main" id="{DFEE34E4-6621-4D79-832B-7D293FBFD131}"/>
+                <a16:creationId xmlns:a16="http://schemas.microsoft.com/office/drawing/2014/main" id="{AEC92D34-70AA-4687-A0CB-5DC4D47A8248}"/>
               </a:ext>
             </a:extLst>
           </p:cNvPr>
@@ -10727,7 +10727,7 @@
           <p:cNvPr id="14" name="">
             <a:extLst xmlns:a="http://schemas.openxmlformats.org/drawingml/2006/main">
               <a:ext uri="{FF2B5EF4-FFF2-40B4-BE49-F238E27FC236}">
-                <a16:creationId xmlns:a16="http://schemas.microsoft.com/office/drawing/2014/main" id="{D0921806-B96D-410F-972D-E41CBFF91A95}"/>
+                <a16:creationId xmlns:a16="http://schemas.microsoft.com/office/drawing/2014/main" id="{AB327AF6-F312-46B4-8DD4-2C9A5449B02A}"/>
               </a:ext>
             </a:extLst>
           </p:cNvPr>
@@ -10777,7 +10777,7 @@
           <p:cNvPr id="15" name="">
             <a:extLst xmlns:a="http://schemas.openxmlformats.org/drawingml/2006/main">
               <a:ext uri="{FF2B5EF4-FFF2-40B4-BE49-F238E27FC236}">
-                <a16:creationId xmlns:a16="http://schemas.microsoft.com/office/drawing/2014/main" id="{54D69E08-3A87-4EE7-9F06-A523E2D1F289}"/>
+                <a16:creationId xmlns:a16="http://schemas.microsoft.com/office/drawing/2014/main" id="{7893FA9E-8550-456C-A3F0-C8A1CE9C5CC8}"/>
               </a:ext>
             </a:extLst>
           </p:cNvPr>
@@ -10827,7 +10827,7 @@
           <p:cNvPr id="16" name="">
             <a:extLst xmlns:a="http://schemas.openxmlformats.org/drawingml/2006/main">
               <a:ext uri="{FF2B5EF4-FFF2-40B4-BE49-F238E27FC236}">
-                <a16:creationId xmlns:a16="http://schemas.microsoft.com/office/drawing/2014/main" id="{1CC3E3DF-EBEF-47C5-B92B-067CB56C5556}"/>
+                <a16:creationId xmlns:a16="http://schemas.microsoft.com/office/drawing/2014/main" id="{5C22B906-2F20-4D80-89D1-DE6BA5CD7CE3}"/>
               </a:ext>
             </a:extLst>
           </p:cNvPr>
@@ -10877,7 +10877,7 @@
           <p:cNvPr id="17" name="">
             <a:extLst xmlns:a="http://schemas.openxmlformats.org/drawingml/2006/main">
               <a:ext uri="{FF2B5EF4-FFF2-40B4-BE49-F238E27FC236}">
-                <a16:creationId xmlns:a16="http://schemas.microsoft.com/office/drawing/2014/main" id="{5FAD57F7-E67D-45F0-882F-77B06D5E0284}"/>
+                <a16:creationId xmlns:a16="http://schemas.microsoft.com/office/drawing/2014/main" id="{81B7F534-0280-4CBC-86A1-34F373E4401F}"/>
               </a:ext>
             </a:extLst>
           </p:cNvPr>
@@ -10912,7 +10912,7 @@
           <p:cNvPr id="18" name="">
             <a:extLst xmlns:a="http://schemas.openxmlformats.org/drawingml/2006/main">
               <a:ext uri="{FF2B5EF4-FFF2-40B4-BE49-F238E27FC236}">
-                <a16:creationId xmlns:a16="http://schemas.microsoft.com/office/drawing/2014/main" id="{AE7BDB4E-947B-41BC-95AD-7BC5590ED2BE}"/>
+                <a16:creationId xmlns:a16="http://schemas.microsoft.com/office/drawing/2014/main" id="{EEBDAB28-9C96-461A-86CF-6F458C49AB3B}"/>
               </a:ext>
             </a:extLst>
           </p:cNvPr>
@@ -10945,7 +10945,7 @@
           <p:cNvPr id="19" name="">
             <a:extLst xmlns:a="http://schemas.openxmlformats.org/drawingml/2006/main">
               <a:ext uri="{FF2B5EF4-FFF2-40B4-BE49-F238E27FC236}">
-                <a16:creationId xmlns:a16="http://schemas.microsoft.com/office/drawing/2014/main" id="{4952FD3A-F2CF-48B2-9409-D4434D7DBBC2}"/>
+                <a16:creationId xmlns:a16="http://schemas.microsoft.com/office/drawing/2014/main" id="{22972798-313C-4D19-9423-456C63308B73}"/>
               </a:ext>
             </a:extLst>
           </p:cNvPr>
@@ -10995,7 +10995,7 @@
           <p:cNvPr id="20" name="">
             <a:extLst xmlns:a="http://schemas.openxmlformats.org/drawingml/2006/main">
               <a:ext uri="{FF2B5EF4-FFF2-40B4-BE49-F238E27FC236}">
-                <a16:creationId xmlns:a16="http://schemas.microsoft.com/office/drawing/2014/main" id="{24138CF4-996E-4594-85FF-073A199BD553}"/>
+                <a16:creationId xmlns:a16="http://schemas.microsoft.com/office/drawing/2014/main" id="{02CEF0EE-F579-4B5A-ABB6-1B794482BD06}"/>
               </a:ext>
             </a:extLst>
           </p:cNvPr>
@@ -11045,7 +11045,7 @@
           <p:cNvPr id="21" name="">
             <a:extLst xmlns:a="http://schemas.openxmlformats.org/drawingml/2006/main">
               <a:ext uri="{FF2B5EF4-FFF2-40B4-BE49-F238E27FC236}">
-                <a16:creationId xmlns:a16="http://schemas.microsoft.com/office/drawing/2014/main" id="{278EACC3-0012-4EFD-A2FC-A448629ECB02}"/>
+                <a16:creationId xmlns:a16="http://schemas.microsoft.com/office/drawing/2014/main" id="{69219BAC-912B-4B5C-9B4F-6BAD1753BF5F}"/>
               </a:ext>
             </a:extLst>
           </p:cNvPr>
@@ -11076,7 +11076,7 @@
           <p:cNvPr id="22" name="">
             <a:extLst xmlns:a="http://schemas.openxmlformats.org/drawingml/2006/main">
               <a:ext uri="{FF2B5EF4-FFF2-40B4-BE49-F238E27FC236}">
-                <a16:creationId xmlns:a16="http://schemas.microsoft.com/office/drawing/2014/main" id="{77E36802-AD41-404E-9D45-3477646D36C4}"/>
+                <a16:creationId xmlns:a16="http://schemas.microsoft.com/office/drawing/2014/main" id="{DA93C5AF-9E8D-42F6-A993-73EC0E9B81A0}"/>
               </a:ext>
             </a:extLst>
           </p:cNvPr>
@@ -11126,7 +11126,7 @@
           <p:cNvPr id="23" name="">
             <a:extLst xmlns:a="http://schemas.openxmlformats.org/drawingml/2006/main">
               <a:ext uri="{FF2B5EF4-FFF2-40B4-BE49-F238E27FC236}">
-                <a16:creationId xmlns:a16="http://schemas.microsoft.com/office/drawing/2014/main" id="{7EB62FE5-2A46-4B9C-B2A2-71EB06E48C5B}"/>
+                <a16:creationId xmlns:a16="http://schemas.microsoft.com/office/drawing/2014/main" id="{F5F1DA73-BE40-46EA-A68A-0658F8B7BDDF}"/>
               </a:ext>
             </a:extLst>
           </p:cNvPr>
@@ -11174,7 +11174,7 @@
     </p:spTree>
     <p:extLst>
       <p:ext uri="{BB962C8B-B14F-4D97-AF65-F5344CB8AC3E}">
-        <p14:creationId xmlns:p14="http://schemas.microsoft.com/office/powerpoint/2010/main" val="1289986801"/>
+        <p14:creationId xmlns:p14="http://schemas.microsoft.com/office/powerpoint/2010/main" val="1339370193"/>
       </p:ext>
     </p:extLst>
   </p:cSld>
@@ -11205,7 +11205,7 @@
           <p:cNvPr id="24" name="">
             <a:extLst xmlns:a="http://schemas.openxmlformats.org/drawingml/2006/main">
               <a:ext uri="{FF2B5EF4-FFF2-40B4-BE49-F238E27FC236}">
-                <a16:creationId xmlns:a16="http://schemas.microsoft.com/office/drawing/2014/main" id="{F7687F18-0224-44B4-A3B1-0EB4B4E5155D}"/>
+                <a16:creationId xmlns:a16="http://schemas.microsoft.com/office/drawing/2014/main" id="{D4621C39-359D-4760-BA19-152FC8AA42F8}"/>
               </a:ext>
             </a:extLst>
           </p:cNvPr>
@@ -11255,7 +11255,7 @@
           <p:cNvPr id="2" name="">
             <a:extLst xmlns:a="http://schemas.openxmlformats.org/drawingml/2006/main">
               <a:ext uri="{FF2B5EF4-FFF2-40B4-BE49-F238E27FC236}">
-                <a16:creationId xmlns:a16="http://schemas.microsoft.com/office/drawing/2014/main" id="{88D93548-C700-4938-8009-B6DB5C0F129B}"/>
+                <a16:creationId xmlns:a16="http://schemas.microsoft.com/office/drawing/2014/main" id="{FA1876FD-04F6-4E0B-8BB1-36770B55A1B0}"/>
               </a:ext>
             </a:extLst>
           </p:cNvPr>
@@ -11305,7 +11305,7 @@
           <p:cNvPr id="3" name="">
             <a:extLst xmlns:a="http://schemas.openxmlformats.org/drawingml/2006/main">
               <a:ext uri="{FF2B5EF4-FFF2-40B4-BE49-F238E27FC236}">
-                <a16:creationId xmlns:a16="http://schemas.microsoft.com/office/drawing/2014/main" id="{8E177E8F-D0C0-4E6E-B73F-6CAF8D674F99}"/>
+                <a16:creationId xmlns:a16="http://schemas.microsoft.com/office/drawing/2014/main" id="{ABF4798A-0734-476F-96E5-EB2B5E96725B}"/>
               </a:ext>
             </a:extLst>
           </p:cNvPr>
@@ -11355,7 +11355,7 @@
           <p:cNvPr id="4" name="">
             <a:extLst xmlns:a="http://schemas.openxmlformats.org/drawingml/2006/main">
               <a:ext uri="{FF2B5EF4-FFF2-40B4-BE49-F238E27FC236}">
-                <a16:creationId xmlns:a16="http://schemas.microsoft.com/office/drawing/2014/main" id="{E86165B3-6512-4643-9E6A-C7D96B232D3D}"/>
+                <a16:creationId xmlns:a16="http://schemas.microsoft.com/office/drawing/2014/main" id="{8640D999-A346-45B8-A0E4-5F59443980C5}"/>
               </a:ext>
             </a:extLst>
           </p:cNvPr>
@@ -11386,7 +11386,7 @@
           <p:cNvPr id="5" name="">
             <a:extLst xmlns:a="http://schemas.openxmlformats.org/drawingml/2006/main">
               <a:ext uri="{FF2B5EF4-FFF2-40B4-BE49-F238E27FC236}">
-                <a16:creationId xmlns:a16="http://schemas.microsoft.com/office/drawing/2014/main" id="{92B9CC30-5A2E-4BDC-9EE5-86BE957E3B1B}"/>
+                <a16:creationId xmlns:a16="http://schemas.microsoft.com/office/drawing/2014/main" id="{090CFB12-8B06-424A-8117-5C60E79C4C1F}"/>
               </a:ext>
             </a:extLst>
           </p:cNvPr>
@@ -11421,7 +11421,7 @@
           <p:cNvPr id="6" name="">
             <a:extLst xmlns:a="http://schemas.openxmlformats.org/drawingml/2006/main">
               <a:ext uri="{FF2B5EF4-FFF2-40B4-BE49-F238E27FC236}">
-                <a16:creationId xmlns:a16="http://schemas.microsoft.com/office/drawing/2014/main" id="{97F1D44B-606E-44E1-8560-B10418DF1388}"/>
+                <a16:creationId xmlns:a16="http://schemas.microsoft.com/office/drawing/2014/main" id="{33379C20-AB12-4CB1-9034-E6AB6AEFF199}"/>
               </a:ext>
             </a:extLst>
           </p:cNvPr>
@@ -11471,7 +11471,7 @@
           <p:cNvPr id="7" name="">
             <a:extLst xmlns:a="http://schemas.openxmlformats.org/drawingml/2006/main">
               <a:ext uri="{FF2B5EF4-FFF2-40B4-BE49-F238E27FC236}">
-                <a16:creationId xmlns:a16="http://schemas.microsoft.com/office/drawing/2014/main" id="{B43D39A6-4AEE-4B6D-88F4-89312E892FEB}"/>
+                <a16:creationId xmlns:a16="http://schemas.microsoft.com/office/drawing/2014/main" id="{DB97493F-0545-433D-B7BC-3B3906E37866}"/>
               </a:ext>
             </a:extLst>
           </p:cNvPr>
@@ -11528,7 +11528,7 @@
         </p:xfrm>
         <a:graphic xmlns:a="http://schemas.openxmlformats.org/drawingml/2006/main">
           <a:graphicData uri="http://schemas.openxmlformats.org/drawingml/2006/chart">
-            <c:chart xmlns:r="http://schemas.openxmlformats.org/officeDocument/2006/relationships" xmlns:c="http://schemas.openxmlformats.org/drawingml/2006/chart" r:id="R10892901339a41ac"/>
+            <c:chart xmlns:r="http://schemas.openxmlformats.org/officeDocument/2006/relationships" xmlns:c="http://schemas.openxmlformats.org/drawingml/2006/chart" r:id="R2c2006a433024eb9"/>
           </a:graphicData>
         </a:graphic>
       </p:graphicFrame>
@@ -11537,7 +11537,7 @@
           <p:cNvPr id="9" name="">
             <a:extLst xmlns:a="http://schemas.openxmlformats.org/drawingml/2006/main">
               <a:ext uri="{FF2B5EF4-FFF2-40B4-BE49-F238E27FC236}">
-                <a16:creationId xmlns:a16="http://schemas.microsoft.com/office/drawing/2014/main" id="{5CE40187-3064-4330-AF7B-3FC0BEDA5E1F}"/>
+                <a16:creationId xmlns:a16="http://schemas.microsoft.com/office/drawing/2014/main" id="{74B03D2B-DB42-4E7D-AA1A-79F37568879F}"/>
               </a:ext>
             </a:extLst>
           </p:cNvPr>
@@ -11570,7 +11570,7 @@
           <p:cNvPr id="10" name="">
             <a:extLst xmlns:a="http://schemas.openxmlformats.org/drawingml/2006/main">
               <a:ext uri="{FF2B5EF4-FFF2-40B4-BE49-F238E27FC236}">
-                <a16:creationId xmlns:a16="http://schemas.microsoft.com/office/drawing/2014/main" id="{4C1FFE2E-8221-41E8-98BF-1F38B440C94F}"/>
+                <a16:creationId xmlns:a16="http://schemas.microsoft.com/office/drawing/2014/main" id="{1F3F9700-C3AA-4BD0-ADBC-90195F3154A3}"/>
               </a:ext>
             </a:extLst>
           </p:cNvPr>
@@ -11620,7 +11620,7 @@
           <p:cNvPr id="11" name="">
             <a:extLst xmlns:a="http://schemas.openxmlformats.org/drawingml/2006/main">
               <a:ext uri="{FF2B5EF4-FFF2-40B4-BE49-F238E27FC236}">
-                <a16:creationId xmlns:a16="http://schemas.microsoft.com/office/drawing/2014/main" id="{37AB2724-CF2D-4F53-A0C0-1FC2BA7B96D7}"/>
+                <a16:creationId xmlns:a16="http://schemas.microsoft.com/office/drawing/2014/main" id="{F4390733-E99D-4743-AFBB-7A194E8A38A6}"/>
               </a:ext>
             </a:extLst>
           </p:cNvPr>
@@ -11670,7 +11670,7 @@
           <p:cNvPr id="12" name="">
             <a:extLst xmlns:a="http://schemas.openxmlformats.org/drawingml/2006/main">
               <a:ext uri="{FF2B5EF4-FFF2-40B4-BE49-F238E27FC236}">
-                <a16:creationId xmlns:a16="http://schemas.microsoft.com/office/drawing/2014/main" id="{F8438445-2862-49CB-9F51-AB19F434F69F}"/>
+                <a16:creationId xmlns:a16="http://schemas.microsoft.com/office/drawing/2014/main" id="{1FF5C9DC-9D8D-4B96-9C45-FA88D202683E}"/>
               </a:ext>
             </a:extLst>
           </p:cNvPr>
@@ -11720,7 +11720,7 @@
           <p:cNvPr id="13" name="">
             <a:extLst xmlns:a="http://schemas.openxmlformats.org/drawingml/2006/main">
               <a:ext uri="{FF2B5EF4-FFF2-40B4-BE49-F238E27FC236}">
-                <a16:creationId xmlns:a16="http://schemas.microsoft.com/office/drawing/2014/main" id="{209C16C8-3392-4CFB-9B4D-21B04E5BFBEF}"/>
+                <a16:creationId xmlns:a16="http://schemas.microsoft.com/office/drawing/2014/main" id="{560BC6EC-941B-464B-B9BC-708DB1A6AB86}"/>
               </a:ext>
             </a:extLst>
           </p:cNvPr>
@@ -11753,7 +11753,7 @@
           <p:cNvPr id="14" name="">
             <a:extLst xmlns:a="http://schemas.openxmlformats.org/drawingml/2006/main">
               <a:ext uri="{FF2B5EF4-FFF2-40B4-BE49-F238E27FC236}">
-                <a16:creationId xmlns:a16="http://schemas.microsoft.com/office/drawing/2014/main" id="{7FD91F98-6525-4EF9-81B8-112E2BB7D744}"/>
+                <a16:creationId xmlns:a16="http://schemas.microsoft.com/office/drawing/2014/main" id="{506DB62C-608C-46C7-945E-038A6513DCAB}"/>
               </a:ext>
             </a:extLst>
           </p:cNvPr>
@@ -11803,7 +11803,7 @@
           <p:cNvPr id="15" name="">
             <a:extLst xmlns:a="http://schemas.openxmlformats.org/drawingml/2006/main">
               <a:ext uri="{FF2B5EF4-FFF2-40B4-BE49-F238E27FC236}">
-                <a16:creationId xmlns:a16="http://schemas.microsoft.com/office/drawing/2014/main" id="{648326BE-47B4-4BF9-89B9-5EF894A930DA}"/>
+                <a16:creationId xmlns:a16="http://schemas.microsoft.com/office/drawing/2014/main" id="{D8D52822-90AB-4A82-851C-D28F36812C20}"/>
               </a:ext>
             </a:extLst>
           </p:cNvPr>
@@ -11853,7 +11853,7 @@
           <p:cNvPr id="16" name="">
             <a:extLst xmlns:a="http://schemas.openxmlformats.org/drawingml/2006/main">
               <a:ext uri="{FF2B5EF4-FFF2-40B4-BE49-F238E27FC236}">
-                <a16:creationId xmlns:a16="http://schemas.microsoft.com/office/drawing/2014/main" id="{79588B94-130B-4D31-AD7C-479AEA6B91BD}"/>
+                <a16:creationId xmlns:a16="http://schemas.microsoft.com/office/drawing/2014/main" id="{8D596228-D3BB-458C-8C43-7EBDC5798D05}"/>
               </a:ext>
             </a:extLst>
           </p:cNvPr>
@@ -11903,7 +11903,7 @@
           <p:cNvPr id="17" name="">
             <a:extLst xmlns:a="http://schemas.openxmlformats.org/drawingml/2006/main">
               <a:ext uri="{FF2B5EF4-FFF2-40B4-BE49-F238E27FC236}">
-                <a16:creationId xmlns:a16="http://schemas.microsoft.com/office/drawing/2014/main" id="{FB8C2C86-74AA-4900-8868-D079EB8B361C}"/>
+                <a16:creationId xmlns:a16="http://schemas.microsoft.com/office/drawing/2014/main" id="{7780C942-480E-424B-8A85-BB23B3741CB3}"/>
               </a:ext>
             </a:extLst>
           </p:cNvPr>
@@ -11938,7 +11938,7 @@
           <p:cNvPr id="18" name="">
             <a:extLst xmlns:a="http://schemas.openxmlformats.org/drawingml/2006/main">
               <a:ext uri="{FF2B5EF4-FFF2-40B4-BE49-F238E27FC236}">
-                <a16:creationId xmlns:a16="http://schemas.microsoft.com/office/drawing/2014/main" id="{79904D0E-CC57-4158-89B8-5875055755EF}"/>
+                <a16:creationId xmlns:a16="http://schemas.microsoft.com/office/drawing/2014/main" id="{690C47FA-3BF6-4558-95AA-3289A04198FB}"/>
               </a:ext>
             </a:extLst>
           </p:cNvPr>
@@ -11971,7 +11971,7 @@
           <p:cNvPr id="19" name="">
             <a:extLst xmlns:a="http://schemas.openxmlformats.org/drawingml/2006/main">
               <a:ext uri="{FF2B5EF4-FFF2-40B4-BE49-F238E27FC236}">
-                <a16:creationId xmlns:a16="http://schemas.microsoft.com/office/drawing/2014/main" id="{F512615A-85E1-4D8B-A5AC-44F2F2F15BF6}"/>
+                <a16:creationId xmlns:a16="http://schemas.microsoft.com/office/drawing/2014/main" id="{5668D6F1-CB85-4F0F-95A2-8BF03C00EDAE}"/>
               </a:ext>
             </a:extLst>
           </p:cNvPr>
@@ -12021,7 +12021,7 @@
           <p:cNvPr id="20" name="">
             <a:extLst xmlns:a="http://schemas.openxmlformats.org/drawingml/2006/main">
               <a:ext uri="{FF2B5EF4-FFF2-40B4-BE49-F238E27FC236}">
-                <a16:creationId xmlns:a16="http://schemas.microsoft.com/office/drawing/2014/main" id="{1C423D98-8B7F-48CA-8A98-BBB3EC5B6721}"/>
+                <a16:creationId xmlns:a16="http://schemas.microsoft.com/office/drawing/2014/main" id="{C35868A1-30C6-48AB-8509-6A8B74505364}"/>
               </a:ext>
             </a:extLst>
           </p:cNvPr>
@@ -12071,7 +12071,7 @@
           <p:cNvPr id="21" name="">
             <a:extLst xmlns:a="http://schemas.openxmlformats.org/drawingml/2006/main">
               <a:ext uri="{FF2B5EF4-FFF2-40B4-BE49-F238E27FC236}">
-                <a16:creationId xmlns:a16="http://schemas.microsoft.com/office/drawing/2014/main" id="{01AD4F0A-ED8D-4BA2-9AE0-3218B20FBDFD}"/>
+                <a16:creationId xmlns:a16="http://schemas.microsoft.com/office/drawing/2014/main" id="{063865C9-E500-4D7D-9881-ADD1CEDE6F7E}"/>
               </a:ext>
             </a:extLst>
           </p:cNvPr>
@@ -12102,7 +12102,7 @@
           <p:cNvPr id="22" name="">
             <a:extLst xmlns:a="http://schemas.openxmlformats.org/drawingml/2006/main">
               <a:ext uri="{FF2B5EF4-FFF2-40B4-BE49-F238E27FC236}">
-                <a16:creationId xmlns:a16="http://schemas.microsoft.com/office/drawing/2014/main" id="{8EC7FB55-927F-4644-9B34-3D90DCE0406D}"/>
+                <a16:creationId xmlns:a16="http://schemas.microsoft.com/office/drawing/2014/main" id="{09B45C6E-E84D-4954-BF00-B1A88A1C61AB}"/>
               </a:ext>
             </a:extLst>
           </p:cNvPr>
@@ -12152,7 +12152,7 @@
           <p:cNvPr id="23" name="">
             <a:extLst xmlns:a="http://schemas.openxmlformats.org/drawingml/2006/main">
               <a:ext uri="{FF2B5EF4-FFF2-40B4-BE49-F238E27FC236}">
-                <a16:creationId xmlns:a16="http://schemas.microsoft.com/office/drawing/2014/main" id="{8A2EE9CF-28FC-4F93-8989-5995D6A31BC8}"/>
+                <a16:creationId xmlns:a16="http://schemas.microsoft.com/office/drawing/2014/main" id="{1F406AF6-7896-461E-9BF7-00D5CB3F6783}"/>
               </a:ext>
             </a:extLst>
           </p:cNvPr>
@@ -12200,7 +12200,7 @@
     </p:spTree>
     <p:extLst>
       <p:ext uri="{BB962C8B-B14F-4D97-AF65-F5344CB8AC3E}">
-        <p14:creationId xmlns:p14="http://schemas.microsoft.com/office/powerpoint/2010/main" val="1791906614"/>
+        <p14:creationId xmlns:p14="http://schemas.microsoft.com/office/powerpoint/2010/main" val="1870086090"/>
       </p:ext>
     </p:extLst>
   </p:cSld>
@@ -12231,7 +12231,7 @@
           <p:cNvPr id="20" name="">
             <a:extLst xmlns:a="http://schemas.openxmlformats.org/drawingml/2006/main">
               <a:ext uri="{FF2B5EF4-FFF2-40B4-BE49-F238E27FC236}">
-                <a16:creationId xmlns:a16="http://schemas.microsoft.com/office/drawing/2014/main" id="{82C8D8B2-669C-436B-81BF-555B09BFC196}"/>
+                <a16:creationId xmlns:a16="http://schemas.microsoft.com/office/drawing/2014/main" id="{80449F2E-99CF-4CB5-8482-E12AFE2A7BA9}"/>
               </a:ext>
             </a:extLst>
           </p:cNvPr>
@@ -12281,7 +12281,7 @@
           <p:cNvPr id="2" name="">
             <a:extLst xmlns:a="http://schemas.openxmlformats.org/drawingml/2006/main">
               <a:ext uri="{FF2B5EF4-FFF2-40B4-BE49-F238E27FC236}">
-                <a16:creationId xmlns:a16="http://schemas.microsoft.com/office/drawing/2014/main" id="{2B3A1002-BFB7-4B95-AAED-81A6159F19A4}"/>
+                <a16:creationId xmlns:a16="http://schemas.microsoft.com/office/drawing/2014/main" id="{A61481C6-D0CB-4534-A991-0A1E3AAC85C0}"/>
               </a:ext>
             </a:extLst>
           </p:cNvPr>
@@ -12331,7 +12331,7 @@
           <p:cNvPr id="3" name="">
             <a:extLst xmlns:a="http://schemas.openxmlformats.org/drawingml/2006/main">
               <a:ext uri="{FF2B5EF4-FFF2-40B4-BE49-F238E27FC236}">
-                <a16:creationId xmlns:a16="http://schemas.microsoft.com/office/drawing/2014/main" id="{BC3DC52A-29F6-4A27-A6D5-C43CB9876C04}"/>
+                <a16:creationId xmlns:a16="http://schemas.microsoft.com/office/drawing/2014/main" id="{F6AF4530-B9D8-45B1-A24A-0AEBD0112AAC}"/>
               </a:ext>
             </a:extLst>
           </p:cNvPr>
@@ -12381,7 +12381,7 @@
           <p:cNvPr id="4" name="">
             <a:extLst xmlns:a="http://schemas.openxmlformats.org/drawingml/2006/main">
               <a:ext uri="{FF2B5EF4-FFF2-40B4-BE49-F238E27FC236}">
-                <a16:creationId xmlns:a16="http://schemas.microsoft.com/office/drawing/2014/main" id="{1D6B7234-7BF2-467C-8329-892332A45887}"/>
+                <a16:creationId xmlns:a16="http://schemas.microsoft.com/office/drawing/2014/main" id="{C775DE4D-EDDD-4FBC-82EF-9BA56DADA8E2}"/>
               </a:ext>
             </a:extLst>
           </p:cNvPr>
@@ -12412,7 +12412,7 @@
           <p:cNvPr id="5" name="">
             <a:extLst xmlns:a="http://schemas.openxmlformats.org/drawingml/2006/main">
               <a:ext uri="{FF2B5EF4-FFF2-40B4-BE49-F238E27FC236}">
-                <a16:creationId xmlns:a16="http://schemas.microsoft.com/office/drawing/2014/main" id="{6E54A8D0-A6CD-4FDE-91BB-5126138C5E0E}"/>
+                <a16:creationId xmlns:a16="http://schemas.microsoft.com/office/drawing/2014/main" id="{322C6521-61D6-4D17-A5A4-D1A7F101523E}"/>
               </a:ext>
             </a:extLst>
           </p:cNvPr>
@@ -12447,7 +12447,7 @@
           <p:cNvPr id="6" name="">
             <a:extLst xmlns:a="http://schemas.openxmlformats.org/drawingml/2006/main">
               <a:ext uri="{FF2B5EF4-FFF2-40B4-BE49-F238E27FC236}">
-                <a16:creationId xmlns:a16="http://schemas.microsoft.com/office/drawing/2014/main" id="{70B6646C-7084-4BB6-8CB3-FC1A1358924E}"/>
+                <a16:creationId xmlns:a16="http://schemas.microsoft.com/office/drawing/2014/main" id="{B9D9702D-6319-4577-A6AB-A30B845E0CA9}"/>
               </a:ext>
             </a:extLst>
           </p:cNvPr>
@@ -12497,7 +12497,7 @@
           <p:cNvPr id="7" name="">
             <a:extLst xmlns:a="http://schemas.openxmlformats.org/drawingml/2006/main">
               <a:ext uri="{FF2B5EF4-FFF2-40B4-BE49-F238E27FC236}">
-                <a16:creationId xmlns:a16="http://schemas.microsoft.com/office/drawing/2014/main" id="{55DCF0AA-B878-4855-9F15-81C4C13CE383}"/>
+                <a16:creationId xmlns:a16="http://schemas.microsoft.com/office/drawing/2014/main" id="{EFDB13A6-8D5D-4D3D-98DC-A448CA452C98}"/>
               </a:ext>
             </a:extLst>
           </p:cNvPr>
@@ -12554,7 +12554,7 @@
         </p:xfrm>
         <a:graphic xmlns:a="http://schemas.openxmlformats.org/drawingml/2006/main">
           <a:graphicData uri="http://schemas.openxmlformats.org/drawingml/2006/chart">
-            <c:chart xmlns:r="http://schemas.openxmlformats.org/officeDocument/2006/relationships" xmlns:c="http://schemas.openxmlformats.org/drawingml/2006/chart" r:id="Rc79f729bcbb54107"/>
+            <c:chart xmlns:r="http://schemas.openxmlformats.org/officeDocument/2006/relationships" xmlns:c="http://schemas.openxmlformats.org/drawingml/2006/chart" r:id="Recffdeee0cf041a1"/>
           </a:graphicData>
         </a:graphic>
       </p:graphicFrame>
@@ -12563,7 +12563,7 @@
           <p:cNvPr id="9" name="">
             <a:extLst xmlns:a="http://schemas.openxmlformats.org/drawingml/2006/main">
               <a:ext uri="{FF2B5EF4-FFF2-40B4-BE49-F238E27FC236}">
-                <a16:creationId xmlns:a16="http://schemas.microsoft.com/office/drawing/2014/main" id="{90A7D62E-2FBF-40E7-9D3B-E9E235691295}"/>
+                <a16:creationId xmlns:a16="http://schemas.microsoft.com/office/drawing/2014/main" id="{8D882751-28AB-4C6F-A065-587F17CAA638}"/>
               </a:ext>
             </a:extLst>
           </p:cNvPr>
@@ -12598,7 +12598,7 @@
           <p:cNvPr id="10" name="">
             <a:extLst xmlns:a="http://schemas.openxmlformats.org/drawingml/2006/main">
               <a:ext uri="{FF2B5EF4-FFF2-40B4-BE49-F238E27FC236}">
-                <a16:creationId xmlns:a16="http://schemas.microsoft.com/office/drawing/2014/main" id="{DB25022D-C0F9-4137-8118-554047B0FEAA}"/>
+                <a16:creationId xmlns:a16="http://schemas.microsoft.com/office/drawing/2014/main" id="{C49B4A08-6B8C-442D-A621-DE2530929866}"/>
               </a:ext>
             </a:extLst>
           </p:cNvPr>
@@ -12631,7 +12631,7 @@
           <p:cNvPr id="11" name="">
             <a:extLst xmlns:a="http://schemas.openxmlformats.org/drawingml/2006/main">
               <a:ext uri="{FF2B5EF4-FFF2-40B4-BE49-F238E27FC236}">
-                <a16:creationId xmlns:a16="http://schemas.microsoft.com/office/drawing/2014/main" id="{CDE54149-BF92-4AB9-8AAB-E08F5DB58770}"/>
+                <a16:creationId xmlns:a16="http://schemas.microsoft.com/office/drawing/2014/main" id="{589E73CE-1519-4A24-A991-3717D6E6F01B}"/>
               </a:ext>
             </a:extLst>
           </p:cNvPr>
@@ -12681,7 +12681,7 @@
           <p:cNvPr id="12" name="">
             <a:extLst xmlns:a="http://schemas.openxmlformats.org/drawingml/2006/main">
               <a:ext uri="{FF2B5EF4-FFF2-40B4-BE49-F238E27FC236}">
-                <a16:creationId xmlns:a16="http://schemas.microsoft.com/office/drawing/2014/main" id="{D5F88AB9-257B-4C22-AAC9-6E8BFD43ADE6}"/>
+                <a16:creationId xmlns:a16="http://schemas.microsoft.com/office/drawing/2014/main" id="{E011DD7F-B21B-4BC7-84C9-A5FDA51A789B}"/>
               </a:ext>
             </a:extLst>
           </p:cNvPr>
@@ -12731,7 +12731,7 @@
           <p:cNvPr id="13" name="">
             <a:extLst xmlns:a="http://schemas.openxmlformats.org/drawingml/2006/main">
               <a:ext uri="{FF2B5EF4-FFF2-40B4-BE49-F238E27FC236}">
-                <a16:creationId xmlns:a16="http://schemas.microsoft.com/office/drawing/2014/main" id="{AF22335E-718E-4B8F-A497-5997114F9714}"/>
+                <a16:creationId xmlns:a16="http://schemas.microsoft.com/office/drawing/2014/main" id="{C205E1A7-E9AB-460B-AB7C-F396387D7A01}"/>
               </a:ext>
             </a:extLst>
           </p:cNvPr>
@@ -12766,7 +12766,7 @@
           <p:cNvPr id="14" name="">
             <a:extLst xmlns:a="http://schemas.openxmlformats.org/drawingml/2006/main">
               <a:ext uri="{FF2B5EF4-FFF2-40B4-BE49-F238E27FC236}">
-                <a16:creationId xmlns:a16="http://schemas.microsoft.com/office/drawing/2014/main" id="{AC6EE912-1218-4BB2-B1A9-EA7D4673AD8E}"/>
+                <a16:creationId xmlns:a16="http://schemas.microsoft.com/office/drawing/2014/main" id="{49983737-D00B-47E2-986B-2892F3523A33}"/>
               </a:ext>
             </a:extLst>
           </p:cNvPr>
@@ -12799,7 +12799,7 @@
           <p:cNvPr id="15" name="">
             <a:extLst xmlns:a="http://schemas.openxmlformats.org/drawingml/2006/main">
               <a:ext uri="{FF2B5EF4-FFF2-40B4-BE49-F238E27FC236}">
-                <a16:creationId xmlns:a16="http://schemas.microsoft.com/office/drawing/2014/main" id="{147B9293-39B5-463E-8FF0-7FF11E3C1740}"/>
+                <a16:creationId xmlns:a16="http://schemas.microsoft.com/office/drawing/2014/main" id="{B2083B78-4A4B-4432-B3EC-D5EE29CD0A15}"/>
               </a:ext>
             </a:extLst>
           </p:cNvPr>
@@ -12849,7 +12849,7 @@
           <p:cNvPr id="16" name="">
             <a:extLst xmlns:a="http://schemas.openxmlformats.org/drawingml/2006/main">
               <a:ext uri="{FF2B5EF4-FFF2-40B4-BE49-F238E27FC236}">
-                <a16:creationId xmlns:a16="http://schemas.microsoft.com/office/drawing/2014/main" id="{2CC6EC7C-4415-4CB4-AFAE-3DA1BC3E9DD9}"/>
+                <a16:creationId xmlns:a16="http://schemas.microsoft.com/office/drawing/2014/main" id="{5CA70AD2-6CA0-4692-B5A6-6A6FD67D7C2A}"/>
               </a:ext>
             </a:extLst>
           </p:cNvPr>
@@ -12899,7 +12899,7 @@
           <p:cNvPr id="17" name="">
             <a:extLst xmlns:a="http://schemas.openxmlformats.org/drawingml/2006/main">
               <a:ext uri="{FF2B5EF4-FFF2-40B4-BE49-F238E27FC236}">
-                <a16:creationId xmlns:a16="http://schemas.microsoft.com/office/drawing/2014/main" id="{C20254FB-53E7-4FE4-BF4D-2A39DBD5686D}"/>
+                <a16:creationId xmlns:a16="http://schemas.microsoft.com/office/drawing/2014/main" id="{1FDB9386-BBAA-4FC1-B8C0-55A41FFB9B56}"/>
               </a:ext>
             </a:extLst>
           </p:cNvPr>
@@ -12930,7 +12930,7 @@
           <p:cNvPr id="18" name="">
             <a:extLst xmlns:a="http://schemas.openxmlformats.org/drawingml/2006/main">
               <a:ext uri="{FF2B5EF4-FFF2-40B4-BE49-F238E27FC236}">
-                <a16:creationId xmlns:a16="http://schemas.microsoft.com/office/drawing/2014/main" id="{055B9573-C5E1-4BC4-AE1F-2045E1D2C6CC}"/>
+                <a16:creationId xmlns:a16="http://schemas.microsoft.com/office/drawing/2014/main" id="{D7831447-057E-4D7A-A413-F7E9CFDE71B6}"/>
               </a:ext>
             </a:extLst>
           </p:cNvPr>
@@ -12980,7 +12980,7 @@
           <p:cNvPr id="19" name="">
             <a:extLst xmlns:a="http://schemas.openxmlformats.org/drawingml/2006/main">
               <a:ext uri="{FF2B5EF4-FFF2-40B4-BE49-F238E27FC236}">
-                <a16:creationId xmlns:a16="http://schemas.microsoft.com/office/drawing/2014/main" id="{2FAFB9CE-F0B7-4AE1-AB40-37E4AF438CF9}"/>
+                <a16:creationId xmlns:a16="http://schemas.microsoft.com/office/drawing/2014/main" id="{9AFF34DC-A665-494B-93D0-9383C35D7DD5}"/>
               </a:ext>
             </a:extLst>
           </p:cNvPr>
@@ -13028,7 +13028,7 @@
     </p:spTree>
     <p:extLst>
       <p:ext uri="{BB962C8B-B14F-4D97-AF65-F5344CB8AC3E}">
-        <p14:creationId xmlns:p14="http://schemas.microsoft.com/office/powerpoint/2010/main" val="822011949"/>
+        <p14:creationId xmlns:p14="http://schemas.microsoft.com/office/powerpoint/2010/main" val="371781228"/>
       </p:ext>
     </p:extLst>
   </p:cSld>
@@ -13059,7 +13059,7 @@
           <p:cNvPr id="29" name="">
             <a:extLst xmlns:a="http://schemas.openxmlformats.org/drawingml/2006/main">
               <a:ext uri="{FF2B5EF4-FFF2-40B4-BE49-F238E27FC236}">
-                <a16:creationId xmlns:a16="http://schemas.microsoft.com/office/drawing/2014/main" id="{427EBCC6-BDF4-483F-B888-A9E7E75F83E3}"/>
+                <a16:creationId xmlns:a16="http://schemas.microsoft.com/office/drawing/2014/main" id="{FEE25633-E3FF-453C-9B0E-9F64226A1A72}"/>
               </a:ext>
             </a:extLst>
           </p:cNvPr>
@@ -13109,7 +13109,7 @@
           <p:cNvPr id="2" name="">
             <a:extLst xmlns:a="http://schemas.openxmlformats.org/drawingml/2006/main">
               <a:ext uri="{FF2B5EF4-FFF2-40B4-BE49-F238E27FC236}">
-                <a16:creationId xmlns:a16="http://schemas.microsoft.com/office/drawing/2014/main" id="{B0EA93ED-05D5-423F-A793-33831037E2A2}"/>
+                <a16:creationId xmlns:a16="http://schemas.microsoft.com/office/drawing/2014/main" id="{3E63C302-A569-4B0C-9DDC-9CEA8E07B1BB}"/>
               </a:ext>
             </a:extLst>
           </p:cNvPr>
@@ -13159,7 +13159,7 @@
           <p:cNvPr id="3" name="">
             <a:extLst xmlns:a="http://schemas.openxmlformats.org/drawingml/2006/main">
               <a:ext uri="{FF2B5EF4-FFF2-40B4-BE49-F238E27FC236}">
-                <a16:creationId xmlns:a16="http://schemas.microsoft.com/office/drawing/2014/main" id="{3FA22C11-D22A-4BEB-A126-C758D2757CAD}"/>
+                <a16:creationId xmlns:a16="http://schemas.microsoft.com/office/drawing/2014/main" id="{77ED03B7-2421-4151-9081-F7FD22E525A8}"/>
               </a:ext>
             </a:extLst>
           </p:cNvPr>
@@ -13209,7 +13209,7 @@
           <p:cNvPr id="4" name="">
             <a:extLst xmlns:a="http://schemas.openxmlformats.org/drawingml/2006/main">
               <a:ext uri="{FF2B5EF4-FFF2-40B4-BE49-F238E27FC236}">
-                <a16:creationId xmlns:a16="http://schemas.microsoft.com/office/drawing/2014/main" id="{B8108BC6-0A9A-407F-AFE2-0AAE5A70EF18}"/>
+                <a16:creationId xmlns:a16="http://schemas.microsoft.com/office/drawing/2014/main" id="{E20578EF-6A81-4675-B860-5C474142EB44}"/>
               </a:ext>
             </a:extLst>
           </p:cNvPr>
@@ -13240,7 +13240,7 @@
           <p:cNvPr id="5" name="">
             <a:extLst xmlns:a="http://schemas.openxmlformats.org/drawingml/2006/main">
               <a:ext uri="{FF2B5EF4-FFF2-40B4-BE49-F238E27FC236}">
-                <a16:creationId xmlns:a16="http://schemas.microsoft.com/office/drawing/2014/main" id="{B2BC072B-4C03-4107-968E-FB1DE46E4AD4}"/>
+                <a16:creationId xmlns:a16="http://schemas.microsoft.com/office/drawing/2014/main" id="{E326FC8C-35F9-4280-B9C3-953CCDEAA34B}"/>
               </a:ext>
             </a:extLst>
           </p:cNvPr>
@@ -13275,7 +13275,7 @@
           <p:cNvPr id="6" name="">
             <a:extLst xmlns:a="http://schemas.openxmlformats.org/drawingml/2006/main">
               <a:ext uri="{FF2B5EF4-FFF2-40B4-BE49-F238E27FC236}">
-                <a16:creationId xmlns:a16="http://schemas.microsoft.com/office/drawing/2014/main" id="{C4E1A9EC-981F-4E90-ACA9-78A508875ECB}"/>
+                <a16:creationId xmlns:a16="http://schemas.microsoft.com/office/drawing/2014/main" id="{A6B314E3-064E-4DF3-86C7-92AF243331B9}"/>
               </a:ext>
             </a:extLst>
           </p:cNvPr>
@@ -13325,7 +13325,7 @@
           <p:cNvPr id="7" name="">
             <a:extLst xmlns:a="http://schemas.openxmlformats.org/drawingml/2006/main">
               <a:ext uri="{FF2B5EF4-FFF2-40B4-BE49-F238E27FC236}">
-                <a16:creationId xmlns:a16="http://schemas.microsoft.com/office/drawing/2014/main" id="{8F0396CD-929E-441E-B431-0103ACCC339C}"/>
+                <a16:creationId xmlns:a16="http://schemas.microsoft.com/office/drawing/2014/main" id="{69B8D888-E6FD-489F-8CDC-3A42DB0EEB23}"/>
               </a:ext>
             </a:extLst>
           </p:cNvPr>
@@ -13382,7 +13382,7 @@
         </p:xfrm>
         <a:graphic xmlns:a="http://schemas.openxmlformats.org/drawingml/2006/main">
           <a:graphicData uri="http://schemas.openxmlformats.org/drawingml/2006/chart">
-            <c:chart xmlns:r="http://schemas.openxmlformats.org/officeDocument/2006/relationships" xmlns:c="http://schemas.openxmlformats.org/drawingml/2006/chart" r:id="Rf47205b8966e41eb"/>
+            <c:chart xmlns:r="http://schemas.openxmlformats.org/officeDocument/2006/relationships" xmlns:c="http://schemas.openxmlformats.org/drawingml/2006/chart" r:id="R4f31389574814219"/>
           </a:graphicData>
         </a:graphic>
       </p:graphicFrame>
@@ -13391,7 +13391,7 @@
           <p:cNvPr id="9" name="">
             <a:extLst xmlns:a="http://schemas.openxmlformats.org/drawingml/2006/main">
               <a:ext uri="{FF2B5EF4-FFF2-40B4-BE49-F238E27FC236}">
-                <a16:creationId xmlns:a16="http://schemas.microsoft.com/office/drawing/2014/main" id="{63CA4A04-CA39-4F73-B11B-00DE79C4CDB5}"/>
+                <a16:creationId xmlns:a16="http://schemas.microsoft.com/office/drawing/2014/main" id="{5E912D6F-AF49-4E66-90BC-23357AA39B8C}"/>
               </a:ext>
             </a:extLst>
           </p:cNvPr>
@@ -13441,7 +13441,7 @@
           <p:cNvPr id="10" name="">
             <a:extLst xmlns:a="http://schemas.openxmlformats.org/drawingml/2006/main">
               <a:ext uri="{FF2B5EF4-FFF2-40B4-BE49-F238E27FC236}">
-                <a16:creationId xmlns:a16="http://schemas.microsoft.com/office/drawing/2014/main" id="{FA6EB9D3-D67B-4672-B8C2-F5C5EABADF36}"/>
+                <a16:creationId xmlns:a16="http://schemas.microsoft.com/office/drawing/2014/main" id="{CE3D331B-7EFF-4F34-919A-16799C69FEBB}"/>
               </a:ext>
             </a:extLst>
           </p:cNvPr>
@@ -13491,7 +13491,7 @@
           <p:cNvPr id="11" name="">
             <a:extLst xmlns:a="http://schemas.openxmlformats.org/drawingml/2006/main">
               <a:ext uri="{FF2B5EF4-FFF2-40B4-BE49-F238E27FC236}">
-                <a16:creationId xmlns:a16="http://schemas.microsoft.com/office/drawing/2014/main" id="{F0568A95-B1ED-46F6-8018-3C9AAC36376A}"/>
+                <a16:creationId xmlns:a16="http://schemas.microsoft.com/office/drawing/2014/main" id="{060B6598-AC86-4F90-901D-A8B42A479E41}"/>
               </a:ext>
             </a:extLst>
           </p:cNvPr>
@@ -13541,7 +13541,7 @@
           <p:cNvPr id="12" name="">
             <a:extLst xmlns:a="http://schemas.openxmlformats.org/drawingml/2006/main">
               <a:ext uri="{FF2B5EF4-FFF2-40B4-BE49-F238E27FC236}">
-                <a16:creationId xmlns:a16="http://schemas.microsoft.com/office/drawing/2014/main" id="{76ED9568-5E76-4A05-9BBE-2CAAFCA0733B}"/>
+                <a16:creationId xmlns:a16="http://schemas.microsoft.com/office/drawing/2014/main" id="{ADA13215-880B-4AF2-93AE-60BE600E95E0}"/>
               </a:ext>
             </a:extLst>
           </p:cNvPr>
@@ -13591,7 +13591,7 @@
           <p:cNvPr id="13" name="">
             <a:extLst xmlns:a="http://schemas.openxmlformats.org/drawingml/2006/main">
               <a:ext uri="{FF2B5EF4-FFF2-40B4-BE49-F238E27FC236}">
-                <a16:creationId xmlns:a16="http://schemas.microsoft.com/office/drawing/2014/main" id="{A14B0D09-5B33-4DE5-A4CB-0497DC8F7511}"/>
+                <a16:creationId xmlns:a16="http://schemas.microsoft.com/office/drawing/2014/main" id="{1C47B885-8BD9-4998-9258-9279D8C595ED}"/>
               </a:ext>
             </a:extLst>
           </p:cNvPr>
@@ -13641,7 +13641,7 @@
           <p:cNvPr id="14" name="">
             <a:extLst xmlns:a="http://schemas.openxmlformats.org/drawingml/2006/main">
               <a:ext uri="{FF2B5EF4-FFF2-40B4-BE49-F238E27FC236}">
-                <a16:creationId xmlns:a16="http://schemas.microsoft.com/office/drawing/2014/main" id="{EF660941-F4A3-4D82-B617-5B96C0694DF0}"/>
+                <a16:creationId xmlns:a16="http://schemas.microsoft.com/office/drawing/2014/main" id="{C7985464-CF74-4C87-9343-BF91FA5DB97D}"/>
               </a:ext>
             </a:extLst>
           </p:cNvPr>
@@ -13691,7 +13691,7 @@
           <p:cNvPr id="15" name="">
             <a:extLst xmlns:a="http://schemas.openxmlformats.org/drawingml/2006/main">
               <a:ext uri="{FF2B5EF4-FFF2-40B4-BE49-F238E27FC236}">
-                <a16:creationId xmlns:a16="http://schemas.microsoft.com/office/drawing/2014/main" id="{8E85FC37-8904-4DE7-BBD6-76BF95DD793D}"/>
+                <a16:creationId xmlns:a16="http://schemas.microsoft.com/office/drawing/2014/main" id="{2487E429-65C1-4352-B6AE-1DE4958241D3}"/>
               </a:ext>
             </a:extLst>
           </p:cNvPr>
@@ -13741,7 +13741,7 @@
           <p:cNvPr id="16" name="">
             <a:extLst xmlns:a="http://schemas.openxmlformats.org/drawingml/2006/main">
               <a:ext uri="{FF2B5EF4-FFF2-40B4-BE49-F238E27FC236}">
-                <a16:creationId xmlns:a16="http://schemas.microsoft.com/office/drawing/2014/main" id="{6EDBDDBB-0D2E-47A6-AEEC-3072F235C24D}"/>
+                <a16:creationId xmlns:a16="http://schemas.microsoft.com/office/drawing/2014/main" id="{38E6CB32-B30A-4991-A3B3-45A263105C29}"/>
               </a:ext>
             </a:extLst>
           </p:cNvPr>
@@ -13791,7 +13791,7 @@
           <p:cNvPr id="17" name="">
             <a:extLst xmlns:a="http://schemas.openxmlformats.org/drawingml/2006/main">
               <a:ext uri="{FF2B5EF4-FFF2-40B4-BE49-F238E27FC236}">
-                <a16:creationId xmlns:a16="http://schemas.microsoft.com/office/drawing/2014/main" id="{60866F7F-5114-4C4E-B9F4-1B3AA7855EC4}"/>
+                <a16:creationId xmlns:a16="http://schemas.microsoft.com/office/drawing/2014/main" id="{0E9E561E-3C73-4AB2-A485-0A0DE7D8C4AD}"/>
               </a:ext>
             </a:extLst>
           </p:cNvPr>
@@ -13841,7 +13841,7 @@
           <p:cNvPr id="18" name="">
             <a:extLst xmlns:a="http://schemas.openxmlformats.org/drawingml/2006/main">
               <a:ext uri="{FF2B5EF4-FFF2-40B4-BE49-F238E27FC236}">
-                <a16:creationId xmlns:a16="http://schemas.microsoft.com/office/drawing/2014/main" id="{8E35848B-5FC9-461B-A9C2-A745AA316E16}"/>
+                <a16:creationId xmlns:a16="http://schemas.microsoft.com/office/drawing/2014/main" id="{CE816607-A15F-4E7A-A917-60D7ABD70E1F}"/>
               </a:ext>
             </a:extLst>
           </p:cNvPr>
@@ -13891,7 +13891,7 @@
           <p:cNvPr id="19" name="">
             <a:extLst xmlns:a="http://schemas.openxmlformats.org/drawingml/2006/main">
               <a:ext uri="{FF2B5EF4-FFF2-40B4-BE49-F238E27FC236}">
-                <a16:creationId xmlns:a16="http://schemas.microsoft.com/office/drawing/2014/main" id="{43D083D9-E852-49A8-B9E9-BB842BAF1B21}"/>
+                <a16:creationId xmlns:a16="http://schemas.microsoft.com/office/drawing/2014/main" id="{4FF37E38-A8BF-4867-9B79-DA9BE6B84305}"/>
               </a:ext>
             </a:extLst>
           </p:cNvPr>
@@ -13941,7 +13941,7 @@
           <p:cNvPr id="20" name="">
             <a:extLst xmlns:a="http://schemas.openxmlformats.org/drawingml/2006/main">
               <a:ext uri="{FF2B5EF4-FFF2-40B4-BE49-F238E27FC236}">
-                <a16:creationId xmlns:a16="http://schemas.microsoft.com/office/drawing/2014/main" id="{955E5E0C-D253-46A1-B609-4DA09E72F18D}"/>
+                <a16:creationId xmlns:a16="http://schemas.microsoft.com/office/drawing/2014/main" id="{0A919FF5-11F8-41BA-996D-7A7905785DC1}"/>
               </a:ext>
             </a:extLst>
           </p:cNvPr>
@@ -13991,7 +13991,7 @@
           <p:cNvPr id="21" name="">
             <a:extLst xmlns:a="http://schemas.openxmlformats.org/drawingml/2006/main">
               <a:ext uri="{FF2B5EF4-FFF2-40B4-BE49-F238E27FC236}">
-                <a16:creationId xmlns:a16="http://schemas.microsoft.com/office/drawing/2014/main" id="{958C0996-D34D-4637-ADDE-BD3B79262F69}"/>
+                <a16:creationId xmlns:a16="http://schemas.microsoft.com/office/drawing/2014/main" id="{BA348D5E-6219-4E13-87A5-F68B973045D7}"/>
               </a:ext>
             </a:extLst>
           </p:cNvPr>
@@ -14041,7 +14041,7 @@
           <p:cNvPr id="22" name="">
             <a:extLst xmlns:a="http://schemas.openxmlformats.org/drawingml/2006/main">
               <a:ext uri="{FF2B5EF4-FFF2-40B4-BE49-F238E27FC236}">
-                <a16:creationId xmlns:a16="http://schemas.microsoft.com/office/drawing/2014/main" id="{D5B345B4-FB1B-4FCA-937B-20EB04C00611}"/>
+                <a16:creationId xmlns:a16="http://schemas.microsoft.com/office/drawing/2014/main" id="{5EA957DD-28C7-4E78-84F6-425DA683B55B}"/>
               </a:ext>
             </a:extLst>
           </p:cNvPr>
@@ -14076,7 +14076,7 @@
           <p:cNvPr id="23" name="">
             <a:extLst xmlns:a="http://schemas.openxmlformats.org/drawingml/2006/main">
               <a:ext uri="{FF2B5EF4-FFF2-40B4-BE49-F238E27FC236}">
-                <a16:creationId xmlns:a16="http://schemas.microsoft.com/office/drawing/2014/main" id="{B04A8523-340F-4558-B3C1-6A3AC3DDC215}"/>
+                <a16:creationId xmlns:a16="http://schemas.microsoft.com/office/drawing/2014/main" id="{4F3EAD26-2469-4141-B1B1-2DA161925DB3}"/>
               </a:ext>
             </a:extLst>
           </p:cNvPr>
@@ -14109,7 +14109,7 @@
           <p:cNvPr id="24" name="">
             <a:extLst xmlns:a="http://schemas.openxmlformats.org/drawingml/2006/main">
               <a:ext uri="{FF2B5EF4-FFF2-40B4-BE49-F238E27FC236}">
-                <a16:creationId xmlns:a16="http://schemas.microsoft.com/office/drawing/2014/main" id="{F860EA9F-D044-4B07-BDEB-53074A445CE3}"/>
+                <a16:creationId xmlns:a16="http://schemas.microsoft.com/office/drawing/2014/main" id="{740D0A0D-8062-498C-999F-D2D82CD31DC7}"/>
               </a:ext>
             </a:extLst>
           </p:cNvPr>
@@ -14159,7 +14159,7 @@
           <p:cNvPr id="25" name="">
             <a:extLst xmlns:a="http://schemas.openxmlformats.org/drawingml/2006/main">
               <a:ext uri="{FF2B5EF4-FFF2-40B4-BE49-F238E27FC236}">
-                <a16:creationId xmlns:a16="http://schemas.microsoft.com/office/drawing/2014/main" id="{EA982454-2F4A-4F64-9C49-5FC7327F015D}"/>
+                <a16:creationId xmlns:a16="http://schemas.microsoft.com/office/drawing/2014/main" id="{4E9B36C0-DF97-4194-80D3-46BC548D20DF}"/>
               </a:ext>
             </a:extLst>
           </p:cNvPr>
@@ -14209,7 +14209,7 @@
           <p:cNvPr id="26" name="">
             <a:extLst xmlns:a="http://schemas.openxmlformats.org/drawingml/2006/main">
               <a:ext uri="{FF2B5EF4-FFF2-40B4-BE49-F238E27FC236}">
-                <a16:creationId xmlns:a16="http://schemas.microsoft.com/office/drawing/2014/main" id="{D14ECD14-4838-43C1-A506-2BC215C1B121}"/>
+                <a16:creationId xmlns:a16="http://schemas.microsoft.com/office/drawing/2014/main" id="{DA74754D-3066-414C-8901-8ED6882E8C30}"/>
               </a:ext>
             </a:extLst>
           </p:cNvPr>
@@ -14240,7 +14240,7 @@
           <p:cNvPr id="27" name="">
             <a:extLst xmlns:a="http://schemas.openxmlformats.org/drawingml/2006/main">
               <a:ext uri="{FF2B5EF4-FFF2-40B4-BE49-F238E27FC236}">
-                <a16:creationId xmlns:a16="http://schemas.microsoft.com/office/drawing/2014/main" id="{A9DFD676-DBD4-4ABE-92BE-0397A6451CC2}"/>
+                <a16:creationId xmlns:a16="http://schemas.microsoft.com/office/drawing/2014/main" id="{F18C4E52-5E1F-48AA-9ADC-300AA4B27EAD}"/>
               </a:ext>
             </a:extLst>
           </p:cNvPr>
@@ -14290,7 +14290,7 @@
           <p:cNvPr id="28" name="">
             <a:extLst xmlns:a="http://schemas.openxmlformats.org/drawingml/2006/main">
               <a:ext uri="{FF2B5EF4-FFF2-40B4-BE49-F238E27FC236}">
-                <a16:creationId xmlns:a16="http://schemas.microsoft.com/office/drawing/2014/main" id="{E9D8A7FC-79A8-45C8-9D44-1B50862AF3DF}"/>
+                <a16:creationId xmlns:a16="http://schemas.microsoft.com/office/drawing/2014/main" id="{D35007B3-73AD-4A51-82A3-DA4F7B6F3C03}"/>
               </a:ext>
             </a:extLst>
           </p:cNvPr>
@@ -14338,7 +14338,7 @@
     </p:spTree>
     <p:extLst>
       <p:ext uri="{BB962C8B-B14F-4D97-AF65-F5344CB8AC3E}">
-        <p14:creationId xmlns:p14="http://schemas.microsoft.com/office/powerpoint/2010/main" val="1339612715"/>
+        <p14:creationId xmlns:p14="http://schemas.microsoft.com/office/powerpoint/2010/main" val="2029509634"/>
       </p:ext>
     </p:extLst>
   </p:cSld>
@@ -14369,7 +14369,7 @@
           <p:cNvPr id="24" name="">
             <a:extLst xmlns:a="http://schemas.openxmlformats.org/drawingml/2006/main">
               <a:ext uri="{FF2B5EF4-FFF2-40B4-BE49-F238E27FC236}">
-                <a16:creationId xmlns:a16="http://schemas.microsoft.com/office/drawing/2014/main" id="{34B37338-3060-4D4F-9324-712E80358696}"/>
+                <a16:creationId xmlns:a16="http://schemas.microsoft.com/office/drawing/2014/main" id="{E41F6113-26AA-40FC-AA54-B1534AD9EFE4}"/>
               </a:ext>
             </a:extLst>
           </p:cNvPr>
@@ -14419,7 +14419,7 @@
           <p:cNvPr id="2" name="">
             <a:extLst xmlns:a="http://schemas.openxmlformats.org/drawingml/2006/main">
               <a:ext uri="{FF2B5EF4-FFF2-40B4-BE49-F238E27FC236}">
-                <a16:creationId xmlns:a16="http://schemas.microsoft.com/office/drawing/2014/main" id="{D58C4FB7-541C-482C-B459-2F25C533ED98}"/>
+                <a16:creationId xmlns:a16="http://schemas.microsoft.com/office/drawing/2014/main" id="{437A25D6-ED5C-4558-A67A-27EA76BAE591}"/>
               </a:ext>
             </a:extLst>
           </p:cNvPr>
@@ -14469,7 +14469,7 @@
           <p:cNvPr id="3" name="">
             <a:extLst xmlns:a="http://schemas.openxmlformats.org/drawingml/2006/main">
               <a:ext uri="{FF2B5EF4-FFF2-40B4-BE49-F238E27FC236}">
-                <a16:creationId xmlns:a16="http://schemas.microsoft.com/office/drawing/2014/main" id="{8A49566B-B561-4ECD-8DA9-F2DAD375A132}"/>
+                <a16:creationId xmlns:a16="http://schemas.microsoft.com/office/drawing/2014/main" id="{854393EA-4F4F-48CD-B35A-93460AAB13C1}"/>
               </a:ext>
             </a:extLst>
           </p:cNvPr>
@@ -14519,7 +14519,7 @@
           <p:cNvPr id="4" name="">
             <a:extLst xmlns:a="http://schemas.openxmlformats.org/drawingml/2006/main">
               <a:ext uri="{FF2B5EF4-FFF2-40B4-BE49-F238E27FC236}">
-                <a16:creationId xmlns:a16="http://schemas.microsoft.com/office/drawing/2014/main" id="{8B649016-C5A8-4354-9613-E721482E41D8}"/>
+                <a16:creationId xmlns:a16="http://schemas.microsoft.com/office/drawing/2014/main" id="{22E6CF52-5020-4A07-B5E8-871CCAA424F2}"/>
               </a:ext>
             </a:extLst>
           </p:cNvPr>
@@ -14550,7 +14550,7 @@
           <p:cNvPr id="5" name="">
             <a:extLst xmlns:a="http://schemas.openxmlformats.org/drawingml/2006/main">
               <a:ext uri="{FF2B5EF4-FFF2-40B4-BE49-F238E27FC236}">
-                <a16:creationId xmlns:a16="http://schemas.microsoft.com/office/drawing/2014/main" id="{DE3404F6-812B-447B-9E8E-7F01F5011121}"/>
+                <a16:creationId xmlns:a16="http://schemas.microsoft.com/office/drawing/2014/main" id="{3F1D5490-2D50-4674-A876-2EA51451C9B2}"/>
               </a:ext>
             </a:extLst>
           </p:cNvPr>
@@ -14585,7 +14585,7 @@
           <p:cNvPr id="6" name="">
             <a:extLst xmlns:a="http://schemas.openxmlformats.org/drawingml/2006/main">
               <a:ext uri="{FF2B5EF4-FFF2-40B4-BE49-F238E27FC236}">
-                <a16:creationId xmlns:a16="http://schemas.microsoft.com/office/drawing/2014/main" id="{313C9E52-7EB6-4B6B-97B3-19372ACE133A}"/>
+                <a16:creationId xmlns:a16="http://schemas.microsoft.com/office/drawing/2014/main" id="{D2B3AB10-7E80-4DD6-9EA0-212260B20668}"/>
               </a:ext>
             </a:extLst>
           </p:cNvPr>
@@ -14635,7 +14635,7 @@
           <p:cNvPr id="7" name="">
             <a:extLst xmlns:a="http://schemas.openxmlformats.org/drawingml/2006/main">
               <a:ext uri="{FF2B5EF4-FFF2-40B4-BE49-F238E27FC236}">
-                <a16:creationId xmlns:a16="http://schemas.microsoft.com/office/drawing/2014/main" id="{FFE59B2E-02F2-40F7-8947-ACE0223E91F4}"/>
+                <a16:creationId xmlns:a16="http://schemas.microsoft.com/office/drawing/2014/main" id="{117061F3-E709-4129-84E1-4971F5F1FB83}"/>
               </a:ext>
             </a:extLst>
           </p:cNvPr>
@@ -14692,7 +14692,7 @@
         </p:xfrm>
         <a:graphic xmlns:a="http://schemas.openxmlformats.org/drawingml/2006/main">
           <a:graphicData uri="http://schemas.openxmlformats.org/drawingml/2006/chart">
-            <c:chart xmlns:r="http://schemas.openxmlformats.org/officeDocument/2006/relationships" xmlns:c="http://schemas.openxmlformats.org/drawingml/2006/chart" r:id="R9f94f42c72b94e35"/>
+            <c:chart xmlns:r="http://schemas.openxmlformats.org/officeDocument/2006/relationships" xmlns:c="http://schemas.openxmlformats.org/drawingml/2006/chart" r:id="R79e7db130c064066"/>
           </a:graphicData>
         </a:graphic>
       </p:graphicFrame>
@@ -14701,7 +14701,7 @@
           <p:cNvPr id="9" name="">
             <a:extLst xmlns:a="http://schemas.openxmlformats.org/drawingml/2006/main">
               <a:ext uri="{FF2B5EF4-FFF2-40B4-BE49-F238E27FC236}">
-                <a16:creationId xmlns:a16="http://schemas.microsoft.com/office/drawing/2014/main" id="{0645F845-7876-4DE2-9C46-AE188469390A}"/>
+                <a16:creationId xmlns:a16="http://schemas.microsoft.com/office/drawing/2014/main" id="{BA19104A-E411-483A-876B-C1C69D76313C}"/>
               </a:ext>
             </a:extLst>
           </p:cNvPr>
@@ -14734,7 +14734,7 @@
           <p:cNvPr id="10" name="">
             <a:extLst xmlns:a="http://schemas.openxmlformats.org/drawingml/2006/main">
               <a:ext uri="{FF2B5EF4-FFF2-40B4-BE49-F238E27FC236}">
-                <a16:creationId xmlns:a16="http://schemas.microsoft.com/office/drawing/2014/main" id="{E032623B-D1A2-4942-9EA0-78379F52EECB}"/>
+                <a16:creationId xmlns:a16="http://schemas.microsoft.com/office/drawing/2014/main" id="{22E9E785-D961-4191-B551-EE71CD231FCF}"/>
               </a:ext>
             </a:extLst>
           </p:cNvPr>
@@ -14784,7 +14784,7 @@
           <p:cNvPr id="11" name="">
             <a:extLst xmlns:a="http://schemas.openxmlformats.org/drawingml/2006/main">
               <a:ext uri="{FF2B5EF4-FFF2-40B4-BE49-F238E27FC236}">
-                <a16:creationId xmlns:a16="http://schemas.microsoft.com/office/drawing/2014/main" id="{12959FD7-963B-4BAD-8632-090CB4622F89}"/>
+                <a16:creationId xmlns:a16="http://schemas.microsoft.com/office/drawing/2014/main" id="{B0ABFEE8-5E96-44EE-970C-A8F0D75AE3F5}"/>
               </a:ext>
             </a:extLst>
           </p:cNvPr>
@@ -14834,7 +14834,7 @@
           <p:cNvPr id="12" name="">
             <a:extLst xmlns:a="http://schemas.openxmlformats.org/drawingml/2006/main">
               <a:ext uri="{FF2B5EF4-FFF2-40B4-BE49-F238E27FC236}">
-                <a16:creationId xmlns:a16="http://schemas.microsoft.com/office/drawing/2014/main" id="{C4E501B9-422B-4720-B3A3-92EF428A3463}"/>
+                <a16:creationId xmlns:a16="http://schemas.microsoft.com/office/drawing/2014/main" id="{6E2D70EF-33B0-4746-985D-681CE27FFE96}"/>
               </a:ext>
             </a:extLst>
           </p:cNvPr>
@@ -14884,7 +14884,7 @@
           <p:cNvPr id="13" name="">
             <a:extLst xmlns:a="http://schemas.openxmlformats.org/drawingml/2006/main">
               <a:ext uri="{FF2B5EF4-FFF2-40B4-BE49-F238E27FC236}">
-                <a16:creationId xmlns:a16="http://schemas.microsoft.com/office/drawing/2014/main" id="{F57DD259-0566-43C0-9A8E-16C88CF2D43C}"/>
+                <a16:creationId xmlns:a16="http://schemas.microsoft.com/office/drawing/2014/main" id="{185AC052-3728-4B9F-9438-CC49271B6516}"/>
               </a:ext>
             </a:extLst>
           </p:cNvPr>
@@ -14917,7 +14917,7 @@
           <p:cNvPr id="14" name="">
             <a:extLst xmlns:a="http://schemas.openxmlformats.org/drawingml/2006/main">
               <a:ext uri="{FF2B5EF4-FFF2-40B4-BE49-F238E27FC236}">
-                <a16:creationId xmlns:a16="http://schemas.microsoft.com/office/drawing/2014/main" id="{9D29D127-741D-47D9-967F-D379FDB48E6B}"/>
+                <a16:creationId xmlns:a16="http://schemas.microsoft.com/office/drawing/2014/main" id="{E2BD1AB8-D748-4134-BFCA-D74F0E53A86D}"/>
               </a:ext>
             </a:extLst>
           </p:cNvPr>
@@ -14967,7 +14967,7 @@
           <p:cNvPr id="15" name="">
             <a:extLst xmlns:a="http://schemas.openxmlformats.org/drawingml/2006/main">
               <a:ext uri="{FF2B5EF4-FFF2-40B4-BE49-F238E27FC236}">
-                <a16:creationId xmlns:a16="http://schemas.microsoft.com/office/drawing/2014/main" id="{01FAB27E-86C6-42DF-B4A4-F4F013FE5B76}"/>
+                <a16:creationId xmlns:a16="http://schemas.microsoft.com/office/drawing/2014/main" id="{AB75FBCB-F9A6-43FA-8B45-B700F766D44A}"/>
               </a:ext>
             </a:extLst>
           </p:cNvPr>
@@ -15017,7 +15017,7 @@
           <p:cNvPr id="16" name="">
             <a:extLst xmlns:a="http://schemas.openxmlformats.org/drawingml/2006/main">
               <a:ext uri="{FF2B5EF4-FFF2-40B4-BE49-F238E27FC236}">
-                <a16:creationId xmlns:a16="http://schemas.microsoft.com/office/drawing/2014/main" id="{5A2264CB-9BF0-42C9-AD0D-56D297A6110B}"/>
+                <a16:creationId xmlns:a16="http://schemas.microsoft.com/office/drawing/2014/main" id="{1899AF30-68C9-4CD8-BD7E-561EDC56C6B5}"/>
               </a:ext>
             </a:extLst>
           </p:cNvPr>
@@ -15067,7 +15067,7 @@
           <p:cNvPr id="17" name="">
             <a:extLst xmlns:a="http://schemas.openxmlformats.org/drawingml/2006/main">
               <a:ext uri="{FF2B5EF4-FFF2-40B4-BE49-F238E27FC236}">
-                <a16:creationId xmlns:a16="http://schemas.microsoft.com/office/drawing/2014/main" id="{6B06A3E6-F1D1-4B59-B391-9FC7183C2DAF}"/>
+                <a16:creationId xmlns:a16="http://schemas.microsoft.com/office/drawing/2014/main" id="{C6799BA1-DDF0-47E3-B977-6D88B4D26F48}"/>
               </a:ext>
             </a:extLst>
           </p:cNvPr>
@@ -15102,7 +15102,7 @@
           <p:cNvPr id="18" name="">
             <a:extLst xmlns:a="http://schemas.openxmlformats.org/drawingml/2006/main">
               <a:ext uri="{FF2B5EF4-FFF2-40B4-BE49-F238E27FC236}">
-                <a16:creationId xmlns:a16="http://schemas.microsoft.com/office/drawing/2014/main" id="{B13E4C36-6867-42B3-9BEB-8EDE332F19A7}"/>
+                <a16:creationId xmlns:a16="http://schemas.microsoft.com/office/drawing/2014/main" id="{FE97AC81-0D08-4644-A986-C9831A32379B}"/>
               </a:ext>
             </a:extLst>
           </p:cNvPr>
@@ -15135,7 +15135,7 @@
           <p:cNvPr id="19" name="">
             <a:extLst xmlns:a="http://schemas.openxmlformats.org/drawingml/2006/main">
               <a:ext uri="{FF2B5EF4-FFF2-40B4-BE49-F238E27FC236}">
-                <a16:creationId xmlns:a16="http://schemas.microsoft.com/office/drawing/2014/main" id="{3C1ED3CF-61E4-45AA-87E2-873382117A92}"/>
+                <a16:creationId xmlns:a16="http://schemas.microsoft.com/office/drawing/2014/main" id="{4F9B57A8-6CFA-42B6-8DE5-29FE87A1BA84}"/>
               </a:ext>
             </a:extLst>
           </p:cNvPr>
@@ -15185,7 +15185,7 @@
           <p:cNvPr id="20" name="">
             <a:extLst xmlns:a="http://schemas.openxmlformats.org/drawingml/2006/main">
               <a:ext uri="{FF2B5EF4-FFF2-40B4-BE49-F238E27FC236}">
-                <a16:creationId xmlns:a16="http://schemas.microsoft.com/office/drawing/2014/main" id="{EF2B3094-600F-4A78-A8D4-F62F3452F43C}"/>
+                <a16:creationId xmlns:a16="http://schemas.microsoft.com/office/drawing/2014/main" id="{CD114AC6-38C7-4D4D-AFB2-9C460AEC61BB}"/>
               </a:ext>
             </a:extLst>
           </p:cNvPr>
@@ -15235,7 +15235,7 @@
           <p:cNvPr id="21" name="">
             <a:extLst xmlns:a="http://schemas.openxmlformats.org/drawingml/2006/main">
               <a:ext uri="{FF2B5EF4-FFF2-40B4-BE49-F238E27FC236}">
-                <a16:creationId xmlns:a16="http://schemas.microsoft.com/office/drawing/2014/main" id="{A4DE8309-A480-42CB-9423-A80A6E7FCC85}"/>
+                <a16:creationId xmlns:a16="http://schemas.microsoft.com/office/drawing/2014/main" id="{B7FA139D-05A5-4C19-8ABA-EDEF27F1D900}"/>
               </a:ext>
             </a:extLst>
           </p:cNvPr>
@@ -15266,7 +15266,7 @@
           <p:cNvPr id="22" name="">
             <a:extLst xmlns:a="http://schemas.openxmlformats.org/drawingml/2006/main">
               <a:ext uri="{FF2B5EF4-FFF2-40B4-BE49-F238E27FC236}">
-                <a16:creationId xmlns:a16="http://schemas.microsoft.com/office/drawing/2014/main" id="{74AF76A5-5473-475D-88DF-7A71BD4B8ABC}"/>
+                <a16:creationId xmlns:a16="http://schemas.microsoft.com/office/drawing/2014/main" id="{797716AF-6E87-45B1-AE8D-7286AABC9506}"/>
               </a:ext>
             </a:extLst>
           </p:cNvPr>
@@ -15316,7 +15316,7 @@
           <p:cNvPr id="23" name="">
             <a:extLst xmlns:a="http://schemas.openxmlformats.org/drawingml/2006/main">
               <a:ext uri="{FF2B5EF4-FFF2-40B4-BE49-F238E27FC236}">
-                <a16:creationId xmlns:a16="http://schemas.microsoft.com/office/drawing/2014/main" id="{6717B90E-38CC-4B9C-9597-A4CBE3294FCE}"/>
+                <a16:creationId xmlns:a16="http://schemas.microsoft.com/office/drawing/2014/main" id="{9C32D370-B6B1-42E2-BB58-915C11B0D8A8}"/>
               </a:ext>
             </a:extLst>
           </p:cNvPr>
@@ -15364,7 +15364,7 @@
     </p:spTree>
     <p:extLst>
       <p:ext uri="{BB962C8B-B14F-4D97-AF65-F5344CB8AC3E}">
-        <p14:creationId xmlns:p14="http://schemas.microsoft.com/office/powerpoint/2010/main" val="1868239136"/>
+        <p14:creationId xmlns:p14="http://schemas.microsoft.com/office/powerpoint/2010/main" val="1198195538"/>
       </p:ext>
     </p:extLst>
   </p:cSld>
@@ -15395,7 +15395,7 @@
           <p:cNvPr id="20" name="">
             <a:extLst xmlns:a="http://schemas.openxmlformats.org/drawingml/2006/main">
               <a:ext uri="{FF2B5EF4-FFF2-40B4-BE49-F238E27FC236}">
-                <a16:creationId xmlns:a16="http://schemas.microsoft.com/office/drawing/2014/main" id="{3552D5DB-04EE-44EB-9D0B-06F4C2E14CB3}"/>
+                <a16:creationId xmlns:a16="http://schemas.microsoft.com/office/drawing/2014/main" id="{F38672D4-A377-4BDB-93BE-A563A17B6D37}"/>
               </a:ext>
             </a:extLst>
           </p:cNvPr>
@@ -15445,7 +15445,7 @@
           <p:cNvPr id="2" name="">
             <a:extLst xmlns:a="http://schemas.openxmlformats.org/drawingml/2006/main">
               <a:ext uri="{FF2B5EF4-FFF2-40B4-BE49-F238E27FC236}">
-                <a16:creationId xmlns:a16="http://schemas.microsoft.com/office/drawing/2014/main" id="{58BCCB2A-AFDA-4CE3-A5B6-F69D419DFCB1}"/>
+                <a16:creationId xmlns:a16="http://schemas.microsoft.com/office/drawing/2014/main" id="{BF119DCC-3BF7-4FDC-A83D-A35FF65FC3F2}"/>
               </a:ext>
             </a:extLst>
           </p:cNvPr>
@@ -15495,7 +15495,7 @@
           <p:cNvPr id="3" name="">
             <a:extLst xmlns:a="http://schemas.openxmlformats.org/drawingml/2006/main">
               <a:ext uri="{FF2B5EF4-FFF2-40B4-BE49-F238E27FC236}">
-                <a16:creationId xmlns:a16="http://schemas.microsoft.com/office/drawing/2014/main" id="{C3FA45F9-C707-425C-84B3-648FD54A9078}"/>
+                <a16:creationId xmlns:a16="http://schemas.microsoft.com/office/drawing/2014/main" id="{B87BBBB1-E78A-4AF6-B1D1-C47F18ADFC53}"/>
               </a:ext>
             </a:extLst>
           </p:cNvPr>
@@ -15545,7 +15545,7 @@
           <p:cNvPr id="4" name="">
             <a:extLst xmlns:a="http://schemas.openxmlformats.org/drawingml/2006/main">
               <a:ext uri="{FF2B5EF4-FFF2-40B4-BE49-F238E27FC236}">
-                <a16:creationId xmlns:a16="http://schemas.microsoft.com/office/drawing/2014/main" id="{2E2268C8-8499-403C-A586-E2E671D98FFD}"/>
+                <a16:creationId xmlns:a16="http://schemas.microsoft.com/office/drawing/2014/main" id="{38EBF2E3-5049-4EB4-9FBF-E04B11222332}"/>
               </a:ext>
             </a:extLst>
           </p:cNvPr>
@@ -15576,7 +15576,7 @@
           <p:cNvPr id="5" name="">
             <a:extLst xmlns:a="http://schemas.openxmlformats.org/drawingml/2006/main">
               <a:ext uri="{FF2B5EF4-FFF2-40B4-BE49-F238E27FC236}">
-                <a16:creationId xmlns:a16="http://schemas.microsoft.com/office/drawing/2014/main" id="{1AB10E14-F897-4720-B83C-082FA389CD43}"/>
+                <a16:creationId xmlns:a16="http://schemas.microsoft.com/office/drawing/2014/main" id="{58E9F4CD-FF4D-4460-BE32-92B6658FAC34}"/>
               </a:ext>
             </a:extLst>
           </p:cNvPr>
@@ -15611,7 +15611,7 @@
           <p:cNvPr id="6" name="">
             <a:extLst xmlns:a="http://schemas.openxmlformats.org/drawingml/2006/main">
               <a:ext uri="{FF2B5EF4-FFF2-40B4-BE49-F238E27FC236}">
-                <a16:creationId xmlns:a16="http://schemas.microsoft.com/office/drawing/2014/main" id="{6DD8BC33-A3F4-4E60-9B0A-1A8134E65176}"/>
+                <a16:creationId xmlns:a16="http://schemas.microsoft.com/office/drawing/2014/main" id="{95545D83-E1B2-4F34-915B-71429E82AA7A}"/>
               </a:ext>
             </a:extLst>
           </p:cNvPr>
@@ -15661,7 +15661,7 @@
           <p:cNvPr id="7" name="">
             <a:extLst xmlns:a="http://schemas.openxmlformats.org/drawingml/2006/main">
               <a:ext uri="{FF2B5EF4-FFF2-40B4-BE49-F238E27FC236}">
-                <a16:creationId xmlns:a16="http://schemas.microsoft.com/office/drawing/2014/main" id="{F3C65E2B-A6F0-4EFA-A574-5AB3D777CFA7}"/>
+                <a16:creationId xmlns:a16="http://schemas.microsoft.com/office/drawing/2014/main" id="{6FD8333A-449D-4F96-A7DB-34256AFA0828}"/>
               </a:ext>
             </a:extLst>
           </p:cNvPr>
@@ -15718,7 +15718,7 @@
         </p:xfrm>
         <a:graphic xmlns:a="http://schemas.openxmlformats.org/drawingml/2006/main">
           <a:graphicData uri="http://schemas.openxmlformats.org/drawingml/2006/chart">
-            <c:chart xmlns:r="http://schemas.openxmlformats.org/officeDocument/2006/relationships" xmlns:c="http://schemas.openxmlformats.org/drawingml/2006/chart" r:id="Rb3e5d4f6d526484c"/>
+            <c:chart xmlns:r="http://schemas.openxmlformats.org/officeDocument/2006/relationships" xmlns:c="http://schemas.openxmlformats.org/drawingml/2006/chart" r:id="R6e9573e5884b4d78"/>
           </a:graphicData>
         </a:graphic>
       </p:graphicFrame>
@@ -15727,7 +15727,7 @@
           <p:cNvPr id="9" name="">
             <a:extLst xmlns:a="http://schemas.openxmlformats.org/drawingml/2006/main">
               <a:ext uri="{FF2B5EF4-FFF2-40B4-BE49-F238E27FC236}">
-                <a16:creationId xmlns:a16="http://schemas.microsoft.com/office/drawing/2014/main" id="{17279D5A-7ED2-4409-BAAF-F9E505F52833}"/>
+                <a16:creationId xmlns:a16="http://schemas.microsoft.com/office/drawing/2014/main" id="{BF142592-B245-4A03-8D69-36052A2436DC}"/>
               </a:ext>
             </a:extLst>
           </p:cNvPr>
@@ -15762,7 +15762,7 @@
           <p:cNvPr id="10" name="">
             <a:extLst xmlns:a="http://schemas.openxmlformats.org/drawingml/2006/main">
               <a:ext uri="{FF2B5EF4-FFF2-40B4-BE49-F238E27FC236}">
-                <a16:creationId xmlns:a16="http://schemas.microsoft.com/office/drawing/2014/main" id="{C7531E55-C052-4C8C-9329-B2F02F07A156}"/>
+                <a16:creationId xmlns:a16="http://schemas.microsoft.com/office/drawing/2014/main" id="{51114F91-5628-4AC1-A99A-0B9A1D337455}"/>
               </a:ext>
             </a:extLst>
           </p:cNvPr>
@@ -15795,7 +15795,7 @@
           <p:cNvPr id="11" name="">
             <a:extLst xmlns:a="http://schemas.openxmlformats.org/drawingml/2006/main">
               <a:ext uri="{FF2B5EF4-FFF2-40B4-BE49-F238E27FC236}">
-                <a16:creationId xmlns:a16="http://schemas.microsoft.com/office/drawing/2014/main" id="{3442B126-8D87-4248-B6E7-1F14DE158346}"/>
+                <a16:creationId xmlns:a16="http://schemas.microsoft.com/office/drawing/2014/main" id="{D76F4EED-4776-4E65-BFF6-193CFA9504F7}"/>
               </a:ext>
             </a:extLst>
           </p:cNvPr>
@@ -15845,7 +15845,7 @@
           <p:cNvPr id="12" name="">
             <a:extLst xmlns:a="http://schemas.openxmlformats.org/drawingml/2006/main">
               <a:ext uri="{FF2B5EF4-FFF2-40B4-BE49-F238E27FC236}">
-                <a16:creationId xmlns:a16="http://schemas.microsoft.com/office/drawing/2014/main" id="{7C0395CF-8E07-446C-A407-F9E7322DC288}"/>
+                <a16:creationId xmlns:a16="http://schemas.microsoft.com/office/drawing/2014/main" id="{50235217-DB4F-40D7-92B5-01F232BB8A0E}"/>
               </a:ext>
             </a:extLst>
           </p:cNvPr>
@@ -15895,7 +15895,7 @@
           <p:cNvPr id="13" name="">
             <a:extLst xmlns:a="http://schemas.openxmlformats.org/drawingml/2006/main">
               <a:ext uri="{FF2B5EF4-FFF2-40B4-BE49-F238E27FC236}">
-                <a16:creationId xmlns:a16="http://schemas.microsoft.com/office/drawing/2014/main" id="{7FECC879-9AB6-4365-8788-E4E283DB3923}"/>
+                <a16:creationId xmlns:a16="http://schemas.microsoft.com/office/drawing/2014/main" id="{6430BA87-C3D4-455A-AB10-EDED2201A39C}"/>
               </a:ext>
             </a:extLst>
           </p:cNvPr>
@@ -15930,7 +15930,7 @@
           <p:cNvPr id="14" name="">
             <a:extLst xmlns:a="http://schemas.openxmlformats.org/drawingml/2006/main">
               <a:ext uri="{FF2B5EF4-FFF2-40B4-BE49-F238E27FC236}">
-                <a16:creationId xmlns:a16="http://schemas.microsoft.com/office/drawing/2014/main" id="{114D7C38-2DB3-4CC1-9F5A-0B1D88D35EEB}"/>
+                <a16:creationId xmlns:a16="http://schemas.microsoft.com/office/drawing/2014/main" id="{57AEA783-9FB4-4C6C-8F4F-8E2AD650EBC6}"/>
               </a:ext>
             </a:extLst>
           </p:cNvPr>
@@ -15963,7 +15963,7 @@
           <p:cNvPr id="15" name="">
             <a:extLst xmlns:a="http://schemas.openxmlformats.org/drawingml/2006/main">
               <a:ext uri="{FF2B5EF4-FFF2-40B4-BE49-F238E27FC236}">
-                <a16:creationId xmlns:a16="http://schemas.microsoft.com/office/drawing/2014/main" id="{2D5A4AE7-A83E-4A55-8141-1A9F1AC80AB7}"/>
+                <a16:creationId xmlns:a16="http://schemas.microsoft.com/office/drawing/2014/main" id="{67A25B5E-2B05-4FBE-9F24-A0029706B75F}"/>
               </a:ext>
             </a:extLst>
           </p:cNvPr>
@@ -16013,7 +16013,7 @@
           <p:cNvPr id="16" name="">
             <a:extLst xmlns:a="http://schemas.openxmlformats.org/drawingml/2006/main">
               <a:ext uri="{FF2B5EF4-FFF2-40B4-BE49-F238E27FC236}">
-                <a16:creationId xmlns:a16="http://schemas.microsoft.com/office/drawing/2014/main" id="{589AD504-D9EE-43EE-8B00-92CD54EF713C}"/>
+                <a16:creationId xmlns:a16="http://schemas.microsoft.com/office/drawing/2014/main" id="{484163CA-C689-497E-9919-CB26D793DA66}"/>
               </a:ext>
             </a:extLst>
           </p:cNvPr>
@@ -16063,7 +16063,7 @@
           <p:cNvPr id="17" name="">
             <a:extLst xmlns:a="http://schemas.openxmlformats.org/drawingml/2006/main">
               <a:ext uri="{FF2B5EF4-FFF2-40B4-BE49-F238E27FC236}">
-                <a16:creationId xmlns:a16="http://schemas.microsoft.com/office/drawing/2014/main" id="{D4A3D0E0-F77E-4DC0-86A7-A533F0E57CB9}"/>
+                <a16:creationId xmlns:a16="http://schemas.microsoft.com/office/drawing/2014/main" id="{3E3513AD-F7B8-42C5-AA47-EE082739047F}"/>
               </a:ext>
             </a:extLst>
           </p:cNvPr>
@@ -16094,7 +16094,7 @@
           <p:cNvPr id="18" name="">
             <a:extLst xmlns:a="http://schemas.openxmlformats.org/drawingml/2006/main">
               <a:ext uri="{FF2B5EF4-FFF2-40B4-BE49-F238E27FC236}">
-                <a16:creationId xmlns:a16="http://schemas.microsoft.com/office/drawing/2014/main" id="{BBCD47E0-023D-4489-8D60-65189582B2B3}"/>
+                <a16:creationId xmlns:a16="http://schemas.microsoft.com/office/drawing/2014/main" id="{B2AA177E-9278-45C5-85B6-D9B9956B0A09}"/>
               </a:ext>
             </a:extLst>
           </p:cNvPr>
@@ -16144,7 +16144,7 @@
           <p:cNvPr id="19" name="">
             <a:extLst xmlns:a="http://schemas.openxmlformats.org/drawingml/2006/main">
               <a:ext uri="{FF2B5EF4-FFF2-40B4-BE49-F238E27FC236}">
-                <a16:creationId xmlns:a16="http://schemas.microsoft.com/office/drawing/2014/main" id="{03F4E4EF-6733-44DD-906C-3A2154D60DD3}"/>
+                <a16:creationId xmlns:a16="http://schemas.microsoft.com/office/drawing/2014/main" id="{DD43F2AB-620D-4B57-9ED6-55A3A4D9C53A}"/>
               </a:ext>
             </a:extLst>
           </p:cNvPr>
@@ -16192,7 +16192,7 @@
     </p:spTree>
     <p:extLst>
       <p:ext uri="{BB962C8B-B14F-4D97-AF65-F5344CB8AC3E}">
-        <p14:creationId xmlns:p14="http://schemas.microsoft.com/office/powerpoint/2010/main" val="2033039794"/>
+        <p14:creationId xmlns:p14="http://schemas.microsoft.com/office/powerpoint/2010/main" val="481981510"/>
       </p:ext>
     </p:extLst>
   </p:cSld>

</xml_diff>